<commit_message>
Final Upgrade: Directly rendered transparent PNGs and Premium UI
</commit_message>
<xml_diff>
--- a/output/1.pptx
+++ b/output/1.pptx
@@ -3104,8 +3104,8 @@
         </p:nvCxnSpPr>
         <p:spPr>
           <a:xfrm>
-            <a:off x="2286000.0" y="2571750.0"/>
-            <a:ext cx="4572000.0" cy="0.0"/>
+            <a:off x="4343400.0" y="2571750.0"/>
+            <a:ext cx="1920240.0" cy="0.0"/>
           </a:xfrm>
           <a:prstGeom prst="line">
             <a:avLst/>
@@ -3139,8 +3139,8 @@
         </p:nvCxnSpPr>
         <p:spPr>
           <a:xfrm flipV="1">
-            <a:off x="4572000.0" y="285750.0"/>
-            <a:ext cx="0.0" cy="4572000.0"/>
+            <a:off x="4572000.0" y="971550.0"/>
+            <a:ext cx="0.0" cy="1828800.0"/>
           </a:xfrm>
           <a:prstGeom prst="line">
             <a:avLst/>
@@ -3166,6 +3166,1910 @@
           </a:fontRef>
         </p:style>
       </p:cxnSp>
+      <p:cxnSp>
+        <p:nvCxnSpPr>
+          <p:cNvPr id="4" name="Connector 3"/>
+          <p:cNvCxnSpPr/>
+          <p:nvPr/>
+        </p:nvCxnSpPr>
+        <p:spPr>
+          <a:xfrm flipV="1">
+            <a:off x="4572000.0" y="2526030.0"/>
+            <a:ext cx="228600.0" cy="45720.0"/>
+          </a:xfrm>
+          <a:prstGeom prst="line">
+            <a:avLst/>
+          </a:prstGeom>
+          <a:ln w="25400">
+            <a:solidFill>
+              <a:srgbClr val="00C8FF"/>
+            </a:solidFill>
+          </a:ln>
+        </p:spPr>
+        <p:style>
+          <a:lnRef idx="2">
+            <a:schemeClr val="accent1"/>
+          </a:lnRef>
+          <a:fillRef idx="0">
+            <a:schemeClr val="accent1"/>
+          </a:fillRef>
+          <a:effectRef idx="1">
+            <a:schemeClr val="accent1"/>
+          </a:effectRef>
+          <a:fontRef idx="minor">
+            <a:schemeClr val="tx1"/>
+          </a:fontRef>
+        </p:style>
+      </p:cxnSp>
+      <p:cxnSp>
+        <p:nvCxnSpPr>
+          <p:cNvPr id="5" name="Connector 4"/>
+          <p:cNvCxnSpPr/>
+          <p:nvPr/>
+        </p:nvCxnSpPr>
+        <p:spPr>
+          <a:xfrm flipV="1">
+            <a:off x="4800600.0" y="2434590.0"/>
+            <a:ext cx="228600.0" cy="91440.0"/>
+          </a:xfrm>
+          <a:prstGeom prst="line">
+            <a:avLst/>
+          </a:prstGeom>
+          <a:ln w="25400">
+            <a:solidFill>
+              <a:srgbClr val="00C8FF"/>
+            </a:solidFill>
+          </a:ln>
+        </p:spPr>
+        <p:style>
+          <a:lnRef idx="2">
+            <a:schemeClr val="accent1"/>
+          </a:lnRef>
+          <a:fillRef idx="0">
+            <a:schemeClr val="accent1"/>
+          </a:fillRef>
+          <a:effectRef idx="1">
+            <a:schemeClr val="accent1"/>
+          </a:effectRef>
+          <a:fontRef idx="minor">
+            <a:schemeClr val="tx1"/>
+          </a:fontRef>
+        </p:style>
+      </p:cxnSp>
+      <p:cxnSp>
+        <p:nvCxnSpPr>
+          <p:cNvPr id="6" name="Connector 5"/>
+          <p:cNvCxnSpPr/>
+          <p:nvPr/>
+        </p:nvCxnSpPr>
+        <p:spPr>
+          <a:xfrm flipV="1">
+            <a:off x="5029200.0" y="2297430.0"/>
+            <a:ext cx="228600.0" cy="137160.0"/>
+          </a:xfrm>
+          <a:prstGeom prst="line">
+            <a:avLst/>
+          </a:prstGeom>
+          <a:ln w="25400">
+            <a:solidFill>
+              <a:srgbClr val="00C8FF"/>
+            </a:solidFill>
+          </a:ln>
+        </p:spPr>
+        <p:style>
+          <a:lnRef idx="2">
+            <a:schemeClr val="accent1"/>
+          </a:lnRef>
+          <a:fillRef idx="0">
+            <a:schemeClr val="accent1"/>
+          </a:fillRef>
+          <a:effectRef idx="1">
+            <a:schemeClr val="accent1"/>
+          </a:effectRef>
+          <a:fontRef idx="minor">
+            <a:schemeClr val="tx1"/>
+          </a:fontRef>
+        </p:style>
+      </p:cxnSp>
+      <p:cxnSp>
+        <p:nvCxnSpPr>
+          <p:cNvPr id="7" name="Connector 6"/>
+          <p:cNvCxnSpPr/>
+          <p:nvPr/>
+        </p:nvCxnSpPr>
+        <p:spPr>
+          <a:xfrm flipV="1">
+            <a:off x="5257800.0" y="2114550.0"/>
+            <a:ext cx="228600.0" cy="182880.0"/>
+          </a:xfrm>
+          <a:prstGeom prst="line">
+            <a:avLst/>
+          </a:prstGeom>
+          <a:ln w="25400">
+            <a:solidFill>
+              <a:srgbClr val="00C8FF"/>
+            </a:solidFill>
+          </a:ln>
+        </p:spPr>
+        <p:style>
+          <a:lnRef idx="2">
+            <a:schemeClr val="accent1"/>
+          </a:lnRef>
+          <a:fillRef idx="0">
+            <a:schemeClr val="accent1"/>
+          </a:fillRef>
+          <a:effectRef idx="1">
+            <a:schemeClr val="accent1"/>
+          </a:effectRef>
+          <a:fontRef idx="minor">
+            <a:schemeClr val="tx1"/>
+          </a:fontRef>
+        </p:style>
+      </p:cxnSp>
+      <p:cxnSp>
+        <p:nvCxnSpPr>
+          <p:cNvPr id="8" name="Connector 7"/>
+          <p:cNvCxnSpPr/>
+          <p:nvPr/>
+        </p:nvCxnSpPr>
+        <p:spPr>
+          <a:xfrm flipV="1">
+            <a:off x="5486400.0" y="1977390.0"/>
+            <a:ext cx="91440.0" cy="137160.0"/>
+          </a:xfrm>
+          <a:prstGeom prst="line">
+            <a:avLst/>
+          </a:prstGeom>
+          <a:ln w="25400">
+            <a:solidFill>
+              <a:srgbClr val="00C8FF"/>
+            </a:solidFill>
+          </a:ln>
+        </p:spPr>
+        <p:style>
+          <a:lnRef idx="2">
+            <a:schemeClr val="accent1"/>
+          </a:lnRef>
+          <a:fillRef idx="0">
+            <a:schemeClr val="accent1"/>
+          </a:fillRef>
+          <a:effectRef idx="1">
+            <a:schemeClr val="accent1"/>
+          </a:effectRef>
+          <a:fontRef idx="minor">
+            <a:schemeClr val="tx1"/>
+          </a:fontRef>
+        </p:style>
+      </p:cxnSp>
+      <p:cxnSp>
+        <p:nvCxnSpPr>
+          <p:cNvPr id="9" name="Connector 8"/>
+          <p:cNvCxnSpPr/>
+          <p:nvPr/>
+        </p:nvCxnSpPr>
+        <p:spPr>
+          <a:xfrm flipV="1">
+            <a:off x="5577840.0" y="1885950.0"/>
+            <a:ext cx="45720.0" cy="91440.0"/>
+          </a:xfrm>
+          <a:prstGeom prst="line">
+            <a:avLst/>
+          </a:prstGeom>
+          <a:ln w="25400">
+            <a:solidFill>
+              <a:srgbClr val="00C8FF"/>
+            </a:solidFill>
+          </a:ln>
+        </p:spPr>
+        <p:style>
+          <a:lnRef idx="2">
+            <a:schemeClr val="accent1"/>
+          </a:lnRef>
+          <a:fillRef idx="0">
+            <a:schemeClr val="accent1"/>
+          </a:fillRef>
+          <a:effectRef idx="1">
+            <a:schemeClr val="accent1"/>
+          </a:effectRef>
+          <a:fontRef idx="minor">
+            <a:schemeClr val="tx1"/>
+          </a:fontRef>
+        </p:style>
+      </p:cxnSp>
+      <p:cxnSp>
+        <p:nvCxnSpPr>
+          <p:cNvPr id="10" name="Connector 9"/>
+          <p:cNvCxnSpPr/>
+          <p:nvPr/>
+        </p:nvCxnSpPr>
+        <p:spPr>
+          <a:xfrm flipV="1">
+            <a:off x="5623560.0" y="1794510.0"/>
+            <a:ext cx="45720.0" cy="91440.0"/>
+          </a:xfrm>
+          <a:prstGeom prst="line">
+            <a:avLst/>
+          </a:prstGeom>
+          <a:ln w="25400">
+            <a:solidFill>
+              <a:srgbClr val="00C8FF"/>
+            </a:solidFill>
+          </a:ln>
+        </p:spPr>
+        <p:style>
+          <a:lnRef idx="2">
+            <a:schemeClr val="accent1"/>
+          </a:lnRef>
+          <a:fillRef idx="0">
+            <a:schemeClr val="accent1"/>
+          </a:fillRef>
+          <a:effectRef idx="1">
+            <a:schemeClr val="accent1"/>
+          </a:effectRef>
+          <a:fontRef idx="minor">
+            <a:schemeClr val="tx1"/>
+          </a:fontRef>
+        </p:style>
+      </p:cxnSp>
+      <p:cxnSp>
+        <p:nvCxnSpPr>
+          <p:cNvPr id="11" name="Connector 10"/>
+          <p:cNvCxnSpPr/>
+          <p:nvPr/>
+        </p:nvCxnSpPr>
+        <p:spPr>
+          <a:xfrm flipV="1">
+            <a:off x="5669280.0" y="1748790.0"/>
+            <a:ext cx="22860.0" cy="45720.0"/>
+          </a:xfrm>
+          <a:prstGeom prst="line">
+            <a:avLst/>
+          </a:prstGeom>
+          <a:ln w="25400">
+            <a:solidFill>
+              <a:srgbClr val="00C8FF"/>
+            </a:solidFill>
+          </a:ln>
+        </p:spPr>
+        <p:style>
+          <a:lnRef idx="2">
+            <a:schemeClr val="accent1"/>
+          </a:lnRef>
+          <a:fillRef idx="0">
+            <a:schemeClr val="accent1"/>
+          </a:fillRef>
+          <a:effectRef idx="1">
+            <a:schemeClr val="accent1"/>
+          </a:effectRef>
+          <a:fontRef idx="minor">
+            <a:schemeClr val="tx1"/>
+          </a:fontRef>
+        </p:style>
+      </p:cxnSp>
+      <p:cxnSp>
+        <p:nvCxnSpPr>
+          <p:cNvPr id="12" name="Connector 11"/>
+          <p:cNvCxnSpPr/>
+          <p:nvPr/>
+        </p:nvCxnSpPr>
+        <p:spPr>
+          <a:xfrm flipV="1">
+            <a:off x="5692140.0" y="1611630.0"/>
+            <a:ext cx="45720.0" cy="137160.0"/>
+          </a:xfrm>
+          <a:prstGeom prst="line">
+            <a:avLst/>
+          </a:prstGeom>
+          <a:ln w="25400">
+            <a:solidFill>
+              <a:srgbClr val="00C8FF"/>
+            </a:solidFill>
+          </a:ln>
+        </p:spPr>
+        <p:style>
+          <a:lnRef idx="2">
+            <a:schemeClr val="accent1"/>
+          </a:lnRef>
+          <a:fillRef idx="0">
+            <a:schemeClr val="accent1"/>
+          </a:fillRef>
+          <a:effectRef idx="1">
+            <a:schemeClr val="accent1"/>
+          </a:effectRef>
+          <a:fontRef idx="minor">
+            <a:schemeClr val="tx1"/>
+          </a:fontRef>
+        </p:style>
+      </p:cxnSp>
+      <p:cxnSp>
+        <p:nvCxnSpPr>
+          <p:cNvPr id="13" name="Connector 12"/>
+          <p:cNvCxnSpPr/>
+          <p:nvPr/>
+        </p:nvCxnSpPr>
+        <p:spPr>
+          <a:xfrm flipV="1">
+            <a:off x="5737860.0" y="1520190.0"/>
+            <a:ext cx="45720.0" cy="91440.0"/>
+          </a:xfrm>
+          <a:prstGeom prst="line">
+            <a:avLst/>
+          </a:prstGeom>
+          <a:ln w="25400">
+            <a:solidFill>
+              <a:srgbClr val="00C8FF"/>
+            </a:solidFill>
+          </a:ln>
+        </p:spPr>
+        <p:style>
+          <a:lnRef idx="2">
+            <a:schemeClr val="accent1"/>
+          </a:lnRef>
+          <a:fillRef idx="0">
+            <a:schemeClr val="accent1"/>
+          </a:fillRef>
+          <a:effectRef idx="1">
+            <a:schemeClr val="accent1"/>
+          </a:effectRef>
+          <a:fontRef idx="minor">
+            <a:schemeClr val="tx1"/>
+          </a:fontRef>
+        </p:style>
+      </p:cxnSp>
+      <p:cxnSp>
+        <p:nvCxnSpPr>
+          <p:cNvPr id="14" name="Connector 13"/>
+          <p:cNvCxnSpPr/>
+          <p:nvPr/>
+        </p:nvCxnSpPr>
+        <p:spPr>
+          <a:xfrm flipV="1">
+            <a:off x="5783580.0" y="1428750.0"/>
+            <a:ext cx="45720.0" cy="91440.0"/>
+          </a:xfrm>
+          <a:prstGeom prst="line">
+            <a:avLst/>
+          </a:prstGeom>
+          <a:ln w="25400">
+            <a:solidFill>
+              <a:srgbClr val="00C8FF"/>
+            </a:solidFill>
+          </a:ln>
+        </p:spPr>
+        <p:style>
+          <a:lnRef idx="2">
+            <a:schemeClr val="accent1"/>
+          </a:lnRef>
+          <a:fillRef idx="0">
+            <a:schemeClr val="accent1"/>
+          </a:fillRef>
+          <a:effectRef idx="1">
+            <a:schemeClr val="accent1"/>
+          </a:effectRef>
+          <a:fontRef idx="minor">
+            <a:schemeClr val="tx1"/>
+          </a:fontRef>
+        </p:style>
+      </p:cxnSp>
+      <p:cxnSp>
+        <p:nvCxnSpPr>
+          <p:cNvPr id="15" name="Connector 14"/>
+          <p:cNvCxnSpPr/>
+          <p:nvPr/>
+        </p:nvCxnSpPr>
+        <p:spPr>
+          <a:xfrm>
+            <a:off x="4572000.0" y="1657350.0"/>
+            <a:ext cx="45720.0" cy="45720.0"/>
+          </a:xfrm>
+          <a:prstGeom prst="line">
+            <a:avLst/>
+          </a:prstGeom>
+          <a:ln w="25400">
+            <a:solidFill>
+              <a:srgbClr val="00C8FF"/>
+            </a:solidFill>
+          </a:ln>
+        </p:spPr>
+        <p:style>
+          <a:lnRef idx="2">
+            <a:schemeClr val="accent1"/>
+          </a:lnRef>
+          <a:fillRef idx="0">
+            <a:schemeClr val="accent1"/>
+          </a:fillRef>
+          <a:effectRef idx="1">
+            <a:schemeClr val="accent1"/>
+          </a:effectRef>
+          <a:fontRef idx="minor">
+            <a:schemeClr val="tx1"/>
+          </a:fontRef>
+        </p:style>
+      </p:cxnSp>
+      <p:cxnSp>
+        <p:nvCxnSpPr>
+          <p:cNvPr id="16" name="Connector 15"/>
+          <p:cNvCxnSpPr/>
+          <p:nvPr/>
+        </p:nvCxnSpPr>
+        <p:spPr>
+          <a:xfrm>
+            <a:off x="4617720.0" y="1703070.0"/>
+            <a:ext cx="45720.0" cy="45720.0"/>
+          </a:xfrm>
+          <a:prstGeom prst="line">
+            <a:avLst/>
+          </a:prstGeom>
+          <a:ln w="25400">
+            <a:solidFill>
+              <a:srgbClr val="00C8FF"/>
+            </a:solidFill>
+          </a:ln>
+        </p:spPr>
+        <p:style>
+          <a:lnRef idx="2">
+            <a:schemeClr val="accent1"/>
+          </a:lnRef>
+          <a:fillRef idx="0">
+            <a:schemeClr val="accent1"/>
+          </a:fillRef>
+          <a:effectRef idx="1">
+            <a:schemeClr val="accent1"/>
+          </a:effectRef>
+          <a:fontRef idx="minor">
+            <a:schemeClr val="tx1"/>
+          </a:fontRef>
+        </p:style>
+      </p:cxnSp>
+      <p:cxnSp>
+        <p:nvCxnSpPr>
+          <p:cNvPr id="17" name="Connector 16"/>
+          <p:cNvCxnSpPr/>
+          <p:nvPr/>
+        </p:nvCxnSpPr>
+        <p:spPr>
+          <a:xfrm>
+            <a:off x="4663440.0" y="1748790.0"/>
+            <a:ext cx="45720.0" cy="45720.0"/>
+          </a:xfrm>
+          <a:prstGeom prst="line">
+            <a:avLst/>
+          </a:prstGeom>
+          <a:ln w="25400">
+            <a:solidFill>
+              <a:srgbClr val="00C8FF"/>
+            </a:solidFill>
+          </a:ln>
+        </p:spPr>
+        <p:style>
+          <a:lnRef idx="2">
+            <a:schemeClr val="accent1"/>
+          </a:lnRef>
+          <a:fillRef idx="0">
+            <a:schemeClr val="accent1"/>
+          </a:fillRef>
+          <a:effectRef idx="1">
+            <a:schemeClr val="accent1"/>
+          </a:effectRef>
+          <a:fontRef idx="minor">
+            <a:schemeClr val="tx1"/>
+          </a:fontRef>
+        </p:style>
+      </p:cxnSp>
+      <p:cxnSp>
+        <p:nvCxnSpPr>
+          <p:cNvPr id="18" name="Connector 17"/>
+          <p:cNvCxnSpPr/>
+          <p:nvPr/>
+        </p:nvCxnSpPr>
+        <p:spPr>
+          <a:xfrm>
+            <a:off x="4709160.0" y="1794510.0"/>
+            <a:ext cx="45720.0" cy="45720.0"/>
+          </a:xfrm>
+          <a:prstGeom prst="line">
+            <a:avLst/>
+          </a:prstGeom>
+          <a:ln w="25400">
+            <a:solidFill>
+              <a:srgbClr val="00C8FF"/>
+            </a:solidFill>
+          </a:ln>
+        </p:spPr>
+        <p:style>
+          <a:lnRef idx="2">
+            <a:schemeClr val="accent1"/>
+          </a:lnRef>
+          <a:fillRef idx="0">
+            <a:schemeClr val="accent1"/>
+          </a:fillRef>
+          <a:effectRef idx="1">
+            <a:schemeClr val="accent1"/>
+          </a:effectRef>
+          <a:fontRef idx="minor">
+            <a:schemeClr val="tx1"/>
+          </a:fontRef>
+        </p:style>
+      </p:cxnSp>
+      <p:cxnSp>
+        <p:nvCxnSpPr>
+          <p:cNvPr id="19" name="Connector 18"/>
+          <p:cNvCxnSpPr/>
+          <p:nvPr/>
+        </p:nvCxnSpPr>
+        <p:spPr>
+          <a:xfrm>
+            <a:off x="4754880.0" y="1840230.0"/>
+            <a:ext cx="45720.0" cy="45720.0"/>
+          </a:xfrm>
+          <a:prstGeom prst="line">
+            <a:avLst/>
+          </a:prstGeom>
+          <a:ln w="25400">
+            <a:solidFill>
+              <a:srgbClr val="00C8FF"/>
+            </a:solidFill>
+          </a:ln>
+        </p:spPr>
+        <p:style>
+          <a:lnRef idx="2">
+            <a:schemeClr val="accent1"/>
+          </a:lnRef>
+          <a:fillRef idx="0">
+            <a:schemeClr val="accent1"/>
+          </a:fillRef>
+          <a:effectRef idx="1">
+            <a:schemeClr val="accent1"/>
+          </a:effectRef>
+          <a:fontRef idx="minor">
+            <a:schemeClr val="tx1"/>
+          </a:fontRef>
+        </p:style>
+      </p:cxnSp>
+      <p:cxnSp>
+        <p:nvCxnSpPr>
+          <p:cNvPr id="20" name="Connector 19"/>
+          <p:cNvCxnSpPr/>
+          <p:nvPr/>
+        </p:nvCxnSpPr>
+        <p:spPr>
+          <a:xfrm>
+            <a:off x="4800600.0" y="1885950.0"/>
+            <a:ext cx="45720.0" cy="45720.0"/>
+          </a:xfrm>
+          <a:prstGeom prst="line">
+            <a:avLst/>
+          </a:prstGeom>
+          <a:ln w="25400">
+            <a:solidFill>
+              <a:srgbClr val="00C8FF"/>
+            </a:solidFill>
+          </a:ln>
+        </p:spPr>
+        <p:style>
+          <a:lnRef idx="2">
+            <a:schemeClr val="accent1"/>
+          </a:lnRef>
+          <a:fillRef idx="0">
+            <a:schemeClr val="accent1"/>
+          </a:fillRef>
+          <a:effectRef idx="1">
+            <a:schemeClr val="accent1"/>
+          </a:effectRef>
+          <a:fontRef idx="minor">
+            <a:schemeClr val="tx1"/>
+          </a:fontRef>
+        </p:style>
+      </p:cxnSp>
+      <p:cxnSp>
+        <p:nvCxnSpPr>
+          <p:cNvPr id="21" name="Connector 20"/>
+          <p:cNvCxnSpPr/>
+          <p:nvPr/>
+        </p:nvCxnSpPr>
+        <p:spPr>
+          <a:xfrm>
+            <a:off x="4846320.0" y="1931670.0"/>
+            <a:ext cx="45720.0" cy="45720.0"/>
+          </a:xfrm>
+          <a:prstGeom prst="line">
+            <a:avLst/>
+          </a:prstGeom>
+          <a:ln w="25400">
+            <a:solidFill>
+              <a:srgbClr val="00C8FF"/>
+            </a:solidFill>
+          </a:ln>
+        </p:spPr>
+        <p:style>
+          <a:lnRef idx="2">
+            <a:schemeClr val="accent1"/>
+          </a:lnRef>
+          <a:fillRef idx="0">
+            <a:schemeClr val="accent1"/>
+          </a:fillRef>
+          <a:effectRef idx="1">
+            <a:schemeClr val="accent1"/>
+          </a:effectRef>
+          <a:fontRef idx="minor">
+            <a:schemeClr val="tx1"/>
+          </a:fontRef>
+        </p:style>
+      </p:cxnSp>
+      <p:cxnSp>
+        <p:nvCxnSpPr>
+          <p:cNvPr id="22" name="Connector 21"/>
+          <p:cNvCxnSpPr/>
+          <p:nvPr/>
+        </p:nvCxnSpPr>
+        <p:spPr>
+          <a:xfrm>
+            <a:off x="4892040.0" y="1977390.0"/>
+            <a:ext cx="45720.0" cy="45720.0"/>
+          </a:xfrm>
+          <a:prstGeom prst="line">
+            <a:avLst/>
+          </a:prstGeom>
+          <a:ln w="25400">
+            <a:solidFill>
+              <a:srgbClr val="00C8FF"/>
+            </a:solidFill>
+          </a:ln>
+        </p:spPr>
+        <p:style>
+          <a:lnRef idx="2">
+            <a:schemeClr val="accent1"/>
+          </a:lnRef>
+          <a:fillRef idx="0">
+            <a:schemeClr val="accent1"/>
+          </a:fillRef>
+          <a:effectRef idx="1">
+            <a:schemeClr val="accent1"/>
+          </a:effectRef>
+          <a:fontRef idx="minor">
+            <a:schemeClr val="tx1"/>
+          </a:fontRef>
+        </p:style>
+      </p:cxnSp>
+      <p:cxnSp>
+        <p:nvCxnSpPr>
+          <p:cNvPr id="23" name="Connector 22"/>
+          <p:cNvCxnSpPr/>
+          <p:nvPr/>
+        </p:nvCxnSpPr>
+        <p:spPr>
+          <a:xfrm>
+            <a:off x="4937760.0" y="2023110.0"/>
+            <a:ext cx="45720.0" cy="45720.0"/>
+          </a:xfrm>
+          <a:prstGeom prst="line">
+            <a:avLst/>
+          </a:prstGeom>
+          <a:ln w="25400">
+            <a:solidFill>
+              <a:srgbClr val="00C8FF"/>
+            </a:solidFill>
+          </a:ln>
+        </p:spPr>
+        <p:style>
+          <a:lnRef idx="2">
+            <a:schemeClr val="accent1"/>
+          </a:lnRef>
+          <a:fillRef idx="0">
+            <a:schemeClr val="accent1"/>
+          </a:fillRef>
+          <a:effectRef idx="1">
+            <a:schemeClr val="accent1"/>
+          </a:effectRef>
+          <a:fontRef idx="minor">
+            <a:schemeClr val="tx1"/>
+          </a:fontRef>
+        </p:style>
+      </p:cxnSp>
+      <p:cxnSp>
+        <p:nvCxnSpPr>
+          <p:cNvPr id="24" name="Connector 23"/>
+          <p:cNvCxnSpPr/>
+          <p:nvPr/>
+        </p:nvCxnSpPr>
+        <p:spPr>
+          <a:xfrm flipV="1">
+            <a:off x="5029200.0" y="1611630.0"/>
+            <a:ext cx="45720.0" cy="45720.0"/>
+          </a:xfrm>
+          <a:prstGeom prst="line">
+            <a:avLst/>
+          </a:prstGeom>
+          <a:ln w="25400">
+            <a:solidFill>
+              <a:srgbClr val="00C8FF"/>
+            </a:solidFill>
+          </a:ln>
+        </p:spPr>
+        <p:style>
+          <a:lnRef idx="2">
+            <a:schemeClr val="accent1"/>
+          </a:lnRef>
+          <a:fillRef idx="0">
+            <a:schemeClr val="accent1"/>
+          </a:fillRef>
+          <a:effectRef idx="1">
+            <a:schemeClr val="accent1"/>
+          </a:effectRef>
+          <a:fontRef idx="minor">
+            <a:schemeClr val="tx1"/>
+          </a:fontRef>
+        </p:style>
+      </p:cxnSp>
+      <p:cxnSp>
+        <p:nvCxnSpPr>
+          <p:cNvPr id="25" name="Connector 24"/>
+          <p:cNvCxnSpPr/>
+          <p:nvPr/>
+        </p:nvCxnSpPr>
+        <p:spPr>
+          <a:xfrm flipV="1">
+            <a:off x="5074920.0" y="1565910.0"/>
+            <a:ext cx="45720.0" cy="45720.0"/>
+          </a:xfrm>
+          <a:prstGeom prst="line">
+            <a:avLst/>
+          </a:prstGeom>
+          <a:ln w="25400">
+            <a:solidFill>
+              <a:srgbClr val="00C8FF"/>
+            </a:solidFill>
+          </a:ln>
+        </p:spPr>
+        <p:style>
+          <a:lnRef idx="2">
+            <a:schemeClr val="accent1"/>
+          </a:lnRef>
+          <a:fillRef idx="0">
+            <a:schemeClr val="accent1"/>
+          </a:fillRef>
+          <a:effectRef idx="1">
+            <a:schemeClr val="accent1"/>
+          </a:effectRef>
+          <a:fontRef idx="minor">
+            <a:schemeClr val="tx1"/>
+          </a:fontRef>
+        </p:style>
+      </p:cxnSp>
+      <p:cxnSp>
+        <p:nvCxnSpPr>
+          <p:cNvPr id="26" name="Connector 25"/>
+          <p:cNvCxnSpPr/>
+          <p:nvPr/>
+        </p:nvCxnSpPr>
+        <p:spPr>
+          <a:xfrm flipV="1">
+            <a:off x="5120640.0" y="1520190.0"/>
+            <a:ext cx="45720.0" cy="45720.0"/>
+          </a:xfrm>
+          <a:prstGeom prst="line">
+            <a:avLst/>
+          </a:prstGeom>
+          <a:ln w="25400">
+            <a:solidFill>
+              <a:srgbClr val="00C8FF"/>
+            </a:solidFill>
+          </a:ln>
+        </p:spPr>
+        <p:style>
+          <a:lnRef idx="2">
+            <a:schemeClr val="accent1"/>
+          </a:lnRef>
+          <a:fillRef idx="0">
+            <a:schemeClr val="accent1"/>
+          </a:fillRef>
+          <a:effectRef idx="1">
+            <a:schemeClr val="accent1"/>
+          </a:effectRef>
+          <a:fontRef idx="minor">
+            <a:schemeClr val="tx1"/>
+          </a:fontRef>
+        </p:style>
+      </p:cxnSp>
+      <p:cxnSp>
+        <p:nvCxnSpPr>
+          <p:cNvPr id="27" name="Connector 26"/>
+          <p:cNvCxnSpPr/>
+          <p:nvPr/>
+        </p:nvCxnSpPr>
+        <p:spPr>
+          <a:xfrm flipV="1">
+            <a:off x="5166360.0" y="1474470.0"/>
+            <a:ext cx="45720.0" cy="45720.0"/>
+          </a:xfrm>
+          <a:prstGeom prst="line">
+            <a:avLst/>
+          </a:prstGeom>
+          <a:ln w="25400">
+            <a:solidFill>
+              <a:srgbClr val="00C8FF"/>
+            </a:solidFill>
+          </a:ln>
+        </p:spPr>
+        <p:style>
+          <a:lnRef idx="2">
+            <a:schemeClr val="accent1"/>
+          </a:lnRef>
+          <a:fillRef idx="0">
+            <a:schemeClr val="accent1"/>
+          </a:fillRef>
+          <a:effectRef idx="1">
+            <a:schemeClr val="accent1"/>
+          </a:effectRef>
+          <a:fontRef idx="minor">
+            <a:schemeClr val="tx1"/>
+          </a:fontRef>
+        </p:style>
+      </p:cxnSp>
+      <p:cxnSp>
+        <p:nvCxnSpPr>
+          <p:cNvPr id="28" name="Connector 27"/>
+          <p:cNvCxnSpPr/>
+          <p:nvPr/>
+        </p:nvCxnSpPr>
+        <p:spPr>
+          <a:xfrm flipV="1">
+            <a:off x="5212080.0" y="1428750.0"/>
+            <a:ext cx="45720.0" cy="45720.0"/>
+          </a:xfrm>
+          <a:prstGeom prst="line">
+            <a:avLst/>
+          </a:prstGeom>
+          <a:ln w="25400">
+            <a:solidFill>
+              <a:srgbClr val="00C8FF"/>
+            </a:solidFill>
+          </a:ln>
+        </p:spPr>
+        <p:style>
+          <a:lnRef idx="2">
+            <a:schemeClr val="accent1"/>
+          </a:lnRef>
+          <a:fillRef idx="0">
+            <a:schemeClr val="accent1"/>
+          </a:fillRef>
+          <a:effectRef idx="1">
+            <a:schemeClr val="accent1"/>
+          </a:effectRef>
+          <a:fontRef idx="minor">
+            <a:schemeClr val="tx1"/>
+          </a:fontRef>
+        </p:style>
+      </p:cxnSp>
+      <p:cxnSp>
+        <p:nvCxnSpPr>
+          <p:cNvPr id="29" name="Connector 28"/>
+          <p:cNvCxnSpPr/>
+          <p:nvPr/>
+        </p:nvCxnSpPr>
+        <p:spPr>
+          <a:xfrm flipV="1">
+            <a:off x="5257800.0" y="1383030.0"/>
+            <a:ext cx="45720.0" cy="45720.0"/>
+          </a:xfrm>
+          <a:prstGeom prst="line">
+            <a:avLst/>
+          </a:prstGeom>
+          <a:ln w="25400">
+            <a:solidFill>
+              <a:srgbClr val="00C8FF"/>
+            </a:solidFill>
+          </a:ln>
+        </p:spPr>
+        <p:style>
+          <a:lnRef idx="2">
+            <a:schemeClr val="accent1"/>
+          </a:lnRef>
+          <a:fillRef idx="0">
+            <a:schemeClr val="accent1"/>
+          </a:fillRef>
+          <a:effectRef idx="1">
+            <a:schemeClr val="accent1"/>
+          </a:effectRef>
+          <a:fontRef idx="minor">
+            <a:schemeClr val="tx1"/>
+          </a:fontRef>
+        </p:style>
+      </p:cxnSp>
+      <p:cxnSp>
+        <p:nvCxnSpPr>
+          <p:cNvPr id="30" name="Connector 29"/>
+          <p:cNvCxnSpPr/>
+          <p:nvPr/>
+        </p:nvCxnSpPr>
+        <p:spPr>
+          <a:xfrm flipV="1">
+            <a:off x="5303520.0" y="1337310.0"/>
+            <a:ext cx="45720.0" cy="45720.0"/>
+          </a:xfrm>
+          <a:prstGeom prst="line">
+            <a:avLst/>
+          </a:prstGeom>
+          <a:ln w="25400">
+            <a:solidFill>
+              <a:srgbClr val="00C8FF"/>
+            </a:solidFill>
+          </a:ln>
+        </p:spPr>
+        <p:style>
+          <a:lnRef idx="2">
+            <a:schemeClr val="accent1"/>
+          </a:lnRef>
+          <a:fillRef idx="0">
+            <a:schemeClr val="accent1"/>
+          </a:fillRef>
+          <a:effectRef idx="1">
+            <a:schemeClr val="accent1"/>
+          </a:effectRef>
+          <a:fontRef idx="minor">
+            <a:schemeClr val="tx1"/>
+          </a:fontRef>
+        </p:style>
+      </p:cxnSp>
+      <p:cxnSp>
+        <p:nvCxnSpPr>
+          <p:cNvPr id="31" name="Connector 30"/>
+          <p:cNvCxnSpPr/>
+          <p:nvPr/>
+        </p:nvCxnSpPr>
+        <p:spPr>
+          <a:xfrm flipV="1">
+            <a:off x="5349240.0" y="1291590.0"/>
+            <a:ext cx="45720.0" cy="45720.0"/>
+          </a:xfrm>
+          <a:prstGeom prst="line">
+            <a:avLst/>
+          </a:prstGeom>
+          <a:ln w="25400">
+            <a:solidFill>
+              <a:srgbClr val="00C8FF"/>
+            </a:solidFill>
+          </a:ln>
+        </p:spPr>
+        <p:style>
+          <a:lnRef idx="2">
+            <a:schemeClr val="accent1"/>
+          </a:lnRef>
+          <a:fillRef idx="0">
+            <a:schemeClr val="accent1"/>
+          </a:fillRef>
+          <a:effectRef idx="1">
+            <a:schemeClr val="accent1"/>
+          </a:effectRef>
+          <a:fontRef idx="minor">
+            <a:schemeClr val="tx1"/>
+          </a:fontRef>
+        </p:style>
+      </p:cxnSp>
+      <p:cxnSp>
+        <p:nvCxnSpPr>
+          <p:cNvPr id="32" name="Connector 31"/>
+          <p:cNvCxnSpPr/>
+          <p:nvPr/>
+        </p:nvCxnSpPr>
+        <p:spPr>
+          <a:xfrm flipV="1">
+            <a:off x="5394960.0" y="1245870.0"/>
+            <a:ext cx="45720.0" cy="45720.0"/>
+          </a:xfrm>
+          <a:prstGeom prst="line">
+            <a:avLst/>
+          </a:prstGeom>
+          <a:ln w="25400">
+            <a:solidFill>
+              <a:srgbClr val="00C8FF"/>
+            </a:solidFill>
+          </a:ln>
+        </p:spPr>
+        <p:style>
+          <a:lnRef idx="2">
+            <a:schemeClr val="accent1"/>
+          </a:lnRef>
+          <a:fillRef idx="0">
+            <a:schemeClr val="accent1"/>
+          </a:fillRef>
+          <a:effectRef idx="1">
+            <a:schemeClr val="accent1"/>
+          </a:effectRef>
+          <a:fontRef idx="minor">
+            <a:schemeClr val="tx1"/>
+          </a:fontRef>
+        </p:style>
+      </p:cxnSp>
+      <p:cxnSp>
+        <p:nvCxnSpPr>
+          <p:cNvPr id="33" name="Connector 32"/>
+          <p:cNvCxnSpPr/>
+          <p:nvPr/>
+        </p:nvCxnSpPr>
+        <p:spPr>
+          <a:xfrm flipV="1">
+            <a:off x="5440680.0" y="1200150.0"/>
+            <a:ext cx="45720.0" cy="45720.0"/>
+          </a:xfrm>
+          <a:prstGeom prst="line">
+            <a:avLst/>
+          </a:prstGeom>
+          <a:ln w="25400">
+            <a:solidFill>
+              <a:srgbClr val="00C8FF"/>
+            </a:solidFill>
+          </a:ln>
+        </p:spPr>
+        <p:style>
+          <a:lnRef idx="2">
+            <a:schemeClr val="accent1"/>
+          </a:lnRef>
+          <a:fillRef idx="0">
+            <a:schemeClr val="accent1"/>
+          </a:fillRef>
+          <a:effectRef idx="1">
+            <a:schemeClr val="accent1"/>
+          </a:effectRef>
+          <a:fontRef idx="minor">
+            <a:schemeClr val="tx1"/>
+          </a:fontRef>
+        </p:style>
+      </p:cxnSp>
+      <p:sp>
+        <p:nvSpPr>
+          <p:cNvPr id="34" name="Oval 33"/>
+          <p:cNvSpPr/>
+          <p:nvPr/>
+        </p:nvSpPr>
+        <p:spPr>
+          <a:xfrm>
+            <a:off x="5676900" y="1619250"/>
+            <a:ext cx="76200" cy="76200"/>
+          </a:xfrm>
+          <a:prstGeom prst="ellipse">
+            <a:avLst/>
+          </a:prstGeom>
+          <a:noFill/>
+          <a:ln>
+            <a:solidFill>
+              <a:srgbClr val="FFFFFF"/>
+            </a:solidFill>
+          </a:ln>
+        </p:spPr>
+        <p:style>
+          <a:lnRef idx="1">
+            <a:schemeClr val="accent1"/>
+          </a:lnRef>
+          <a:fillRef idx="3">
+            <a:schemeClr val="accent1"/>
+          </a:fillRef>
+          <a:effectRef idx="2">
+            <a:schemeClr val="accent1"/>
+          </a:effectRef>
+          <a:fontRef idx="minor">
+            <a:schemeClr val="lt1"/>
+          </a:fontRef>
+        </p:style>
+        <p:txBody>
+          <a:bodyPr rtlCol="0" anchor="ctr"/>
+          <a:lstStyle/>
+          <a:p>
+            <a:pPr algn="ctr"/>
+          </a:p>
+        </p:txBody>
+      </p:sp>
+      <p:sp>
+        <p:nvSpPr>
+          <p:cNvPr id="35" name="Oval 34"/>
+          <p:cNvSpPr/>
+          <p:nvPr/>
+        </p:nvSpPr>
+        <p:spPr>
+          <a:xfrm>
+            <a:off x="4991100" y="2076450"/>
+            <a:ext cx="76200" cy="76200"/>
+          </a:xfrm>
+          <a:prstGeom prst="ellipse">
+            <a:avLst/>
+          </a:prstGeom>
+          <a:noFill/>
+          <a:ln>
+            <a:solidFill>
+              <a:srgbClr val="FFFFFF"/>
+            </a:solidFill>
+          </a:ln>
+        </p:spPr>
+        <p:style>
+          <a:lnRef idx="1">
+            <a:schemeClr val="accent1"/>
+          </a:lnRef>
+          <a:fillRef idx="3">
+            <a:schemeClr val="accent1"/>
+          </a:fillRef>
+          <a:effectRef idx="2">
+            <a:schemeClr val="accent1"/>
+          </a:effectRef>
+          <a:fontRef idx="minor">
+            <a:schemeClr val="lt1"/>
+          </a:fontRef>
+        </p:style>
+        <p:txBody>
+          <a:bodyPr rtlCol="0" anchor="ctr"/>
+          <a:lstStyle/>
+          <a:p>
+            <a:pPr algn="ctr"/>
+          </a:p>
+        </p:txBody>
+      </p:sp>
+      <p:sp>
+        <p:nvSpPr>
+          <p:cNvPr id="36" name="Oval 35"/>
+          <p:cNvSpPr/>
+          <p:nvPr/>
+        </p:nvSpPr>
+        <p:spPr>
+          <a:xfrm>
+            <a:off x="4991100" y="1619250"/>
+            <a:ext cx="76200" cy="76200"/>
+          </a:xfrm>
+          <a:prstGeom prst="ellipse">
+            <a:avLst/>
+          </a:prstGeom>
+          <a:solidFill>
+            <a:srgbClr val="FFFFFF"/>
+          </a:solidFill>
+          <a:ln>
+            <a:solidFill>
+              <a:srgbClr val="FFFFFF"/>
+            </a:solidFill>
+          </a:ln>
+        </p:spPr>
+        <p:style>
+          <a:lnRef idx="1">
+            <a:schemeClr val="accent1"/>
+          </a:lnRef>
+          <a:fillRef idx="3">
+            <a:schemeClr val="accent1"/>
+          </a:fillRef>
+          <a:effectRef idx="2">
+            <a:schemeClr val="accent1"/>
+          </a:effectRef>
+          <a:fontRef idx="minor">
+            <a:schemeClr val="lt1"/>
+          </a:fontRef>
+        </p:style>
+        <p:txBody>
+          <a:bodyPr rtlCol="0" anchor="ctr"/>
+          <a:lstStyle/>
+          <a:p>
+            <a:pPr algn="ctr"/>
+          </a:p>
+        </p:txBody>
+      </p:sp>
+      <p:sp>
+        <p:nvSpPr>
+          <p:cNvPr id="37" name="TextBox 36"/>
+          <p:cNvSpPr txBox="1"/>
+          <p:nvPr/>
+        </p:nvSpPr>
+        <p:spPr>
+          <a:xfrm>
+            <a:off x="4480560" y="2663190"/>
+            <a:ext cx="635000" cy="254000"/>
+          </a:xfrm>
+          <a:prstGeom prst="rect">
+            <a:avLst/>
+          </a:prstGeom>
+          <a:noFill/>
+        </p:spPr>
+        <p:txBody>
+          <a:bodyPr wrap="none">
+            <a:spAutoFit/>
+          </a:bodyPr>
+          <a:lstStyle/>
+          <a:p>
+            <a:pPr>
+              <a:defRPr sz="1200">
+                <a:solidFill>
+                  <a:srgbClr val="FFFFFF"/>
+                </a:solidFill>
+                <a:latin typeface="Inter"/>
+              </a:defRPr>
+            </a:pPr>
+            <a:r>
+              <a:t>O</a:t>
+            </a:r>
+          </a:p>
+        </p:txBody>
+      </p:sp>
+      <p:sp>
+        <p:nvSpPr>
+          <p:cNvPr id="38" name="TextBox 37"/>
+          <p:cNvSpPr txBox="1"/>
+          <p:nvPr/>
+        </p:nvSpPr>
+        <p:spPr>
+          <a:xfrm>
+            <a:off x="6217920" y="2663190"/>
+            <a:ext cx="635000" cy="254000"/>
+          </a:xfrm>
+          <a:prstGeom prst="rect">
+            <a:avLst/>
+          </a:prstGeom>
+          <a:noFill/>
+        </p:spPr>
+        <p:txBody>
+          <a:bodyPr wrap="none">
+            <a:spAutoFit/>
+          </a:bodyPr>
+          <a:lstStyle/>
+          <a:p>
+            <a:pPr>
+              <a:defRPr sz="1200">
+                <a:solidFill>
+                  <a:srgbClr val="FFFFFF"/>
+                </a:solidFill>
+                <a:latin typeface="Inter"/>
+              </a:defRPr>
+            </a:pPr>
+            <a:r>
+              <a:t>x</a:t>
+            </a:r>
+          </a:p>
+        </p:txBody>
+      </p:sp>
+      <p:sp>
+        <p:nvSpPr>
+          <p:cNvPr id="39" name="TextBox 38"/>
+          <p:cNvSpPr txBox="1"/>
+          <p:nvPr/>
+        </p:nvSpPr>
+        <p:spPr>
+          <a:xfrm>
+            <a:off x="4480560" y="1017270"/>
+            <a:ext cx="635000" cy="254000"/>
+          </a:xfrm>
+          <a:prstGeom prst="rect">
+            <a:avLst/>
+          </a:prstGeom>
+          <a:noFill/>
+        </p:spPr>
+        <p:txBody>
+          <a:bodyPr wrap="none">
+            <a:spAutoFit/>
+          </a:bodyPr>
+          <a:lstStyle/>
+          <a:p>
+            <a:pPr>
+              <a:defRPr sz="1200">
+                <a:solidFill>
+                  <a:srgbClr val="FFFFFF"/>
+                </a:solidFill>
+                <a:latin typeface="Inter"/>
+              </a:defRPr>
+            </a:pPr>
+            <a:r>
+              <a:t>y</a:t>
+            </a:r>
+          </a:p>
+        </p:txBody>
+      </p:sp>
+      <p:sp>
+        <p:nvSpPr>
+          <p:cNvPr id="40" name="TextBox 39"/>
+          <p:cNvSpPr txBox="1"/>
+          <p:nvPr/>
+        </p:nvSpPr>
+        <p:spPr>
+          <a:xfrm>
+            <a:off x="5715000" y="2663190"/>
+            <a:ext cx="635000" cy="254000"/>
+          </a:xfrm>
+          <a:prstGeom prst="rect">
+            <a:avLst/>
+          </a:prstGeom>
+          <a:noFill/>
+        </p:spPr>
+        <p:txBody>
+          <a:bodyPr wrap="none">
+            <a:spAutoFit/>
+          </a:bodyPr>
+          <a:lstStyle/>
+          <a:p>
+            <a:pPr>
+              <a:defRPr sz="1200">
+                <a:solidFill>
+                  <a:srgbClr val="FFFFFF"/>
+                </a:solidFill>
+                <a:latin typeface="Inter"/>
+              </a:defRPr>
+            </a:pPr>
+            <a:r>
+              <a:t>a</a:t>
+            </a:r>
+          </a:p>
+        </p:txBody>
+      </p:sp>
+      <p:sp>
+        <p:nvSpPr>
+          <p:cNvPr id="41" name="TextBox 40"/>
+          <p:cNvSpPr txBox="1"/>
+          <p:nvPr/>
+        </p:nvSpPr>
+        <p:spPr>
+          <a:xfrm>
+            <a:off x="4480560" y="1657350"/>
+            <a:ext cx="635000" cy="254000"/>
+          </a:xfrm>
+          <a:prstGeom prst="rect">
+            <a:avLst/>
+          </a:prstGeom>
+          <a:noFill/>
+        </p:spPr>
+        <p:txBody>
+          <a:bodyPr wrap="none">
+            <a:spAutoFit/>
+          </a:bodyPr>
+          <a:lstStyle/>
+          <a:p>
+            <a:pPr>
+              <a:defRPr sz="1200">
+                <a:solidFill>
+                  <a:srgbClr val="FFFFFF"/>
+                </a:solidFill>
+                <a:latin typeface="Inter"/>
+              </a:defRPr>
+            </a:pPr>
+            <a:r>
+              <a:t>L</a:t>
+            </a:r>
+          </a:p>
+        </p:txBody>
+      </p:sp>
+      <p:sp>
+        <p:nvSpPr>
+          <p:cNvPr id="42" name="TextBox 41"/>
+          <p:cNvSpPr txBox="1"/>
+          <p:nvPr/>
+        </p:nvSpPr>
+        <p:spPr>
+          <a:xfrm>
+            <a:off x="5806440" y="1565910"/>
+            <a:ext cx="635000" cy="254000"/>
+          </a:xfrm>
+          <a:prstGeom prst="rect">
+            <a:avLst/>
+          </a:prstGeom>
+          <a:noFill/>
+        </p:spPr>
+        <p:txBody>
+          <a:bodyPr wrap="none">
+            <a:spAutoFit/>
+          </a:bodyPr>
+          <a:lstStyle/>
+          <a:p>
+            <a:pPr>
+              <a:defRPr sz="1200">
+                <a:solidFill>
+                  <a:srgbClr val="FFFFFF"/>
+                </a:solidFill>
+                <a:latin typeface="Inter"/>
+              </a:defRPr>
+            </a:pPr>
+            <a:r>
+              <a:t>y=f(x)</a:t>
+            </a:r>
+          </a:p>
+        </p:txBody>
+      </p:sp>
+      <p:sp>
+        <p:nvSpPr>
+          <p:cNvPr id="43" name="TextBox 42"/>
+          <p:cNvSpPr txBox="1"/>
+          <p:nvPr/>
+        </p:nvSpPr>
+        <p:spPr>
+          <a:xfrm>
+            <a:off x="4572000" y="2571750"/>
+            <a:ext cx="635000" cy="254000"/>
+          </a:xfrm>
+          <a:prstGeom prst="rect">
+            <a:avLst/>
+          </a:prstGeom>
+          <a:noFill/>
+        </p:spPr>
+        <p:txBody>
+          <a:bodyPr wrap="none">
+            <a:spAutoFit/>
+          </a:bodyPr>
+          <a:lstStyle/>
+          <a:p>
+            <a:pPr>
+              <a:defRPr sz="1200">
+                <a:solidFill>
+                  <a:srgbClr val="FFFFFF"/>
+                </a:solidFill>
+                <a:latin typeface="Inter"/>
+              </a:defRPr>
+            </a:pPr>
+          </a:p>
+        </p:txBody>
+      </p:sp>
+      <p:sp>
+        <p:nvSpPr>
+          <p:cNvPr id="44" name="TextBox 43"/>
+          <p:cNvSpPr txBox="1"/>
+          <p:nvPr/>
+        </p:nvSpPr>
+        <p:spPr>
+          <a:xfrm>
+            <a:off x="4572000" y="2571750"/>
+            <a:ext cx="635000" cy="254000"/>
+          </a:xfrm>
+          <a:prstGeom prst="rect">
+            <a:avLst/>
+          </a:prstGeom>
+          <a:noFill/>
+        </p:spPr>
+        <p:txBody>
+          <a:bodyPr wrap="none">
+            <a:spAutoFit/>
+          </a:bodyPr>
+          <a:lstStyle/>
+          <a:p>
+            <a:pPr>
+              <a:defRPr sz="1200">
+                <a:solidFill>
+                  <a:srgbClr val="FFFFFF"/>
+                </a:solidFill>
+                <a:latin typeface="Inter"/>
+              </a:defRPr>
+            </a:pPr>
+          </a:p>
+        </p:txBody>
+      </p:sp>
+      <p:sp>
+        <p:nvSpPr>
+          <p:cNvPr id="45" name="TextBox 44"/>
+          <p:cNvSpPr txBox="1"/>
+          <p:nvPr/>
+        </p:nvSpPr>
+        <p:spPr>
+          <a:xfrm>
+            <a:off x="4572000" y="2571750"/>
+            <a:ext cx="635000" cy="254000"/>
+          </a:xfrm>
+          <a:prstGeom prst="rect">
+            <a:avLst/>
+          </a:prstGeom>
+          <a:noFill/>
+        </p:spPr>
+        <p:txBody>
+          <a:bodyPr wrap="none">
+            <a:spAutoFit/>
+          </a:bodyPr>
+          <a:lstStyle/>
+          <a:p>
+            <a:pPr>
+              <a:defRPr sz="1200">
+                <a:solidFill>
+                  <a:srgbClr val="FFFFFF"/>
+                </a:solidFill>
+                <a:latin typeface="Inter"/>
+              </a:defRPr>
+            </a:pPr>
+          </a:p>
+        </p:txBody>
+      </p:sp>
+      <p:sp>
+        <p:nvSpPr>
+          <p:cNvPr id="46" name="TextBox 45"/>
+          <p:cNvSpPr txBox="1"/>
+          <p:nvPr/>
+        </p:nvSpPr>
+        <p:spPr>
+          <a:xfrm>
+            <a:off x="4572000" y="2571750"/>
+            <a:ext cx="635000" cy="254000"/>
+          </a:xfrm>
+          <a:prstGeom prst="rect">
+            <a:avLst/>
+          </a:prstGeom>
+          <a:noFill/>
+        </p:spPr>
+        <p:txBody>
+          <a:bodyPr wrap="none">
+            <a:spAutoFit/>
+          </a:bodyPr>
+          <a:lstStyle/>
+          <a:p>
+            <a:pPr>
+              <a:defRPr sz="1200">
+                <a:solidFill>
+                  <a:srgbClr val="FFFFFF"/>
+                </a:solidFill>
+                <a:latin typeface="Inter"/>
+              </a:defRPr>
+            </a:pPr>
+          </a:p>
+        </p:txBody>
+      </p:sp>
+      <p:sp>
+        <p:nvSpPr>
+          <p:cNvPr id="47" name="TextBox 46"/>
+          <p:cNvSpPr txBox="1"/>
+          <p:nvPr/>
+        </p:nvSpPr>
+        <p:spPr>
+          <a:xfrm>
+            <a:off x="4572000" y="2571750"/>
+            <a:ext cx="635000" cy="254000"/>
+          </a:xfrm>
+          <a:prstGeom prst="rect">
+            <a:avLst/>
+          </a:prstGeom>
+          <a:noFill/>
+        </p:spPr>
+        <p:txBody>
+          <a:bodyPr wrap="none">
+            <a:spAutoFit/>
+          </a:bodyPr>
+          <a:lstStyle/>
+          <a:p>
+            <a:pPr>
+              <a:defRPr sz="1200">
+                <a:solidFill>
+                  <a:srgbClr val="FFFFFF"/>
+                </a:solidFill>
+                <a:latin typeface="Inter"/>
+              </a:defRPr>
+            </a:pPr>
+          </a:p>
+        </p:txBody>
+      </p:sp>
+      <p:sp>
+        <p:nvSpPr>
+          <p:cNvPr id="48" name="TextBox 47"/>
+          <p:cNvSpPr txBox="1"/>
+          <p:nvPr/>
+        </p:nvSpPr>
+        <p:spPr>
+          <a:xfrm>
+            <a:off x="4572000" y="2571750"/>
+            <a:ext cx="635000" cy="254000"/>
+          </a:xfrm>
+          <a:prstGeom prst="rect">
+            <a:avLst/>
+          </a:prstGeom>
+          <a:noFill/>
+        </p:spPr>
+        <p:txBody>
+          <a:bodyPr wrap="none">
+            <a:spAutoFit/>
+          </a:bodyPr>
+          <a:lstStyle/>
+          <a:p>
+            <a:pPr>
+              <a:defRPr sz="1200">
+                <a:solidFill>
+                  <a:srgbClr val="FFFFFF"/>
+                </a:solidFill>
+                <a:latin typeface="Inter"/>
+              </a:defRPr>
+            </a:pPr>
+          </a:p>
+        </p:txBody>
+      </p:sp>
+      <p:sp>
+        <p:nvSpPr>
+          <p:cNvPr id="49" name="TextBox 48"/>
+          <p:cNvSpPr txBox="1"/>
+          <p:nvPr/>
+        </p:nvSpPr>
+        <p:spPr>
+          <a:xfrm>
+            <a:off x="5029200" y="2663190"/>
+            <a:ext cx="635000" cy="254000"/>
+          </a:xfrm>
+          <a:prstGeom prst="rect">
+            <a:avLst/>
+          </a:prstGeom>
+          <a:noFill/>
+        </p:spPr>
+        <p:txBody>
+          <a:bodyPr wrap="none">
+            <a:spAutoFit/>
+          </a:bodyPr>
+          <a:lstStyle/>
+          <a:p>
+            <a:pPr>
+              <a:defRPr sz="1200">
+                <a:solidFill>
+                  <a:srgbClr val="FFFFFF"/>
+                </a:solidFill>
+                <a:latin typeface="Inter"/>
+              </a:defRPr>
+            </a:pPr>
+            <a:r>
+              <a:t>1</a:t>
+            </a:r>
+          </a:p>
+        </p:txBody>
+      </p:sp>
+      <p:sp>
+        <p:nvSpPr>
+          <p:cNvPr id="50" name="TextBox 49"/>
+          <p:cNvSpPr txBox="1"/>
+          <p:nvPr/>
+        </p:nvSpPr>
+        <p:spPr>
+          <a:xfrm>
+            <a:off x="4480560" y="2114550"/>
+            <a:ext cx="635000" cy="254000"/>
+          </a:xfrm>
+          <a:prstGeom prst="rect">
+            <a:avLst/>
+          </a:prstGeom>
+          <a:noFill/>
+        </p:spPr>
+        <p:txBody>
+          <a:bodyPr wrap="none">
+            <a:spAutoFit/>
+          </a:bodyPr>
+          <a:lstStyle/>
+          <a:p>
+            <a:pPr>
+              <a:defRPr sz="1200">
+                <a:solidFill>
+                  <a:srgbClr val="FFFFFF"/>
+                </a:solidFill>
+                <a:latin typeface="Inter"/>
+              </a:defRPr>
+            </a:pPr>
+            <a:r>
+              <a:t>1</a:t>
+            </a:r>
+          </a:p>
+        </p:txBody>
+      </p:sp>
+      <p:sp>
+        <p:nvSpPr>
+          <p:cNvPr id="51" name="TextBox 50"/>
+          <p:cNvSpPr txBox="1"/>
+          <p:nvPr/>
+        </p:nvSpPr>
+        <p:spPr>
+          <a:xfrm>
+            <a:off x="4480560" y="1657350"/>
+            <a:ext cx="635000" cy="254000"/>
+          </a:xfrm>
+          <a:prstGeom prst="rect">
+            <a:avLst/>
+          </a:prstGeom>
+          <a:noFill/>
+        </p:spPr>
+        <p:txBody>
+          <a:bodyPr wrap="none">
+            <a:spAutoFit/>
+          </a:bodyPr>
+          <a:lstStyle/>
+          <a:p>
+            <a:pPr>
+              <a:defRPr sz="1200">
+                <a:solidFill>
+                  <a:srgbClr val="FFFFFF"/>
+                </a:solidFill>
+                <a:latin typeface="Inter"/>
+              </a:defRPr>
+            </a:pPr>
+            <a:r>
+              <a:t>2</a:t>
+            </a:r>
+          </a:p>
+        </p:txBody>
+      </p:sp>
+      <p:sp>
+        <p:nvSpPr>
+          <p:cNvPr id="52" name="TextBox 51"/>
+          <p:cNvSpPr txBox="1"/>
+          <p:nvPr/>
+        </p:nvSpPr>
+        <p:spPr>
+          <a:xfrm>
+            <a:off x="5394960" y="1291590"/>
+            <a:ext cx="635000" cy="254000"/>
+          </a:xfrm>
+          <a:prstGeom prst="rect">
+            <a:avLst/>
+          </a:prstGeom>
+          <a:noFill/>
+        </p:spPr>
+        <p:txBody>
+          <a:bodyPr wrap="none">
+            <a:spAutoFit/>
+          </a:bodyPr>
+          <a:lstStyle/>
+          <a:p>
+            <a:pPr>
+              <a:defRPr sz="1200">
+                <a:solidFill>
+                  <a:srgbClr val="FFFFFF"/>
+                </a:solidFill>
+                <a:latin typeface="Inter"/>
+              </a:defRPr>
+            </a:pPr>
+            <a:r>
+              <a:t>y=f(x)</a:t>
+            </a:r>
+          </a:p>
+        </p:txBody>
+      </p:sp>
+      <p:sp>
+        <p:nvSpPr>
+          <p:cNvPr id="53" name="TextBox 52"/>
+          <p:cNvSpPr txBox="1"/>
+          <p:nvPr/>
+        </p:nvSpPr>
+        <p:spPr>
+          <a:xfrm>
+            <a:off x="4572000" y="2571750"/>
+            <a:ext cx="635000" cy="254000"/>
+          </a:xfrm>
+          <a:prstGeom prst="rect">
+            <a:avLst/>
+          </a:prstGeom>
+          <a:noFill/>
+        </p:spPr>
+        <p:txBody>
+          <a:bodyPr wrap="none">
+            <a:spAutoFit/>
+          </a:bodyPr>
+          <a:lstStyle/>
+          <a:p>
+            <a:pPr>
+              <a:defRPr sz="1200">
+                <a:solidFill>
+                  <a:srgbClr val="FFFFFF"/>
+                </a:solidFill>
+                <a:latin typeface="Inter"/>
+              </a:defRPr>
+            </a:pPr>
+          </a:p>
+        </p:txBody>
+      </p:sp>
+      <p:sp>
+        <p:nvSpPr>
+          <p:cNvPr id="54" name="TextBox 53"/>
+          <p:cNvSpPr txBox="1"/>
+          <p:nvPr/>
+        </p:nvSpPr>
+        <p:spPr>
+          <a:xfrm>
+            <a:off x="4572000" y="2571750"/>
+            <a:ext cx="635000" cy="254000"/>
+          </a:xfrm>
+          <a:prstGeom prst="rect">
+            <a:avLst/>
+          </a:prstGeom>
+          <a:noFill/>
+        </p:spPr>
+        <p:txBody>
+          <a:bodyPr wrap="none">
+            <a:spAutoFit/>
+          </a:bodyPr>
+          <a:lstStyle/>
+          <a:p>
+            <a:pPr>
+              <a:defRPr sz="1200">
+                <a:solidFill>
+                  <a:srgbClr val="FFFFFF"/>
+                </a:solidFill>
+                <a:latin typeface="Inter"/>
+              </a:defRPr>
+            </a:pPr>
+          </a:p>
+        </p:txBody>
+      </p:sp>
+      <p:sp>
+        <p:nvSpPr>
+          <p:cNvPr id="55" name="TextBox 54"/>
+          <p:cNvSpPr txBox="1"/>
+          <p:nvPr/>
+        </p:nvSpPr>
+        <p:spPr>
+          <a:xfrm>
+            <a:off x="4572000" y="2571750"/>
+            <a:ext cx="635000" cy="254000"/>
+          </a:xfrm>
+          <a:prstGeom prst="rect">
+            <a:avLst/>
+          </a:prstGeom>
+          <a:noFill/>
+        </p:spPr>
+        <p:txBody>
+          <a:bodyPr wrap="none">
+            <a:spAutoFit/>
+          </a:bodyPr>
+          <a:lstStyle/>
+          <a:p>
+            <a:pPr>
+              <a:defRPr sz="1200">
+                <a:solidFill>
+                  <a:srgbClr val="FFFFFF"/>
+                </a:solidFill>
+                <a:latin typeface="Inter"/>
+              </a:defRPr>
+            </a:pPr>
+          </a:p>
+        </p:txBody>
+      </p:sp>
+      <p:sp>
+        <p:nvSpPr>
+          <p:cNvPr id="56" name="TextBox 55"/>
+          <p:cNvSpPr txBox="1"/>
+          <p:nvPr/>
+        </p:nvSpPr>
+        <p:spPr>
+          <a:xfrm>
+            <a:off x="4572000" y="2571750"/>
+            <a:ext cx="635000" cy="254000"/>
+          </a:xfrm>
+          <a:prstGeom prst="rect">
+            <a:avLst/>
+          </a:prstGeom>
+          <a:noFill/>
+        </p:spPr>
+        <p:txBody>
+          <a:bodyPr wrap="none">
+            <a:spAutoFit/>
+          </a:bodyPr>
+          <a:lstStyle/>
+          <a:p>
+            <a:pPr>
+              <a:defRPr sz="1200">
+                <a:solidFill>
+                  <a:srgbClr val="FFFFFF"/>
+                </a:solidFill>
+                <a:latin typeface="Inter"/>
+              </a:defRPr>
+            </a:pPr>
+          </a:p>
+        </p:txBody>
+      </p:sp>
+      <p:sp>
+        <p:nvSpPr>
+          <p:cNvPr id="57" name="TextBox 56"/>
+          <p:cNvSpPr txBox="1"/>
+          <p:nvPr/>
+        </p:nvSpPr>
+        <p:spPr>
+          <a:xfrm>
+            <a:off x="4572000" y="2571750"/>
+            <a:ext cx="635000" cy="254000"/>
+          </a:xfrm>
+          <a:prstGeom prst="rect">
+            <a:avLst/>
+          </a:prstGeom>
+          <a:noFill/>
+        </p:spPr>
+        <p:txBody>
+          <a:bodyPr wrap="none">
+            <a:spAutoFit/>
+          </a:bodyPr>
+          <a:lstStyle/>
+          <a:p>
+            <a:pPr>
+              <a:defRPr sz="1200">
+                <a:solidFill>
+                  <a:srgbClr val="FFFFFF"/>
+                </a:solidFill>
+                <a:latin typeface="Inter"/>
+              </a:defRPr>
+            </a:pPr>
+          </a:p>
+        </p:txBody>
+      </p:sp>
     </p:spTree>
   </p:cSld>
   <p:clrMapOvr>

</xml_diff>

<commit_message>
feat: upgrade graph rendering engine with textbook style
</commit_message>
<xml_diff>
--- a/output/1.pptx
+++ b/output/1.pptx
@@ -3104,8 +3104,8 @@
         </p:nvCxnSpPr>
         <p:spPr>
           <a:xfrm>
-            <a:off x="4343400.0" y="2571750.0"/>
-            <a:ext cx="1920240.0" cy="0.0"/>
+            <a:off x="2286000.0" y="2571750.0"/>
+            <a:ext cx="4572000.0" cy="0.0"/>
           </a:xfrm>
           <a:prstGeom prst="line">
             <a:avLst/>
@@ -3139,8 +3139,8 @@
         </p:nvCxnSpPr>
         <p:spPr>
           <a:xfrm flipV="1">
-            <a:off x="4572000.0" y="971550.0"/>
-            <a:ext cx="0.0" cy="1828800.0"/>
+            <a:off x="4572000.0" y="285750.0"/>
+            <a:ext cx="0.0" cy="4572000.0"/>
           </a:xfrm>
           <a:prstGeom prst="line">
             <a:avLst/>
@@ -3174,8 +3174,8 @@
         </p:nvCxnSpPr>
         <p:spPr>
           <a:xfrm flipV="1">
-            <a:off x="4572000.0" y="2526030.0"/>
-            <a:ext cx="228600.0" cy="45720.0"/>
+            <a:off x="4572000.0" y="2375656.92"/>
+            <a:ext cx="42062.40000000037" cy="196093.08000000007"/>
           </a:xfrm>
           <a:prstGeom prst="line">
             <a:avLst/>
@@ -3209,8 +3209,8 @@
         </p:nvCxnSpPr>
         <p:spPr>
           <a:xfrm flipV="1">
-            <a:off x="4800600.0" y="2434590.0"/>
-            <a:ext cx="228600.0" cy="91440.0"/>
+            <a:off x="4614062.4" y="2294412.48"/>
+            <a:ext cx="42062.39999999944" cy="81244.43999999994"/>
           </a:xfrm>
           <a:prstGeom prst="line">
             <a:avLst/>
@@ -3244,8 +3244,8 @@
         </p:nvCxnSpPr>
         <p:spPr>
           <a:xfrm flipV="1">
-            <a:off x="5029200.0" y="2297430.0"/>
-            <a:ext cx="228600.0" cy="137160.0"/>
+            <a:off x="4656124.8" y="2232141.84"/>
+            <a:ext cx="42062.40000000037" cy="62270.64000000013"/>
           </a:xfrm>
           <a:prstGeom prst="line">
             <a:avLst/>
@@ -3279,8 +3279,8 @@
         </p:nvCxnSpPr>
         <p:spPr>
           <a:xfrm flipV="1">
-            <a:off x="5257800.0" y="2114550.0"/>
-            <a:ext cx="228600.0" cy="182880.0"/>
+            <a:off x="4698187.2" y="2180432.52"/>
+            <a:ext cx="42062.39999999944" cy="51709.31999999983"/>
           </a:xfrm>
           <a:prstGeom prst="line">
             <a:avLst/>
@@ -3314,8 +3314,8 @@
         </p:nvCxnSpPr>
         <p:spPr>
           <a:xfrm flipV="1">
-            <a:off x="5486400.0" y="1977390.0"/>
-            <a:ext cx="91440.0" cy="137160.0"/>
+            <a:off x="4740249.6" y="2135306.88"/>
+            <a:ext cx="42062.40000000037" cy="45125.64000000013"/>
           </a:xfrm>
           <a:prstGeom prst="line">
             <a:avLst/>
@@ -3349,8 +3349,8 @@
         </p:nvCxnSpPr>
         <p:spPr>
           <a:xfrm flipV="1">
-            <a:off x="5577840.0" y="1885950.0"/>
-            <a:ext cx="45720.0" cy="91440.0"/>
+            <a:off x="4782312.0" y="2095073.28"/>
+            <a:ext cx="42062.40000000037" cy="40233.59999999986"/>
           </a:xfrm>
           <a:prstGeom prst="line">
             <a:avLst/>
@@ -3384,8 +3384,8 @@
         </p:nvCxnSpPr>
         <p:spPr>
           <a:xfrm flipV="1">
-            <a:off x="5623560.0" y="1794510.0"/>
-            <a:ext cx="45720.0" cy="91440.0"/>
+            <a:off x="4824374.4" y="2058863.04"/>
+            <a:ext cx="42062.39999999944" cy="36210.23999999999"/>
           </a:xfrm>
           <a:prstGeom prst="line">
             <a:avLst/>
@@ -3419,8 +3419,8 @@
         </p:nvCxnSpPr>
         <p:spPr>
           <a:xfrm flipV="1">
-            <a:off x="5669280.0" y="1748790.0"/>
-            <a:ext cx="22860.0" cy="45720.0"/>
+            <a:off x="4866436.8" y="2025853.2000000002"/>
+            <a:ext cx="42062.40000000037" cy="33009.83999999985"/>
           </a:xfrm>
           <a:prstGeom prst="line">
             <a:avLst/>
@@ -3454,8 +3454,8 @@
         </p:nvCxnSpPr>
         <p:spPr>
           <a:xfrm flipV="1">
-            <a:off x="5692140.0" y="1611630.0"/>
-            <a:ext cx="45720.0" cy="137160.0"/>
+            <a:off x="4908499.2" y="1995495.12"/>
+            <a:ext cx="42062.39999999944" cy="30358.080000000075"/>
           </a:xfrm>
           <a:prstGeom prst="line">
             <a:avLst/>
@@ -3489,8 +3489,8 @@
         </p:nvCxnSpPr>
         <p:spPr>
           <a:xfrm flipV="1">
-            <a:off x="5737860.0" y="1520190.0"/>
-            <a:ext cx="45720.0" cy="91440.0"/>
+            <a:off x="4950561.6" y="1967514.48"/>
+            <a:ext cx="42062.40000000037" cy="27980.64000000013"/>
           </a:xfrm>
           <a:prstGeom prst="line">
             <a:avLst/>
@@ -3524,8 +3524,8 @@
         </p:nvCxnSpPr>
         <p:spPr>
           <a:xfrm flipV="1">
-            <a:off x="5783580.0" y="1428750.0"/>
-            <a:ext cx="45720.0" cy="91440.0"/>
+            <a:off x="4992624.0" y="1941591.24"/>
+            <a:ext cx="42062.40000000037" cy="25923.23999999999"/>
           </a:xfrm>
           <a:prstGeom prst="line">
             <a:avLst/>
@@ -3558,9 +3558,9 @@
           <p:nvPr/>
         </p:nvCxnSpPr>
         <p:spPr>
-          <a:xfrm>
-            <a:off x="4572000.0" y="1657350.0"/>
-            <a:ext cx="45720.0" cy="45720.0"/>
+          <a:xfrm flipV="1">
+            <a:off x="5034686.4" y="1917496.7999999998"/>
+            <a:ext cx="42062.39999999944" cy="24094.440000000177"/>
           </a:xfrm>
           <a:prstGeom prst="line">
             <a:avLst/>
@@ -3593,9 +3593,9 @@
           <p:nvPr/>
         </p:nvCxnSpPr>
         <p:spPr>
-          <a:xfrm>
-            <a:off x="4617720.0" y="1703070.0"/>
-            <a:ext cx="45720.0" cy="45720.0"/>
+          <a:xfrm flipV="1">
+            <a:off x="5076748.8" y="1894956.8399999999"/>
+            <a:ext cx="42062.40000000037" cy="22539.959999999963"/>
           </a:xfrm>
           <a:prstGeom prst="line">
             <a:avLst/>
@@ -3628,9 +3628,9 @@
           <p:nvPr/>
         </p:nvCxnSpPr>
         <p:spPr>
-          <a:xfrm>
-            <a:off x="4663440.0" y="1748790.0"/>
-            <a:ext cx="45720.0" cy="45720.0"/>
+          <a:xfrm flipV="1">
+            <a:off x="5118811.2" y="1873834.2000000002"/>
+            <a:ext cx="42062.39999999944" cy="21122.639999999665"/>
           </a:xfrm>
           <a:prstGeom prst="line">
             <a:avLst/>
@@ -3663,9 +3663,9 @@
           <p:nvPr/>
         </p:nvCxnSpPr>
         <p:spPr>
-          <a:xfrm>
-            <a:off x="4709160.0" y="1794510.0"/>
-            <a:ext cx="45720.0" cy="45720.0"/>
+          <a:xfrm flipV="1">
+            <a:off x="5160873.6" y="1853946.0"/>
+            <a:ext cx="42062.40000000037" cy="19888.200000000186"/>
           </a:xfrm>
           <a:prstGeom prst="line">
             <a:avLst/>
@@ -3698,9 +3698,9 @@
           <p:nvPr/>
         </p:nvCxnSpPr>
         <p:spPr>
-          <a:xfrm>
-            <a:off x="4754880.0" y="1840230.0"/>
-            <a:ext cx="45720.0" cy="45720.0"/>
+          <a:xfrm flipV="1">
+            <a:off x="5202936.0" y="1835155.08"/>
+            <a:ext cx="42062.40000000037" cy="18790.919999999925"/>
           </a:xfrm>
           <a:prstGeom prst="line">
             <a:avLst/>
@@ -3733,9 +3733,9 @@
           <p:nvPr/>
         </p:nvCxnSpPr>
         <p:spPr>
-          <a:xfrm>
-            <a:off x="4800600.0" y="1885950.0"/>
-            <a:ext cx="45720.0" cy="45720.0"/>
+          <a:xfrm flipV="1">
+            <a:off x="5244998.4" y="1817324.28"/>
+            <a:ext cx="42062.39999999944" cy="17830.800000000047"/>
           </a:xfrm>
           <a:prstGeom prst="line">
             <a:avLst/>
@@ -3768,9 +3768,9 @@
           <p:nvPr/>
         </p:nvCxnSpPr>
         <p:spPr>
-          <a:xfrm>
-            <a:off x="4846320.0" y="1931670.0"/>
-            <a:ext cx="45720.0" cy="45720.0"/>
+          <a:xfrm flipV="1">
+            <a:off x="5287060.8" y="1800362.1600000001"/>
+            <a:ext cx="42062.40000000037" cy="16962.11999999988"/>
           </a:xfrm>
           <a:prstGeom prst="line">
             <a:avLst/>
@@ -3803,9 +3803,9 @@
           <p:nvPr/>
         </p:nvCxnSpPr>
         <p:spPr>
-          <a:xfrm>
-            <a:off x="4892040.0" y="1977390.0"/>
-            <a:ext cx="45720.0" cy="45720.0"/>
+          <a:xfrm flipV="1">
+            <a:off x="5329123.2" y="1784223.0"/>
+            <a:ext cx="42062.39999999944" cy="16139.160000000149"/>
           </a:xfrm>
           <a:prstGeom prst="line">
             <a:avLst/>
@@ -3838,9 +3838,9 @@
           <p:nvPr/>
         </p:nvCxnSpPr>
         <p:spPr>
-          <a:xfrm>
-            <a:off x="4937760.0" y="2023110.0"/>
-            <a:ext cx="45720.0" cy="45720.0"/>
+          <a:xfrm flipV="1">
+            <a:off x="5371185.6" y="1768769.6400000001"/>
+            <a:ext cx="42062.40000000037" cy="15453.35999999987"/>
           </a:xfrm>
           <a:prstGeom prst="line">
             <a:avLst/>
@@ -3874,8 +3874,8 @@
         </p:nvCxnSpPr>
         <p:spPr>
           <a:xfrm flipV="1">
-            <a:off x="5029200.0" y="1611630.0"/>
-            <a:ext cx="45720.0" cy="45720.0"/>
+            <a:off x="5413248.0" y="1754047.8"/>
+            <a:ext cx="42062.40000000037" cy="14721.840000000084"/>
           </a:xfrm>
           <a:prstGeom prst="line">
             <a:avLst/>
@@ -3909,8 +3909,8 @@
         </p:nvCxnSpPr>
         <p:spPr>
           <a:xfrm flipV="1">
-            <a:off x="5074920.0" y="1565910.0"/>
-            <a:ext cx="45720.0" cy="45720.0"/>
+            <a:off x="5455310.4" y="1739920.32"/>
+            <a:ext cx="42062.39999999944" cy="14127.479999999981"/>
           </a:xfrm>
           <a:prstGeom prst="line">
             <a:avLst/>
@@ -3944,8 +3944,8 @@
         </p:nvCxnSpPr>
         <p:spPr>
           <a:xfrm flipV="1">
-            <a:off x="5120640.0" y="1520190.0"/>
-            <a:ext cx="45720.0" cy="45720.0"/>
+            <a:off x="5497372.8" y="1726341.48"/>
+            <a:ext cx="42062.40000000037" cy="13578.840000000084"/>
           </a:xfrm>
           <a:prstGeom prst="line">
             <a:avLst/>
@@ -3979,8 +3979,8 @@
         </p:nvCxnSpPr>
         <p:spPr>
           <a:xfrm flipV="1">
-            <a:off x="5166360.0" y="1474470.0"/>
-            <a:ext cx="45720.0" cy="45720.0"/>
+            <a:off x="5539435.2" y="1713311.28"/>
+            <a:ext cx="42062.39999999944" cy="13030.199999999953"/>
           </a:xfrm>
           <a:prstGeom prst="line">
             <a:avLst/>
@@ -4014,8 +4014,8 @@
         </p:nvCxnSpPr>
         <p:spPr>
           <a:xfrm flipV="1">
-            <a:off x="5212080.0" y="1428750.0"/>
-            <a:ext cx="45720.0" cy="45720.0"/>
+            <a:off x="5581497.6" y="1700784.0"/>
+            <a:ext cx="42062.40000000037" cy="12527.280000000028"/>
           </a:xfrm>
           <a:prstGeom prst="line">
             <a:avLst/>
@@ -4041,190 +4041,15 @@
           </a:fontRef>
         </p:style>
       </p:cxnSp>
-      <p:cxnSp>
-        <p:nvCxnSpPr>
-          <p:cNvPr id="29" name="Connector 28"/>
-          <p:cNvCxnSpPr/>
-          <p:nvPr/>
-        </p:nvCxnSpPr>
-        <p:spPr>
-          <a:xfrm flipV="1">
-            <a:off x="5257800.0" y="1383030.0"/>
-            <a:ext cx="45720.0" cy="45720.0"/>
-          </a:xfrm>
-          <a:prstGeom prst="line">
-            <a:avLst/>
-          </a:prstGeom>
-          <a:ln w="25400">
-            <a:solidFill>
-              <a:srgbClr val="00C8FF"/>
-            </a:solidFill>
-          </a:ln>
-        </p:spPr>
-        <p:style>
-          <a:lnRef idx="2">
-            <a:schemeClr val="accent1"/>
-          </a:lnRef>
-          <a:fillRef idx="0">
-            <a:schemeClr val="accent1"/>
-          </a:fillRef>
-          <a:effectRef idx="1">
-            <a:schemeClr val="accent1"/>
-          </a:effectRef>
-          <a:fontRef idx="minor">
-            <a:schemeClr val="tx1"/>
-          </a:fontRef>
-        </p:style>
-      </p:cxnSp>
-      <p:cxnSp>
-        <p:nvCxnSpPr>
-          <p:cNvPr id="30" name="Connector 29"/>
-          <p:cNvCxnSpPr/>
-          <p:nvPr/>
-        </p:nvCxnSpPr>
-        <p:spPr>
-          <a:xfrm flipV="1">
-            <a:off x="5303520.0" y="1337310.0"/>
-            <a:ext cx="45720.0" cy="45720.0"/>
-          </a:xfrm>
-          <a:prstGeom prst="line">
-            <a:avLst/>
-          </a:prstGeom>
-          <a:ln w="25400">
-            <a:solidFill>
-              <a:srgbClr val="00C8FF"/>
-            </a:solidFill>
-          </a:ln>
-        </p:spPr>
-        <p:style>
-          <a:lnRef idx="2">
-            <a:schemeClr val="accent1"/>
-          </a:lnRef>
-          <a:fillRef idx="0">
-            <a:schemeClr val="accent1"/>
-          </a:fillRef>
-          <a:effectRef idx="1">
-            <a:schemeClr val="accent1"/>
-          </a:effectRef>
-          <a:fontRef idx="minor">
-            <a:schemeClr val="tx1"/>
-          </a:fontRef>
-        </p:style>
-      </p:cxnSp>
-      <p:cxnSp>
-        <p:nvCxnSpPr>
-          <p:cNvPr id="31" name="Connector 30"/>
-          <p:cNvCxnSpPr/>
-          <p:nvPr/>
-        </p:nvCxnSpPr>
-        <p:spPr>
-          <a:xfrm flipV="1">
-            <a:off x="5349240.0" y="1291590.0"/>
-            <a:ext cx="45720.0" cy="45720.0"/>
-          </a:xfrm>
-          <a:prstGeom prst="line">
-            <a:avLst/>
-          </a:prstGeom>
-          <a:ln w="25400">
-            <a:solidFill>
-              <a:srgbClr val="00C8FF"/>
-            </a:solidFill>
-          </a:ln>
-        </p:spPr>
-        <p:style>
-          <a:lnRef idx="2">
-            <a:schemeClr val="accent1"/>
-          </a:lnRef>
-          <a:fillRef idx="0">
-            <a:schemeClr val="accent1"/>
-          </a:fillRef>
-          <a:effectRef idx="1">
-            <a:schemeClr val="accent1"/>
-          </a:effectRef>
-          <a:fontRef idx="minor">
-            <a:schemeClr val="tx1"/>
-          </a:fontRef>
-        </p:style>
-      </p:cxnSp>
-      <p:cxnSp>
-        <p:nvCxnSpPr>
-          <p:cNvPr id="32" name="Connector 31"/>
-          <p:cNvCxnSpPr/>
-          <p:nvPr/>
-        </p:nvCxnSpPr>
-        <p:spPr>
-          <a:xfrm flipV="1">
-            <a:off x="5394960.0" y="1245870.0"/>
-            <a:ext cx="45720.0" cy="45720.0"/>
-          </a:xfrm>
-          <a:prstGeom prst="line">
-            <a:avLst/>
-          </a:prstGeom>
-          <a:ln w="25400">
-            <a:solidFill>
-              <a:srgbClr val="00C8FF"/>
-            </a:solidFill>
-          </a:ln>
-        </p:spPr>
-        <p:style>
-          <a:lnRef idx="2">
-            <a:schemeClr val="accent1"/>
-          </a:lnRef>
-          <a:fillRef idx="0">
-            <a:schemeClr val="accent1"/>
-          </a:fillRef>
-          <a:effectRef idx="1">
-            <a:schemeClr val="accent1"/>
-          </a:effectRef>
-          <a:fontRef idx="minor">
-            <a:schemeClr val="tx1"/>
-          </a:fontRef>
-        </p:style>
-      </p:cxnSp>
-      <p:cxnSp>
-        <p:nvCxnSpPr>
-          <p:cNvPr id="33" name="Connector 32"/>
-          <p:cNvCxnSpPr/>
-          <p:nvPr/>
-        </p:nvCxnSpPr>
-        <p:spPr>
-          <a:xfrm flipV="1">
-            <a:off x="5440680.0" y="1200150.0"/>
-            <a:ext cx="45720.0" cy="45720.0"/>
-          </a:xfrm>
-          <a:prstGeom prst="line">
-            <a:avLst/>
-          </a:prstGeom>
-          <a:ln w="25400">
-            <a:solidFill>
-              <a:srgbClr val="00C8FF"/>
-            </a:solidFill>
-          </a:ln>
-        </p:spPr>
-        <p:style>
-          <a:lnRef idx="2">
-            <a:schemeClr val="accent1"/>
-          </a:lnRef>
-          <a:fillRef idx="0">
-            <a:schemeClr val="accent1"/>
-          </a:fillRef>
-          <a:effectRef idx="1">
-            <a:schemeClr val="accent1"/>
-          </a:effectRef>
-          <a:fontRef idx="minor">
-            <a:schemeClr val="tx1"/>
-          </a:fontRef>
-        </p:style>
-      </p:cxnSp>
-      <p:sp>
-        <p:nvSpPr>
-          <p:cNvPr id="34" name="Oval 33"/>
+      <p:sp>
+        <p:nvSpPr>
+          <p:cNvPr id="29" name="Oval 28"/>
           <p:cNvSpPr/>
           <p:nvPr/>
         </p:nvSpPr>
         <p:spPr>
           <a:xfrm>
-            <a:off x="5676900" y="1619250"/>
+            <a:off x="5448300" y="1710690"/>
             <a:ext cx="76200" cy="76200"/>
           </a:xfrm>
           <a:prstGeom prst="ellipse">
@@ -4261,101 +4086,13 @@
       </p:sp>
       <p:sp>
         <p:nvSpPr>
-          <p:cNvPr id="35" name="Oval 34"/>
-          <p:cNvSpPr/>
-          <p:nvPr/>
-        </p:nvSpPr>
-        <p:spPr>
-          <a:xfrm>
-            <a:off x="4991100" y="2076450"/>
-            <a:ext cx="76200" cy="76200"/>
-          </a:xfrm>
-          <a:prstGeom prst="ellipse">
-            <a:avLst/>
-          </a:prstGeom>
-          <a:noFill/>
-          <a:ln>
-            <a:solidFill>
-              <a:srgbClr val="FFFFFF"/>
-            </a:solidFill>
-          </a:ln>
-        </p:spPr>
-        <p:style>
-          <a:lnRef idx="1">
-            <a:schemeClr val="accent1"/>
-          </a:lnRef>
-          <a:fillRef idx="3">
-            <a:schemeClr val="accent1"/>
-          </a:fillRef>
-          <a:effectRef idx="2">
-            <a:schemeClr val="accent1"/>
-          </a:effectRef>
-          <a:fontRef idx="minor">
-            <a:schemeClr val="lt1"/>
-          </a:fontRef>
-        </p:style>
-        <p:txBody>
-          <a:bodyPr rtlCol="0" anchor="ctr"/>
-          <a:lstStyle/>
-          <a:p>
-            <a:pPr algn="ctr"/>
-          </a:p>
-        </p:txBody>
-      </p:sp>
-      <p:sp>
-        <p:nvSpPr>
-          <p:cNvPr id="36" name="Oval 35"/>
-          <p:cNvSpPr/>
-          <p:nvPr/>
-        </p:nvSpPr>
-        <p:spPr>
-          <a:xfrm>
-            <a:off x="4991100" y="1619250"/>
-            <a:ext cx="76200" cy="76200"/>
-          </a:xfrm>
-          <a:prstGeom prst="ellipse">
-            <a:avLst/>
-          </a:prstGeom>
-          <a:solidFill>
-            <a:srgbClr val="FFFFFF"/>
-          </a:solidFill>
-          <a:ln>
-            <a:solidFill>
-              <a:srgbClr val="FFFFFF"/>
-            </a:solidFill>
-          </a:ln>
-        </p:spPr>
-        <p:style>
-          <a:lnRef idx="1">
-            <a:schemeClr val="accent1"/>
-          </a:lnRef>
-          <a:fillRef idx="3">
-            <a:schemeClr val="accent1"/>
-          </a:fillRef>
-          <a:effectRef idx="2">
-            <a:schemeClr val="accent1"/>
-          </a:effectRef>
-          <a:fontRef idx="minor">
-            <a:schemeClr val="lt1"/>
-          </a:fontRef>
-        </p:style>
-        <p:txBody>
-          <a:bodyPr rtlCol="0" anchor="ctr"/>
-          <a:lstStyle/>
-          <a:p>
-            <a:pPr algn="ctr"/>
-          </a:p>
-        </p:txBody>
-      </p:sp>
-      <p:sp>
-        <p:nvSpPr>
-          <p:cNvPr id="37" name="TextBox 36"/>
+          <p:cNvPr id="30" name="TextBox 29"/>
           <p:cNvSpPr txBox="1"/>
           <p:nvPr/>
         </p:nvSpPr>
         <p:spPr>
           <a:xfrm>
-            <a:off x="4480560" y="2663190"/>
+            <a:off x="5486400" y="2754630"/>
             <a:ext cx="635000" cy="254000"/>
           </a:xfrm>
           <a:prstGeom prst="rect">
@@ -4378,20 +4115,20 @@
               </a:defRPr>
             </a:pPr>
             <a:r>
-              <a:t>O</a:t>
-            </a:r>
-          </a:p>
-        </p:txBody>
-      </p:sp>
-      <p:sp>
-        <p:nvSpPr>
-          <p:cNvPr id="38" name="TextBox 37"/>
+              <a:t>a</a:t>
+            </a:r>
+          </a:p>
+        </p:txBody>
+      </p:sp>
+      <p:sp>
+        <p:nvSpPr>
+          <p:cNvPr id="31" name="TextBox 30"/>
           <p:cNvSpPr txBox="1"/>
           <p:nvPr/>
         </p:nvSpPr>
         <p:spPr>
           <a:xfrm>
-            <a:off x="6217920" y="2663190"/>
+            <a:off x="4389120" y="1748790"/>
             <a:ext cx="635000" cy="254000"/>
           </a:xfrm>
           <a:prstGeom prst="rect">
@@ -4414,659 +4151,8 @@
               </a:defRPr>
             </a:pPr>
             <a:r>
-              <a:t>x</a:t>
-            </a:r>
-          </a:p>
-        </p:txBody>
-      </p:sp>
-      <p:sp>
-        <p:nvSpPr>
-          <p:cNvPr id="39" name="TextBox 38"/>
-          <p:cNvSpPr txBox="1"/>
-          <p:nvPr/>
-        </p:nvSpPr>
-        <p:spPr>
-          <a:xfrm>
-            <a:off x="4480560" y="1017270"/>
-            <a:ext cx="635000" cy="254000"/>
-          </a:xfrm>
-          <a:prstGeom prst="rect">
-            <a:avLst/>
-          </a:prstGeom>
-          <a:noFill/>
-        </p:spPr>
-        <p:txBody>
-          <a:bodyPr wrap="none">
-            <a:spAutoFit/>
-          </a:bodyPr>
-          <a:lstStyle/>
-          <a:p>
-            <a:pPr>
-              <a:defRPr sz="1200">
-                <a:solidFill>
-                  <a:srgbClr val="FFFFFF"/>
-                </a:solidFill>
-                <a:latin typeface="Inter"/>
-              </a:defRPr>
-            </a:pPr>
-            <a:r>
-              <a:t>y</a:t>
-            </a:r>
-          </a:p>
-        </p:txBody>
-      </p:sp>
-      <p:sp>
-        <p:nvSpPr>
-          <p:cNvPr id="40" name="TextBox 39"/>
-          <p:cNvSpPr txBox="1"/>
-          <p:nvPr/>
-        </p:nvSpPr>
-        <p:spPr>
-          <a:xfrm>
-            <a:off x="5715000" y="2663190"/>
-            <a:ext cx="635000" cy="254000"/>
-          </a:xfrm>
-          <a:prstGeom prst="rect">
-            <a:avLst/>
-          </a:prstGeom>
-          <a:noFill/>
-        </p:spPr>
-        <p:txBody>
-          <a:bodyPr wrap="none">
-            <a:spAutoFit/>
-          </a:bodyPr>
-          <a:lstStyle/>
-          <a:p>
-            <a:pPr>
-              <a:defRPr sz="1200">
-                <a:solidFill>
-                  <a:srgbClr val="FFFFFF"/>
-                </a:solidFill>
-                <a:latin typeface="Inter"/>
-              </a:defRPr>
-            </a:pPr>
-            <a:r>
-              <a:t>a</a:t>
-            </a:r>
-          </a:p>
-        </p:txBody>
-      </p:sp>
-      <p:sp>
-        <p:nvSpPr>
-          <p:cNvPr id="41" name="TextBox 40"/>
-          <p:cNvSpPr txBox="1"/>
-          <p:nvPr/>
-        </p:nvSpPr>
-        <p:spPr>
-          <a:xfrm>
-            <a:off x="4480560" y="1657350"/>
-            <a:ext cx="635000" cy="254000"/>
-          </a:xfrm>
-          <a:prstGeom prst="rect">
-            <a:avLst/>
-          </a:prstGeom>
-          <a:noFill/>
-        </p:spPr>
-        <p:txBody>
-          <a:bodyPr wrap="none">
-            <a:spAutoFit/>
-          </a:bodyPr>
-          <a:lstStyle/>
-          <a:p>
-            <a:pPr>
-              <a:defRPr sz="1200">
-                <a:solidFill>
-                  <a:srgbClr val="FFFFFF"/>
-                </a:solidFill>
-                <a:latin typeface="Inter"/>
-              </a:defRPr>
-            </a:pPr>
-            <a:r>
               <a:t>L</a:t>
             </a:r>
-          </a:p>
-        </p:txBody>
-      </p:sp>
-      <p:sp>
-        <p:nvSpPr>
-          <p:cNvPr id="42" name="TextBox 41"/>
-          <p:cNvSpPr txBox="1"/>
-          <p:nvPr/>
-        </p:nvSpPr>
-        <p:spPr>
-          <a:xfrm>
-            <a:off x="5806440" y="1565910"/>
-            <a:ext cx="635000" cy="254000"/>
-          </a:xfrm>
-          <a:prstGeom prst="rect">
-            <a:avLst/>
-          </a:prstGeom>
-          <a:noFill/>
-        </p:spPr>
-        <p:txBody>
-          <a:bodyPr wrap="none">
-            <a:spAutoFit/>
-          </a:bodyPr>
-          <a:lstStyle/>
-          <a:p>
-            <a:pPr>
-              <a:defRPr sz="1200">
-                <a:solidFill>
-                  <a:srgbClr val="FFFFFF"/>
-                </a:solidFill>
-                <a:latin typeface="Inter"/>
-              </a:defRPr>
-            </a:pPr>
-            <a:r>
-              <a:t>y=f(x)</a:t>
-            </a:r>
-          </a:p>
-        </p:txBody>
-      </p:sp>
-      <p:sp>
-        <p:nvSpPr>
-          <p:cNvPr id="43" name="TextBox 42"/>
-          <p:cNvSpPr txBox="1"/>
-          <p:nvPr/>
-        </p:nvSpPr>
-        <p:spPr>
-          <a:xfrm>
-            <a:off x="4572000" y="2571750"/>
-            <a:ext cx="635000" cy="254000"/>
-          </a:xfrm>
-          <a:prstGeom prst="rect">
-            <a:avLst/>
-          </a:prstGeom>
-          <a:noFill/>
-        </p:spPr>
-        <p:txBody>
-          <a:bodyPr wrap="none">
-            <a:spAutoFit/>
-          </a:bodyPr>
-          <a:lstStyle/>
-          <a:p>
-            <a:pPr>
-              <a:defRPr sz="1200">
-                <a:solidFill>
-                  <a:srgbClr val="FFFFFF"/>
-                </a:solidFill>
-                <a:latin typeface="Inter"/>
-              </a:defRPr>
-            </a:pPr>
-          </a:p>
-        </p:txBody>
-      </p:sp>
-      <p:sp>
-        <p:nvSpPr>
-          <p:cNvPr id="44" name="TextBox 43"/>
-          <p:cNvSpPr txBox="1"/>
-          <p:nvPr/>
-        </p:nvSpPr>
-        <p:spPr>
-          <a:xfrm>
-            <a:off x="4572000" y="2571750"/>
-            <a:ext cx="635000" cy="254000"/>
-          </a:xfrm>
-          <a:prstGeom prst="rect">
-            <a:avLst/>
-          </a:prstGeom>
-          <a:noFill/>
-        </p:spPr>
-        <p:txBody>
-          <a:bodyPr wrap="none">
-            <a:spAutoFit/>
-          </a:bodyPr>
-          <a:lstStyle/>
-          <a:p>
-            <a:pPr>
-              <a:defRPr sz="1200">
-                <a:solidFill>
-                  <a:srgbClr val="FFFFFF"/>
-                </a:solidFill>
-                <a:latin typeface="Inter"/>
-              </a:defRPr>
-            </a:pPr>
-          </a:p>
-        </p:txBody>
-      </p:sp>
-      <p:sp>
-        <p:nvSpPr>
-          <p:cNvPr id="45" name="TextBox 44"/>
-          <p:cNvSpPr txBox="1"/>
-          <p:nvPr/>
-        </p:nvSpPr>
-        <p:spPr>
-          <a:xfrm>
-            <a:off x="4572000" y="2571750"/>
-            <a:ext cx="635000" cy="254000"/>
-          </a:xfrm>
-          <a:prstGeom prst="rect">
-            <a:avLst/>
-          </a:prstGeom>
-          <a:noFill/>
-        </p:spPr>
-        <p:txBody>
-          <a:bodyPr wrap="none">
-            <a:spAutoFit/>
-          </a:bodyPr>
-          <a:lstStyle/>
-          <a:p>
-            <a:pPr>
-              <a:defRPr sz="1200">
-                <a:solidFill>
-                  <a:srgbClr val="FFFFFF"/>
-                </a:solidFill>
-                <a:latin typeface="Inter"/>
-              </a:defRPr>
-            </a:pPr>
-          </a:p>
-        </p:txBody>
-      </p:sp>
-      <p:sp>
-        <p:nvSpPr>
-          <p:cNvPr id="46" name="TextBox 45"/>
-          <p:cNvSpPr txBox="1"/>
-          <p:nvPr/>
-        </p:nvSpPr>
-        <p:spPr>
-          <a:xfrm>
-            <a:off x="4572000" y="2571750"/>
-            <a:ext cx="635000" cy="254000"/>
-          </a:xfrm>
-          <a:prstGeom prst="rect">
-            <a:avLst/>
-          </a:prstGeom>
-          <a:noFill/>
-        </p:spPr>
-        <p:txBody>
-          <a:bodyPr wrap="none">
-            <a:spAutoFit/>
-          </a:bodyPr>
-          <a:lstStyle/>
-          <a:p>
-            <a:pPr>
-              <a:defRPr sz="1200">
-                <a:solidFill>
-                  <a:srgbClr val="FFFFFF"/>
-                </a:solidFill>
-                <a:latin typeface="Inter"/>
-              </a:defRPr>
-            </a:pPr>
-          </a:p>
-        </p:txBody>
-      </p:sp>
-      <p:sp>
-        <p:nvSpPr>
-          <p:cNvPr id="47" name="TextBox 46"/>
-          <p:cNvSpPr txBox="1"/>
-          <p:nvPr/>
-        </p:nvSpPr>
-        <p:spPr>
-          <a:xfrm>
-            <a:off x="4572000" y="2571750"/>
-            <a:ext cx="635000" cy="254000"/>
-          </a:xfrm>
-          <a:prstGeom prst="rect">
-            <a:avLst/>
-          </a:prstGeom>
-          <a:noFill/>
-        </p:spPr>
-        <p:txBody>
-          <a:bodyPr wrap="none">
-            <a:spAutoFit/>
-          </a:bodyPr>
-          <a:lstStyle/>
-          <a:p>
-            <a:pPr>
-              <a:defRPr sz="1200">
-                <a:solidFill>
-                  <a:srgbClr val="FFFFFF"/>
-                </a:solidFill>
-                <a:latin typeface="Inter"/>
-              </a:defRPr>
-            </a:pPr>
-          </a:p>
-        </p:txBody>
-      </p:sp>
-      <p:sp>
-        <p:nvSpPr>
-          <p:cNvPr id="48" name="TextBox 47"/>
-          <p:cNvSpPr txBox="1"/>
-          <p:nvPr/>
-        </p:nvSpPr>
-        <p:spPr>
-          <a:xfrm>
-            <a:off x="4572000" y="2571750"/>
-            <a:ext cx="635000" cy="254000"/>
-          </a:xfrm>
-          <a:prstGeom prst="rect">
-            <a:avLst/>
-          </a:prstGeom>
-          <a:noFill/>
-        </p:spPr>
-        <p:txBody>
-          <a:bodyPr wrap="none">
-            <a:spAutoFit/>
-          </a:bodyPr>
-          <a:lstStyle/>
-          <a:p>
-            <a:pPr>
-              <a:defRPr sz="1200">
-                <a:solidFill>
-                  <a:srgbClr val="FFFFFF"/>
-                </a:solidFill>
-                <a:latin typeface="Inter"/>
-              </a:defRPr>
-            </a:pPr>
-          </a:p>
-        </p:txBody>
-      </p:sp>
-      <p:sp>
-        <p:nvSpPr>
-          <p:cNvPr id="49" name="TextBox 48"/>
-          <p:cNvSpPr txBox="1"/>
-          <p:nvPr/>
-        </p:nvSpPr>
-        <p:spPr>
-          <a:xfrm>
-            <a:off x="5029200" y="2663190"/>
-            <a:ext cx="635000" cy="254000"/>
-          </a:xfrm>
-          <a:prstGeom prst="rect">
-            <a:avLst/>
-          </a:prstGeom>
-          <a:noFill/>
-        </p:spPr>
-        <p:txBody>
-          <a:bodyPr wrap="none">
-            <a:spAutoFit/>
-          </a:bodyPr>
-          <a:lstStyle/>
-          <a:p>
-            <a:pPr>
-              <a:defRPr sz="1200">
-                <a:solidFill>
-                  <a:srgbClr val="FFFFFF"/>
-                </a:solidFill>
-                <a:latin typeface="Inter"/>
-              </a:defRPr>
-            </a:pPr>
-            <a:r>
-              <a:t>1</a:t>
-            </a:r>
-          </a:p>
-        </p:txBody>
-      </p:sp>
-      <p:sp>
-        <p:nvSpPr>
-          <p:cNvPr id="50" name="TextBox 49"/>
-          <p:cNvSpPr txBox="1"/>
-          <p:nvPr/>
-        </p:nvSpPr>
-        <p:spPr>
-          <a:xfrm>
-            <a:off x="4480560" y="2114550"/>
-            <a:ext cx="635000" cy="254000"/>
-          </a:xfrm>
-          <a:prstGeom prst="rect">
-            <a:avLst/>
-          </a:prstGeom>
-          <a:noFill/>
-        </p:spPr>
-        <p:txBody>
-          <a:bodyPr wrap="none">
-            <a:spAutoFit/>
-          </a:bodyPr>
-          <a:lstStyle/>
-          <a:p>
-            <a:pPr>
-              <a:defRPr sz="1200">
-                <a:solidFill>
-                  <a:srgbClr val="FFFFFF"/>
-                </a:solidFill>
-                <a:latin typeface="Inter"/>
-              </a:defRPr>
-            </a:pPr>
-            <a:r>
-              <a:t>1</a:t>
-            </a:r>
-          </a:p>
-        </p:txBody>
-      </p:sp>
-      <p:sp>
-        <p:nvSpPr>
-          <p:cNvPr id="51" name="TextBox 50"/>
-          <p:cNvSpPr txBox="1"/>
-          <p:nvPr/>
-        </p:nvSpPr>
-        <p:spPr>
-          <a:xfrm>
-            <a:off x="4480560" y="1657350"/>
-            <a:ext cx="635000" cy="254000"/>
-          </a:xfrm>
-          <a:prstGeom prst="rect">
-            <a:avLst/>
-          </a:prstGeom>
-          <a:noFill/>
-        </p:spPr>
-        <p:txBody>
-          <a:bodyPr wrap="none">
-            <a:spAutoFit/>
-          </a:bodyPr>
-          <a:lstStyle/>
-          <a:p>
-            <a:pPr>
-              <a:defRPr sz="1200">
-                <a:solidFill>
-                  <a:srgbClr val="FFFFFF"/>
-                </a:solidFill>
-                <a:latin typeface="Inter"/>
-              </a:defRPr>
-            </a:pPr>
-            <a:r>
-              <a:t>2</a:t>
-            </a:r>
-          </a:p>
-        </p:txBody>
-      </p:sp>
-      <p:sp>
-        <p:nvSpPr>
-          <p:cNvPr id="52" name="TextBox 51"/>
-          <p:cNvSpPr txBox="1"/>
-          <p:nvPr/>
-        </p:nvSpPr>
-        <p:spPr>
-          <a:xfrm>
-            <a:off x="5394960" y="1291590"/>
-            <a:ext cx="635000" cy="254000"/>
-          </a:xfrm>
-          <a:prstGeom prst="rect">
-            <a:avLst/>
-          </a:prstGeom>
-          <a:noFill/>
-        </p:spPr>
-        <p:txBody>
-          <a:bodyPr wrap="none">
-            <a:spAutoFit/>
-          </a:bodyPr>
-          <a:lstStyle/>
-          <a:p>
-            <a:pPr>
-              <a:defRPr sz="1200">
-                <a:solidFill>
-                  <a:srgbClr val="FFFFFF"/>
-                </a:solidFill>
-                <a:latin typeface="Inter"/>
-              </a:defRPr>
-            </a:pPr>
-            <a:r>
-              <a:t>y=f(x)</a:t>
-            </a:r>
-          </a:p>
-        </p:txBody>
-      </p:sp>
-      <p:sp>
-        <p:nvSpPr>
-          <p:cNvPr id="53" name="TextBox 52"/>
-          <p:cNvSpPr txBox="1"/>
-          <p:nvPr/>
-        </p:nvSpPr>
-        <p:spPr>
-          <a:xfrm>
-            <a:off x="4572000" y="2571750"/>
-            <a:ext cx="635000" cy="254000"/>
-          </a:xfrm>
-          <a:prstGeom prst="rect">
-            <a:avLst/>
-          </a:prstGeom>
-          <a:noFill/>
-        </p:spPr>
-        <p:txBody>
-          <a:bodyPr wrap="none">
-            <a:spAutoFit/>
-          </a:bodyPr>
-          <a:lstStyle/>
-          <a:p>
-            <a:pPr>
-              <a:defRPr sz="1200">
-                <a:solidFill>
-                  <a:srgbClr val="FFFFFF"/>
-                </a:solidFill>
-                <a:latin typeface="Inter"/>
-              </a:defRPr>
-            </a:pPr>
-          </a:p>
-        </p:txBody>
-      </p:sp>
-      <p:sp>
-        <p:nvSpPr>
-          <p:cNvPr id="54" name="TextBox 53"/>
-          <p:cNvSpPr txBox="1"/>
-          <p:nvPr/>
-        </p:nvSpPr>
-        <p:spPr>
-          <a:xfrm>
-            <a:off x="4572000" y="2571750"/>
-            <a:ext cx="635000" cy="254000"/>
-          </a:xfrm>
-          <a:prstGeom prst="rect">
-            <a:avLst/>
-          </a:prstGeom>
-          <a:noFill/>
-        </p:spPr>
-        <p:txBody>
-          <a:bodyPr wrap="none">
-            <a:spAutoFit/>
-          </a:bodyPr>
-          <a:lstStyle/>
-          <a:p>
-            <a:pPr>
-              <a:defRPr sz="1200">
-                <a:solidFill>
-                  <a:srgbClr val="FFFFFF"/>
-                </a:solidFill>
-                <a:latin typeface="Inter"/>
-              </a:defRPr>
-            </a:pPr>
-          </a:p>
-        </p:txBody>
-      </p:sp>
-      <p:sp>
-        <p:nvSpPr>
-          <p:cNvPr id="55" name="TextBox 54"/>
-          <p:cNvSpPr txBox="1"/>
-          <p:nvPr/>
-        </p:nvSpPr>
-        <p:spPr>
-          <a:xfrm>
-            <a:off x="4572000" y="2571750"/>
-            <a:ext cx="635000" cy="254000"/>
-          </a:xfrm>
-          <a:prstGeom prst="rect">
-            <a:avLst/>
-          </a:prstGeom>
-          <a:noFill/>
-        </p:spPr>
-        <p:txBody>
-          <a:bodyPr wrap="none">
-            <a:spAutoFit/>
-          </a:bodyPr>
-          <a:lstStyle/>
-          <a:p>
-            <a:pPr>
-              <a:defRPr sz="1200">
-                <a:solidFill>
-                  <a:srgbClr val="FFFFFF"/>
-                </a:solidFill>
-                <a:latin typeface="Inter"/>
-              </a:defRPr>
-            </a:pPr>
-          </a:p>
-        </p:txBody>
-      </p:sp>
-      <p:sp>
-        <p:nvSpPr>
-          <p:cNvPr id="56" name="TextBox 55"/>
-          <p:cNvSpPr txBox="1"/>
-          <p:nvPr/>
-        </p:nvSpPr>
-        <p:spPr>
-          <a:xfrm>
-            <a:off x="4572000" y="2571750"/>
-            <a:ext cx="635000" cy="254000"/>
-          </a:xfrm>
-          <a:prstGeom prst="rect">
-            <a:avLst/>
-          </a:prstGeom>
-          <a:noFill/>
-        </p:spPr>
-        <p:txBody>
-          <a:bodyPr wrap="none">
-            <a:spAutoFit/>
-          </a:bodyPr>
-          <a:lstStyle/>
-          <a:p>
-            <a:pPr>
-              <a:defRPr sz="1200">
-                <a:solidFill>
-                  <a:srgbClr val="FFFFFF"/>
-                </a:solidFill>
-                <a:latin typeface="Inter"/>
-              </a:defRPr>
-            </a:pPr>
-          </a:p>
-        </p:txBody>
-      </p:sp>
-      <p:sp>
-        <p:nvSpPr>
-          <p:cNvPr id="57" name="TextBox 56"/>
-          <p:cNvSpPr txBox="1"/>
-          <p:nvPr/>
-        </p:nvSpPr>
-        <p:spPr>
-          <a:xfrm>
-            <a:off x="4572000" y="2571750"/>
-            <a:ext cx="635000" cy="254000"/>
-          </a:xfrm>
-          <a:prstGeom prst="rect">
-            <a:avLst/>
-          </a:prstGeom>
-          <a:noFill/>
-        </p:spPr>
-        <p:txBody>
-          <a:bodyPr wrap="none">
-            <a:spAutoFit/>
-          </a:bodyPr>
-          <a:lstStyle/>
-          <a:p>
-            <a:pPr>
-              <a:defRPr sz="1200">
-                <a:solidFill>
-                  <a:srgbClr val="FFFFFF"/>
-                </a:solidFill>
-                <a:latin typeface="Inter"/>
-              </a:defRPr>
-            </a:pPr>
           </a:p>
         </p:txBody>
       </p:sp>

</xml_diff>

<commit_message>
feat: 6개 그래프 1:1 변환 완료 (gemini-2.5-flash 신규 SDK)
</commit_message>
<xml_diff>
--- a/output/1.pptx
+++ b/output/1.pptx
@@ -3174,8 +3174,8 @@
         </p:nvCxnSpPr>
         <p:spPr>
           <a:xfrm flipV="1">
-            <a:off x="4572000.0" y="2375656.92"/>
-            <a:ext cx="42062.40000000037" cy="196093.08000000007"/>
+            <a:off x="3200400.0" y="2983230.0"/>
+            <a:ext cx="228600.0" cy="137160.0"/>
           </a:xfrm>
           <a:prstGeom prst="line">
             <a:avLst/>
@@ -3209,8 +3209,8 @@
         </p:nvCxnSpPr>
         <p:spPr>
           <a:xfrm flipV="1">
-            <a:off x="4614062.4" y="2294412.48"/>
-            <a:ext cx="42062.39999999944" cy="81244.43999999994"/>
+            <a:off x="3429000.0" y="2846070.0"/>
+            <a:ext cx="228600.0" cy="137160.0"/>
           </a:xfrm>
           <a:prstGeom prst="line">
             <a:avLst/>
@@ -3244,8 +3244,8 @@
         </p:nvCxnSpPr>
         <p:spPr>
           <a:xfrm flipV="1">
-            <a:off x="4656124.8" y="2232141.84"/>
-            <a:ext cx="42062.40000000037" cy="62270.64000000013"/>
+            <a:off x="3657600.0" y="2708910.0"/>
+            <a:ext cx="228600.0" cy="137160.0"/>
           </a:xfrm>
           <a:prstGeom prst="line">
             <a:avLst/>
@@ -3279,8 +3279,8 @@
         </p:nvCxnSpPr>
         <p:spPr>
           <a:xfrm flipV="1">
-            <a:off x="4698187.2" y="2180432.52"/>
-            <a:ext cx="42062.39999999944" cy="51709.31999999983"/>
+            <a:off x="3886200.0" y="2571750.0"/>
+            <a:ext cx="228600.0" cy="137160.0"/>
           </a:xfrm>
           <a:prstGeom prst="line">
             <a:avLst/>
@@ -3314,8 +3314,8 @@
         </p:nvCxnSpPr>
         <p:spPr>
           <a:xfrm flipV="1">
-            <a:off x="4740249.6" y="2135306.88"/>
-            <a:ext cx="42062.40000000037" cy="45125.64000000013"/>
+            <a:off x="4114800.0" y="2480310.0"/>
+            <a:ext cx="228600.0" cy="91440.0"/>
           </a:xfrm>
           <a:prstGeom prst="line">
             <a:avLst/>
@@ -3349,8 +3349,8 @@
         </p:nvCxnSpPr>
         <p:spPr>
           <a:xfrm flipV="1">
-            <a:off x="4782312.0" y="2095073.28"/>
-            <a:ext cx="42062.40000000037" cy="40233.59999999986"/>
+            <a:off x="4343400.0" y="2388870.0"/>
+            <a:ext cx="228600.0" cy="91440.0"/>
           </a:xfrm>
           <a:prstGeom prst="line">
             <a:avLst/>
@@ -3384,8 +3384,8 @@
         </p:nvCxnSpPr>
         <p:spPr>
           <a:xfrm flipV="1">
-            <a:off x="4824374.4" y="2058863.04"/>
-            <a:ext cx="42062.39999999944" cy="36210.23999999999"/>
+            <a:off x="4572000.0" y="2297430.0"/>
+            <a:ext cx="228600.0" cy="91440.0"/>
           </a:xfrm>
           <a:prstGeom prst="line">
             <a:avLst/>
@@ -3419,8 +3419,8 @@
         </p:nvCxnSpPr>
         <p:spPr>
           <a:xfrm flipV="1">
-            <a:off x="4866436.8" y="2025853.2000000002"/>
-            <a:ext cx="42062.40000000037" cy="33009.83999999985"/>
+            <a:off x="4800600.0" y="2160270.0"/>
+            <a:ext cx="228600.0" cy="137160.0"/>
           </a:xfrm>
           <a:prstGeom prst="line">
             <a:avLst/>
@@ -3454,8 +3454,8 @@
         </p:nvCxnSpPr>
         <p:spPr>
           <a:xfrm flipV="1">
-            <a:off x="4908499.2" y="1995495.12"/>
-            <a:ext cx="42062.39999999944" cy="30358.080000000075"/>
+            <a:off x="5029200.0" y="2023110.0"/>
+            <a:ext cx="228600.0" cy="137160.0"/>
           </a:xfrm>
           <a:prstGeom prst="line">
             <a:avLst/>
@@ -3489,8 +3489,8 @@
         </p:nvCxnSpPr>
         <p:spPr>
           <a:xfrm flipV="1">
-            <a:off x="4950561.6" y="1967514.48"/>
-            <a:ext cx="42062.40000000037" cy="27980.64000000013"/>
+            <a:off x="5257800.0" y="1885950.0"/>
+            <a:ext cx="228600.0" cy="137160.0"/>
           </a:xfrm>
           <a:prstGeom prst="line">
             <a:avLst/>
@@ -3524,8 +3524,8 @@
         </p:nvCxnSpPr>
         <p:spPr>
           <a:xfrm flipV="1">
-            <a:off x="4992624.0" y="1941591.24"/>
-            <a:ext cx="42062.40000000037" cy="25923.23999999999"/>
+            <a:off x="5486400.0" y="1703070.0"/>
+            <a:ext cx="228600.0" cy="182880.0"/>
           </a:xfrm>
           <a:prstGeom prst="line">
             <a:avLst/>
@@ -3559,8 +3559,8 @@
         </p:nvCxnSpPr>
         <p:spPr>
           <a:xfrm flipV="1">
-            <a:off x="5034686.4" y="1917496.7999999998"/>
-            <a:ext cx="42062.39999999944" cy="24094.440000000177"/>
+            <a:off x="5715000.0" y="1565910.0"/>
+            <a:ext cx="228600.0" cy="137160.0"/>
           </a:xfrm>
           <a:prstGeom prst="line">
             <a:avLst/>
@@ -3594,8 +3594,8 @@
         </p:nvCxnSpPr>
         <p:spPr>
           <a:xfrm flipV="1">
-            <a:off x="5076748.8" y="1894956.8399999999"/>
-            <a:ext cx="42062.40000000037" cy="22539.959999999963"/>
+            <a:off x="5943600.0" y="1428750.0"/>
+            <a:ext cx="228600.0" cy="137160.0"/>
           </a:xfrm>
           <a:prstGeom prst="line">
             <a:avLst/>
@@ -3629,8 +3629,8 @@
         </p:nvCxnSpPr>
         <p:spPr>
           <a:xfrm flipV="1">
-            <a:off x="5118811.2" y="1873834.2000000002"/>
-            <a:ext cx="42062.39999999944" cy="21122.639999999665"/>
+            <a:off x="6172200.0" y="1291590.0"/>
+            <a:ext cx="137160.0" cy="137160.0"/>
           </a:xfrm>
           <a:prstGeom prst="line">
             <a:avLst/>
@@ -3664,8 +3664,8 @@
         </p:nvCxnSpPr>
         <p:spPr>
           <a:xfrm flipV="1">
-            <a:off x="5160873.6" y="1853946.0"/>
-            <a:ext cx="42062.40000000037" cy="19888.200000000186"/>
+            <a:off x="6309360.0" y="1200150.0"/>
+            <a:ext cx="91440.0" cy="91440.0"/>
           </a:xfrm>
           <a:prstGeom prst="line">
             <a:avLst/>
@@ -3699,8 +3699,8 @@
         </p:nvCxnSpPr>
         <p:spPr>
           <a:xfrm flipV="1">
-            <a:off x="5202936.0" y="1835155.08"/>
-            <a:ext cx="42062.40000000037" cy="18790.919999999925"/>
+            <a:off x="6400800.0" y="1108710.0"/>
+            <a:ext cx="91440.0" cy="91440.0"/>
           </a:xfrm>
           <a:prstGeom prst="line">
             <a:avLst/>
@@ -3734,8 +3734,8 @@
         </p:nvCxnSpPr>
         <p:spPr>
           <a:xfrm flipV="1">
-            <a:off x="5244998.4" y="1817324.28"/>
-            <a:ext cx="42062.39999999944" cy="17830.800000000047"/>
+            <a:off x="6492240.0" y="1017270.0"/>
+            <a:ext cx="137160.0" cy="91440.0"/>
           </a:xfrm>
           <a:prstGeom prst="line">
             <a:avLst/>
@@ -3769,8 +3769,8 @@
         </p:nvCxnSpPr>
         <p:spPr>
           <a:xfrm flipV="1">
-            <a:off x="5287060.8" y="1800362.1600000001"/>
-            <a:ext cx="42062.40000000037" cy="16962.11999999988"/>
+            <a:off x="6629400.0" y="925830.0"/>
+            <a:ext cx="137160.0" cy="91440.0"/>
           </a:xfrm>
           <a:prstGeom prst="line">
             <a:avLst/>
@@ -3804,8 +3804,8 @@
         </p:nvCxnSpPr>
         <p:spPr>
           <a:xfrm flipV="1">
-            <a:off x="5329123.2" y="1784223.0"/>
-            <a:ext cx="42062.39999999944" cy="16139.160000000149"/>
+            <a:off x="6766560.0" y="880110.0"/>
+            <a:ext cx="91440.0" cy="45720.0"/>
           </a:xfrm>
           <a:prstGeom prst="line">
             <a:avLst/>
@@ -3831,225 +3831,15 @@
           </a:fontRef>
         </p:style>
       </p:cxnSp>
-      <p:cxnSp>
-        <p:nvCxnSpPr>
-          <p:cNvPr id="23" name="Connector 22"/>
-          <p:cNvCxnSpPr/>
-          <p:nvPr/>
-        </p:nvCxnSpPr>
-        <p:spPr>
-          <a:xfrm flipV="1">
-            <a:off x="5371185.6" y="1768769.6400000001"/>
-            <a:ext cx="42062.40000000037" cy="15453.35999999987"/>
-          </a:xfrm>
-          <a:prstGeom prst="line">
-            <a:avLst/>
-          </a:prstGeom>
-          <a:ln w="25400">
-            <a:solidFill>
-              <a:srgbClr val="00C8FF"/>
-            </a:solidFill>
-          </a:ln>
-        </p:spPr>
-        <p:style>
-          <a:lnRef idx="2">
-            <a:schemeClr val="accent1"/>
-          </a:lnRef>
-          <a:fillRef idx="0">
-            <a:schemeClr val="accent1"/>
-          </a:fillRef>
-          <a:effectRef idx="1">
-            <a:schemeClr val="accent1"/>
-          </a:effectRef>
-          <a:fontRef idx="minor">
-            <a:schemeClr val="tx1"/>
-          </a:fontRef>
-        </p:style>
-      </p:cxnSp>
-      <p:cxnSp>
-        <p:nvCxnSpPr>
-          <p:cNvPr id="24" name="Connector 23"/>
-          <p:cNvCxnSpPr/>
-          <p:nvPr/>
-        </p:nvCxnSpPr>
-        <p:spPr>
-          <a:xfrm flipV="1">
-            <a:off x="5413248.0" y="1754047.8"/>
-            <a:ext cx="42062.40000000037" cy="14721.840000000084"/>
-          </a:xfrm>
-          <a:prstGeom prst="line">
-            <a:avLst/>
-          </a:prstGeom>
-          <a:ln w="25400">
-            <a:solidFill>
-              <a:srgbClr val="00C8FF"/>
-            </a:solidFill>
-          </a:ln>
-        </p:spPr>
-        <p:style>
-          <a:lnRef idx="2">
-            <a:schemeClr val="accent1"/>
-          </a:lnRef>
-          <a:fillRef idx="0">
-            <a:schemeClr val="accent1"/>
-          </a:fillRef>
-          <a:effectRef idx="1">
-            <a:schemeClr val="accent1"/>
-          </a:effectRef>
-          <a:fontRef idx="minor">
-            <a:schemeClr val="tx1"/>
-          </a:fontRef>
-        </p:style>
-      </p:cxnSp>
-      <p:cxnSp>
-        <p:nvCxnSpPr>
-          <p:cNvPr id="25" name="Connector 24"/>
-          <p:cNvCxnSpPr/>
-          <p:nvPr/>
-        </p:nvCxnSpPr>
-        <p:spPr>
-          <a:xfrm flipV="1">
-            <a:off x="5455310.4" y="1739920.32"/>
-            <a:ext cx="42062.39999999944" cy="14127.479999999981"/>
-          </a:xfrm>
-          <a:prstGeom prst="line">
-            <a:avLst/>
-          </a:prstGeom>
-          <a:ln w="25400">
-            <a:solidFill>
-              <a:srgbClr val="00C8FF"/>
-            </a:solidFill>
-          </a:ln>
-        </p:spPr>
-        <p:style>
-          <a:lnRef idx="2">
-            <a:schemeClr val="accent1"/>
-          </a:lnRef>
-          <a:fillRef idx="0">
-            <a:schemeClr val="accent1"/>
-          </a:fillRef>
-          <a:effectRef idx="1">
-            <a:schemeClr val="accent1"/>
-          </a:effectRef>
-          <a:fontRef idx="minor">
-            <a:schemeClr val="tx1"/>
-          </a:fontRef>
-        </p:style>
-      </p:cxnSp>
-      <p:cxnSp>
-        <p:nvCxnSpPr>
-          <p:cNvPr id="26" name="Connector 25"/>
-          <p:cNvCxnSpPr/>
-          <p:nvPr/>
-        </p:nvCxnSpPr>
-        <p:spPr>
-          <a:xfrm flipV="1">
-            <a:off x="5497372.8" y="1726341.48"/>
-            <a:ext cx="42062.40000000037" cy="13578.840000000084"/>
-          </a:xfrm>
-          <a:prstGeom prst="line">
-            <a:avLst/>
-          </a:prstGeom>
-          <a:ln w="25400">
-            <a:solidFill>
-              <a:srgbClr val="00C8FF"/>
-            </a:solidFill>
-          </a:ln>
-        </p:spPr>
-        <p:style>
-          <a:lnRef idx="2">
-            <a:schemeClr val="accent1"/>
-          </a:lnRef>
-          <a:fillRef idx="0">
-            <a:schemeClr val="accent1"/>
-          </a:fillRef>
-          <a:effectRef idx="1">
-            <a:schemeClr val="accent1"/>
-          </a:effectRef>
-          <a:fontRef idx="minor">
-            <a:schemeClr val="tx1"/>
-          </a:fontRef>
-        </p:style>
-      </p:cxnSp>
-      <p:cxnSp>
-        <p:nvCxnSpPr>
-          <p:cNvPr id="27" name="Connector 26"/>
-          <p:cNvCxnSpPr/>
-          <p:nvPr/>
-        </p:nvCxnSpPr>
-        <p:spPr>
-          <a:xfrm flipV="1">
-            <a:off x="5539435.2" y="1713311.28"/>
-            <a:ext cx="42062.39999999944" cy="13030.199999999953"/>
-          </a:xfrm>
-          <a:prstGeom prst="line">
-            <a:avLst/>
-          </a:prstGeom>
-          <a:ln w="25400">
-            <a:solidFill>
-              <a:srgbClr val="00C8FF"/>
-            </a:solidFill>
-          </a:ln>
-        </p:spPr>
-        <p:style>
-          <a:lnRef idx="2">
-            <a:schemeClr val="accent1"/>
-          </a:lnRef>
-          <a:fillRef idx="0">
-            <a:schemeClr val="accent1"/>
-          </a:fillRef>
-          <a:effectRef idx="1">
-            <a:schemeClr val="accent1"/>
-          </a:effectRef>
-          <a:fontRef idx="minor">
-            <a:schemeClr val="tx1"/>
-          </a:fontRef>
-        </p:style>
-      </p:cxnSp>
-      <p:cxnSp>
-        <p:nvCxnSpPr>
-          <p:cNvPr id="28" name="Connector 27"/>
-          <p:cNvCxnSpPr/>
-          <p:nvPr/>
-        </p:nvCxnSpPr>
-        <p:spPr>
-          <a:xfrm flipV="1">
-            <a:off x="5581497.6" y="1700784.0"/>
-            <a:ext cx="42062.40000000037" cy="12527.280000000028"/>
-          </a:xfrm>
-          <a:prstGeom prst="line">
-            <a:avLst/>
-          </a:prstGeom>
-          <a:ln w="25400">
-            <a:solidFill>
-              <a:srgbClr val="00C8FF"/>
-            </a:solidFill>
-          </a:ln>
-        </p:spPr>
-        <p:style>
-          <a:lnRef idx="2">
-            <a:schemeClr val="accent1"/>
-          </a:lnRef>
-          <a:fillRef idx="0">
-            <a:schemeClr val="accent1"/>
-          </a:fillRef>
-          <a:effectRef idx="1">
-            <a:schemeClr val="accent1"/>
-          </a:effectRef>
-          <a:fontRef idx="minor">
-            <a:schemeClr val="tx1"/>
-          </a:fontRef>
-        </p:style>
-      </p:cxnSp>
-      <p:sp>
-        <p:nvSpPr>
-          <p:cNvPr id="29" name="Oval 28"/>
+      <p:sp>
+        <p:nvSpPr>
+          <p:cNvPr id="23" name="Oval 22"/>
           <p:cNvSpPr/>
           <p:nvPr/>
         </p:nvSpPr>
         <p:spPr>
           <a:xfrm>
-            <a:off x="5448300" y="1710690"/>
+            <a:off x="6134100" y="1390650"/>
             <a:ext cx="76200" cy="76200"/>
           </a:xfrm>
           <a:prstGeom prst="ellipse">
@@ -4086,13 +3876,13 @@
       </p:sp>
       <p:sp>
         <p:nvSpPr>
-          <p:cNvPr id="30" name="TextBox 29"/>
+          <p:cNvPr id="24" name="TextBox 23"/>
           <p:cNvSpPr txBox="1"/>
           <p:nvPr/>
         </p:nvSpPr>
         <p:spPr>
           <a:xfrm>
-            <a:off x="5486400" y="2754630"/>
+            <a:off x="5715000" y="1200150"/>
             <a:ext cx="635000" cy="254000"/>
           </a:xfrm>
           <a:prstGeom prst="rect">
@@ -4115,20 +3905,56 @@
               </a:defRPr>
             </a:pPr>
             <a:r>
-              <a:t>a</a:t>
-            </a:r>
-          </a:p>
-        </p:txBody>
-      </p:sp>
-      <p:sp>
-        <p:nvSpPr>
-          <p:cNvPr id="31" name="TextBox 30"/>
+              <a:t>y=f(x)</a:t>
+            </a:r>
+          </a:p>
+        </p:txBody>
+      </p:sp>
+      <p:sp>
+        <p:nvSpPr>
+          <p:cNvPr id="25" name="TextBox 24"/>
           <p:cNvSpPr txBox="1"/>
           <p:nvPr/>
         </p:nvSpPr>
         <p:spPr>
           <a:xfrm>
-            <a:off x="4389120" y="1748790"/>
+            <a:off x="6172200" y="2754630"/>
+            <a:ext cx="635000" cy="254000"/>
+          </a:xfrm>
+          <a:prstGeom prst="rect">
+            <a:avLst/>
+          </a:prstGeom>
+          <a:noFill/>
+        </p:spPr>
+        <p:txBody>
+          <a:bodyPr wrap="none">
+            <a:spAutoFit/>
+          </a:bodyPr>
+          <a:lstStyle/>
+          <a:p>
+            <a:pPr>
+              <a:defRPr sz="1200">
+                <a:solidFill>
+                  <a:srgbClr val="FFFFFF"/>
+                </a:solidFill>
+                <a:latin typeface="Inter"/>
+              </a:defRPr>
+            </a:pPr>
+            <a:r>
+              <a:t>a</a:t>
+            </a:r>
+          </a:p>
+        </p:txBody>
+      </p:sp>
+      <p:sp>
+        <p:nvSpPr>
+          <p:cNvPr id="26" name="TextBox 25"/>
+          <p:cNvSpPr txBox="1"/>
+          <p:nvPr/>
+        </p:nvSpPr>
+        <p:spPr>
+          <a:xfrm>
+            <a:off x="4434840" y="1428750"/>
             <a:ext cx="635000" cy="254000"/>
           </a:xfrm>
           <a:prstGeom prst="rect">

</xml_diff>

<commit_message>
feat: implement high-fidelity math graph rendering and prepare for Render deployment
</commit_message>
<xml_diff>
--- a/output/1.pptx
+++ b/output/1.pptx
@@ -3104,8 +3104,8 @@
         </p:nvCxnSpPr>
         <p:spPr>
           <a:xfrm>
-            <a:off x="2286000.0" y="2571750.0"/>
-            <a:ext cx="4572000.0" cy="0.0"/>
+            <a:off x="3794760.0" y="2571750.0"/>
+            <a:ext cx="2423160.0" cy="0.0"/>
           </a:xfrm>
           <a:prstGeom prst="line">
             <a:avLst/>
@@ -3139,8 +3139,8 @@
         </p:nvCxnSpPr>
         <p:spPr>
           <a:xfrm flipV="1">
-            <a:off x="4572000.0" y="285750.0"/>
-            <a:ext cx="0.0" cy="4572000.0"/>
+            <a:off x="4572000.0" y="1428750.0"/>
+            <a:ext cx="0.0" cy="1691640.0"/>
           </a:xfrm>
           <a:prstGeom prst="line">
             <a:avLst/>
@@ -3166,41 +3166,1255 @@
           </a:fontRef>
         </p:style>
       </p:cxnSp>
-      <p:cxnSp>
-        <p:nvCxnSpPr>
-          <p:cNvPr id="4" name="Connector 3"/>
-          <p:cNvCxnSpPr/>
+      <p:sp>
+        <p:nvSpPr>
+          <p:cNvPr id="4" name="Freeform 3"/>
+          <p:cNvSpPr/>
           <p:nvPr/>
-        </p:nvCxnSpPr>
+        </p:nvSpPr>
         <p:spPr>
-          <a:xfrm flipV="1">
-            <a:off x="4251960.0" y="2800350.0"/>
-            <a:ext cx="45720.0" cy="91440.0"/>
+          <a:xfrm>
+            <a:off x="3886200" y="1698498"/>
+            <a:ext cx="2240280" cy="1330452"/>
           </a:xfrm>
-          <a:prstGeom prst="line">
+          <a:custGeom>
             <a:avLst/>
-          </a:prstGeom>
-          <a:ln w="25400">
+            <a:gdLst/>
+            <a:ahLst/>
+            <a:cxnLst/>
+            <a:rect l="l" t="t" r="r" b="b"/>
+            <a:pathLst>
+              <a:path w="2240280" h="1330452">
+                <a:moveTo>
+                  <a:pt x="0" y="1330452"/>
+                </a:moveTo>
+                <a:lnTo>
+                  <a:pt x="8639" y="1323540"/>
+                </a:lnTo>
+                <a:close/>
+                <a:lnTo>
+                  <a:pt x="17279" y="1316629"/>
+                </a:lnTo>
+                <a:close/>
+                <a:lnTo>
+                  <a:pt x="25918" y="1309717"/>
+                </a:lnTo>
+                <a:close/>
+                <a:lnTo>
+                  <a:pt x="34558" y="1302806"/>
+                </a:lnTo>
+                <a:close/>
+                <a:lnTo>
+                  <a:pt x="43197" y="1295894"/>
+                </a:lnTo>
+                <a:close/>
+                <a:lnTo>
+                  <a:pt x="51836" y="1288983"/>
+                </a:lnTo>
+                <a:close/>
+                <a:lnTo>
+                  <a:pt x="60476" y="1282071"/>
+                </a:lnTo>
+                <a:close/>
+                <a:lnTo>
+                  <a:pt x="69115" y="1275160"/>
+                </a:lnTo>
+                <a:close/>
+                <a:lnTo>
+                  <a:pt x="77755" y="1268248"/>
+                </a:lnTo>
+                <a:close/>
+                <a:lnTo>
+                  <a:pt x="86394" y="1261337"/>
+                </a:lnTo>
+                <a:close/>
+                <a:lnTo>
+                  <a:pt x="95033" y="1254425"/>
+                </a:lnTo>
+                <a:close/>
+                <a:lnTo>
+                  <a:pt x="103673" y="1247514"/>
+                </a:lnTo>
+                <a:close/>
+                <a:lnTo>
+                  <a:pt x="112312" y="1240602"/>
+                </a:lnTo>
+                <a:close/>
+                <a:lnTo>
+                  <a:pt x="120952" y="1233691"/>
+                </a:lnTo>
+                <a:close/>
+                <a:lnTo>
+                  <a:pt x="129591" y="1226779"/>
+                </a:lnTo>
+                <a:close/>
+                <a:lnTo>
+                  <a:pt x="138230" y="1219868"/>
+                </a:lnTo>
+                <a:close/>
+                <a:lnTo>
+                  <a:pt x="146870" y="1212956"/>
+                </a:lnTo>
+                <a:close/>
+                <a:lnTo>
+                  <a:pt x="155509" y="1206045"/>
+                </a:lnTo>
+                <a:close/>
+                <a:lnTo>
+                  <a:pt x="164149" y="1199133"/>
+                </a:lnTo>
+                <a:close/>
+                <a:lnTo>
+                  <a:pt x="172788" y="1192222"/>
+                </a:lnTo>
+                <a:close/>
+                <a:lnTo>
+                  <a:pt x="181427" y="1185310"/>
+                </a:lnTo>
+                <a:close/>
+                <a:lnTo>
+                  <a:pt x="190067" y="1178399"/>
+                </a:lnTo>
+                <a:close/>
+                <a:lnTo>
+                  <a:pt x="198706" y="1171487"/>
+                </a:lnTo>
+                <a:close/>
+                <a:lnTo>
+                  <a:pt x="207346" y="1164576"/>
+                </a:lnTo>
+                <a:close/>
+                <a:lnTo>
+                  <a:pt x="215985" y="1157664"/>
+                </a:lnTo>
+                <a:close/>
+                <a:lnTo>
+                  <a:pt x="224624" y="1150753"/>
+                </a:lnTo>
+                <a:close/>
+                <a:lnTo>
+                  <a:pt x="233264" y="1143841"/>
+                </a:lnTo>
+                <a:close/>
+                <a:lnTo>
+                  <a:pt x="241903" y="1136929"/>
+                </a:lnTo>
+                <a:close/>
+                <a:lnTo>
+                  <a:pt x="250543" y="1130018"/>
+                </a:lnTo>
+                <a:close/>
+                <a:lnTo>
+                  <a:pt x="259182" y="1123106"/>
+                </a:lnTo>
+                <a:close/>
+                <a:lnTo>
+                  <a:pt x="267821" y="1116195"/>
+                </a:lnTo>
+                <a:close/>
+                <a:lnTo>
+                  <a:pt x="276461" y="1109283"/>
+                </a:lnTo>
+                <a:close/>
+                <a:lnTo>
+                  <a:pt x="285100" y="1102372"/>
+                </a:lnTo>
+                <a:close/>
+                <a:lnTo>
+                  <a:pt x="293740" y="1095460"/>
+                </a:lnTo>
+                <a:close/>
+                <a:lnTo>
+                  <a:pt x="302379" y="1088549"/>
+                </a:lnTo>
+                <a:close/>
+                <a:lnTo>
+                  <a:pt x="311018" y="1081637"/>
+                </a:lnTo>
+                <a:close/>
+                <a:lnTo>
+                  <a:pt x="319658" y="1074726"/>
+                </a:lnTo>
+                <a:close/>
+                <a:lnTo>
+                  <a:pt x="328297" y="1067814"/>
+                </a:lnTo>
+                <a:close/>
+                <a:lnTo>
+                  <a:pt x="336937" y="1060902"/>
+                </a:lnTo>
+                <a:close/>
+                <a:lnTo>
+                  <a:pt x="345576" y="1053992"/>
+                </a:lnTo>
+                <a:close/>
+                <a:lnTo>
+                  <a:pt x="354215" y="1047082"/>
+                </a:lnTo>
+                <a:close/>
+                <a:lnTo>
+                  <a:pt x="362855" y="1040169"/>
+                </a:lnTo>
+                <a:close/>
+                <a:lnTo>
+                  <a:pt x="371494" y="1033253"/>
+                </a:lnTo>
+                <a:close/>
+                <a:lnTo>
+                  <a:pt x="380134" y="1026338"/>
+                </a:lnTo>
+                <a:close/>
+                <a:lnTo>
+                  <a:pt x="388773" y="1019434"/>
+                </a:lnTo>
+                <a:close/>
+                <a:lnTo>
+                  <a:pt x="397412" y="1012544"/>
+                </a:lnTo>
+                <a:close/>
+                <a:lnTo>
+                  <a:pt x="406052" y="1005635"/>
+                </a:lnTo>
+                <a:close/>
+                <a:lnTo>
+                  <a:pt x="414691" y="998672"/>
+                </a:lnTo>
+                <a:close/>
+                <a:lnTo>
+                  <a:pt x="423331" y="991688"/>
+                </a:lnTo>
+                <a:close/>
+                <a:lnTo>
+                  <a:pt x="431970" y="984823"/>
+                </a:lnTo>
+                <a:close/>
+                <a:lnTo>
+                  <a:pt x="440609" y="978178"/>
+                </a:lnTo>
+                <a:close/>
+                <a:lnTo>
+                  <a:pt x="449249" y="971440"/>
+                </a:lnTo>
+                <a:close/>
+                <a:lnTo>
+                  <a:pt x="457888" y="964069"/>
+                </a:lnTo>
+                <a:close/>
+                <a:lnTo>
+                  <a:pt x="466527" y="955750"/>
+                </a:lnTo>
+                <a:close/>
+                <a:lnTo>
+                  <a:pt x="475167" y="946887"/>
+                </a:lnTo>
+                <a:close/>
+                <a:lnTo>
+                  <a:pt x="483806" y="938014"/>
+                </a:lnTo>
+                <a:close/>
+                <a:lnTo>
+                  <a:pt x="492446" y="929360"/>
+                </a:lnTo>
+                <a:close/>
+                <a:lnTo>
+                  <a:pt x="501085" y="920795"/>
+                </a:lnTo>
+                <a:close/>
+                <a:lnTo>
+                  <a:pt x="509724" y="912181"/>
+                </a:lnTo>
+                <a:close/>
+                <a:lnTo>
+                  <a:pt x="518364" y="903524"/>
+                </a:lnTo>
+                <a:close/>
+                <a:lnTo>
+                  <a:pt x="527003" y="894894"/>
+                </a:lnTo>
+                <a:close/>
+                <a:lnTo>
+                  <a:pt x="535643" y="886313"/>
+                </a:lnTo>
+                <a:close/>
+                <a:lnTo>
+                  <a:pt x="544282" y="877673"/>
+                </a:lnTo>
+                <a:close/>
+                <a:lnTo>
+                  <a:pt x="552921" y="868858"/>
+                </a:lnTo>
+                <a:close/>
+                <a:lnTo>
+                  <a:pt x="561561" y="860022"/>
+                </a:lnTo>
+                <a:close/>
+                <a:lnTo>
+                  <a:pt x="570200" y="851596"/>
+                </a:lnTo>
+                <a:close/>
+                <a:lnTo>
+                  <a:pt x="578840" y="843812"/>
+                </a:lnTo>
+                <a:close/>
+                <a:lnTo>
+                  <a:pt x="587479" y="835550"/>
+                </a:lnTo>
+                <a:close/>
+                <a:lnTo>
+                  <a:pt x="596118" y="825172"/>
+                </a:lnTo>
+                <a:close/>
+                <a:lnTo>
+                  <a:pt x="604758" y="811987"/>
+                </a:lnTo>
+                <a:close/>
+                <a:lnTo>
+                  <a:pt x="613397" y="797411"/>
+                </a:lnTo>
+                <a:close/>
+                <a:lnTo>
+                  <a:pt x="622037" y="783065"/>
+                </a:lnTo>
+                <a:close/>
+                <a:lnTo>
+                  <a:pt x="630676" y="769353"/>
+                </a:lnTo>
+                <a:close/>
+                <a:lnTo>
+                  <a:pt x="639315" y="755619"/>
+                </a:lnTo>
+                <a:close/>
+                <a:lnTo>
+                  <a:pt x="647955" y="741398"/>
+                </a:lnTo>
+                <a:close/>
+                <a:lnTo>
+                  <a:pt x="656594" y="727371"/>
+                </a:lnTo>
+                <a:close/>
+                <a:lnTo>
+                  <a:pt x="665234" y="714588"/>
+                </a:lnTo>
+                <a:close/>
+                <a:lnTo>
+                  <a:pt x="673873" y="703569"/>
+                </a:lnTo>
+                <a:close/>
+                <a:lnTo>
+                  <a:pt x="682512" y="693849"/>
+                </a:lnTo>
+                <a:close/>
+                <a:lnTo>
+                  <a:pt x="691152" y="684868"/>
+                </a:lnTo>
+                <a:close/>
+                <a:lnTo>
+                  <a:pt x="699791" y="676246"/>
+                </a:lnTo>
+                <a:close/>
+                <a:lnTo>
+                  <a:pt x="708431" y="667739"/>
+                </a:lnTo>
+                <a:close/>
+                <a:lnTo>
+                  <a:pt x="717070" y="659149"/>
+                </a:lnTo>
+                <a:close/>
+                <a:lnTo>
+                  <a:pt x="725709" y="650486"/>
+                </a:lnTo>
+                <a:close/>
+                <a:lnTo>
+                  <a:pt x="734349" y="641816"/>
+                </a:lnTo>
+                <a:close/>
+                <a:lnTo>
+                  <a:pt x="742988" y="633172"/>
+                </a:lnTo>
+                <a:close/>
+                <a:lnTo>
+                  <a:pt x="751628" y="624542"/>
+                </a:lnTo>
+                <a:close/>
+                <a:lnTo>
+                  <a:pt x="760267" y="615908"/>
+                </a:lnTo>
+                <a:close/>
+                <a:lnTo>
+                  <a:pt x="768906" y="607268"/>
+                </a:lnTo>
+                <a:close/>
+                <a:lnTo>
+                  <a:pt x="777546" y="598626"/>
+                </a:lnTo>
+                <a:close/>
+                <a:lnTo>
+                  <a:pt x="786185" y="589986"/>
+                </a:lnTo>
+                <a:close/>
+                <a:lnTo>
+                  <a:pt x="794825" y="581347"/>
+                </a:lnTo>
+                <a:close/>
+                <a:lnTo>
+                  <a:pt x="803464" y="572708"/>
+                </a:lnTo>
+                <a:close/>
+                <a:lnTo>
+                  <a:pt x="812103" y="564067"/>
+                </a:lnTo>
+                <a:close/>
+                <a:lnTo>
+                  <a:pt x="820743" y="555428"/>
+                </a:lnTo>
+                <a:close/>
+                <a:lnTo>
+                  <a:pt x="829382" y="546794"/>
+                </a:lnTo>
+                <a:close/>
+                <a:lnTo>
+                  <a:pt x="838022" y="538158"/>
+                </a:lnTo>
+                <a:close/>
+                <a:lnTo>
+                  <a:pt x="846661" y="529509"/>
+                </a:lnTo>
+                <a:close/>
+                <a:lnTo>
+                  <a:pt x="855300" y="520849"/>
+                </a:lnTo>
+                <a:close/>
+                <a:lnTo>
+                  <a:pt x="863940" y="512209"/>
+                </a:lnTo>
+                <a:close/>
+                <a:lnTo>
+                  <a:pt x="872579" y="503627"/>
+                </a:lnTo>
+                <a:close/>
+                <a:lnTo>
+                  <a:pt x="881219" y="495055"/>
+                </a:lnTo>
+                <a:close/>
+                <a:lnTo>
+                  <a:pt x="889858" y="486354"/>
+                </a:lnTo>
+                <a:close/>
+                <a:lnTo>
+                  <a:pt x="898497" y="477437"/>
+                </a:lnTo>
+                <a:close/>
+                <a:lnTo>
+                  <a:pt x="907137" y="468655"/>
+                </a:lnTo>
+                <a:close/>
+                <a:lnTo>
+                  <a:pt x="915776" y="460547"/>
+                </a:lnTo>
+                <a:close/>
+                <a:lnTo>
+                  <a:pt x="924416" y="453377"/>
+                </a:lnTo>
+                <a:close/>
+                <a:lnTo>
+                  <a:pt x="933055" y="446710"/>
+                </a:lnTo>
+                <a:close/>
+                <a:lnTo>
+                  <a:pt x="941694" y="440019"/>
+                </a:lnTo>
+                <a:close/>
+                <a:lnTo>
+                  <a:pt x="950334" y="433112"/>
+                </a:lnTo>
+                <a:close/>
+                <a:lnTo>
+                  <a:pt x="958973" y="426122"/>
+                </a:lnTo>
+                <a:close/>
+                <a:lnTo>
+                  <a:pt x="967613" y="419174"/>
+                </a:lnTo>
+                <a:close/>
+                <a:lnTo>
+                  <a:pt x="976252" y="412274"/>
+                </a:lnTo>
+                <a:close/>
+                <a:lnTo>
+                  <a:pt x="984891" y="405382"/>
+                </a:lnTo>
+                <a:close/>
+                <a:lnTo>
+                  <a:pt x="993531" y="398474"/>
+                </a:lnTo>
+                <a:close/>
+                <a:lnTo>
+                  <a:pt x="1002170" y="391558"/>
+                </a:lnTo>
+                <a:close/>
+                <a:lnTo>
+                  <a:pt x="1010810" y="384643"/>
+                </a:lnTo>
+                <a:close/>
+                <a:lnTo>
+                  <a:pt x="1019449" y="377732"/>
+                </a:lnTo>
+                <a:close/>
+                <a:lnTo>
+                  <a:pt x="1028088" y="370821"/>
+                </a:lnTo>
+                <a:close/>
+                <a:lnTo>
+                  <a:pt x="1036728" y="363909"/>
+                </a:lnTo>
+                <a:close/>
+                <a:lnTo>
+                  <a:pt x="1045367" y="356997"/>
+                </a:lnTo>
+                <a:close/>
+                <a:lnTo>
+                  <a:pt x="1054007" y="350088"/>
+                </a:lnTo>
+                <a:close/>
+                <a:lnTo>
+                  <a:pt x="1062646" y="343182"/>
+                </a:lnTo>
+                <a:close/>
+                <a:lnTo>
+                  <a:pt x="1071285" y="336268"/>
+                </a:lnTo>
+                <a:close/>
+                <a:lnTo>
+                  <a:pt x="1079925" y="329339"/>
+                </a:lnTo>
+                <a:close/>
+                <a:lnTo>
+                  <a:pt x="1088564" y="322413"/>
+                </a:lnTo>
+                <a:close/>
+                <a:lnTo>
+                  <a:pt x="1097204" y="315529"/>
+                </a:lnTo>
+                <a:close/>
+                <a:lnTo>
+                  <a:pt x="1105843" y="308695"/>
+                </a:lnTo>
+                <a:close/>
+                <a:lnTo>
+                  <a:pt x="1114482" y="301800"/>
+                </a:lnTo>
+                <a:close/>
+                <a:lnTo>
+                  <a:pt x="1123122" y="294700"/>
+                </a:lnTo>
+                <a:close/>
+                <a:lnTo>
+                  <a:pt x="1131761" y="287517"/>
+                </a:lnTo>
+                <a:close/>
+                <a:lnTo>
+                  <a:pt x="1140401" y="280760"/>
+                </a:lnTo>
+                <a:close/>
+                <a:lnTo>
+                  <a:pt x="1149040" y="274910"/>
+                </a:lnTo>
+                <a:close/>
+                <a:lnTo>
+                  <a:pt x="1157679" y="269806"/>
+                </a:lnTo>
+                <a:close/>
+                <a:lnTo>
+                  <a:pt x="1166319" y="264913"/>
+                </a:lnTo>
+                <a:close/>
+                <a:lnTo>
+                  <a:pt x="1174958" y="259821"/>
+                </a:lnTo>
+                <a:close/>
+                <a:lnTo>
+                  <a:pt x="1183598" y="254579"/>
+                </a:lnTo>
+                <a:close/>
+                <a:lnTo>
+                  <a:pt x="1192237" y="249331"/>
+                </a:lnTo>
+                <a:close/>
+                <a:lnTo>
+                  <a:pt x="1200876" y="244141"/>
+                </a:lnTo>
+                <a:close/>
+                <a:lnTo>
+                  <a:pt x="1209516" y="238978"/>
+                </a:lnTo>
+                <a:close/>
+                <a:lnTo>
+                  <a:pt x="1218155" y="233806"/>
+                </a:lnTo>
+                <a:close/>
+                <a:lnTo>
+                  <a:pt x="1226795" y="228620"/>
+                </a:lnTo>
+                <a:close/>
+                <a:lnTo>
+                  <a:pt x="1235434" y="223431"/>
+                </a:lnTo>
+                <a:close/>
+                <a:lnTo>
+                  <a:pt x="1244073" y="218246"/>
+                </a:lnTo>
+                <a:close/>
+                <a:lnTo>
+                  <a:pt x="1252713" y="213064"/>
+                </a:lnTo>
+                <a:close/>
+                <a:lnTo>
+                  <a:pt x="1261352" y="207880"/>
+                </a:lnTo>
+                <a:close/>
+                <a:lnTo>
+                  <a:pt x="1269992" y="202696"/>
+                </a:lnTo>
+                <a:close/>
+                <a:lnTo>
+                  <a:pt x="1278631" y="197513"/>
+                </a:lnTo>
+                <a:close/>
+                <a:lnTo>
+                  <a:pt x="1287270" y="192334"/>
+                </a:lnTo>
+                <a:close/>
+                <a:lnTo>
+                  <a:pt x="1295910" y="187153"/>
+                </a:lnTo>
+                <a:close/>
+                <a:lnTo>
+                  <a:pt x="1304549" y="181959"/>
+                </a:lnTo>
+                <a:close/>
+                <a:lnTo>
+                  <a:pt x="1313188" y="176755"/>
+                </a:lnTo>
+                <a:close/>
+                <a:lnTo>
+                  <a:pt x="1321828" y="171574"/>
+                </a:lnTo>
+                <a:close/>
+                <a:lnTo>
+                  <a:pt x="1330467" y="166452"/>
+                </a:lnTo>
+                <a:close/>
+                <a:lnTo>
+                  <a:pt x="1339107" y="161331"/>
+                </a:lnTo>
+                <a:close/>
+                <a:lnTo>
+                  <a:pt x="1347746" y="156069"/>
+                </a:lnTo>
+                <a:close/>
+                <a:lnTo>
+                  <a:pt x="1356385" y="150600"/>
+                </a:lnTo>
+                <a:close/>
+                <a:lnTo>
+                  <a:pt x="1365025" y="145308"/>
+                </a:lnTo>
+                <a:close/>
+                <a:lnTo>
+                  <a:pt x="1373664" y="140731"/>
+                </a:lnTo>
+                <a:close/>
+                <a:lnTo>
+                  <a:pt x="1382304" y="137075"/>
+                </a:lnTo>
+                <a:close/>
+                <a:lnTo>
+                  <a:pt x="1390943" y="133881"/>
+                </a:lnTo>
+                <a:close/>
+                <a:lnTo>
+                  <a:pt x="1399582" y="130630"/>
+                </a:lnTo>
+                <a:close/>
+                <a:lnTo>
+                  <a:pt x="1408222" y="127169"/>
+                </a:lnTo>
+                <a:close/>
+                <a:lnTo>
+                  <a:pt x="1416861" y="123631"/>
+                </a:lnTo>
+                <a:close/>
+                <a:lnTo>
+                  <a:pt x="1425501" y="120133"/>
+                </a:lnTo>
+                <a:close/>
+                <a:lnTo>
+                  <a:pt x="1434140" y="116687"/>
+                </a:lnTo>
+                <a:close/>
+                <a:lnTo>
+                  <a:pt x="1442779" y="113276"/>
+                </a:lnTo>
+                <a:close/>
+                <a:lnTo>
+                  <a:pt x="1451419" y="109863"/>
+                </a:lnTo>
+                <a:close/>
+                <a:lnTo>
+                  <a:pt x="1460058" y="106384"/>
+                </a:lnTo>
+                <a:close/>
+                <a:lnTo>
+                  <a:pt x="1468698" y="102789"/>
+                </a:lnTo>
+                <a:close/>
+                <a:lnTo>
+                  <a:pt x="1477337" y="99228"/>
+                </a:lnTo>
+                <a:close/>
+                <a:lnTo>
+                  <a:pt x="1485976" y="95986"/>
+                </a:lnTo>
+                <a:close/>
+                <a:lnTo>
+                  <a:pt x="1494616" y="93242"/>
+                </a:lnTo>
+                <a:close/>
+                <a:lnTo>
+                  <a:pt x="1503255" y="90758"/>
+                </a:lnTo>
+                <a:close/>
+                <a:lnTo>
+                  <a:pt x="1511895" y="88197"/>
+                </a:lnTo>
+                <a:close/>
+                <a:lnTo>
+                  <a:pt x="1520534" y="85489"/>
+                </a:lnTo>
+                <a:close/>
+                <a:lnTo>
+                  <a:pt x="1529173" y="82941"/>
+                </a:lnTo>
+                <a:close/>
+                <a:lnTo>
+                  <a:pt x="1537813" y="80856"/>
+                </a:lnTo>
+                <a:close/>
+                <a:lnTo>
+                  <a:pt x="1546452" y="79169"/>
+                </a:lnTo>
+                <a:close/>
+                <a:lnTo>
+                  <a:pt x="1555092" y="77612"/>
+                </a:lnTo>
+                <a:close/>
+                <a:lnTo>
+                  <a:pt x="1563731" y="75971"/>
+                </a:lnTo>
+                <a:close/>
+                <a:lnTo>
+                  <a:pt x="1572370" y="74214"/>
+                </a:lnTo>
+                <a:close/>
+                <a:lnTo>
+                  <a:pt x="1581010" y="72348"/>
+                </a:lnTo>
+                <a:close/>
+                <a:lnTo>
+                  <a:pt x="1589649" y="70489"/>
+                </a:lnTo>
+                <a:close/>
+                <a:lnTo>
+                  <a:pt x="1598289" y="68878"/>
+                </a:lnTo>
+                <a:close/>
+                <a:lnTo>
+                  <a:pt x="1606928" y="67725"/>
+                </a:lnTo>
+                <a:close/>
+                <a:lnTo>
+                  <a:pt x="1615567" y="66918"/>
+                </a:lnTo>
+                <a:close/>
+                <a:lnTo>
+                  <a:pt x="1624207" y="66193"/>
+                </a:lnTo>
+                <a:close/>
+                <a:lnTo>
+                  <a:pt x="1632847" y="65365"/>
+                </a:lnTo>
+                <a:close/>
+                <a:lnTo>
+                  <a:pt x="1641486" y="64470"/>
+                </a:lnTo>
+                <a:close/>
+                <a:lnTo>
+                  <a:pt x="1650124" y="63578"/>
+                </a:lnTo>
+                <a:close/>
+                <a:lnTo>
+                  <a:pt x="1658762" y="62713"/>
+                </a:lnTo>
+                <a:close/>
+                <a:lnTo>
+                  <a:pt x="1667403" y="61859"/>
+                </a:lnTo>
+                <a:close/>
+                <a:lnTo>
+                  <a:pt x="1676048" y="60995"/>
+                </a:lnTo>
+                <a:close/>
+                <a:lnTo>
+                  <a:pt x="1684690" y="60128"/>
+                </a:lnTo>
+                <a:close/>
+                <a:lnTo>
+                  <a:pt x="1693318" y="59270"/>
+                </a:lnTo>
+                <a:close/>
+                <a:lnTo>
+                  <a:pt x="1701935" y="58422"/>
+                </a:lnTo>
+                <a:close/>
+                <a:lnTo>
+                  <a:pt x="1710579" y="57556"/>
+                </a:lnTo>
+                <a:close/>
+                <a:lnTo>
+                  <a:pt x="1719285" y="56642"/>
+                </a:lnTo>
+                <a:close/>
+                <a:lnTo>
+                  <a:pt x="1727991" y="55729"/>
+                </a:lnTo>
+                <a:close/>
+                <a:lnTo>
+                  <a:pt x="1736542" y="54931"/>
+                </a:lnTo>
+                <a:close/>
+                <a:lnTo>
+                  <a:pt x="1744873" y="54335"/>
+                </a:lnTo>
+                <a:close/>
+                <a:lnTo>
+                  <a:pt x="1753405" y="53856"/>
+                </a:lnTo>
+                <a:close/>
+                <a:lnTo>
+                  <a:pt x="1762709" y="53354"/>
+                </a:lnTo>
+                <a:close/>
+                <a:lnTo>
+                  <a:pt x="1772480" y="52784"/>
+                </a:lnTo>
+                <a:close/>
+                <a:lnTo>
+                  <a:pt x="1780740" y="52272"/>
+                </a:lnTo>
+                <a:close/>
+                <a:lnTo>
+                  <a:pt x="1785484" y="51957"/>
+                </a:lnTo>
+                <a:close/>
+                <a:lnTo>
+                  <a:pt x="1787070" y="51828"/>
+                </a:lnTo>
+                <a:close/>
+                <a:lnTo>
+                  <a:pt x="1787624" y="51758"/>
+                </a:lnTo>
+                <a:close/>
+                <a:lnTo>
+                  <a:pt x="1788903" y="51645"/>
+                </a:lnTo>
+                <a:close/>
+                <a:lnTo>
+                  <a:pt x="1790833" y="51495"/>
+                </a:lnTo>
+                <a:close/>
+                <a:lnTo>
+                  <a:pt x="1792838" y="51342"/>
+                </a:lnTo>
+                <a:close/>
+                <a:lnTo>
+                  <a:pt x="1794606" y="51204"/>
+                </a:lnTo>
+                <a:close/>
+                <a:lnTo>
+                  <a:pt x="1796256" y="51069"/>
+                </a:lnTo>
+                <a:close/>
+                <a:lnTo>
+                  <a:pt x="1797931" y="50925"/>
+                </a:lnTo>
+                <a:close/>
+                <a:lnTo>
+                  <a:pt x="1799665" y="50780"/>
+                </a:lnTo>
+                <a:close/>
+                <a:lnTo>
+                  <a:pt x="1801414" y="50655"/>
+                </a:lnTo>
+                <a:close/>
+                <a:lnTo>
+                  <a:pt x="1803148" y="50566"/>
+                </a:lnTo>
+                <a:close/>
+                <a:lnTo>
+                  <a:pt x="1804871" y="50504"/>
+                </a:lnTo>
+                <a:close/>
+                <a:lnTo>
+                  <a:pt x="1806599" y="50459"/>
+                </a:lnTo>
+                <a:close/>
+                <a:lnTo>
+                  <a:pt x="1808332" y="50421"/>
+                </a:lnTo>
+                <a:close/>
+                <a:lnTo>
+                  <a:pt x="1810058" y="50390"/>
+                </a:lnTo>
+                <a:close/>
+                <a:lnTo>
+                  <a:pt x="1811762" y="50367"/>
+                </a:lnTo>
+                <a:close/>
+                <a:lnTo>
+                  <a:pt x="1813474" y="50350"/>
+                </a:lnTo>
+                <a:close/>
+                <a:lnTo>
+                  <a:pt x="1815244" y="50337"/>
+                </a:lnTo>
+                <a:close/>
+                <a:lnTo>
+                  <a:pt x="1817072" y="50326"/>
+                </a:lnTo>
+                <a:close/>
+                <a:lnTo>
+                  <a:pt x="1818802" y="50318"/>
+                </a:lnTo>
+                <a:close/>
+                <a:lnTo>
+                  <a:pt x="1820263" y="50312"/>
+                </a:lnTo>
+                <a:close/>
+                <a:lnTo>
+                  <a:pt x="1821669" y="50308"/>
+                </a:lnTo>
+                <a:close/>
+                <a:lnTo>
+                  <a:pt x="1823682" y="50302"/>
+                </a:lnTo>
+                <a:close/>
+                <a:lnTo>
+                  <a:pt x="1826840" y="50296"/>
+                </a:lnTo>
+                <a:close/>
+                <a:lnTo>
+                  <a:pt x="1830567" y="50288"/>
+                </a:lnTo>
+                <a:close/>
+                <a:lnTo>
+                  <a:pt x="1833781" y="50282"/>
+                </a:lnTo>
+                <a:close/>
+                <a:lnTo>
+                  <a:pt x="1835845" y="50277"/>
+                </a:lnTo>
+                <a:close/>
+                <a:lnTo>
+                  <a:pt x="1837266" y="50272"/>
+                </a:lnTo>
+                <a:close/>
+                <a:lnTo>
+                  <a:pt x="1838713" y="50266"/>
+                </a:lnTo>
+                <a:close/>
+                <a:lnTo>
+                  <a:pt x="1840432" y="50257"/>
+                </a:lnTo>
+                <a:close/>
+                <a:lnTo>
+                  <a:pt x="1842259" y="50248"/>
+                </a:lnTo>
+                <a:close/>
+                <a:lnTo>
+                  <a:pt x="1844034" y="50238"/>
+                </a:lnTo>
+                <a:close/>
+                <a:lnTo>
+                  <a:pt x="1845748" y="50230"/>
+                </a:lnTo>
+                <a:close/>
+                <a:lnTo>
+                  <a:pt x="1847451" y="50222"/>
+                </a:lnTo>
+                <a:close/>
+                <a:lnTo>
+                  <a:pt x="1849176" y="50215"/>
+                </a:lnTo>
+                <a:close/>
+                <a:lnTo>
+                  <a:pt x="1850909" y="50206"/>
+                </a:lnTo>
+                <a:close/>
+                <a:lnTo>
+                  <a:pt x="1852637" y="50192"/>
+                </a:lnTo>
+                <a:close/>
+                <a:lnTo>
+                  <a:pt x="1854361" y="50175"/>
+                </a:lnTo>
+                <a:close/>
+                <a:lnTo>
+                  <a:pt x="1856093" y="50156"/>
+                </a:lnTo>
+                <a:close/>
+                <a:lnTo>
+                  <a:pt x="1857842" y="50138"/>
+                </a:lnTo>
+                <a:close/>
+                <a:lnTo>
+                  <a:pt x="1859578" y="50121"/>
+                </a:lnTo>
+                <a:close/>
+                <a:lnTo>
+                  <a:pt x="1861257" y="50105"/>
+                </a:lnTo>
+                <a:close/>
+                <a:lnTo>
+                  <a:pt x="1862904" y="50089"/>
+                </a:lnTo>
+                <a:close/>
+                <a:lnTo>
+                  <a:pt x="1864663" y="50071"/>
+                </a:lnTo>
+                <a:close/>
+                <a:lnTo>
+                  <a:pt x="1866658" y="50049"/>
+                </a:lnTo>
+                <a:close/>
+                <a:lnTo>
+                  <a:pt x="1868606" y="50028"/>
+                </a:lnTo>
+                <a:close/>
+                <a:lnTo>
+                  <a:pt x="1869934" y="50018"/>
+                </a:lnTo>
+                <a:close/>
+                <a:lnTo>
+                  <a:pt x="1870493" y="50020"/>
+                </a:lnTo>
+                <a:close/>
+                <a:lnTo>
+                  <a:pt x="1871970" y="50007"/>
+                </a:lnTo>
+                <a:close/>
+                <a:lnTo>
+                  <a:pt x="1876505" y="49942"/>
+                </a:lnTo>
+                <a:close/>
+                <a:lnTo>
+                  <a:pt x="1884624" y="49816"/>
+                </a:lnTo>
+                <a:close/>
+                <a:lnTo>
+                  <a:pt x="1894370" y="49657"/>
+                </a:lnTo>
+                <a:close/>
+                <a:lnTo>
+                  <a:pt x="1903726" y="49495"/>
+                </a:lnTo>
+                <a:close/>
+                <a:lnTo>
+                  <a:pt x="1912284" y="49329"/>
+                </a:lnTo>
+                <a:close/>
+                <a:lnTo>
+                  <a:pt x="1920612" y="49140"/>
+                </a:lnTo>
+                <a:close/>
+                <a:lnTo>
+                  <a:pt x="1929150" y="48911"/>
+                </a:lnTo>
+                <a:close/>
+                <a:lnTo>
+                  <a:pt x="1937851" y="48642"/>
+                </a:lnTo>
+                <a:close/>
+                <a:lnTo>
+                  <a:pt x="1946560" y="48338"/>
+                </a:lnTo>
+                <a:close/>
+                <a:lnTo>
+                  <a:pt x="1955207" y="48001"/>
+                </a:lnTo>
+                <a:close/>
+                <a:lnTo>
+                  <a:pt x="1963824" y="47641"/>
+                </a:lnTo>
+                <a:close/>
+                <a:lnTo>
+                  <a:pt x="1972451" y="47266"/>
+                </a:lnTo>
+                <a:close/>
+                <a:lnTo>
+                  <a:pt x="1981093" y="46907"/>
+                </a:lnTo>
+                <a:close/>
+                <a:lnTo>
+                  <a:pt x="1989738" y="46606"/>
+                </a:lnTo>
+                <a:close/>
+                <a:lnTo>
+                  <a:pt x="1998379" y="46356"/>
+                </a:lnTo>
+                <a:close/>
+                <a:lnTo>
+                  <a:pt x="2007017" y="46009"/>
+                </a:lnTo>
+                <a:close/>
+                <a:lnTo>
+                  <a:pt x="2015655" y="45398"/>
+                </a:lnTo>
+                <a:close/>
+                <a:lnTo>
+                  <a:pt x="2024295" y="44528"/>
+                </a:lnTo>
+                <a:close/>
+                <a:lnTo>
+                  <a:pt x="2032934" y="43597"/>
+                </a:lnTo>
+                <a:close/>
+                <a:lnTo>
+                  <a:pt x="2041574" y="42774"/>
+                </a:lnTo>
+                <a:close/>
+                <a:lnTo>
+                  <a:pt x="2050213" y="41963"/>
+                </a:lnTo>
+                <a:close/>
+                <a:lnTo>
+                  <a:pt x="2058853" y="40956"/>
+                </a:lnTo>
+                <a:close/>
+                <a:lnTo>
+                  <a:pt x="2067492" y="39647"/>
+                </a:lnTo>
+                <a:close/>
+                <a:lnTo>
+                  <a:pt x="2076131" y="38187"/>
+                </a:lnTo>
+                <a:close/>
+                <a:lnTo>
+                  <a:pt x="2084771" y="36757"/>
+                </a:lnTo>
+                <a:close/>
+                <a:lnTo>
+                  <a:pt x="2093410" y="35396"/>
+                </a:lnTo>
+                <a:close/>
+                <a:lnTo>
+                  <a:pt x="2102050" y="34011"/>
+                </a:lnTo>
+                <a:close/>
+                <a:lnTo>
+                  <a:pt x="2110689" y="32519"/>
+                </a:lnTo>
+                <a:close/>
+                <a:lnTo>
+                  <a:pt x="2119328" y="30946"/>
+                </a:lnTo>
+                <a:close/>
+                <a:lnTo>
+                  <a:pt x="2127968" y="29353"/>
+                </a:lnTo>
+                <a:close/>
+                <a:lnTo>
+                  <a:pt x="2136607" y="27738"/>
+                </a:lnTo>
+                <a:close/>
+                <a:lnTo>
+                  <a:pt x="2145247" y="25965"/>
+                </a:lnTo>
+                <a:close/>
+                <a:lnTo>
+                  <a:pt x="2153886" y="23898"/>
+                </a:lnTo>
+                <a:close/>
+                <a:lnTo>
+                  <a:pt x="2162525" y="21607"/>
+                </a:lnTo>
+                <a:close/>
+                <a:lnTo>
+                  <a:pt x="2171165" y="19337"/>
+                </a:lnTo>
+                <a:close/>
+                <a:lnTo>
+                  <a:pt x="2179804" y="17265"/>
+                </a:lnTo>
+                <a:close/>
+                <a:lnTo>
+                  <a:pt x="2188444" y="15247"/>
+                </a:lnTo>
+                <a:close/>
+                <a:lnTo>
+                  <a:pt x="2197083" y="13038"/>
+                </a:lnTo>
+                <a:close/>
+                <a:lnTo>
+                  <a:pt x="2205722" y="10528"/>
+                </a:lnTo>
+                <a:close/>
+                <a:lnTo>
+                  <a:pt x="2214362" y="7831"/>
+                </a:lnTo>
+                <a:close/>
+                <a:lnTo>
+                  <a:pt x="2223001" y="5086"/>
+                </a:lnTo>
+                <a:close/>
+                <a:lnTo>
+                  <a:pt x="2231641" y="2430"/>
+                </a:lnTo>
+                <a:close/>
+                <a:lnTo>
+                  <a:pt x="2240280" y="0"/>
+                </a:lnTo>
+                <a:close/>
+              </a:path>
+            </a:pathLst>
+          </a:custGeom>
+          <a:ln w="31750">
             <a:solidFill>
-              <a:srgbClr val="00C8FF"/>
+              <a:srgbClr val="00E5FF"/>
             </a:solidFill>
           </a:ln>
         </p:spPr>
         <p:style>
-          <a:lnRef idx="2">
+          <a:lnRef idx="1">
             <a:schemeClr val="accent1"/>
           </a:lnRef>
-          <a:fillRef idx="0">
+          <a:fillRef idx="3">
             <a:schemeClr val="accent1"/>
           </a:fillRef>
-          <a:effectRef idx="1">
+          <a:effectRef idx="2">
             <a:schemeClr val="accent1"/>
           </a:effectRef>
           <a:fontRef idx="minor">
-            <a:schemeClr val="tx1"/>
+            <a:schemeClr val="lt1"/>
           </a:fontRef>
         </p:style>
-      </p:cxnSp>
+        <p:txBody>
+          <a:bodyPr rtlCol="0" anchor="ctr"/>
+          <a:lstStyle/>
+          <a:p>
+            <a:pPr algn="ctr"/>
+          </a:p>
+        </p:txBody>
+      </p:sp>
       <p:cxnSp>
         <p:nvCxnSpPr>
           <p:cNvPr id="5" name="Connector 4"/>
@@ -3209,16 +4423,17 @@
         </p:nvCxnSpPr>
         <p:spPr>
           <a:xfrm flipV="1">
-            <a:off x="4297680.0" y="2731770.0"/>
-            <a:ext cx="45720.0" cy="68580.0"/>
+            <a:off x="5715000.0" y="1748790.0"/>
+            <a:ext cx="0.0" cy="822960.0"/>
           </a:xfrm>
           <a:prstGeom prst="line">
             <a:avLst/>
           </a:prstGeom>
-          <a:ln w="25400">
+          <a:ln w="12700">
             <a:solidFill>
-              <a:srgbClr val="00C8FF"/>
+              <a:srgbClr val="787878"/>
             </a:solidFill>
+            <a:prstDash val="sysDash"/>
           </a:ln>
         </p:spPr>
         <p:style>
@@ -3243,17 +4458,18 @@
           <p:nvPr/>
         </p:nvCxnSpPr>
         <p:spPr>
-          <a:xfrm flipV="1">
-            <a:off x="4343400.0" y="2663190.0"/>
-            <a:ext cx="45720.0" cy="68580.0"/>
+          <a:xfrm>
+            <a:off x="4572000.0" y="1748790.0"/>
+            <a:ext cx="1143000.0" cy="0.0"/>
           </a:xfrm>
           <a:prstGeom prst="line">
             <a:avLst/>
           </a:prstGeom>
-          <a:ln w="25400">
+          <a:ln w="12700">
             <a:solidFill>
-              <a:srgbClr val="00C8FF"/>
+              <a:srgbClr val="787878"/>
             </a:solidFill>
+            <a:prstDash val="sysDash"/>
           </a:ln>
         </p:spPr>
         <p:style>
@@ -3271,41 +4487,51 @@
           </a:fontRef>
         </p:style>
       </p:cxnSp>
-      <p:cxnSp>
-        <p:nvCxnSpPr>
-          <p:cNvPr id="7" name="Connector 6"/>
-          <p:cNvCxnSpPr/>
+      <p:sp>
+        <p:nvSpPr>
+          <p:cNvPr id="7" name="Oval 6"/>
+          <p:cNvSpPr/>
           <p:nvPr/>
-        </p:nvCxnSpPr>
+        </p:nvSpPr>
         <p:spPr>
-          <a:xfrm flipV="1">
-            <a:off x="4389120.0" y="2594610.0"/>
-            <a:ext cx="45720.0" cy="68580.0"/>
+          <a:xfrm>
+            <a:off x="5664200" y="1697990"/>
+            <a:ext cx="101600" cy="101600"/>
           </a:xfrm>
-          <a:prstGeom prst="line">
+          <a:prstGeom prst="ellipse">
             <a:avLst/>
           </a:prstGeom>
-          <a:ln w="25400">
+          <a:solidFill>
+            <a:srgbClr val="0A0A0A"/>
+          </a:solidFill>
+          <a:ln w="12700">
             <a:solidFill>
-              <a:srgbClr val="00C8FF"/>
+              <a:srgbClr val="FFFFFF"/>
             </a:solidFill>
           </a:ln>
         </p:spPr>
         <p:style>
-          <a:lnRef idx="2">
+          <a:lnRef idx="1">
             <a:schemeClr val="accent1"/>
           </a:lnRef>
-          <a:fillRef idx="0">
+          <a:fillRef idx="3">
             <a:schemeClr val="accent1"/>
           </a:fillRef>
-          <a:effectRef idx="1">
+          <a:effectRef idx="2">
             <a:schemeClr val="accent1"/>
           </a:effectRef>
           <a:fontRef idx="minor">
-            <a:schemeClr val="tx1"/>
+            <a:schemeClr val="lt1"/>
           </a:fontRef>
         </p:style>
-      </p:cxnSp>
+        <p:txBody>
+          <a:bodyPr rtlCol="0" anchor="ctr"/>
+          <a:lstStyle/>
+          <a:p>
+            <a:pPr algn="ctr"/>
+          </a:p>
+        </p:txBody>
+      </p:sp>
       <p:cxnSp>
         <p:nvCxnSpPr>
           <p:cNvPr id="8" name="Connector 7"/>
@@ -3313,16 +4539,16 @@
           <p:nvPr/>
         </p:nvCxnSpPr>
         <p:spPr>
-          <a:xfrm flipV="1">
-            <a:off x="4434840.0" y="2526030.0"/>
-            <a:ext cx="45720.0" cy="68580.0"/>
+          <a:xfrm>
+            <a:off x="5394960.0" y="2571750.0"/>
+            <a:ext cx="182880.0" cy="0.0"/>
           </a:xfrm>
           <a:prstGeom prst="line">
             <a:avLst/>
           </a:prstGeom>
-          <a:ln w="25400">
+          <a:ln w="15240">
             <a:solidFill>
-              <a:srgbClr val="00C8FF"/>
+              <a:srgbClr val="B4B4B4"/>
             </a:solidFill>
           </a:ln>
         </p:spPr>
@@ -3348,16 +4574,16 @@
           <p:nvPr/>
         </p:nvCxnSpPr>
         <p:spPr>
-          <a:xfrm flipV="1">
-            <a:off x="4480560.0" y="2434590.0"/>
-            <a:ext cx="45720.0" cy="91440.0"/>
+          <a:xfrm flipH="1">
+            <a:off x="5852160.0" y="2571750.0"/>
+            <a:ext cx="182880.0" cy="0.0"/>
           </a:xfrm>
           <a:prstGeom prst="line">
             <a:avLst/>
           </a:prstGeom>
-          <a:ln w="25400">
+          <a:ln w="15240">
             <a:solidFill>
-              <a:srgbClr val="00C8FF"/>
+              <a:srgbClr val="B4B4B4"/>
             </a:solidFill>
           </a:ln>
         </p:spPr>
@@ -3376,1634 +4602,430 @@
           </a:fontRef>
         </p:style>
       </p:cxnSp>
-      <p:cxnSp>
-        <p:nvCxnSpPr>
-          <p:cNvPr id="10" name="Connector 9"/>
-          <p:cNvCxnSpPr/>
+      <p:sp>
+        <p:nvSpPr>
+          <p:cNvPr id="10" name="Freeform 9"/>
+          <p:cNvSpPr/>
           <p:nvPr/>
-        </p:nvCxnSpPr>
-        <p:spPr>
-          <a:xfrm flipV="1">
-            <a:off x="4526280.0" y="2343150.0"/>
-            <a:ext cx="45720.0" cy="91440.0"/>
-          </a:xfrm>
-          <a:prstGeom prst="line">
-            <a:avLst/>
-          </a:prstGeom>
-          <a:ln w="25400">
-            <a:solidFill>
-              <a:srgbClr val="00C8FF"/>
-            </a:solidFill>
-          </a:ln>
-        </p:spPr>
-        <p:style>
-          <a:lnRef idx="2">
-            <a:schemeClr val="accent1"/>
-          </a:lnRef>
-          <a:fillRef idx="0">
-            <a:schemeClr val="accent1"/>
-          </a:fillRef>
-          <a:effectRef idx="1">
-            <a:schemeClr val="accent1"/>
-          </a:effectRef>
-          <a:fontRef idx="minor">
-            <a:schemeClr val="tx1"/>
-          </a:fontRef>
-        </p:style>
-      </p:cxnSp>
-      <p:cxnSp>
-        <p:nvCxnSpPr>
-          <p:cNvPr id="11" name="Connector 10"/>
-          <p:cNvCxnSpPr/>
-          <p:nvPr/>
-        </p:nvCxnSpPr>
-        <p:spPr>
-          <a:xfrm flipV="1">
-            <a:off x="4572000.0" y="2297430.0"/>
-            <a:ext cx="45720.0" cy="45720.0"/>
-          </a:xfrm>
-          <a:prstGeom prst="line">
-            <a:avLst/>
-          </a:prstGeom>
-          <a:ln w="25400">
-            <a:solidFill>
-              <a:srgbClr val="00C8FF"/>
-            </a:solidFill>
-          </a:ln>
-        </p:spPr>
-        <p:style>
-          <a:lnRef idx="2">
-            <a:schemeClr val="accent1"/>
-          </a:lnRef>
-          <a:fillRef idx="0">
-            <a:schemeClr val="accent1"/>
-          </a:fillRef>
-          <a:effectRef idx="1">
-            <a:schemeClr val="accent1"/>
-          </a:effectRef>
-          <a:fontRef idx="minor">
-            <a:schemeClr val="tx1"/>
-          </a:fontRef>
-        </p:style>
-      </p:cxnSp>
-      <p:cxnSp>
-        <p:nvCxnSpPr>
-          <p:cNvPr id="12" name="Connector 11"/>
-          <p:cNvCxnSpPr/>
-          <p:nvPr/>
-        </p:nvCxnSpPr>
-        <p:spPr>
-          <a:xfrm flipV="1">
-            <a:off x="4617720.0" y="2251710.0"/>
-            <a:ext cx="45720.0" cy="45720.0"/>
-          </a:xfrm>
-          <a:prstGeom prst="line">
-            <a:avLst/>
-          </a:prstGeom>
-          <a:ln w="25400">
-            <a:solidFill>
-              <a:srgbClr val="00C8FF"/>
-            </a:solidFill>
-          </a:ln>
-        </p:spPr>
-        <p:style>
-          <a:lnRef idx="2">
-            <a:schemeClr val="accent1"/>
-          </a:lnRef>
-          <a:fillRef idx="0">
-            <a:schemeClr val="accent1"/>
-          </a:fillRef>
-          <a:effectRef idx="1">
-            <a:schemeClr val="accent1"/>
-          </a:effectRef>
-          <a:fontRef idx="minor">
-            <a:schemeClr val="tx1"/>
-          </a:fontRef>
-        </p:style>
-      </p:cxnSp>
-      <p:cxnSp>
-        <p:nvCxnSpPr>
-          <p:cNvPr id="13" name="Connector 12"/>
-          <p:cNvCxnSpPr/>
-          <p:nvPr/>
-        </p:nvCxnSpPr>
-        <p:spPr>
-          <a:xfrm flipV="1">
-            <a:off x="4663440.0" y="2205990.0"/>
-            <a:ext cx="45720.0" cy="45720.0"/>
-          </a:xfrm>
-          <a:prstGeom prst="line">
-            <a:avLst/>
-          </a:prstGeom>
-          <a:ln w="25400">
-            <a:solidFill>
-              <a:srgbClr val="00C8FF"/>
-            </a:solidFill>
-          </a:ln>
-        </p:spPr>
-        <p:style>
-          <a:lnRef idx="2">
-            <a:schemeClr val="accent1"/>
-          </a:lnRef>
-          <a:fillRef idx="0">
-            <a:schemeClr val="accent1"/>
-          </a:fillRef>
-          <a:effectRef idx="1">
-            <a:schemeClr val="accent1"/>
-          </a:effectRef>
-          <a:fontRef idx="minor">
-            <a:schemeClr val="tx1"/>
-          </a:fontRef>
-        </p:style>
-      </p:cxnSp>
-      <p:cxnSp>
-        <p:nvCxnSpPr>
-          <p:cNvPr id="14" name="Connector 13"/>
-          <p:cNvCxnSpPr/>
-          <p:nvPr/>
-        </p:nvCxnSpPr>
-        <p:spPr>
-          <a:xfrm flipV="1">
-            <a:off x="4709160.0" y="2160270.0"/>
-            <a:ext cx="45720.0" cy="45720.0"/>
-          </a:xfrm>
-          <a:prstGeom prst="line">
-            <a:avLst/>
-          </a:prstGeom>
-          <a:ln w="25400">
-            <a:solidFill>
-              <a:srgbClr val="00C8FF"/>
-            </a:solidFill>
-          </a:ln>
-        </p:spPr>
-        <p:style>
-          <a:lnRef idx="2">
-            <a:schemeClr val="accent1"/>
-          </a:lnRef>
-          <a:fillRef idx="0">
-            <a:schemeClr val="accent1"/>
-          </a:fillRef>
-          <a:effectRef idx="1">
-            <a:schemeClr val="accent1"/>
-          </a:effectRef>
-          <a:fontRef idx="minor">
-            <a:schemeClr val="tx1"/>
-          </a:fontRef>
-        </p:style>
-      </p:cxnSp>
-      <p:cxnSp>
-        <p:nvCxnSpPr>
-          <p:cNvPr id="15" name="Connector 14"/>
-          <p:cNvCxnSpPr/>
-          <p:nvPr/>
-        </p:nvCxnSpPr>
-        <p:spPr>
-          <a:xfrm flipV="1">
-            <a:off x="4754880.0" y="2114550.0"/>
-            <a:ext cx="45720.0" cy="45720.0"/>
-          </a:xfrm>
-          <a:prstGeom prst="line">
-            <a:avLst/>
-          </a:prstGeom>
-          <a:ln w="25400">
-            <a:solidFill>
-              <a:srgbClr val="00C8FF"/>
-            </a:solidFill>
-          </a:ln>
-        </p:spPr>
-        <p:style>
-          <a:lnRef idx="2">
-            <a:schemeClr val="accent1"/>
-          </a:lnRef>
-          <a:fillRef idx="0">
-            <a:schemeClr val="accent1"/>
-          </a:fillRef>
-          <a:effectRef idx="1">
-            <a:schemeClr val="accent1"/>
-          </a:effectRef>
-          <a:fontRef idx="minor">
-            <a:schemeClr val="tx1"/>
-          </a:fontRef>
-        </p:style>
-      </p:cxnSp>
-      <p:cxnSp>
-        <p:nvCxnSpPr>
-          <p:cNvPr id="16" name="Connector 15"/>
-          <p:cNvCxnSpPr/>
-          <p:nvPr/>
-        </p:nvCxnSpPr>
-        <p:spPr>
-          <a:xfrm flipV="1">
-            <a:off x="4800600.0" y="2091690.0"/>
-            <a:ext cx="45720.0" cy="22860.0"/>
-          </a:xfrm>
-          <a:prstGeom prst="line">
-            <a:avLst/>
-          </a:prstGeom>
-          <a:ln w="25400">
-            <a:solidFill>
-              <a:srgbClr val="00C8FF"/>
-            </a:solidFill>
-          </a:ln>
-        </p:spPr>
-        <p:style>
-          <a:lnRef idx="2">
-            <a:schemeClr val="accent1"/>
-          </a:lnRef>
-          <a:fillRef idx="0">
-            <a:schemeClr val="accent1"/>
-          </a:fillRef>
-          <a:effectRef idx="1">
-            <a:schemeClr val="accent1"/>
-          </a:effectRef>
-          <a:fontRef idx="minor">
-            <a:schemeClr val="tx1"/>
-          </a:fontRef>
-        </p:style>
-      </p:cxnSp>
-      <p:cxnSp>
-        <p:nvCxnSpPr>
-          <p:cNvPr id="17" name="Connector 16"/>
-          <p:cNvCxnSpPr/>
-          <p:nvPr/>
-        </p:nvCxnSpPr>
-        <p:spPr>
-          <a:xfrm flipV="1">
-            <a:off x="4846320.0" y="2068830.0"/>
-            <a:ext cx="45720.0" cy="22860.0"/>
-          </a:xfrm>
-          <a:prstGeom prst="line">
-            <a:avLst/>
-          </a:prstGeom>
-          <a:ln w="25400">
-            <a:solidFill>
-              <a:srgbClr val="00C8FF"/>
-            </a:solidFill>
-          </a:ln>
-        </p:spPr>
-        <p:style>
-          <a:lnRef idx="2">
-            <a:schemeClr val="accent1"/>
-          </a:lnRef>
-          <a:fillRef idx="0">
-            <a:schemeClr val="accent1"/>
-          </a:fillRef>
-          <a:effectRef idx="1">
-            <a:schemeClr val="accent1"/>
-          </a:effectRef>
-          <a:fontRef idx="minor">
-            <a:schemeClr val="tx1"/>
-          </a:fontRef>
-        </p:style>
-      </p:cxnSp>
-      <p:cxnSp>
-        <p:nvCxnSpPr>
-          <p:cNvPr id="18" name="Connector 17"/>
-          <p:cNvCxnSpPr/>
-          <p:nvPr/>
-        </p:nvCxnSpPr>
-        <p:spPr>
-          <a:xfrm flipV="1">
-            <a:off x="4892040.0" y="2045970.0"/>
-            <a:ext cx="45720.0" cy="22860.0"/>
-          </a:xfrm>
-          <a:prstGeom prst="line">
-            <a:avLst/>
-          </a:prstGeom>
-          <a:ln w="25400">
-            <a:solidFill>
-              <a:srgbClr val="00C8FF"/>
-            </a:solidFill>
-          </a:ln>
-        </p:spPr>
-        <p:style>
-          <a:lnRef idx="2">
-            <a:schemeClr val="accent1"/>
-          </a:lnRef>
-          <a:fillRef idx="0">
-            <a:schemeClr val="accent1"/>
-          </a:fillRef>
-          <a:effectRef idx="1">
-            <a:schemeClr val="accent1"/>
-          </a:effectRef>
-          <a:fontRef idx="minor">
-            <a:schemeClr val="tx1"/>
-          </a:fontRef>
-        </p:style>
-      </p:cxnSp>
-      <p:cxnSp>
-        <p:nvCxnSpPr>
-          <p:cNvPr id="19" name="Connector 18"/>
-          <p:cNvCxnSpPr/>
-          <p:nvPr/>
-        </p:nvCxnSpPr>
-        <p:spPr>
-          <a:xfrm flipV="1">
-            <a:off x="4937760.0" y="2023110.0"/>
-            <a:ext cx="45720.0" cy="22860.0"/>
-          </a:xfrm>
-          <a:prstGeom prst="line">
-            <a:avLst/>
-          </a:prstGeom>
-          <a:ln w="25400">
-            <a:solidFill>
-              <a:srgbClr val="00C8FF"/>
-            </a:solidFill>
-          </a:ln>
-        </p:spPr>
-        <p:style>
-          <a:lnRef idx="2">
-            <a:schemeClr val="accent1"/>
-          </a:lnRef>
-          <a:fillRef idx="0">
-            <a:schemeClr val="accent1"/>
-          </a:fillRef>
-          <a:effectRef idx="1">
-            <a:schemeClr val="accent1"/>
-          </a:effectRef>
-          <a:fontRef idx="minor">
-            <a:schemeClr val="tx1"/>
-          </a:fontRef>
-        </p:style>
-      </p:cxnSp>
-      <p:cxnSp>
-        <p:nvCxnSpPr>
-          <p:cNvPr id="20" name="Connector 19"/>
-          <p:cNvCxnSpPr/>
-          <p:nvPr/>
-        </p:nvCxnSpPr>
-        <p:spPr>
-          <a:xfrm flipV="1">
-            <a:off x="4983480.0" y="2000250.0"/>
-            <a:ext cx="45720.0" cy="22860.0"/>
-          </a:xfrm>
-          <a:prstGeom prst="line">
-            <a:avLst/>
-          </a:prstGeom>
-          <a:ln w="25400">
-            <a:solidFill>
-              <a:srgbClr val="00C8FF"/>
-            </a:solidFill>
-          </a:ln>
-        </p:spPr>
-        <p:style>
-          <a:lnRef idx="2">
-            <a:schemeClr val="accent1"/>
-          </a:lnRef>
-          <a:fillRef idx="0">
-            <a:schemeClr val="accent1"/>
-          </a:fillRef>
-          <a:effectRef idx="1">
-            <a:schemeClr val="accent1"/>
-          </a:effectRef>
-          <a:fontRef idx="minor">
-            <a:schemeClr val="tx1"/>
-          </a:fontRef>
-        </p:style>
-      </p:cxnSp>
-      <p:cxnSp>
-        <p:nvCxnSpPr>
-          <p:cNvPr id="21" name="Connector 20"/>
-          <p:cNvCxnSpPr/>
-          <p:nvPr/>
-        </p:nvCxnSpPr>
-        <p:spPr>
-          <a:xfrm flipV="1">
-            <a:off x="5029200.0" y="1977390.0"/>
-            <a:ext cx="45720.0" cy="22860.0"/>
-          </a:xfrm>
-          <a:prstGeom prst="line">
-            <a:avLst/>
-          </a:prstGeom>
-          <a:ln w="25400">
-            <a:solidFill>
-              <a:srgbClr val="00C8FF"/>
-            </a:solidFill>
-          </a:ln>
-        </p:spPr>
-        <p:style>
-          <a:lnRef idx="2">
-            <a:schemeClr val="accent1"/>
-          </a:lnRef>
-          <a:fillRef idx="0">
-            <a:schemeClr val="accent1"/>
-          </a:fillRef>
-          <a:effectRef idx="1">
-            <a:schemeClr val="accent1"/>
-          </a:effectRef>
-          <a:fontRef idx="minor">
-            <a:schemeClr val="tx1"/>
-          </a:fontRef>
-        </p:style>
-      </p:cxnSp>
-      <p:cxnSp>
-        <p:nvCxnSpPr>
-          <p:cNvPr id="22" name="Connector 21"/>
-          <p:cNvCxnSpPr/>
-          <p:nvPr/>
-        </p:nvCxnSpPr>
-        <p:spPr>
-          <a:xfrm flipV="1">
-            <a:off x="5074920.0" y="1954530.0"/>
-            <a:ext cx="45720.0" cy="22860.0"/>
-          </a:xfrm>
-          <a:prstGeom prst="line">
-            <a:avLst/>
-          </a:prstGeom>
-          <a:ln w="25400">
-            <a:solidFill>
-              <a:srgbClr val="00C8FF"/>
-            </a:solidFill>
-          </a:ln>
-        </p:spPr>
-        <p:style>
-          <a:lnRef idx="2">
-            <a:schemeClr val="accent1"/>
-          </a:lnRef>
-          <a:fillRef idx="0">
-            <a:schemeClr val="accent1"/>
-          </a:fillRef>
-          <a:effectRef idx="1">
-            <a:schemeClr val="accent1"/>
-          </a:effectRef>
-          <a:fontRef idx="minor">
-            <a:schemeClr val="tx1"/>
-          </a:fontRef>
-        </p:style>
-      </p:cxnSp>
-      <p:cxnSp>
-        <p:nvCxnSpPr>
-          <p:cNvPr id="23" name="Connector 22"/>
-          <p:cNvCxnSpPr/>
-          <p:nvPr/>
-        </p:nvCxnSpPr>
-        <p:spPr>
-          <a:xfrm flipV="1">
-            <a:off x="5120640.0" y="1931670.0"/>
-            <a:ext cx="45720.0" cy="22860.0"/>
-          </a:xfrm>
-          <a:prstGeom prst="line">
-            <a:avLst/>
-          </a:prstGeom>
-          <a:ln w="25400">
-            <a:solidFill>
-              <a:srgbClr val="00C8FF"/>
-            </a:solidFill>
-          </a:ln>
-        </p:spPr>
-        <p:style>
-          <a:lnRef idx="2">
-            <a:schemeClr val="accent1"/>
-          </a:lnRef>
-          <a:fillRef idx="0">
-            <a:schemeClr val="accent1"/>
-          </a:fillRef>
-          <a:effectRef idx="1">
-            <a:schemeClr val="accent1"/>
-          </a:effectRef>
-          <a:fontRef idx="minor">
-            <a:schemeClr val="tx1"/>
-          </a:fontRef>
-        </p:style>
-      </p:cxnSp>
-      <p:cxnSp>
-        <p:nvCxnSpPr>
-          <p:cNvPr id="24" name="Connector 23"/>
-          <p:cNvCxnSpPr/>
-          <p:nvPr/>
-        </p:nvCxnSpPr>
-        <p:spPr>
-          <a:xfrm flipV="1">
-            <a:off x="5166360.0" y="1908810.0"/>
-            <a:ext cx="45720.0" cy="22860.0"/>
-          </a:xfrm>
-          <a:prstGeom prst="line">
-            <a:avLst/>
-          </a:prstGeom>
-          <a:ln w="25400">
-            <a:solidFill>
-              <a:srgbClr val="00C8FF"/>
-            </a:solidFill>
-          </a:ln>
-        </p:spPr>
-        <p:style>
-          <a:lnRef idx="2">
-            <a:schemeClr val="accent1"/>
-          </a:lnRef>
-          <a:fillRef idx="0">
-            <a:schemeClr val="accent1"/>
-          </a:fillRef>
-          <a:effectRef idx="1">
-            <a:schemeClr val="accent1"/>
-          </a:effectRef>
-          <a:fontRef idx="minor">
-            <a:schemeClr val="tx1"/>
-          </a:fontRef>
-        </p:style>
-      </p:cxnSp>
-      <p:cxnSp>
-        <p:nvCxnSpPr>
-          <p:cNvPr id="25" name="Connector 24"/>
-          <p:cNvCxnSpPr/>
-          <p:nvPr/>
-        </p:nvCxnSpPr>
-        <p:spPr>
-          <a:xfrm flipV="1">
-            <a:off x="5212080.0" y="1885950.0"/>
-            <a:ext cx="45720.0" cy="22860.0"/>
-          </a:xfrm>
-          <a:prstGeom prst="line">
-            <a:avLst/>
-          </a:prstGeom>
-          <a:ln w="25400">
-            <a:solidFill>
-              <a:srgbClr val="00C8FF"/>
-            </a:solidFill>
-          </a:ln>
-        </p:spPr>
-        <p:style>
-          <a:lnRef idx="2">
-            <a:schemeClr val="accent1"/>
-          </a:lnRef>
-          <a:fillRef idx="0">
-            <a:schemeClr val="accent1"/>
-          </a:fillRef>
-          <a:effectRef idx="1">
-            <a:schemeClr val="accent1"/>
-          </a:effectRef>
-          <a:fontRef idx="minor">
-            <a:schemeClr val="tx1"/>
-          </a:fontRef>
-        </p:style>
-      </p:cxnSp>
-      <p:cxnSp>
-        <p:nvCxnSpPr>
-          <p:cNvPr id="26" name="Connector 25"/>
-          <p:cNvCxnSpPr/>
-          <p:nvPr/>
-        </p:nvCxnSpPr>
-        <p:spPr>
-          <a:xfrm flipV="1">
-            <a:off x="5257800.0" y="1863090.0"/>
-            <a:ext cx="45720.0" cy="22860.0"/>
-          </a:xfrm>
-          <a:prstGeom prst="line">
-            <a:avLst/>
-          </a:prstGeom>
-          <a:ln w="25400">
-            <a:solidFill>
-              <a:srgbClr val="00C8FF"/>
-            </a:solidFill>
-          </a:ln>
-        </p:spPr>
-        <p:style>
-          <a:lnRef idx="2">
-            <a:schemeClr val="accent1"/>
-          </a:lnRef>
-          <a:fillRef idx="0">
-            <a:schemeClr val="accent1"/>
-          </a:fillRef>
-          <a:effectRef idx="1">
-            <a:schemeClr val="accent1"/>
-          </a:effectRef>
-          <a:fontRef idx="minor">
-            <a:schemeClr val="tx1"/>
-          </a:fontRef>
-        </p:style>
-      </p:cxnSp>
-      <p:cxnSp>
-        <p:nvCxnSpPr>
-          <p:cNvPr id="27" name="Connector 26"/>
-          <p:cNvCxnSpPr/>
-          <p:nvPr/>
-        </p:nvCxnSpPr>
-        <p:spPr>
-          <a:xfrm flipV="1">
-            <a:off x="5303520.0" y="1840230.0"/>
-            <a:ext cx="45720.0" cy="22860.0"/>
-          </a:xfrm>
-          <a:prstGeom prst="line">
-            <a:avLst/>
-          </a:prstGeom>
-          <a:ln w="25400">
-            <a:solidFill>
-              <a:srgbClr val="00C8FF"/>
-            </a:solidFill>
-          </a:ln>
-        </p:spPr>
-        <p:style>
-          <a:lnRef idx="2">
-            <a:schemeClr val="accent1"/>
-          </a:lnRef>
-          <a:fillRef idx="0">
-            <a:schemeClr val="accent1"/>
-          </a:fillRef>
-          <a:effectRef idx="1">
-            <a:schemeClr val="accent1"/>
-          </a:effectRef>
-          <a:fontRef idx="minor">
-            <a:schemeClr val="tx1"/>
-          </a:fontRef>
-        </p:style>
-      </p:cxnSp>
-      <p:cxnSp>
-        <p:nvCxnSpPr>
-          <p:cNvPr id="28" name="Connector 27"/>
-          <p:cNvCxnSpPr/>
-          <p:nvPr/>
-        </p:nvCxnSpPr>
-        <p:spPr>
-          <a:xfrm flipV="1">
-            <a:off x="5349240.0" y="1817370.0"/>
-            <a:ext cx="45720.0" cy="22860.0"/>
-          </a:xfrm>
-          <a:prstGeom prst="line">
-            <a:avLst/>
-          </a:prstGeom>
-          <a:ln w="25400">
-            <a:solidFill>
-              <a:srgbClr val="00C8FF"/>
-            </a:solidFill>
-          </a:ln>
-        </p:spPr>
-        <p:style>
-          <a:lnRef idx="2">
-            <a:schemeClr val="accent1"/>
-          </a:lnRef>
-          <a:fillRef idx="0">
-            <a:schemeClr val="accent1"/>
-          </a:fillRef>
-          <a:effectRef idx="1">
-            <a:schemeClr val="accent1"/>
-          </a:effectRef>
-          <a:fontRef idx="minor">
-            <a:schemeClr val="tx1"/>
-          </a:fontRef>
-        </p:style>
-      </p:cxnSp>
-      <p:cxnSp>
-        <p:nvCxnSpPr>
-          <p:cNvPr id="29" name="Connector 28"/>
-          <p:cNvCxnSpPr/>
-          <p:nvPr/>
-        </p:nvCxnSpPr>
-        <p:spPr>
-          <a:xfrm flipV="1">
-            <a:off x="5394960.0" y="1794510.0"/>
-            <a:ext cx="45720.0" cy="22860.0"/>
-          </a:xfrm>
-          <a:prstGeom prst="line">
-            <a:avLst/>
-          </a:prstGeom>
-          <a:ln w="25400">
-            <a:solidFill>
-              <a:srgbClr val="00C8FF"/>
-            </a:solidFill>
-          </a:ln>
-        </p:spPr>
-        <p:style>
-          <a:lnRef idx="2">
-            <a:schemeClr val="accent1"/>
-          </a:lnRef>
-          <a:fillRef idx="0">
-            <a:schemeClr val="accent1"/>
-          </a:fillRef>
-          <a:effectRef idx="1">
-            <a:schemeClr val="accent1"/>
-          </a:effectRef>
-          <a:fontRef idx="minor">
-            <a:schemeClr val="tx1"/>
-          </a:fontRef>
-        </p:style>
-      </p:cxnSp>
-      <p:cxnSp>
-        <p:nvCxnSpPr>
-          <p:cNvPr id="30" name="Connector 29"/>
-          <p:cNvCxnSpPr/>
-          <p:nvPr/>
-        </p:nvCxnSpPr>
-        <p:spPr>
-          <a:xfrm flipV="1">
-            <a:off x="5440680.0" y="1771650.0"/>
-            <a:ext cx="45720.0" cy="22860.0"/>
-          </a:xfrm>
-          <a:prstGeom prst="line">
-            <a:avLst/>
-          </a:prstGeom>
-          <a:ln w="25400">
-            <a:solidFill>
-              <a:srgbClr val="00C8FF"/>
-            </a:solidFill>
-          </a:ln>
-        </p:spPr>
-        <p:style>
-          <a:lnRef idx="2">
-            <a:schemeClr val="accent1"/>
-          </a:lnRef>
-          <a:fillRef idx="0">
-            <a:schemeClr val="accent1"/>
-          </a:fillRef>
-          <a:effectRef idx="1">
-            <a:schemeClr val="accent1"/>
-          </a:effectRef>
-          <a:fontRef idx="minor">
-            <a:schemeClr val="tx1"/>
-          </a:fontRef>
-        </p:style>
-      </p:cxnSp>
-      <p:cxnSp>
-        <p:nvCxnSpPr>
-          <p:cNvPr id="31" name="Connector 30"/>
-          <p:cNvCxnSpPr/>
-          <p:nvPr/>
-        </p:nvCxnSpPr>
-        <p:spPr>
-          <a:xfrm flipV="1">
-            <a:off x="5486400.0" y="1748790.0"/>
-            <a:ext cx="45720.0" cy="22860.0"/>
-          </a:xfrm>
-          <a:prstGeom prst="line">
-            <a:avLst/>
-          </a:prstGeom>
-          <a:ln w="25400">
-            <a:solidFill>
-              <a:srgbClr val="00C8FF"/>
-            </a:solidFill>
-          </a:ln>
-        </p:spPr>
-        <p:style>
-          <a:lnRef idx="2">
-            <a:schemeClr val="accent1"/>
-          </a:lnRef>
-          <a:fillRef idx="0">
-            <a:schemeClr val="accent1"/>
-          </a:fillRef>
-          <a:effectRef idx="1">
-            <a:schemeClr val="accent1"/>
-          </a:effectRef>
-          <a:fontRef idx="minor">
-            <a:schemeClr val="tx1"/>
-          </a:fontRef>
-        </p:style>
-      </p:cxnSp>
-      <p:cxnSp>
-        <p:nvCxnSpPr>
-          <p:cNvPr id="32" name="Connector 31"/>
-          <p:cNvCxnSpPr/>
-          <p:nvPr/>
-        </p:nvCxnSpPr>
-        <p:spPr>
-          <a:xfrm flipV="1">
-            <a:off x="5532120.0" y="1725930.0"/>
-            <a:ext cx="45720.0" cy="22860.0"/>
-          </a:xfrm>
-          <a:prstGeom prst="line">
-            <a:avLst/>
-          </a:prstGeom>
-          <a:ln w="25400">
-            <a:solidFill>
-              <a:srgbClr val="00C8FF"/>
-            </a:solidFill>
-          </a:ln>
-        </p:spPr>
-        <p:style>
-          <a:lnRef idx="2">
-            <a:schemeClr val="accent1"/>
-          </a:lnRef>
-          <a:fillRef idx="0">
-            <a:schemeClr val="accent1"/>
-          </a:fillRef>
-          <a:effectRef idx="1">
-            <a:schemeClr val="accent1"/>
-          </a:effectRef>
-          <a:fontRef idx="minor">
-            <a:schemeClr val="tx1"/>
-          </a:fontRef>
-        </p:style>
-      </p:cxnSp>
-      <p:cxnSp>
-        <p:nvCxnSpPr>
-          <p:cNvPr id="33" name="Connector 32"/>
-          <p:cNvCxnSpPr/>
-          <p:nvPr/>
-        </p:nvCxnSpPr>
-        <p:spPr>
-          <a:xfrm flipV="1">
-            <a:off x="5577840.0" y="1703070.0"/>
-            <a:ext cx="45720.0" cy="22860.0"/>
-          </a:xfrm>
-          <a:prstGeom prst="line">
-            <a:avLst/>
-          </a:prstGeom>
-          <a:ln w="25400">
-            <a:solidFill>
-              <a:srgbClr val="00C8FF"/>
-            </a:solidFill>
-          </a:ln>
-        </p:spPr>
-        <p:style>
-          <a:lnRef idx="2">
-            <a:schemeClr val="accent1"/>
-          </a:lnRef>
-          <a:fillRef idx="0">
-            <a:schemeClr val="accent1"/>
-          </a:fillRef>
-          <a:effectRef idx="1">
-            <a:schemeClr val="accent1"/>
-          </a:effectRef>
-          <a:fontRef idx="minor">
-            <a:schemeClr val="tx1"/>
-          </a:fontRef>
-        </p:style>
-      </p:cxnSp>
-      <p:cxnSp>
-        <p:nvCxnSpPr>
-          <p:cNvPr id="34" name="Connector 33"/>
-          <p:cNvCxnSpPr/>
-          <p:nvPr/>
-        </p:nvCxnSpPr>
-        <p:spPr>
-          <a:xfrm flipV="1">
-            <a:off x="5623560.0" y="1689354.0"/>
-            <a:ext cx="45720.0" cy="13716.0"/>
-          </a:xfrm>
-          <a:prstGeom prst="line">
-            <a:avLst/>
-          </a:prstGeom>
-          <a:ln w="25400">
-            <a:solidFill>
-              <a:srgbClr val="00C8FF"/>
-            </a:solidFill>
-          </a:ln>
-        </p:spPr>
-        <p:style>
-          <a:lnRef idx="2">
-            <a:schemeClr val="accent1"/>
-          </a:lnRef>
-          <a:fillRef idx="0">
-            <a:schemeClr val="accent1"/>
-          </a:fillRef>
-          <a:effectRef idx="1">
-            <a:schemeClr val="accent1"/>
-          </a:effectRef>
-          <a:fontRef idx="minor">
-            <a:schemeClr val="tx1"/>
-          </a:fontRef>
-        </p:style>
-      </p:cxnSp>
-      <p:cxnSp>
-        <p:nvCxnSpPr>
-          <p:cNvPr id="35" name="Connector 34"/>
-          <p:cNvCxnSpPr/>
-          <p:nvPr/>
-        </p:nvCxnSpPr>
-        <p:spPr>
-          <a:xfrm flipV="1">
-            <a:off x="5669280.0" y="1675638.0"/>
-            <a:ext cx="45720.0" cy="13716.0"/>
-          </a:xfrm>
-          <a:prstGeom prst="line">
-            <a:avLst/>
-          </a:prstGeom>
-          <a:ln w="25400">
-            <a:solidFill>
-              <a:srgbClr val="00C8FF"/>
-            </a:solidFill>
-          </a:ln>
-        </p:spPr>
-        <p:style>
-          <a:lnRef idx="2">
-            <a:schemeClr val="accent1"/>
-          </a:lnRef>
-          <a:fillRef idx="0">
-            <a:schemeClr val="accent1"/>
-          </a:fillRef>
-          <a:effectRef idx="1">
-            <a:schemeClr val="accent1"/>
-          </a:effectRef>
-          <a:fontRef idx="minor">
-            <a:schemeClr val="tx1"/>
-          </a:fontRef>
-        </p:style>
-      </p:cxnSp>
-      <p:cxnSp>
-        <p:nvCxnSpPr>
-          <p:cNvPr id="36" name="Connector 35"/>
-          <p:cNvCxnSpPr/>
-          <p:nvPr/>
-        </p:nvCxnSpPr>
-        <p:spPr>
-          <a:xfrm flipV="1">
-            <a:off x="5715000.0" y="1661922.0"/>
-            <a:ext cx="45720.0" cy="13716.0"/>
-          </a:xfrm>
-          <a:prstGeom prst="line">
-            <a:avLst/>
-          </a:prstGeom>
-          <a:ln w="25400">
-            <a:solidFill>
-              <a:srgbClr val="00C8FF"/>
-            </a:solidFill>
-          </a:ln>
-        </p:spPr>
-        <p:style>
-          <a:lnRef idx="2">
-            <a:schemeClr val="accent1"/>
-          </a:lnRef>
-          <a:fillRef idx="0">
-            <a:schemeClr val="accent1"/>
-          </a:fillRef>
-          <a:effectRef idx="1">
-            <a:schemeClr val="accent1"/>
-          </a:effectRef>
-          <a:fontRef idx="minor">
-            <a:schemeClr val="tx1"/>
-          </a:fontRef>
-        </p:style>
-      </p:cxnSp>
-      <p:cxnSp>
-        <p:nvCxnSpPr>
-          <p:cNvPr id="37" name="Connector 36"/>
-          <p:cNvCxnSpPr/>
-          <p:nvPr/>
-        </p:nvCxnSpPr>
-        <p:spPr>
-          <a:xfrm flipV="1">
-            <a:off x="5760720.0" y="1648206.0"/>
-            <a:ext cx="45720.0" cy="13716.0"/>
-          </a:xfrm>
-          <a:prstGeom prst="line">
-            <a:avLst/>
-          </a:prstGeom>
-          <a:ln w="25400">
-            <a:solidFill>
-              <a:srgbClr val="00C8FF"/>
-            </a:solidFill>
-          </a:ln>
-        </p:spPr>
-        <p:style>
-          <a:lnRef idx="2">
-            <a:schemeClr val="accent1"/>
-          </a:lnRef>
-          <a:fillRef idx="0">
-            <a:schemeClr val="accent1"/>
-          </a:fillRef>
-          <a:effectRef idx="1">
-            <a:schemeClr val="accent1"/>
-          </a:effectRef>
-          <a:fontRef idx="minor">
-            <a:schemeClr val="tx1"/>
-          </a:fontRef>
-        </p:style>
-      </p:cxnSp>
-      <p:cxnSp>
-        <p:nvCxnSpPr>
-          <p:cNvPr id="38" name="Connector 37"/>
-          <p:cNvCxnSpPr/>
-          <p:nvPr/>
-        </p:nvCxnSpPr>
-        <p:spPr>
-          <a:xfrm flipV="1">
-            <a:off x="5806440.0" y="1634490.0"/>
-            <a:ext cx="45720.0" cy="13716.0"/>
-          </a:xfrm>
-          <a:prstGeom prst="line">
-            <a:avLst/>
-          </a:prstGeom>
-          <a:ln w="25400">
-            <a:solidFill>
-              <a:srgbClr val="00C8FF"/>
-            </a:solidFill>
-          </a:ln>
-        </p:spPr>
-        <p:style>
-          <a:lnRef idx="2">
-            <a:schemeClr val="accent1"/>
-          </a:lnRef>
-          <a:fillRef idx="0">
-            <a:schemeClr val="accent1"/>
-          </a:fillRef>
-          <a:effectRef idx="1">
-            <a:schemeClr val="accent1"/>
-          </a:effectRef>
-          <a:fontRef idx="minor">
-            <a:schemeClr val="tx1"/>
-          </a:fontRef>
-        </p:style>
-      </p:cxnSp>
-      <p:cxnSp>
-        <p:nvCxnSpPr>
-          <p:cNvPr id="39" name="Connector 38"/>
-          <p:cNvCxnSpPr/>
-          <p:nvPr/>
-        </p:nvCxnSpPr>
-        <p:spPr>
-          <a:xfrm flipV="1">
-            <a:off x="5852160.0" y="1625346.0"/>
-            <a:ext cx="45720.0" cy="9144.0"/>
-          </a:xfrm>
-          <a:prstGeom prst="line">
-            <a:avLst/>
-          </a:prstGeom>
-          <a:ln w="25400">
-            <a:solidFill>
-              <a:srgbClr val="00C8FF"/>
-            </a:solidFill>
-          </a:ln>
-        </p:spPr>
-        <p:style>
-          <a:lnRef idx="2">
-            <a:schemeClr val="accent1"/>
-          </a:lnRef>
-          <a:fillRef idx="0">
-            <a:schemeClr val="accent1"/>
-          </a:fillRef>
-          <a:effectRef idx="1">
-            <a:schemeClr val="accent1"/>
-          </a:effectRef>
-          <a:fontRef idx="minor">
-            <a:schemeClr val="tx1"/>
-          </a:fontRef>
-        </p:style>
-      </p:cxnSp>
-      <p:cxnSp>
-        <p:nvCxnSpPr>
-          <p:cNvPr id="40" name="Connector 39"/>
-          <p:cNvCxnSpPr/>
-          <p:nvPr/>
-        </p:nvCxnSpPr>
-        <p:spPr>
-          <a:xfrm flipV="1">
-            <a:off x="5897880.0" y="1616202.0"/>
-            <a:ext cx="45720.0" cy="9144.0"/>
-          </a:xfrm>
-          <a:prstGeom prst="line">
-            <a:avLst/>
-          </a:prstGeom>
-          <a:ln w="25400">
-            <a:solidFill>
-              <a:srgbClr val="00C8FF"/>
-            </a:solidFill>
-          </a:ln>
-        </p:spPr>
-        <p:style>
-          <a:lnRef idx="2">
-            <a:schemeClr val="accent1"/>
-          </a:lnRef>
-          <a:fillRef idx="0">
-            <a:schemeClr val="accent1"/>
-          </a:fillRef>
-          <a:effectRef idx="1">
-            <a:schemeClr val="accent1"/>
-          </a:effectRef>
-          <a:fontRef idx="minor">
-            <a:schemeClr val="tx1"/>
-          </a:fontRef>
-        </p:style>
-      </p:cxnSp>
-      <p:cxnSp>
-        <p:nvCxnSpPr>
-          <p:cNvPr id="41" name="Connector 40"/>
-          <p:cNvCxnSpPr/>
-          <p:nvPr/>
-        </p:nvCxnSpPr>
-        <p:spPr>
-          <a:xfrm flipV="1">
-            <a:off x="5943600.0" y="1611630.0"/>
-            <a:ext cx="45720.0" cy="4572.0"/>
-          </a:xfrm>
-          <a:prstGeom prst="line">
-            <a:avLst/>
-          </a:prstGeom>
-          <a:ln w="25400">
-            <a:solidFill>
-              <a:srgbClr val="00C8FF"/>
-            </a:solidFill>
-          </a:ln>
-        </p:spPr>
-        <p:style>
-          <a:lnRef idx="2">
-            <a:schemeClr val="accent1"/>
-          </a:lnRef>
-          <a:fillRef idx="0">
-            <a:schemeClr val="accent1"/>
-          </a:fillRef>
-          <a:effectRef idx="1">
-            <a:schemeClr val="accent1"/>
-          </a:effectRef>
-          <a:fontRef idx="minor">
-            <a:schemeClr val="tx1"/>
-          </a:fontRef>
-        </p:style>
-      </p:cxnSp>
-      <p:cxnSp>
-        <p:nvCxnSpPr>
-          <p:cNvPr id="42" name="Connector 41"/>
-          <p:cNvCxnSpPr/>
-          <p:nvPr/>
-        </p:nvCxnSpPr>
+        </p:nvSpPr>
         <p:spPr>
           <a:xfrm>
-            <a:off x="5989320.0" y="1611630.0"/>
-            <a:ext cx="45720.0" cy="0.0"/>
+            <a:off x="5257800" y="1748799"/>
+            <a:ext cx="452628" cy="91431"/>
           </a:xfrm>
-          <a:prstGeom prst="line">
+          <a:custGeom>
             <a:avLst/>
-          </a:prstGeom>
-          <a:ln w="25400">
+            <a:gdLst/>
+            <a:ahLst/>
+            <a:cxnLst/>
+            <a:rect l="l" t="t" r="r" b="b"/>
+            <a:pathLst>
+              <a:path w="452628" h="91431">
+                <a:moveTo>
+                  <a:pt x="0" y="91431"/>
+                </a:moveTo>
+                <a:lnTo>
+                  <a:pt x="6235" y="88933"/>
+                </a:lnTo>
+                <a:close/>
+                <a:lnTo>
+                  <a:pt x="12469" y="86439"/>
+                </a:lnTo>
+                <a:close/>
+                <a:lnTo>
+                  <a:pt x="18704" y="83947"/>
+                </a:lnTo>
+                <a:close/>
+                <a:lnTo>
+                  <a:pt x="24938" y="81457"/>
+                </a:lnTo>
+                <a:close/>
+                <a:lnTo>
+                  <a:pt x="31173" y="78966"/>
+                </a:lnTo>
+                <a:close/>
+                <a:lnTo>
+                  <a:pt x="37407" y="76473"/>
+                </a:lnTo>
+                <a:close/>
+                <a:lnTo>
+                  <a:pt x="43642" y="73976"/>
+                </a:lnTo>
+                <a:close/>
+                <a:lnTo>
+                  <a:pt x="49876" y="71475"/>
+                </a:lnTo>
+                <a:close/>
+                <a:lnTo>
+                  <a:pt x="56111" y="68973"/>
+                </a:lnTo>
+                <a:close/>
+                <a:lnTo>
+                  <a:pt x="62345" y="66479"/>
+                </a:lnTo>
+                <a:close/>
+                <a:lnTo>
+                  <a:pt x="68580" y="63999"/>
+                </a:lnTo>
+                <a:close/>
+                <a:lnTo>
+                  <a:pt x="74815" y="61536"/>
+                </a:lnTo>
+                <a:close/>
+                <a:lnTo>
+                  <a:pt x="81049" y="59066"/>
+                </a:lnTo>
+                <a:close/>
+                <a:lnTo>
+                  <a:pt x="87284" y="56560"/>
+                </a:lnTo>
+                <a:close/>
+                <a:lnTo>
+                  <a:pt x="93518" y="53990"/>
+                </a:lnTo>
+                <a:close/>
+                <a:lnTo>
+                  <a:pt x="99753" y="51379"/>
+                </a:lnTo>
+                <a:close/>
+                <a:lnTo>
+                  <a:pt x="105987" y="48828"/>
+                </a:lnTo>
+                <a:close/>
+                <a:lnTo>
+                  <a:pt x="112222" y="46448"/>
+                </a:lnTo>
+                <a:close/>
+                <a:lnTo>
+                  <a:pt x="118456" y="44335"/>
+                </a:lnTo>
+                <a:close/>
+                <a:lnTo>
+                  <a:pt x="124691" y="42449"/>
+                </a:lnTo>
+                <a:close/>
+                <a:lnTo>
+                  <a:pt x="130925" y="40665"/>
+                </a:lnTo>
+                <a:close/>
+                <a:lnTo>
+                  <a:pt x="137160" y="38853"/>
+                </a:lnTo>
+                <a:close/>
+                <a:lnTo>
+                  <a:pt x="143395" y="36927"/>
+                </a:lnTo>
+                <a:close/>
+                <a:lnTo>
+                  <a:pt x="149629" y="34972"/>
+                </a:lnTo>
+                <a:close/>
+                <a:lnTo>
+                  <a:pt x="155864" y="33116"/>
+                </a:lnTo>
+                <a:close/>
+                <a:lnTo>
+                  <a:pt x="162098" y="31483"/>
+                </a:lnTo>
+                <a:close/>
+                <a:lnTo>
+                  <a:pt x="168333" y="30114"/>
+                </a:lnTo>
+                <a:close/>
+                <a:lnTo>
+                  <a:pt x="174567" y="28920"/>
+                </a:lnTo>
+                <a:close/>
+                <a:lnTo>
+                  <a:pt x="180802" y="27798"/>
+                </a:lnTo>
+                <a:close/>
+                <a:lnTo>
+                  <a:pt x="187036" y="26652"/>
+                </a:lnTo>
+                <a:close/>
+                <a:lnTo>
+                  <a:pt x="193271" y="25445"/>
+                </a:lnTo>
+                <a:close/>
+                <a:lnTo>
+                  <a:pt x="199505" y="24177"/>
+                </a:lnTo>
+                <a:close/>
+                <a:lnTo>
+                  <a:pt x="205740" y="22851"/>
+                </a:lnTo>
+                <a:close/>
+                <a:lnTo>
+                  <a:pt x="211975" y="21484"/>
+                </a:lnTo>
+                <a:close/>
+                <a:lnTo>
+                  <a:pt x="218209" y="20155"/>
+                </a:lnTo>
+                <a:close/>
+                <a:lnTo>
+                  <a:pt x="224444" y="18958"/>
+                </a:lnTo>
+                <a:close/>
+                <a:lnTo>
+                  <a:pt x="230678" y="17985"/>
+                </a:lnTo>
+                <a:close/>
+                <a:lnTo>
+                  <a:pt x="236913" y="17258"/>
+                </a:lnTo>
+                <a:close/>
+                <a:lnTo>
+                  <a:pt x="243147" y="16686"/>
+                </a:lnTo>
+                <a:close/>
+                <a:lnTo>
+                  <a:pt x="249382" y="16170"/>
+                </a:lnTo>
+                <a:close/>
+                <a:lnTo>
+                  <a:pt x="255617" y="15616"/>
+                </a:lnTo>
+                <a:close/>
+                <a:lnTo>
+                  <a:pt x="261851" y="15003"/>
+                </a:lnTo>
+                <a:close/>
+                <a:lnTo>
+                  <a:pt x="268086" y="14358"/>
+                </a:lnTo>
+                <a:close/>
+                <a:lnTo>
+                  <a:pt x="274320" y="13707"/>
+                </a:lnTo>
+                <a:close/>
+                <a:lnTo>
+                  <a:pt x="280553" y="13072"/>
+                </a:lnTo>
+                <a:close/>
+                <a:lnTo>
+                  <a:pt x="286787" y="12450"/>
+                </a:lnTo>
+                <a:close/>
+                <a:lnTo>
+                  <a:pt x="293022" y="11833"/>
+                </a:lnTo>
+                <a:close/>
+                <a:lnTo>
+                  <a:pt x="299259" y="11214"/>
+                </a:lnTo>
+                <a:close/>
+                <a:lnTo>
+                  <a:pt x="305499" y="10589"/>
+                </a:lnTo>
+                <a:close/>
+                <a:lnTo>
+                  <a:pt x="311735" y="9963"/>
+                </a:lnTo>
+                <a:close/>
+                <a:lnTo>
+                  <a:pt x="317965" y="9341"/>
+                </a:lnTo>
+                <a:close/>
+                <a:lnTo>
+                  <a:pt x="324186" y="8727"/>
+                </a:lnTo>
+                <a:close/>
+                <a:lnTo>
+                  <a:pt x="330405" y="8115"/>
+                </a:lnTo>
+                <a:close/>
+                <a:lnTo>
+                  <a:pt x="336638" y="7493"/>
+                </a:lnTo>
+                <a:close/>
+                <a:lnTo>
+                  <a:pt x="342900" y="6849"/>
+                </a:lnTo>
+                <a:close/>
+                <a:lnTo>
+                  <a:pt x="349195" y="6180"/>
+                </a:lnTo>
+                <a:close/>
+                <a:lnTo>
+                  <a:pt x="355478" y="5521"/>
+                </a:lnTo>
+                <a:close/>
+                <a:lnTo>
+                  <a:pt x="361688" y="4915"/>
+                </a:lnTo>
+                <a:close/>
+                <a:lnTo>
+                  <a:pt x="367770" y="4407"/>
+                </a:lnTo>
+                <a:close/>
+                <a:lnTo>
+                  <a:pt x="373770" y="4003"/>
+                </a:lnTo>
+                <a:close/>
+                <a:lnTo>
+                  <a:pt x="379891" y="3657"/>
+                </a:lnTo>
+                <a:close/>
+                <a:lnTo>
+                  <a:pt x="386353" y="3314"/>
+                </a:lnTo>
+                <a:close/>
+                <a:lnTo>
+                  <a:pt x="393322" y="2928"/>
+                </a:lnTo>
+                <a:close/>
+                <a:lnTo>
+                  <a:pt x="400373" y="2513"/>
+                </a:lnTo>
+                <a:close/>
+                <a:lnTo>
+                  <a:pt x="406697" y="2125"/>
+                </a:lnTo>
+                <a:close/>
+                <a:lnTo>
+                  <a:pt x="411480" y="1820"/>
+                </a:lnTo>
+                <a:close/>
+                <a:lnTo>
+                  <a:pt x="414178" y="1635"/>
+                </a:lnTo>
+                <a:close/>
+                <a:lnTo>
+                  <a:pt x="415336" y="1541"/>
+                </a:lnTo>
+                <a:close/>
+                <a:lnTo>
+                  <a:pt x="415766" y="1489"/>
+                </a:lnTo>
+                <a:close/>
+                <a:lnTo>
+                  <a:pt x="416279" y="1432"/>
+                </a:lnTo>
+                <a:close/>
+                <a:lnTo>
+                  <a:pt x="417299" y="1345"/>
+                </a:lnTo>
+                <a:close/>
+                <a:lnTo>
+                  <a:pt x="418659" y="1238"/>
+                </a:lnTo>
+                <a:close/>
+                <a:lnTo>
+                  <a:pt x="420141" y="1125"/>
+                </a:lnTo>
+                <a:close/>
+                <a:lnTo>
+                  <a:pt x="421540" y="1018"/>
+                </a:lnTo>
+                <a:close/>
+                <a:lnTo>
+                  <a:pt x="422811" y="919"/>
+                </a:lnTo>
+                <a:close/>
+                <a:lnTo>
+                  <a:pt x="424010" y="822"/>
+                </a:lnTo>
+                <a:close/>
+                <a:lnTo>
+                  <a:pt x="425196" y="723"/>
+                </a:lnTo>
+                <a:close/>
+                <a:lnTo>
+                  <a:pt x="426415" y="617"/>
+                </a:lnTo>
+                <a:close/>
+                <a:lnTo>
+                  <a:pt x="427664" y="511"/>
+                </a:lnTo>
+                <a:close/>
+                <a:lnTo>
+                  <a:pt x="428926" y="413"/>
+                </a:lnTo>
+                <a:close/>
+                <a:lnTo>
+                  <a:pt x="430187" y="332"/>
+                </a:lnTo>
+                <a:close/>
+                <a:lnTo>
+                  <a:pt x="431439" y="269"/>
+                </a:lnTo>
+                <a:close/>
+                <a:lnTo>
+                  <a:pt x="432683" y="222"/>
+                </a:lnTo>
+                <a:close/>
+                <a:lnTo>
+                  <a:pt x="433926" y="185"/>
+                </a:lnTo>
+                <a:close/>
+                <a:lnTo>
+                  <a:pt x="435170" y="153"/>
+                </a:lnTo>
+                <a:close/>
+                <a:lnTo>
+                  <a:pt x="436416" y="126"/>
+                </a:lnTo>
+                <a:close/>
+                <a:lnTo>
+                  <a:pt x="437664" y="102"/>
+                </a:lnTo>
+                <a:close/>
+                <a:lnTo>
+                  <a:pt x="438912" y="82"/>
+                </a:lnTo>
+                <a:close/>
+                <a:lnTo>
+                  <a:pt x="440159" y="66"/>
+                </a:lnTo>
+                <a:close/>
+                <a:lnTo>
+                  <a:pt x="441406" y="53"/>
+                </a:lnTo>
+                <a:close/>
+                <a:lnTo>
+                  <a:pt x="442653" y="43"/>
+                </a:lnTo>
+                <a:close/>
+                <a:lnTo>
+                  <a:pt x="443900" y="34"/>
+                </a:lnTo>
+                <a:close/>
+                <a:lnTo>
+                  <a:pt x="445146" y="27"/>
+                </a:lnTo>
+                <a:close/>
+                <a:lnTo>
+                  <a:pt x="446393" y="21"/>
+                </a:lnTo>
+                <a:close/>
+                <a:lnTo>
+                  <a:pt x="447640" y="15"/>
+                </a:lnTo>
+                <a:close/>
+                <a:lnTo>
+                  <a:pt x="448887" y="11"/>
+                </a:lnTo>
+                <a:close/>
+                <a:lnTo>
+                  <a:pt x="450134" y="7"/>
+                </a:lnTo>
+                <a:close/>
+                <a:lnTo>
+                  <a:pt x="451381" y="4"/>
+                </a:lnTo>
+                <a:close/>
+                <a:lnTo>
+                  <a:pt x="452628" y="0"/>
+                </a:lnTo>
+                <a:close/>
+              </a:path>
+            </a:pathLst>
+          </a:custGeom>
+          <a:ln w="19050">
             <a:solidFill>
-              <a:srgbClr val="00C8FF"/>
-            </a:solidFill>
-          </a:ln>
-        </p:spPr>
-        <p:style>
-          <a:lnRef idx="2">
-            <a:schemeClr val="accent1"/>
-          </a:lnRef>
-          <a:fillRef idx="0">
-            <a:schemeClr val="accent1"/>
-          </a:fillRef>
-          <a:effectRef idx="1">
-            <a:schemeClr val="accent1"/>
-          </a:effectRef>
-          <a:fontRef idx="minor">
-            <a:schemeClr val="tx1"/>
-          </a:fontRef>
-        </p:style>
-      </p:cxnSp>
-      <p:cxnSp>
-        <p:nvCxnSpPr>
-          <p:cNvPr id="43" name="Connector 42"/>
-          <p:cNvCxnSpPr/>
-          <p:nvPr/>
-        </p:nvCxnSpPr>
-        <p:spPr>
-          <a:xfrm flipV="1">
-            <a:off x="6035040.0" y="1565910.0"/>
-            <a:ext cx="45720.0" cy="45720.0"/>
-          </a:xfrm>
-          <a:prstGeom prst="line">
-            <a:avLst/>
-          </a:prstGeom>
-          <a:ln w="25400">
-            <a:solidFill>
-              <a:srgbClr val="00C8FF"/>
-            </a:solidFill>
-          </a:ln>
-        </p:spPr>
-        <p:style>
-          <a:lnRef idx="2">
-            <a:schemeClr val="accent1"/>
-          </a:lnRef>
-          <a:fillRef idx="0">
-            <a:schemeClr val="accent1"/>
-          </a:fillRef>
-          <a:effectRef idx="1">
-            <a:schemeClr val="accent1"/>
-          </a:effectRef>
-          <a:fontRef idx="minor">
-            <a:schemeClr val="tx1"/>
-          </a:fontRef>
-        </p:style>
-      </p:cxnSp>
-      <p:cxnSp>
-        <p:nvCxnSpPr>
-          <p:cNvPr id="44" name="Connector 43"/>
-          <p:cNvCxnSpPr/>
-          <p:nvPr/>
-        </p:nvCxnSpPr>
-        <p:spPr>
-          <a:xfrm flipV="1">
-            <a:off x="6080760.0" y="1520190.0"/>
-            <a:ext cx="45720.0" cy="45720.0"/>
-          </a:xfrm>
-          <a:prstGeom prst="line">
-            <a:avLst/>
-          </a:prstGeom>
-          <a:ln w="25400">
-            <a:solidFill>
-              <a:srgbClr val="00C8FF"/>
-            </a:solidFill>
-          </a:ln>
-        </p:spPr>
-        <p:style>
-          <a:lnRef idx="2">
-            <a:schemeClr val="accent1"/>
-          </a:lnRef>
-          <a:fillRef idx="0">
-            <a:schemeClr val="accent1"/>
-          </a:fillRef>
-          <a:effectRef idx="1">
-            <a:schemeClr val="accent1"/>
-          </a:effectRef>
-          <a:fontRef idx="minor">
-            <a:schemeClr val="tx1"/>
-          </a:fontRef>
-        </p:style>
-      </p:cxnSp>
-      <p:cxnSp>
-        <p:nvCxnSpPr>
-          <p:cNvPr id="45" name="Connector 44"/>
-          <p:cNvCxnSpPr/>
-          <p:nvPr/>
-        </p:nvCxnSpPr>
-        <p:spPr>
-          <a:xfrm flipV="1">
-            <a:off x="6126480.0" y="1474470.0"/>
-            <a:ext cx="45720.0" cy="45720.0"/>
-          </a:xfrm>
-          <a:prstGeom prst="line">
-            <a:avLst/>
-          </a:prstGeom>
-          <a:ln w="25400">
-            <a:solidFill>
-              <a:srgbClr val="00C8FF"/>
-            </a:solidFill>
-          </a:ln>
-        </p:spPr>
-        <p:style>
-          <a:lnRef idx="2">
-            <a:schemeClr val="accent1"/>
-          </a:lnRef>
-          <a:fillRef idx="0">
-            <a:schemeClr val="accent1"/>
-          </a:fillRef>
-          <a:effectRef idx="1">
-            <a:schemeClr val="accent1"/>
-          </a:effectRef>
-          <a:fontRef idx="minor">
-            <a:schemeClr val="tx1"/>
-          </a:fontRef>
-        </p:style>
-      </p:cxnSp>
-      <p:cxnSp>
-        <p:nvCxnSpPr>
-          <p:cNvPr id="46" name="Connector 45"/>
-          <p:cNvCxnSpPr/>
-          <p:nvPr/>
-        </p:nvCxnSpPr>
-        <p:spPr>
-          <a:xfrm flipV="1">
-            <a:off x="6172200.0" y="1428750.0"/>
-            <a:ext cx="45720.0" cy="45720.0"/>
-          </a:xfrm>
-          <a:prstGeom prst="line">
-            <a:avLst/>
-          </a:prstGeom>
-          <a:ln w="25400">
-            <a:solidFill>
-              <a:srgbClr val="00C8FF"/>
-            </a:solidFill>
-          </a:ln>
-        </p:spPr>
-        <p:style>
-          <a:lnRef idx="2">
-            <a:schemeClr val="accent1"/>
-          </a:lnRef>
-          <a:fillRef idx="0">
-            <a:schemeClr val="accent1"/>
-          </a:fillRef>
-          <a:effectRef idx="1">
-            <a:schemeClr val="accent1"/>
-          </a:effectRef>
-          <a:fontRef idx="minor">
-            <a:schemeClr val="tx1"/>
-          </a:fontRef>
-        </p:style>
-      </p:cxnSp>
-      <p:cxnSp>
-        <p:nvCxnSpPr>
-          <p:cNvPr id="47" name="Connector 46"/>
-          <p:cNvCxnSpPr/>
-          <p:nvPr/>
-        </p:nvCxnSpPr>
-        <p:spPr>
-          <a:xfrm flipV="1">
-            <a:off x="6217920.0" y="1360170.0"/>
-            <a:ext cx="45720.0" cy="68580.0"/>
-          </a:xfrm>
-          <a:prstGeom prst="line">
-            <a:avLst/>
-          </a:prstGeom>
-          <a:ln w="25400">
-            <a:solidFill>
-              <a:srgbClr val="00C8FF"/>
-            </a:solidFill>
-          </a:ln>
-        </p:spPr>
-        <p:style>
-          <a:lnRef idx="2">
-            <a:schemeClr val="accent1"/>
-          </a:lnRef>
-          <a:fillRef idx="0">
-            <a:schemeClr val="accent1"/>
-          </a:fillRef>
-          <a:effectRef idx="1">
-            <a:schemeClr val="accent1"/>
-          </a:effectRef>
-          <a:fontRef idx="minor">
-            <a:schemeClr val="tx1"/>
-          </a:fontRef>
-        </p:style>
-      </p:cxnSp>
-      <p:cxnSp>
-        <p:nvCxnSpPr>
-          <p:cNvPr id="48" name="Connector 47"/>
-          <p:cNvCxnSpPr/>
-          <p:nvPr/>
-        </p:nvCxnSpPr>
-        <p:spPr>
-          <a:xfrm flipV="1">
-            <a:off x="6263640.0" y="1291590.0"/>
-            <a:ext cx="45720.0" cy="68580.0"/>
-          </a:xfrm>
-          <a:prstGeom prst="line">
-            <a:avLst/>
-          </a:prstGeom>
-          <a:ln w="25400">
-            <a:solidFill>
-              <a:srgbClr val="00C8FF"/>
-            </a:solidFill>
-          </a:ln>
-        </p:spPr>
-        <p:style>
-          <a:lnRef idx="2">
-            <a:schemeClr val="accent1"/>
-          </a:lnRef>
-          <a:fillRef idx="0">
-            <a:schemeClr val="accent1"/>
-          </a:fillRef>
-          <a:effectRef idx="1">
-            <a:schemeClr val="accent1"/>
-          </a:effectRef>
-          <a:fontRef idx="minor">
-            <a:schemeClr val="tx1"/>
-          </a:fontRef>
-        </p:style>
-      </p:cxnSp>
-      <p:cxnSp>
-        <p:nvCxnSpPr>
-          <p:cNvPr id="49" name="Connector 48"/>
-          <p:cNvCxnSpPr/>
-          <p:nvPr/>
-        </p:nvCxnSpPr>
-        <p:spPr>
-          <a:xfrm flipV="1">
-            <a:off x="6309360.0" y="1200150.0"/>
-            <a:ext cx="45720.0" cy="91440.0"/>
-          </a:xfrm>
-          <a:prstGeom prst="line">
-            <a:avLst/>
-          </a:prstGeom>
-          <a:ln w="25400">
-            <a:solidFill>
-              <a:srgbClr val="00C8FF"/>
-            </a:solidFill>
-          </a:ln>
-        </p:spPr>
-        <p:style>
-          <a:lnRef idx="2">
-            <a:schemeClr val="accent1"/>
-          </a:lnRef>
-          <a:fillRef idx="0">
-            <a:schemeClr val="accent1"/>
-          </a:fillRef>
-          <a:effectRef idx="1">
-            <a:schemeClr val="accent1"/>
-          </a:effectRef>
-          <a:fontRef idx="minor">
-            <a:schemeClr val="tx1"/>
-          </a:fontRef>
-        </p:style>
-      </p:cxnSp>
-      <p:cxnSp>
-        <p:nvCxnSpPr>
-          <p:cNvPr id="50" name="Connector 49"/>
-          <p:cNvCxnSpPr/>
-          <p:nvPr/>
-        </p:nvCxnSpPr>
-        <p:spPr>
-          <a:xfrm flipV="1">
-            <a:off x="6355080.0" y="1108710.0"/>
-            <a:ext cx="45720.0" cy="91440.0"/>
-          </a:xfrm>
-          <a:prstGeom prst="line">
-            <a:avLst/>
-          </a:prstGeom>
-          <a:ln w="25400">
-            <a:solidFill>
-              <a:srgbClr val="00C8FF"/>
-            </a:solidFill>
-          </a:ln>
-        </p:spPr>
-        <p:style>
-          <a:lnRef idx="2">
-            <a:schemeClr val="accent1"/>
-          </a:lnRef>
-          <a:fillRef idx="0">
-            <a:schemeClr val="accent1"/>
-          </a:fillRef>
-          <a:effectRef idx="1">
-            <a:schemeClr val="accent1"/>
-          </a:effectRef>
-          <a:fontRef idx="minor">
-            <a:schemeClr val="tx1"/>
-          </a:fontRef>
-        </p:style>
-      </p:cxnSp>
-      <p:cxnSp>
-        <p:nvCxnSpPr>
-          <p:cNvPr id="51" name="Connector 50"/>
-          <p:cNvCxnSpPr/>
-          <p:nvPr/>
-        </p:nvCxnSpPr>
-        <p:spPr>
-          <a:xfrm flipV="1">
-            <a:off x="6400800.0" y="1017270.0"/>
-            <a:ext cx="45720.0" cy="91440.0"/>
-          </a:xfrm>
-          <a:prstGeom prst="line">
-            <a:avLst/>
-          </a:prstGeom>
-          <a:ln w="25400">
-            <a:solidFill>
-              <a:srgbClr val="00C8FF"/>
-            </a:solidFill>
-          </a:ln>
-        </p:spPr>
-        <p:style>
-          <a:lnRef idx="2">
-            <a:schemeClr val="accent1"/>
-          </a:lnRef>
-          <a:fillRef idx="0">
-            <a:schemeClr val="accent1"/>
-          </a:fillRef>
-          <a:effectRef idx="1">
-            <a:schemeClr val="accent1"/>
-          </a:effectRef>
-          <a:fontRef idx="minor">
-            <a:schemeClr val="tx1"/>
-          </a:fontRef>
-        </p:style>
-      </p:cxnSp>
-      <p:cxnSp>
-        <p:nvCxnSpPr>
-          <p:cNvPr id="52" name="Connector 51"/>
-          <p:cNvCxnSpPr/>
-          <p:nvPr/>
-        </p:nvCxnSpPr>
-        <p:spPr>
-          <a:xfrm flipV="1">
-            <a:off x="6446520.0" y="925830.0"/>
-            <a:ext cx="45720.0" cy="91440.0"/>
-          </a:xfrm>
-          <a:prstGeom prst="line">
-            <a:avLst/>
-          </a:prstGeom>
-          <a:ln w="25400">
-            <a:solidFill>
-              <a:srgbClr val="00C8FF"/>
-            </a:solidFill>
-          </a:ln>
-        </p:spPr>
-        <p:style>
-          <a:lnRef idx="2">
-            <a:schemeClr val="accent1"/>
-          </a:lnRef>
-          <a:fillRef idx="0">
-            <a:schemeClr val="accent1"/>
-          </a:fillRef>
-          <a:effectRef idx="1">
-            <a:schemeClr val="accent1"/>
-          </a:effectRef>
-          <a:fontRef idx="minor">
-            <a:schemeClr val="tx1"/>
-          </a:fontRef>
-        </p:style>
-      </p:cxnSp>
-      <p:cxnSp>
-        <p:nvCxnSpPr>
-          <p:cNvPr id="53" name="Connector 52"/>
-          <p:cNvCxnSpPr/>
-          <p:nvPr/>
-        </p:nvCxnSpPr>
-        <p:spPr>
-          <a:xfrm flipV="1">
-            <a:off x="6492240.0" y="834390.0"/>
-            <a:ext cx="45720.0" cy="91440.0"/>
-          </a:xfrm>
-          <a:prstGeom prst="line">
-            <a:avLst/>
-          </a:prstGeom>
-          <a:ln w="25400">
-            <a:solidFill>
-              <a:srgbClr val="00C8FF"/>
-            </a:solidFill>
-          </a:ln>
-        </p:spPr>
-        <p:style>
-          <a:lnRef idx="2">
-            <a:schemeClr val="accent1"/>
-          </a:lnRef>
-          <a:fillRef idx="0">
-            <a:schemeClr val="accent1"/>
-          </a:fillRef>
-          <a:effectRef idx="1">
-            <a:schemeClr val="accent1"/>
-          </a:effectRef>
-          <a:fontRef idx="minor">
-            <a:schemeClr val="tx1"/>
-          </a:fontRef>
-        </p:style>
-      </p:cxnSp>
-      <p:cxnSp>
-        <p:nvCxnSpPr>
-          <p:cNvPr id="54" name="Connector 53"/>
-          <p:cNvCxnSpPr/>
-          <p:nvPr/>
-        </p:nvCxnSpPr>
-        <p:spPr>
-          <a:xfrm flipV="1">
-            <a:off x="6537960.0" y="742950.0"/>
-            <a:ext cx="45720.0" cy="91440.0"/>
-          </a:xfrm>
-          <a:prstGeom prst="line">
-            <a:avLst/>
-          </a:prstGeom>
-          <a:ln w="25400">
-            <a:solidFill>
-              <a:srgbClr val="00C8FF"/>
-            </a:solidFill>
-          </a:ln>
-        </p:spPr>
-        <p:style>
-          <a:lnRef idx="2">
-            <a:schemeClr val="accent1"/>
-          </a:lnRef>
-          <a:fillRef idx="0">
-            <a:schemeClr val="accent1"/>
-          </a:fillRef>
-          <a:effectRef idx="1">
-            <a:schemeClr val="accent1"/>
-          </a:effectRef>
-          <a:fontRef idx="minor">
-            <a:schemeClr val="tx1"/>
-          </a:fontRef>
-        </p:style>
-      </p:cxnSp>
-      <p:cxnSp>
-        <p:nvCxnSpPr>
-          <p:cNvPr id="55" name="Connector 54"/>
-          <p:cNvCxnSpPr/>
-          <p:nvPr/>
-        </p:nvCxnSpPr>
-        <p:spPr>
-          <a:xfrm flipV="1">
-            <a:off x="6583680.0" y="651510.0"/>
-            <a:ext cx="45720.0" cy="91440.0"/>
-          </a:xfrm>
-          <a:prstGeom prst="line">
-            <a:avLst/>
-          </a:prstGeom>
-          <a:ln w="25400">
-            <a:solidFill>
-              <a:srgbClr val="00C8FF"/>
-            </a:solidFill>
-          </a:ln>
-        </p:spPr>
-        <p:style>
-          <a:lnRef idx="2">
-            <a:schemeClr val="accent1"/>
-          </a:lnRef>
-          <a:fillRef idx="0">
-            <a:schemeClr val="accent1"/>
-          </a:fillRef>
-          <a:effectRef idx="1">
-            <a:schemeClr val="accent1"/>
-          </a:effectRef>
-          <a:fontRef idx="minor">
-            <a:schemeClr val="tx1"/>
-          </a:fontRef>
-        </p:style>
-      </p:cxnSp>
-      <p:sp>
-        <p:nvSpPr>
-          <p:cNvPr id="56" name="Oval 55"/>
-          <p:cNvSpPr/>
-          <p:nvPr/>
-        </p:nvSpPr>
-        <p:spPr>
-          <a:xfrm>
-            <a:off x="5996940" y="1573530"/>
-            <a:ext cx="76200" cy="76200"/>
-          </a:xfrm>
-          <a:prstGeom prst="ellipse">
-            <a:avLst/>
-          </a:prstGeom>
-          <a:noFill/>
-          <a:ln>
-            <a:solidFill>
-              <a:srgbClr val="FFFFFF"/>
+              <a:srgbClr val="B4B4B4"/>
             </a:solidFill>
           </a:ln>
         </p:spPr>
@@ -5031,14 +5053,463 @@
       </p:sp>
       <p:sp>
         <p:nvSpPr>
-          <p:cNvPr id="57" name="TextBox 56"/>
+          <p:cNvPr id="11" name="Freeform 10"/>
+          <p:cNvSpPr/>
+          <p:nvPr/>
+        </p:nvSpPr>
+        <p:spPr>
+          <a:xfrm>
+            <a:off x="5719572" y="1698498"/>
+            <a:ext cx="406908" cy="50283"/>
+          </a:xfrm>
+          <a:custGeom>
+            <a:avLst/>
+            <a:gdLst/>
+            <a:ahLst/>
+            <a:cxnLst/>
+            <a:rect l="l" t="t" r="r" b="b"/>
+            <a:pathLst>
+              <a:path w="406908" h="50283">
+                <a:moveTo>
+                  <a:pt x="406908" y="0"/>
+                </a:moveTo>
+                <a:lnTo>
+                  <a:pt x="401135" y="1592"/>
+                </a:lnTo>
+                <a:close/>
+                <a:lnTo>
+                  <a:pt x="395363" y="3305"/>
+                </a:lnTo>
+                <a:close/>
+                <a:lnTo>
+                  <a:pt x="389590" y="5098"/>
+                </a:lnTo>
+                <a:close/>
+                <a:lnTo>
+                  <a:pt x="383817" y="6932"/>
+                </a:lnTo>
+                <a:close/>
+                <a:lnTo>
+                  <a:pt x="378044" y="8763"/>
+                </a:lnTo>
+                <a:close/>
+                <a:lnTo>
+                  <a:pt x="372272" y="10552"/>
+                </a:lnTo>
+                <a:close/>
+                <a:lnTo>
+                  <a:pt x="366499" y="12257"/>
+                </a:lnTo>
+                <a:close/>
+                <a:lnTo>
+                  <a:pt x="360726" y="13837"/>
+                </a:lnTo>
+                <a:close/>
+                <a:lnTo>
+                  <a:pt x="354953" y="15275"/>
+                </a:lnTo>
+                <a:close/>
+                <a:lnTo>
+                  <a:pt x="349181" y="16629"/>
+                </a:lnTo>
+                <a:close/>
+                <a:lnTo>
+                  <a:pt x="343408" y="17972"/>
+                </a:lnTo>
+                <a:close/>
+                <a:lnTo>
+                  <a:pt x="337635" y="19377"/>
+                </a:lnTo>
+                <a:close/>
+                <a:lnTo>
+                  <a:pt x="331863" y="20882"/>
+                </a:lnTo>
+                <a:close/>
+                <a:lnTo>
+                  <a:pt x="326090" y="22430"/>
+                </a:lnTo>
+                <a:close/>
+                <a:lnTo>
+                  <a:pt x="320317" y="23948"/>
+                </a:lnTo>
+                <a:close/>
+                <a:lnTo>
+                  <a:pt x="314544" y="25362"/>
+                </a:lnTo>
+                <a:close/>
+                <a:lnTo>
+                  <a:pt x="308772" y="26629"/>
+                </a:lnTo>
+                <a:close/>
+                <a:lnTo>
+                  <a:pt x="302999" y="27783"/>
+                </a:lnTo>
+                <a:close/>
+                <a:lnTo>
+                  <a:pt x="297226" y="28869"/>
+                </a:lnTo>
+                <a:close/>
+                <a:lnTo>
+                  <a:pt x="291453" y="29931"/>
+                </a:lnTo>
+                <a:close/>
+                <a:lnTo>
+                  <a:pt x="285681" y="30997"/>
+                </a:lnTo>
+                <a:close/>
+                <a:lnTo>
+                  <a:pt x="279908" y="32053"/>
+                </a:lnTo>
+                <a:close/>
+                <a:lnTo>
+                  <a:pt x="274135" y="33082"/>
+                </a:lnTo>
+                <a:close/>
+                <a:lnTo>
+                  <a:pt x="268363" y="34063"/>
+                </a:lnTo>
+                <a:close/>
+                <a:lnTo>
+                  <a:pt x="262590" y="34994"/>
+                </a:lnTo>
+                <a:close/>
+                <a:lnTo>
+                  <a:pt x="256817" y="35901"/>
+                </a:lnTo>
+                <a:close/>
+                <a:lnTo>
+                  <a:pt x="251044" y="36813"/>
+                </a:lnTo>
+                <a:close/>
+                <a:lnTo>
+                  <a:pt x="245272" y="37761"/>
+                </a:lnTo>
+                <a:close/>
+                <a:lnTo>
+                  <a:pt x="239499" y="38744"/>
+                </a:lnTo>
+                <a:close/>
+                <a:lnTo>
+                  <a:pt x="233726" y="39712"/>
+                </a:lnTo>
+                <a:close/>
+                <a:lnTo>
+                  <a:pt x="227953" y="40608"/>
+                </a:lnTo>
+                <a:close/>
+                <a:lnTo>
+                  <a:pt x="222181" y="41377"/>
+                </a:lnTo>
+                <a:close/>
+                <a:lnTo>
+                  <a:pt x="216408" y="42007"/>
+                </a:lnTo>
+                <a:close/>
+                <a:lnTo>
+                  <a:pt x="210635" y="42554"/>
+                </a:lnTo>
+                <a:close/>
+                <a:lnTo>
+                  <a:pt x="204863" y="43079"/>
+                </a:lnTo>
+                <a:close/>
+                <a:lnTo>
+                  <a:pt x="199090" y="43646"/>
+                </a:lnTo>
+                <a:close/>
+                <a:lnTo>
+                  <a:pt x="193317" y="44267"/>
+                </a:lnTo>
+                <a:close/>
+                <a:lnTo>
+                  <a:pt x="187544" y="44887"/>
+                </a:lnTo>
+                <a:close/>
+                <a:lnTo>
+                  <a:pt x="181771" y="45443"/>
+                </a:lnTo>
+                <a:close/>
+                <a:lnTo>
+                  <a:pt x="175999" y="45874"/>
+                </a:lnTo>
+                <a:close/>
+                <a:lnTo>
+                  <a:pt x="170228" y="46169"/>
+                </a:lnTo>
+                <a:close/>
+                <a:lnTo>
+                  <a:pt x="164456" y="46373"/>
+                </a:lnTo>
+                <a:close/>
+                <a:lnTo>
+                  <a:pt x="158682" y="46539"/>
+                </a:lnTo>
+                <a:close/>
+                <a:lnTo>
+                  <a:pt x="152906" y="46717"/>
+                </a:lnTo>
+                <a:close/>
+                <a:lnTo>
+                  <a:pt x="147129" y="46931"/>
+                </a:lnTo>
+                <a:close/>
+                <a:lnTo>
+                  <a:pt x="141355" y="47168"/>
+                </a:lnTo>
+                <a:close/>
+                <a:lnTo>
+                  <a:pt x="135585" y="47418"/>
+                </a:lnTo>
+                <a:close/>
+                <a:lnTo>
+                  <a:pt x="129824" y="47668"/>
+                </a:lnTo>
+                <a:close/>
+                <a:lnTo>
+                  <a:pt x="124067" y="47910"/>
+                </a:lnTo>
+                <a:close/>
+                <a:lnTo>
+                  <a:pt x="118302" y="48142"/>
+                </a:lnTo>
+                <a:close/>
+                <a:lnTo>
+                  <a:pt x="112516" y="48363"/>
+                </a:lnTo>
+                <a:close/>
+                <a:lnTo>
+                  <a:pt x="106699" y="48568"/>
+                </a:lnTo>
+                <a:close/>
+                <a:lnTo>
+                  <a:pt x="100868" y="48758"/>
+                </a:lnTo>
+                <a:close/>
+                <a:lnTo>
+                  <a:pt x="95069" y="48931"/>
+                </a:lnTo>
+                <a:close/>
+                <a:lnTo>
+                  <a:pt x="89348" y="49087"/>
+                </a:lnTo>
+                <a:close/>
+                <a:lnTo>
+                  <a:pt x="83746" y="49223"/>
+                </a:lnTo>
+                <a:close/>
+                <a:lnTo>
+                  <a:pt x="78188" y="49344"/>
+                </a:lnTo>
+                <a:close/>
+                <a:lnTo>
+                  <a:pt x="72505" y="49456"/>
+                </a:lnTo>
+                <a:close/>
+                <a:lnTo>
+                  <a:pt x="66523" y="49563"/>
+                </a:lnTo>
+                <a:close/>
+                <a:lnTo>
+                  <a:pt x="60099" y="49672"/>
+                </a:lnTo>
+                <a:close/>
+                <a:lnTo>
+                  <a:pt x="53530" y="49779"/>
+                </a:lnTo>
+                <a:close/>
+                <a:lnTo>
+                  <a:pt x="47455" y="49876"/>
+                </a:lnTo>
+                <a:close/>
+                <a:lnTo>
+                  <a:pt x="42521" y="49952"/>
+                </a:lnTo>
+                <a:close/>
+                <a:lnTo>
+                  <a:pt x="39317" y="49998"/>
+                </a:lnTo>
+                <a:close/>
+                <a:lnTo>
+                  <a:pt x="37709" y="50017"/>
+                </a:lnTo>
+                <a:close/>
+                <a:lnTo>
+                  <a:pt x="37060" y="50020"/>
+                </a:lnTo>
+                <a:close/>
+                <a:lnTo>
+                  <a:pt x="36723" y="50018"/>
+                </a:lnTo>
+                <a:close/>
+                <a:lnTo>
+                  <a:pt x="36096" y="50020"/>
+                </a:lnTo>
+                <a:close/>
+                <a:lnTo>
+                  <a:pt x="35049" y="50030"/>
+                </a:lnTo>
+                <a:close/>
+                <a:lnTo>
+                  <a:pt x="33752" y="50044"/>
+                </a:lnTo>
+                <a:close/>
+                <a:lnTo>
+                  <a:pt x="32379" y="50059"/>
+                </a:lnTo>
+                <a:close/>
+                <a:lnTo>
+                  <a:pt x="31088" y="50073"/>
+                </a:lnTo>
+                <a:close/>
+                <a:lnTo>
+                  <a:pt x="29908" y="50085"/>
+                </a:lnTo>
+                <a:close/>
+                <a:lnTo>
+                  <a:pt x="28793" y="50096"/>
+                </a:lnTo>
+                <a:close/>
+                <a:lnTo>
+                  <a:pt x="27697" y="50107"/>
+                </a:lnTo>
+                <a:close/>
+                <a:lnTo>
+                  <a:pt x="26578" y="50117"/>
+                </a:lnTo>
+                <a:close/>
+                <a:lnTo>
+                  <a:pt x="25429" y="50128"/>
+                </a:lnTo>
+                <a:close/>
+                <a:lnTo>
+                  <a:pt x="24264" y="50140"/>
+                </a:lnTo>
+                <a:close/>
+                <a:lnTo>
+                  <a:pt x="23093" y="50152"/>
+                </a:lnTo>
+                <a:close/>
+                <a:lnTo>
+                  <a:pt x="21930" y="50165"/>
+                </a:lnTo>
+                <a:close/>
+                <a:lnTo>
+                  <a:pt x="20774" y="50177"/>
+                </a:lnTo>
+                <a:close/>
+                <a:lnTo>
+                  <a:pt x="19623" y="50189"/>
+                </a:lnTo>
+                <a:close/>
+                <a:lnTo>
+                  <a:pt x="18472" y="50199"/>
+                </a:lnTo>
+                <a:close/>
+                <a:lnTo>
+                  <a:pt x="17320" y="50207"/>
+                </a:lnTo>
+                <a:close/>
+                <a:lnTo>
+                  <a:pt x="16166" y="50213"/>
+                </a:lnTo>
+                <a:close/>
+                <a:lnTo>
+                  <a:pt x="15010" y="50218"/>
+                </a:lnTo>
+                <a:close/>
+                <a:lnTo>
+                  <a:pt x="13855" y="50223"/>
+                </a:lnTo>
+                <a:close/>
+                <a:lnTo>
+                  <a:pt x="12700" y="50228"/>
+                </a:lnTo>
+                <a:close/>
+                <a:lnTo>
+                  <a:pt x="11545" y="50234"/>
+                </a:lnTo>
+                <a:close/>
+                <a:lnTo>
+                  <a:pt x="10391" y="50240"/>
+                </a:lnTo>
+                <a:close/>
+                <a:lnTo>
+                  <a:pt x="9236" y="50246"/>
+                </a:lnTo>
+                <a:close/>
+                <a:lnTo>
+                  <a:pt x="8082" y="50252"/>
+                </a:lnTo>
+                <a:close/>
+                <a:lnTo>
+                  <a:pt x="6927" y="50258"/>
+                </a:lnTo>
+                <a:close/>
+                <a:lnTo>
+                  <a:pt x="5773" y="50264"/>
+                </a:lnTo>
+                <a:close/>
+                <a:lnTo>
+                  <a:pt x="4618" y="50269"/>
+                </a:lnTo>
+                <a:close/>
+                <a:lnTo>
+                  <a:pt x="3464" y="50274"/>
+                </a:lnTo>
+                <a:close/>
+                <a:lnTo>
+                  <a:pt x="2309" y="50278"/>
+                </a:lnTo>
+                <a:close/>
+                <a:lnTo>
+                  <a:pt x="1154" y="50281"/>
+                </a:lnTo>
+                <a:close/>
+                <a:lnTo>
+                  <a:pt x="0" y="50283"/>
+                </a:lnTo>
+                <a:close/>
+              </a:path>
+            </a:pathLst>
+          </a:custGeom>
+          <a:ln w="19050">
+            <a:solidFill>
+              <a:srgbClr val="B4B4B4"/>
+            </a:solidFill>
+          </a:ln>
+        </p:spPr>
+        <p:style>
+          <a:lnRef idx="1">
+            <a:schemeClr val="accent1"/>
+          </a:lnRef>
+          <a:fillRef idx="3">
+            <a:schemeClr val="accent1"/>
+          </a:fillRef>
+          <a:effectRef idx="2">
+            <a:schemeClr val="accent1"/>
+          </a:effectRef>
+          <a:fontRef idx="minor">
+            <a:schemeClr val="lt1"/>
+          </a:fontRef>
+        </p:style>
+        <p:txBody>
+          <a:bodyPr rtlCol="0" anchor="ctr"/>
+          <a:lstStyle/>
+          <a:p>
+            <a:pPr algn="ctr"/>
+          </a:p>
+        </p:txBody>
+      </p:sp>
+      <p:sp>
+        <p:nvSpPr>
+          <p:cNvPr id="12" name="TextBox 11"/>
           <p:cNvSpPr txBox="1"/>
           <p:nvPr/>
         </p:nvSpPr>
         <p:spPr>
           <a:xfrm>
-            <a:off x="6309360" y="971550"/>
-            <a:ext cx="635000" cy="254000"/>
+            <a:off x="4226560" y="2345690"/>
+            <a:ext cx="1524000" cy="508000"/>
           </a:xfrm>
           <a:prstGeom prst="rect">
             <a:avLst/>
@@ -5052,7 +5523,7 @@
           <a:lstStyle/>
           <a:p>
             <a:pPr>
-              <a:defRPr sz="1200">
+              <a:defRPr sz="1400" b="1">
                 <a:solidFill>
                   <a:srgbClr val="FFFFFF"/>
                 </a:solidFill>
@@ -5060,7 +5531,151 @@
               </a:defRPr>
             </a:pPr>
             <a:r>
-              <a:t>$y=f(x)$</a:t>
+              <a:t>O</a:t>
+            </a:r>
+          </a:p>
+        </p:txBody>
+      </p:sp>
+      <p:sp>
+        <p:nvSpPr>
+          <p:cNvPr id="13" name="TextBox 12"/>
+          <p:cNvSpPr txBox="1"/>
+          <p:nvPr/>
+        </p:nvSpPr>
+        <p:spPr>
+          <a:xfrm>
+            <a:off x="5918200" y="2345690"/>
+            <a:ext cx="1524000" cy="508000"/>
+          </a:xfrm>
+          <a:prstGeom prst="rect">
+            <a:avLst/>
+          </a:prstGeom>
+          <a:noFill/>
+        </p:spPr>
+        <p:txBody>
+          <a:bodyPr wrap="none">
+            <a:spAutoFit/>
+          </a:bodyPr>
+          <a:lstStyle/>
+          <a:p>
+            <a:pPr>
+              <a:defRPr sz="1400" b="1">
+                <a:solidFill>
+                  <a:srgbClr val="FFFFFF"/>
+                </a:solidFill>
+                <a:latin typeface="Inter"/>
+              </a:defRPr>
+            </a:pPr>
+            <a:r>
+              <a:t>x</a:t>
+            </a:r>
+          </a:p>
+        </p:txBody>
+      </p:sp>
+      <p:sp>
+        <p:nvSpPr>
+          <p:cNvPr id="14" name="TextBox 13"/>
+          <p:cNvSpPr txBox="1"/>
+          <p:nvPr/>
+        </p:nvSpPr>
+        <p:spPr>
+          <a:xfrm>
+            <a:off x="4226560" y="1156970"/>
+            <a:ext cx="1524000" cy="508000"/>
+          </a:xfrm>
+          <a:prstGeom prst="rect">
+            <a:avLst/>
+          </a:prstGeom>
+          <a:noFill/>
+        </p:spPr>
+        <p:txBody>
+          <a:bodyPr wrap="none">
+            <a:spAutoFit/>
+          </a:bodyPr>
+          <a:lstStyle/>
+          <a:p>
+            <a:pPr>
+              <a:defRPr sz="1400" b="1">
+                <a:solidFill>
+                  <a:srgbClr val="FFFFFF"/>
+                </a:solidFill>
+                <a:latin typeface="Inter"/>
+              </a:defRPr>
+            </a:pPr>
+            <a:r>
+              <a:t>y</a:t>
+            </a:r>
+          </a:p>
+        </p:txBody>
+      </p:sp>
+      <p:sp>
+        <p:nvSpPr>
+          <p:cNvPr id="15" name="TextBox 14"/>
+          <p:cNvSpPr txBox="1"/>
+          <p:nvPr/>
+        </p:nvSpPr>
+        <p:spPr>
+          <a:xfrm>
+            <a:off x="5461000" y="2391410"/>
+            <a:ext cx="1524000" cy="508000"/>
+          </a:xfrm>
+          <a:prstGeom prst="rect">
+            <a:avLst/>
+          </a:prstGeom>
+          <a:noFill/>
+        </p:spPr>
+        <p:txBody>
+          <a:bodyPr wrap="none">
+            <a:spAutoFit/>
+          </a:bodyPr>
+          <a:lstStyle/>
+          <a:p>
+            <a:pPr>
+              <a:defRPr sz="1400" b="1">
+                <a:solidFill>
+                  <a:srgbClr val="FFFFFF"/>
+                </a:solidFill>
+                <a:latin typeface="Inter"/>
+              </a:defRPr>
+            </a:pPr>
+            <a:r>
+              <a:t>a</a:t>
+            </a:r>
+          </a:p>
+        </p:txBody>
+      </p:sp>
+      <p:sp>
+        <p:nvSpPr>
+          <p:cNvPr id="16" name="TextBox 15"/>
+          <p:cNvSpPr txBox="1"/>
+          <p:nvPr/>
+        </p:nvSpPr>
+        <p:spPr>
+          <a:xfrm>
+            <a:off x="4180840" y="1431290"/>
+            <a:ext cx="1524000" cy="508000"/>
+          </a:xfrm>
+          <a:prstGeom prst="rect">
+            <a:avLst/>
+          </a:prstGeom>
+          <a:noFill/>
+        </p:spPr>
+        <p:txBody>
+          <a:bodyPr wrap="none">
+            <a:spAutoFit/>
+          </a:bodyPr>
+          <a:lstStyle/>
+          <a:p>
+            <a:pPr>
+              <a:defRPr sz="1400" b="1">
+                <a:solidFill>
+                  <a:srgbClr val="FFFFFF"/>
+                </a:solidFill>
+                <a:latin typeface="Inter"/>
+              </a:defRPr>
+            </a:pPr>
+            <a:r>
+              <a:t>L</a:t>
             </a:r>
           </a:p>
         </p:txBody>

</xml_diff>

<commit_message>
feat: Perfect Clone v2 - fix label double-render bug, add convergence arrows, robust JSON parsing
</commit_message>
<xml_diff>
--- a/output/1.pptx
+++ b/output/1.pptx
@@ -3104,8 +3104,8 @@
         </p:nvCxnSpPr>
         <p:spPr>
           <a:xfrm>
-            <a:off x="3657600.0" y="2571750.0"/>
-            <a:ext cx="2743200.0" cy="0.0"/>
+            <a:off x="3200400.0" y="2571750.0"/>
+            <a:ext cx="4114800.0" cy="0.0"/>
           </a:xfrm>
           <a:prstGeom prst="line">
             <a:avLst/>
@@ -3139,8 +3139,8 @@
         </p:nvCxnSpPr>
         <p:spPr>
           <a:xfrm flipV="1">
-            <a:off x="4572000.0" y="971550.0"/>
-            <a:ext cx="0.0" cy="2286000.0"/>
+            <a:off x="4572000.0" y="285750.0"/>
+            <a:ext cx="0.0" cy="3200400.0"/>
           </a:xfrm>
           <a:prstGeom prst="line">
             <a:avLst/>
@@ -3174,8 +3174,8 @@
         </p:nvSpPr>
         <p:spPr>
           <a:xfrm>
-            <a:off x="3886200" y="971550"/>
-            <a:ext cx="2057400" cy="2148840"/>
+            <a:off x="3429000" y="368046"/>
+            <a:ext cx="3291840" cy="2807208"/>
           </a:xfrm>
           <a:custGeom>
             <a:avLst/>
@@ -3184,1210 +3184,2410 @@
             <a:cxnLst/>
             <a:rect l="l" t="t" r="r" b="b"/>
             <a:pathLst>
-              <a:path w="2057400" h="2148840">
+              <a:path w="3291840" h="2807208">
                 <a:moveTo>
-                  <a:pt x="0" y="2148840"/>
+                  <a:pt x="0" y="2807208"/>
                 </a:moveTo>
                 <a:lnTo>
-                  <a:pt x="9633" y="2129065"/>
-                </a:lnTo>
-                <a:close/>
-                <a:lnTo>
-                  <a:pt x="19267" y="2109601"/>
-                </a:lnTo>
-                <a:close/>
-                <a:lnTo>
-                  <a:pt x="28900" y="2090450"/>
-                </a:lnTo>
-                <a:close/>
-                <a:lnTo>
-                  <a:pt x="38533" y="2071614"/>
-                </a:lnTo>
-                <a:close/>
-                <a:lnTo>
-                  <a:pt x="48166" y="2053095"/>
-                </a:lnTo>
-                <a:close/>
-                <a:lnTo>
-                  <a:pt x="57800" y="2034895"/>
-                </a:lnTo>
-                <a:close/>
-                <a:lnTo>
-                  <a:pt x="67433" y="2017017"/>
-                </a:lnTo>
-                <a:close/>
-                <a:lnTo>
-                  <a:pt x="77066" y="1999462"/>
-                </a:lnTo>
-                <a:close/>
-                <a:lnTo>
-                  <a:pt x="86700" y="1982232"/>
-                </a:lnTo>
-                <a:close/>
-                <a:lnTo>
-                  <a:pt x="96333" y="1965330"/>
-                </a:lnTo>
-                <a:close/>
-                <a:lnTo>
-                  <a:pt x="105966" y="1948758"/>
-                </a:lnTo>
-                <a:close/>
-                <a:lnTo>
-                  <a:pt x="115600" y="1932517"/>
-                </a:lnTo>
-                <a:close/>
-                <a:lnTo>
-                  <a:pt x="125233" y="1916609"/>
-                </a:lnTo>
-                <a:close/>
-                <a:lnTo>
-                  <a:pt x="134866" y="1901038"/>
-                </a:lnTo>
-                <a:close/>
-                <a:lnTo>
-                  <a:pt x="144500" y="1885804"/>
-                </a:lnTo>
-                <a:close/>
-                <a:lnTo>
-                  <a:pt x="154133" y="1870910"/>
-                </a:lnTo>
-                <a:close/>
-                <a:lnTo>
-                  <a:pt x="163766" y="1856358"/>
-                </a:lnTo>
-                <a:close/>
-                <a:lnTo>
-                  <a:pt x="173400" y="1842150"/>
-                </a:lnTo>
-                <a:close/>
-                <a:lnTo>
-                  <a:pt x="183033" y="1828288"/>
-                </a:lnTo>
-                <a:close/>
-                <a:lnTo>
-                  <a:pt x="192666" y="1814775"/>
-                </a:lnTo>
-                <a:close/>
-                <a:lnTo>
-                  <a:pt x="202300" y="1801611"/>
-                </a:lnTo>
-                <a:close/>
-                <a:lnTo>
-                  <a:pt x="211933" y="1788800"/>
-                </a:lnTo>
-                <a:close/>
-                <a:lnTo>
-                  <a:pt x="221566" y="1776343"/>
-                </a:lnTo>
-                <a:close/>
-                <a:lnTo>
-                  <a:pt x="231200" y="1764242"/>
-                </a:lnTo>
-                <a:close/>
-                <a:lnTo>
-                  <a:pt x="240833" y="1752500"/>
-                </a:lnTo>
-                <a:close/>
-                <a:lnTo>
-                  <a:pt x="250466" y="1741118"/>
-                </a:lnTo>
-                <a:close/>
-                <a:lnTo>
-                  <a:pt x="260099" y="1730099"/>
-                </a:lnTo>
-                <a:close/>
-                <a:lnTo>
-                  <a:pt x="269733" y="1719445"/>
-                </a:lnTo>
-                <a:close/>
-                <a:lnTo>
-                  <a:pt x="279366" y="1709157"/>
-                </a:lnTo>
-                <a:close/>
-                <a:lnTo>
-                  <a:pt x="288999" y="1699231"/>
-                </a:lnTo>
-                <a:close/>
-                <a:lnTo>
-                  <a:pt x="298633" y="1689657"/>
-                </a:lnTo>
-                <a:close/>
-                <a:lnTo>
-                  <a:pt x="308266" y="1680425"/>
-                </a:lnTo>
-                <a:close/>
-                <a:lnTo>
-                  <a:pt x="317899" y="1671524"/>
-                </a:lnTo>
-                <a:close/>
-                <a:lnTo>
-                  <a:pt x="327532" y="1662944"/>
-                </a:lnTo>
-                <a:close/>
-                <a:lnTo>
-                  <a:pt x="337166" y="1654674"/>
-                </a:lnTo>
-                <a:close/>
-                <a:lnTo>
-                  <a:pt x="346799" y="1646705"/>
-                </a:lnTo>
-                <a:close/>
-                <a:lnTo>
-                  <a:pt x="356432" y="1639026"/>
-                </a:lnTo>
-                <a:close/>
-                <a:lnTo>
-                  <a:pt x="366065" y="1631627"/>
-                </a:lnTo>
-                <a:close/>
-                <a:lnTo>
-                  <a:pt x="375699" y="1624497"/>
-                </a:lnTo>
-                <a:close/>
-                <a:lnTo>
-                  <a:pt x="385332" y="1617626"/>
-                </a:lnTo>
-                <a:close/>
-                <a:lnTo>
-                  <a:pt x="394966" y="1611004"/>
-                </a:lnTo>
-                <a:close/>
-                <a:lnTo>
-                  <a:pt x="404599" y="1604620"/>
-                </a:lnTo>
-                <a:close/>
-                <a:lnTo>
-                  <a:pt x="414232" y="1598464"/>
-                </a:lnTo>
-                <a:close/>
-                <a:lnTo>
-                  <a:pt x="423866" y="1592526"/>
-                </a:lnTo>
-                <a:close/>
-                <a:lnTo>
-                  <a:pt x="433499" y="1586799"/>
-                </a:lnTo>
-                <a:close/>
-                <a:lnTo>
-                  <a:pt x="443133" y="1581273"/>
-                </a:lnTo>
-                <a:close/>
-                <a:lnTo>
-                  <a:pt x="452766" y="1575941"/>
-                </a:lnTo>
-                <a:close/>
-                <a:lnTo>
-                  <a:pt x="462400" y="1570794"/>
-                </a:lnTo>
-                <a:close/>
-                <a:lnTo>
-                  <a:pt x="472033" y="1565824"/>
-                </a:lnTo>
-                <a:close/>
-                <a:lnTo>
-                  <a:pt x="481667" y="1561023"/>
-                </a:lnTo>
-                <a:close/>
-                <a:lnTo>
-                  <a:pt x="491300" y="1556382"/>
-                </a:lnTo>
-                <a:close/>
-                <a:lnTo>
-                  <a:pt x="500934" y="1551893"/>
-                </a:lnTo>
-                <a:close/>
-                <a:lnTo>
-                  <a:pt x="510567" y="1547547"/>
-                </a:lnTo>
-                <a:close/>
-                <a:lnTo>
-                  <a:pt x="520200" y="1543338"/>
-                </a:lnTo>
-                <a:close/>
-                <a:lnTo>
-                  <a:pt x="529833" y="1539255"/>
-                </a:lnTo>
-                <a:close/>
-                <a:lnTo>
-                  <a:pt x="539466" y="1535292"/>
-                </a:lnTo>
-                <a:close/>
-                <a:lnTo>
-                  <a:pt x="549099" y="1531439"/>
-                </a:lnTo>
-                <a:close/>
-                <a:lnTo>
-                  <a:pt x="558731" y="1527689"/>
-                </a:lnTo>
-                <a:close/>
-                <a:lnTo>
-                  <a:pt x="568364" y="1524038"/>
-                </a:lnTo>
-                <a:close/>
-                <a:lnTo>
-                  <a:pt x="577996" y="1520482"/>
-                </a:lnTo>
-                <a:close/>
-                <a:lnTo>
-                  <a:pt x="587629" y="1517015"/>
-                </a:lnTo>
-                <a:close/>
-                <a:lnTo>
-                  <a:pt x="597261" y="1513635"/>
-                </a:lnTo>
-                <a:close/>
-                <a:lnTo>
-                  <a:pt x="606894" y="1510338"/>
-                </a:lnTo>
-                <a:close/>
-                <a:lnTo>
-                  <a:pt x="616527" y="1507118"/>
-                </a:lnTo>
-                <a:close/>
-                <a:lnTo>
-                  <a:pt x="626160" y="1503972"/>
-                </a:lnTo>
-                <a:close/>
-                <a:lnTo>
-                  <a:pt x="635793" y="1500897"/>
-                </a:lnTo>
-                <a:close/>
-                <a:lnTo>
-                  <a:pt x="645427" y="1497887"/>
-                </a:lnTo>
-                <a:close/>
-                <a:lnTo>
-                  <a:pt x="655061" y="1494939"/>
-                </a:lnTo>
-                <a:close/>
-                <a:lnTo>
-                  <a:pt x="664695" y="1492049"/>
-                </a:lnTo>
-                <a:close/>
-                <a:lnTo>
-                  <a:pt x="674329" y="1489212"/>
-                </a:lnTo>
-                <a:close/>
-                <a:lnTo>
-                  <a:pt x="683965" y="1486426"/>
-                </a:lnTo>
-                <a:close/>
-                <a:lnTo>
-                  <a:pt x="693600" y="1483684"/>
-                </a:lnTo>
-                <a:close/>
-                <a:lnTo>
-                  <a:pt x="703236" y="1480984"/>
-                </a:lnTo>
-                <a:close/>
-                <a:lnTo>
-                  <a:pt x="712873" y="1478322"/>
-                </a:lnTo>
-                <a:close/>
-                <a:lnTo>
-                  <a:pt x="722509" y="1475694"/>
-                </a:lnTo>
-                <a:close/>
-                <a:lnTo>
-                  <a:pt x="732145" y="1473095"/>
-                </a:lnTo>
-                <a:close/>
-                <a:lnTo>
-                  <a:pt x="741781" y="1470522"/>
-                </a:lnTo>
-                <a:close/>
-                <a:lnTo>
-                  <a:pt x="751417" y="1467971"/>
-                </a:lnTo>
-                <a:close/>
-                <a:lnTo>
-                  <a:pt x="761051" y="1465439"/>
-                </a:lnTo>
-                <a:close/>
-                <a:lnTo>
-                  <a:pt x="770685" y="1462920"/>
-                </a:lnTo>
-                <a:close/>
-                <a:lnTo>
-                  <a:pt x="780318" y="1460411"/>
-                </a:lnTo>
-                <a:close/>
-                <a:lnTo>
-                  <a:pt x="789949" y="1457909"/>
-                </a:lnTo>
-                <a:close/>
-                <a:lnTo>
-                  <a:pt x="799579" y="1455409"/>
-                </a:lnTo>
-                <a:close/>
-                <a:lnTo>
-                  <a:pt x="809208" y="1452908"/>
-                </a:lnTo>
-                <a:close/>
-                <a:lnTo>
-                  <a:pt x="818835" y="1450401"/>
-                </a:lnTo>
-                <a:close/>
-                <a:lnTo>
-                  <a:pt x="828460" y="1447885"/>
-                </a:lnTo>
-                <a:close/>
-                <a:lnTo>
-                  <a:pt x="838083" y="1445352"/>
-                </a:lnTo>
-                <a:close/>
-                <a:lnTo>
-                  <a:pt x="847705" y="1442795"/>
-                </a:lnTo>
-                <a:close/>
-                <a:lnTo>
-                  <a:pt x="857327" y="1440204"/>
-                </a:lnTo>
-                <a:close/>
-                <a:lnTo>
-                  <a:pt x="866950" y="1437570"/>
-                </a:lnTo>
-                <a:close/>
-                <a:lnTo>
-                  <a:pt x="876573" y="1434886"/>
-                </a:lnTo>
-                <a:close/>
-                <a:lnTo>
-                  <a:pt x="886198" y="1432142"/>
-                </a:lnTo>
-                <a:close/>
-                <a:lnTo>
-                  <a:pt x="895826" y="1429329"/>
-                </a:lnTo>
-                <a:close/>
-                <a:lnTo>
-                  <a:pt x="905456" y="1426438"/>
-                </a:lnTo>
-                <a:close/>
-                <a:lnTo>
-                  <a:pt x="915091" y="1423462"/>
-                </a:lnTo>
-                <a:close/>
-                <a:lnTo>
-                  <a:pt x="924729" y="1420391"/>
-                </a:lnTo>
-                <a:close/>
-                <a:lnTo>
-                  <a:pt x="934373" y="1417216"/>
-                </a:lnTo>
-                <a:close/>
-                <a:lnTo>
-                  <a:pt x="944023" y="1413928"/>
-                </a:lnTo>
-                <a:close/>
-                <a:lnTo>
-                  <a:pt x="953679" y="1410520"/>
-                </a:lnTo>
-                <a:close/>
-                <a:lnTo>
-                  <a:pt x="963342" y="1406982"/>
-                </a:lnTo>
-                <a:close/>
-                <a:lnTo>
-                  <a:pt x="973012" y="1403312"/>
-                </a:lnTo>
-                <a:close/>
-                <a:lnTo>
-                  <a:pt x="982685" y="1399521"/>
-                </a:lnTo>
-                <a:close/>
-                <a:lnTo>
-                  <a:pt x="992361" y="1395618"/>
-                </a:lnTo>
-                <a:close/>
-                <a:lnTo>
-                  <a:pt x="1002036" y="1391614"/>
-                </a:lnTo>
-                <a:close/>
-                <a:lnTo>
-                  <a:pt x="1011707" y="1387520"/>
-                </a:lnTo>
-                <a:close/>
-                <a:lnTo>
-                  <a:pt x="1021373" y="1383345"/>
-                </a:lnTo>
-                <a:close/>
-                <a:lnTo>
-                  <a:pt x="1031030" y="1379101"/>
-                </a:lnTo>
-                <a:close/>
-                <a:lnTo>
-                  <a:pt x="1040676" y="1374798"/>
-                </a:lnTo>
-                <a:close/>
-                <a:lnTo>
-                  <a:pt x="1050309" y="1370445"/>
-                </a:lnTo>
-                <a:close/>
-                <a:lnTo>
-                  <a:pt x="1059927" y="1366055"/>
-                </a:lnTo>
-                <a:close/>
-                <a:lnTo>
-                  <a:pt x="1069525" y="1361636"/>
-                </a:lnTo>
-                <a:close/>
-                <a:lnTo>
-                  <a:pt x="1079103" y="1357200"/>
-                </a:lnTo>
-                <a:close/>
-                <a:lnTo>
-                  <a:pt x="1088658" y="1352757"/>
-                </a:lnTo>
-                <a:close/>
-                <a:lnTo>
-                  <a:pt x="1098186" y="1348318"/>
-                </a:lnTo>
-                <a:close/>
-                <a:lnTo>
-                  <a:pt x="1107689" y="1343886"/>
-                </a:lnTo>
-                <a:close/>
-                <a:lnTo>
-                  <a:pt x="1117174" y="1339453"/>
-                </a:lnTo>
-                <a:close/>
-                <a:lnTo>
-                  <a:pt x="1126650" y="1335002"/>
-                </a:lnTo>
-                <a:close/>
-                <a:lnTo>
-                  <a:pt x="1136127" y="1330522"/>
-                </a:lnTo>
-                <a:close/>
-                <a:lnTo>
-                  <a:pt x="1145614" y="1325997"/>
-                </a:lnTo>
-                <a:close/>
-                <a:lnTo>
-                  <a:pt x="1155121" y="1321413"/>
-                </a:lnTo>
-                <a:close/>
-                <a:lnTo>
-                  <a:pt x="1164657" y="1316757"/>
-                </a:lnTo>
-                <a:close/>
-                <a:lnTo>
-                  <a:pt x="1174231" y="1312015"/>
-                </a:lnTo>
-                <a:close/>
-                <a:lnTo>
-                  <a:pt x="1183852" y="1307173"/>
-                </a:lnTo>
-                <a:close/>
-                <a:lnTo>
-                  <a:pt x="1193531" y="1302216"/>
-                </a:lnTo>
-                <a:close/>
-                <a:lnTo>
-                  <a:pt x="1203276" y="1297131"/>
-                </a:lnTo>
-                <a:close/>
-                <a:lnTo>
-                  <a:pt x="1213097" y="1291904"/>
-                </a:lnTo>
-                <a:close/>
-                <a:lnTo>
-                  <a:pt x="1223003" y="1286521"/>
-                </a:lnTo>
-                <a:close/>
-                <a:lnTo>
-                  <a:pt x="1233003" y="1280968"/>
-                </a:lnTo>
-                <a:close/>
-                <a:lnTo>
-                  <a:pt x="1243103" y="1275234"/>
-                </a:lnTo>
-                <a:close/>
-                <a:lnTo>
-                  <a:pt x="1253278" y="1269328"/>
-                </a:lnTo>
-                <a:close/>
-                <a:lnTo>
-                  <a:pt x="1263493" y="1263268"/>
-                </a:lnTo>
-                <a:close/>
-                <a:lnTo>
-                  <a:pt x="1273713" y="1257070"/>
-                </a:lnTo>
-                <a:close/>
-                <a:lnTo>
-                  <a:pt x="1283904" y="1250751"/>
-                </a:lnTo>
-                <a:close/>
-                <a:lnTo>
-                  <a:pt x="1294030" y="1244328"/>
-                </a:lnTo>
-                <a:close/>
-                <a:lnTo>
-                  <a:pt x="1304057" y="1237819"/>
-                </a:lnTo>
-                <a:close/>
-                <a:lnTo>
-                  <a:pt x="1313949" y="1231239"/>
-                </a:lnTo>
-                <a:close/>
-                <a:lnTo>
-                  <a:pt x="1323671" y="1224607"/>
-                </a:lnTo>
-                <a:close/>
-                <a:lnTo>
-                  <a:pt x="1333189" y="1217938"/>
-                </a:lnTo>
-                <a:close/>
-                <a:lnTo>
-                  <a:pt x="1342468" y="1211250"/>
-                </a:lnTo>
-                <a:close/>
-                <a:lnTo>
-                  <a:pt x="1351472" y="1204559"/>
-                </a:lnTo>
-                <a:close/>
-                <a:lnTo>
-                  <a:pt x="1360166" y="1197883"/>
-                </a:lnTo>
-                <a:close/>
-                <a:lnTo>
-                  <a:pt x="1368517" y="1191239"/>
-                </a:lnTo>
-                <a:close/>
-                <a:lnTo>
-                  <a:pt x="1376491" y="1184643"/>
-                </a:lnTo>
-                <a:close/>
-                <a:lnTo>
-                  <a:pt x="1384094" y="1178097"/>
-                </a:lnTo>
-                <a:close/>
-                <a:lnTo>
-                  <a:pt x="1391363" y="1171596"/>
-                </a:lnTo>
-                <a:close/>
-                <a:lnTo>
-                  <a:pt x="1398332" y="1165134"/>
-                </a:lnTo>
-                <a:close/>
-                <a:lnTo>
-                  <a:pt x="1405036" y="1158704"/>
-                </a:lnTo>
-                <a:close/>
-                <a:lnTo>
-                  <a:pt x="1411512" y="1152300"/>
-                </a:lnTo>
-                <a:close/>
-                <a:lnTo>
-                  <a:pt x="1417794" y="1145917"/>
-                </a:lnTo>
-                <a:close/>
-                <a:lnTo>
-                  <a:pt x="1423918" y="1139547"/>
-                </a:lnTo>
-                <a:close/>
-                <a:lnTo>
-                  <a:pt x="1429920" y="1133184"/>
-                </a:lnTo>
-                <a:close/>
-                <a:lnTo>
-                  <a:pt x="1435834" y="1126823"/>
-                </a:lnTo>
-                <a:close/>
-                <a:lnTo>
-                  <a:pt x="1441697" y="1120457"/>
-                </a:lnTo>
-                <a:close/>
-                <a:lnTo>
-                  <a:pt x="1447544" y="1114080"/>
-                </a:lnTo>
-                <a:close/>
-                <a:lnTo>
-                  <a:pt x="1453411" y="1107686"/>
-                </a:lnTo>
-                <a:close/>
-                <a:lnTo>
-                  <a:pt x="1459332" y="1101268"/>
-                </a:lnTo>
-                <a:close/>
-                <a:lnTo>
-                  <a:pt x="1465342" y="1094820"/>
-                </a:lnTo>
-                <a:close/>
-                <a:lnTo>
-                  <a:pt x="1471459" y="1088342"/>
-                </a:lnTo>
-                <a:close/>
-                <a:lnTo>
-                  <a:pt x="1477672" y="1081842"/>
-                </a:lnTo>
-                <a:close/>
-                <a:lnTo>
-                  <a:pt x="1483968" y="1075327"/>
-                </a:lnTo>
-                <a:close/>
-                <a:lnTo>
-                  <a:pt x="1490337" y="1068805"/>
-                </a:lnTo>
-                <a:close/>
-                <a:lnTo>
-                  <a:pt x="1496766" y="1062284"/>
-                </a:lnTo>
-                <a:close/>
-                <a:lnTo>
-                  <a:pt x="1503244" y="1055772"/>
-                </a:lnTo>
-                <a:close/>
-                <a:lnTo>
-                  <a:pt x="1509758" y="1049278"/>
-                </a:lnTo>
-                <a:close/>
-                <a:lnTo>
-                  <a:pt x="1516298" y="1042809"/>
-                </a:lnTo>
-                <a:close/>
-                <a:lnTo>
-                  <a:pt x="1522850" y="1036373"/>
-                </a:lnTo>
-                <a:close/>
-                <a:lnTo>
-                  <a:pt x="1529404" y="1029977"/>
-                </a:lnTo>
-                <a:close/>
-                <a:lnTo>
-                  <a:pt x="1535948" y="1023631"/>
-                </a:lnTo>
-                <a:close/>
-                <a:lnTo>
-                  <a:pt x="1542469" y="1017342"/>
-                </a:lnTo>
-                <a:close/>
-                <a:lnTo>
-                  <a:pt x="1548956" y="1011118"/>
-                </a:lnTo>
-                <a:close/>
-                <a:lnTo>
-                  <a:pt x="1555397" y="1004966"/>
-                </a:lnTo>
-                <a:close/>
-                <a:lnTo>
-                  <a:pt x="1561786" y="998887"/>
-                </a:lnTo>
-                <a:close/>
-                <a:lnTo>
-                  <a:pt x="1568132" y="992858"/>
-                </a:lnTo>
-                <a:close/>
-                <a:lnTo>
-                  <a:pt x="1574448" y="986854"/>
-                </a:lnTo>
-                <a:close/>
-                <a:lnTo>
-                  <a:pt x="1580745" y="980850"/>
-                </a:lnTo>
-                <a:close/>
-                <a:lnTo>
-                  <a:pt x="1587035" y="974818"/>
-                </a:lnTo>
-                <a:close/>
-                <a:lnTo>
-                  <a:pt x="1593329" y="968735"/>
-                </a:lnTo>
-                <a:close/>
-                <a:lnTo>
-                  <a:pt x="1599640" y="962574"/>
-                </a:lnTo>
-                <a:close/>
-                <a:lnTo>
-                  <a:pt x="1605979" y="956310"/>
-                </a:lnTo>
-                <a:close/>
-                <a:lnTo>
-                  <a:pt x="1612358" y="949917"/>
-                </a:lnTo>
-                <a:close/>
-                <a:lnTo>
-                  <a:pt x="1618790" y="943369"/>
-                </a:lnTo>
-                <a:close/>
-                <a:lnTo>
-                  <a:pt x="1625285" y="936641"/>
-                </a:lnTo>
-                <a:close/>
-                <a:lnTo>
-                  <a:pt x="1631855" y="929708"/>
-                </a:lnTo>
-                <a:close/>
-                <a:lnTo>
-                  <a:pt x="1638514" y="922543"/>
-                </a:lnTo>
-                <a:close/>
-                <a:lnTo>
-                  <a:pt x="1645271" y="915121"/>
-                </a:lnTo>
-                <a:close/>
-                <a:lnTo>
-                  <a:pt x="1652133" y="907426"/>
-                </a:lnTo>
-                <a:close/>
-                <a:lnTo>
-                  <a:pt x="1659076" y="899488"/>
-                </a:lnTo>
-                <a:close/>
-                <a:lnTo>
-                  <a:pt x="1666063" y="891354"/>
-                </a:lnTo>
-                <a:close/>
-                <a:lnTo>
-                  <a:pt x="1673060" y="883072"/>
-                </a:lnTo>
-                <a:close/>
-                <a:lnTo>
-                  <a:pt x="1680030" y="874688"/>
-                </a:lnTo>
-                <a:close/>
-                <a:lnTo>
-                  <a:pt x="1686939" y="866250"/>
-                </a:lnTo>
-                <a:close/>
-                <a:lnTo>
-                  <a:pt x="1693750" y="857804"/>
-                </a:lnTo>
-                <a:close/>
-                <a:lnTo>
-                  <a:pt x="1700429" y="849397"/>
-                </a:lnTo>
-                <a:close/>
-                <a:lnTo>
-                  <a:pt x="1706939" y="841077"/>
-                </a:lnTo>
-                <a:close/>
-                <a:lnTo>
-                  <a:pt x="1713246" y="832890"/>
-                </a:lnTo>
-                <a:close/>
-                <a:lnTo>
-                  <a:pt x="1719314" y="824884"/>
-                </a:lnTo>
-                <a:close/>
-                <a:lnTo>
-                  <a:pt x="1725108" y="817104"/>
-                </a:lnTo>
-                <a:close/>
-                <a:lnTo>
-                  <a:pt x="1730592" y="809599"/>
-                </a:lnTo>
-                <a:close/>
-                <a:lnTo>
-                  <a:pt x="1735730" y="802415"/>
-                </a:lnTo>
-                <a:close/>
-                <a:lnTo>
-                  <a:pt x="1740491" y="795596"/>
-                </a:lnTo>
-                <a:close/>
-                <a:lnTo>
-                  <a:pt x="1744883" y="789147"/>
-                </a:lnTo>
-                <a:close/>
-                <a:lnTo>
-                  <a:pt x="1748941" y="783050"/>
-                </a:lnTo>
-                <a:close/>
-                <a:lnTo>
-                  <a:pt x="1752699" y="777283"/>
-                </a:lnTo>
-                <a:close/>
-                <a:lnTo>
-                  <a:pt x="1756193" y="771828"/>
-                </a:lnTo>
-                <a:close/>
-                <a:lnTo>
-                  <a:pt x="1759458" y="766665"/>
-                </a:lnTo>
-                <a:close/>
-                <a:lnTo>
-                  <a:pt x="1762528" y="761773"/>
-                </a:lnTo>
-                <a:close/>
-                <a:lnTo>
-                  <a:pt x="1765438" y="757134"/>
-                </a:lnTo>
-                <a:close/>
-                <a:lnTo>
-                  <a:pt x="1768224" y="752728"/>
-                </a:lnTo>
-                <a:close/>
-                <a:lnTo>
-                  <a:pt x="1770920" y="748534"/>
-                </a:lnTo>
-                <a:close/>
-                <a:lnTo>
-                  <a:pt x="1773562" y="744533"/>
-                </a:lnTo>
-                <a:close/>
-                <a:lnTo>
-                  <a:pt x="1776184" y="740705"/>
-                </a:lnTo>
-                <a:close/>
-                <a:lnTo>
-                  <a:pt x="1778821" y="737031"/>
-                </a:lnTo>
-                <a:close/>
-                <a:lnTo>
-                  <a:pt x="1781508" y="733491"/>
-                </a:lnTo>
-                <a:close/>
-                <a:lnTo>
-                  <a:pt x="1784280" y="730064"/>
-                </a:lnTo>
-                <a:close/>
-                <a:lnTo>
-                  <a:pt x="1787152" y="726734"/>
-                </a:lnTo>
-                <a:close/>
-                <a:lnTo>
-                  <a:pt x="1790116" y="723485"/>
-                </a:lnTo>
-                <a:close/>
-                <a:lnTo>
-                  <a:pt x="1793162" y="720300"/>
-                </a:lnTo>
-                <a:close/>
-                <a:lnTo>
-                  <a:pt x="1796282" y="717165"/>
-                </a:lnTo>
-                <a:close/>
-                <a:lnTo>
-                  <a:pt x="1799465" y="714064"/>
-                </a:lnTo>
-                <a:close/>
-                <a:lnTo>
-                  <a:pt x="1802702" y="710981"/>
-                </a:lnTo>
-                <a:close/>
-                <a:lnTo>
-                  <a:pt x="1805984" y="707902"/>
-                </a:lnTo>
-                <a:close/>
-                <a:lnTo>
-                  <a:pt x="1809302" y="704810"/>
-                </a:lnTo>
-                <a:close/>
-                <a:lnTo>
-                  <a:pt x="1812647" y="701690"/>
-                </a:lnTo>
-                <a:close/>
-                <a:lnTo>
-                  <a:pt x="1816008" y="698526"/>
-                </a:lnTo>
-                <a:close/>
-                <a:lnTo>
-                  <a:pt x="1819376" y="695303"/>
-                </a:lnTo>
-                <a:close/>
-                <a:lnTo>
-                  <a:pt x="1822743" y="692006"/>
-                </a:lnTo>
-                <a:close/>
-                <a:lnTo>
-                  <a:pt x="1826098" y="688619"/>
-                </a:lnTo>
-                <a:close/>
-                <a:lnTo>
-                  <a:pt x="1829433" y="685126"/>
-                </a:lnTo>
-                <a:close/>
-                <a:lnTo>
-                  <a:pt x="1832741" y="681512"/>
-                </a:lnTo>
-                <a:close/>
-                <a:lnTo>
-                  <a:pt x="1836024" y="677765"/>
-                </a:lnTo>
-                <a:close/>
-                <a:lnTo>
-                  <a:pt x="1839285" y="673870"/>
-                </a:lnTo>
-                <a:close/>
-                <a:lnTo>
-                  <a:pt x="1842525" y="669815"/>
-                </a:lnTo>
-                <a:close/>
-                <a:lnTo>
-                  <a:pt x="1845747" y="665587"/>
-                </a:lnTo>
-                <a:close/>
-                <a:lnTo>
-                  <a:pt x="1848955" y="661171"/>
-                </a:lnTo>
-                <a:close/>
-                <a:lnTo>
-                  <a:pt x="1852149" y="656556"/>
-                </a:lnTo>
-                <a:close/>
-                <a:lnTo>
-                  <a:pt x="1855334" y="651727"/>
-                </a:lnTo>
-                <a:close/>
-                <a:lnTo>
-                  <a:pt x="1858511" y="646671"/>
-                </a:lnTo>
-                <a:close/>
-                <a:lnTo>
-                  <a:pt x="1861682" y="641376"/>
-                </a:lnTo>
-                <a:close/>
-                <a:lnTo>
-                  <a:pt x="1864852" y="635828"/>
-                </a:lnTo>
-                <a:close/>
-                <a:lnTo>
-                  <a:pt x="1868021" y="630013"/>
-                </a:lnTo>
-                <a:close/>
-                <a:lnTo>
-                  <a:pt x="1871192" y="623919"/>
-                </a:lnTo>
-                <a:close/>
-                <a:lnTo>
-                  <a:pt x="1874369" y="617532"/>
-                </a:lnTo>
-                <a:close/>
-                <a:lnTo>
-                  <a:pt x="1877552" y="610844"/>
-                </a:lnTo>
-                <a:close/>
-                <a:lnTo>
-                  <a:pt x="1880742" y="603869"/>
-                </a:lnTo>
-                <a:close/>
-                <a:lnTo>
-                  <a:pt x="1883939" y="596628"/>
-                </a:lnTo>
-                <a:close/>
-                <a:lnTo>
-                  <a:pt x="1887141" y="589143"/>
-                </a:lnTo>
-                <a:close/>
-                <a:lnTo>
-                  <a:pt x="1890348" y="581434"/>
-                </a:lnTo>
-                <a:close/>
-                <a:lnTo>
-                  <a:pt x="1893559" y="573522"/>
-                </a:lnTo>
-                <a:close/>
-                <a:lnTo>
-                  <a:pt x="1896774" y="565427"/>
-                </a:lnTo>
-                <a:close/>
-                <a:lnTo>
-                  <a:pt x="1899991" y="557172"/>
-                </a:lnTo>
-                <a:close/>
-                <a:lnTo>
-                  <a:pt x="1903211" y="548777"/>
-                </a:lnTo>
-                <a:close/>
-                <a:lnTo>
-                  <a:pt x="1906433" y="540263"/>
-                </a:lnTo>
-                <a:close/>
-                <a:lnTo>
-                  <a:pt x="1909655" y="531650"/>
-                </a:lnTo>
-                <a:close/>
-                <a:lnTo>
-                  <a:pt x="1912877" y="522960"/>
-                </a:lnTo>
-                <a:close/>
-                <a:lnTo>
-                  <a:pt x="1916099" y="514214"/>
-                </a:lnTo>
-                <a:close/>
-                <a:lnTo>
-                  <a:pt x="1919320" y="505433"/>
-                </a:lnTo>
-                <a:close/>
-                <a:lnTo>
-                  <a:pt x="1922539" y="496634"/>
-                </a:lnTo>
-                <a:close/>
-                <a:lnTo>
-                  <a:pt x="1925756" y="487810"/>
-                </a:lnTo>
-                <a:close/>
-                <a:lnTo>
-                  <a:pt x="1928972" y="478939"/>
-                </a:lnTo>
-                <a:close/>
-                <a:lnTo>
-                  <a:pt x="1932186" y="469996"/>
-                </a:lnTo>
-                <a:close/>
-                <a:lnTo>
-                  <a:pt x="1935398" y="460960"/>
-                </a:lnTo>
-                <a:close/>
-                <a:lnTo>
-                  <a:pt x="1938610" y="451806"/>
-                </a:lnTo>
-                <a:close/>
-                <a:lnTo>
-                  <a:pt x="1941820" y="442513"/>
-                </a:lnTo>
-                <a:close/>
-                <a:lnTo>
-                  <a:pt x="1945029" y="433057"/>
-                </a:lnTo>
-                <a:close/>
-                <a:lnTo>
-                  <a:pt x="1948238" y="423414"/>
-                </a:lnTo>
-                <a:close/>
-                <a:lnTo>
-                  <a:pt x="1951447" y="413563"/>
-                </a:lnTo>
-                <a:close/>
-                <a:lnTo>
-                  <a:pt x="1954655" y="403480"/>
-                </a:lnTo>
-                <a:close/>
-                <a:lnTo>
-                  <a:pt x="1957863" y="393141"/>
-                </a:lnTo>
-                <a:close/>
-                <a:lnTo>
-                  <a:pt x="1961071" y="382524"/>
-                </a:lnTo>
-                <a:close/>
-                <a:lnTo>
-                  <a:pt x="1964279" y="371607"/>
-                </a:lnTo>
-                <a:close/>
-                <a:lnTo>
-                  <a:pt x="1967488" y="360366"/>
-                </a:lnTo>
-                <a:close/>
-                <a:lnTo>
-                  <a:pt x="1970697" y="348801"/>
-                </a:lnTo>
-                <a:close/>
-                <a:lnTo>
-                  <a:pt x="1973907" y="336935"/>
-                </a:lnTo>
-                <a:close/>
-                <a:lnTo>
-                  <a:pt x="1977117" y="324791"/>
-                </a:lnTo>
-                <a:close/>
-                <a:lnTo>
-                  <a:pt x="1980327" y="312393"/>
-                </a:lnTo>
-                <a:close/>
-                <a:lnTo>
-                  <a:pt x="1983538" y="299764"/>
-                </a:lnTo>
-                <a:close/>
-                <a:lnTo>
-                  <a:pt x="1986749" y="286929"/>
-                </a:lnTo>
-                <a:close/>
-                <a:lnTo>
-                  <a:pt x="1989961" y="273910"/>
-                </a:lnTo>
-                <a:close/>
-                <a:lnTo>
-                  <a:pt x="1993172" y="260732"/>
-                </a:lnTo>
-                <a:close/>
-                <a:lnTo>
-                  <a:pt x="1996384" y="247418"/>
-                </a:lnTo>
-                <a:close/>
-                <a:lnTo>
-                  <a:pt x="1999596" y="233991"/>
-                </a:lnTo>
-                <a:close/>
-                <a:lnTo>
-                  <a:pt x="2002808" y="220476"/>
-                </a:lnTo>
-                <a:close/>
-                <a:lnTo>
-                  <a:pt x="2006020" y="206895"/>
-                </a:lnTo>
-                <a:close/>
-                <a:lnTo>
-                  <a:pt x="2009233" y="193272"/>
-                </a:lnTo>
-                <a:close/>
-                <a:lnTo>
-                  <a:pt x="2012445" y="179632"/>
-                </a:lnTo>
-                <a:close/>
-                <a:lnTo>
-                  <a:pt x="2015657" y="165997"/>
-                </a:lnTo>
-                <a:close/>
-                <a:lnTo>
-                  <a:pt x="2018869" y="152392"/>
-                </a:lnTo>
-                <a:close/>
-                <a:lnTo>
-                  <a:pt x="2022082" y="138839"/>
-                </a:lnTo>
-                <a:close/>
-                <a:lnTo>
-                  <a:pt x="2025294" y="125363"/>
-                </a:lnTo>
-                <a:close/>
-                <a:lnTo>
-                  <a:pt x="2028505" y="111987"/>
-                </a:lnTo>
-                <a:close/>
-                <a:lnTo>
-                  <a:pt x="2031717" y="98734"/>
-                </a:lnTo>
-                <a:close/>
-                <a:lnTo>
-                  <a:pt x="2034929" y="85629"/>
-                </a:lnTo>
-                <a:close/>
-                <a:lnTo>
-                  <a:pt x="2038140" y="72695"/>
-                </a:lnTo>
-                <a:close/>
-                <a:lnTo>
-                  <a:pt x="2041351" y="59955"/>
-                </a:lnTo>
-                <a:close/>
-                <a:lnTo>
-                  <a:pt x="2044561" y="47433"/>
-                </a:lnTo>
-                <a:close/>
-                <a:lnTo>
-                  <a:pt x="2047772" y="35153"/>
-                </a:lnTo>
-                <a:close/>
-                <a:lnTo>
-                  <a:pt x="2050982" y="23139"/>
-                </a:lnTo>
-                <a:close/>
-                <a:lnTo>
-                  <a:pt x="2054191" y="11413"/>
-                </a:lnTo>
-                <a:close/>
-                <a:lnTo>
-                  <a:pt x="2057400" y="0"/>
+                  <a:pt x="6755" y="2799101"/>
+                </a:lnTo>
+                <a:close/>
+                <a:lnTo>
+                  <a:pt x="13510" y="2791238"/>
+                </a:lnTo>
+                <a:close/>
+                <a:lnTo>
+                  <a:pt x="20265" y="2783599"/>
+                </a:lnTo>
+                <a:close/>
+                <a:lnTo>
+                  <a:pt x="27020" y="2776170"/>
+                </a:lnTo>
+                <a:close/>
+                <a:lnTo>
+                  <a:pt x="33775" y="2768934"/>
+                </a:lnTo>
+                <a:close/>
+                <a:lnTo>
+                  <a:pt x="40530" y="2761872"/>
+                </a:lnTo>
+                <a:close/>
+                <a:lnTo>
+                  <a:pt x="47285" y="2754969"/>
+                </a:lnTo>
+                <a:close/>
+                <a:lnTo>
+                  <a:pt x="54040" y="2748208"/>
+                </a:lnTo>
+                <a:close/>
+                <a:lnTo>
+                  <a:pt x="60795" y="2741572"/>
+                </a:lnTo>
+                <a:close/>
+                <a:lnTo>
+                  <a:pt x="67550" y="2735043"/>
+                </a:lnTo>
+                <a:close/>
+                <a:lnTo>
+                  <a:pt x="74305" y="2728606"/>
+                </a:lnTo>
+                <a:close/>
+                <a:lnTo>
+                  <a:pt x="81059" y="2722244"/>
+                </a:lnTo>
+                <a:close/>
+                <a:lnTo>
+                  <a:pt x="87814" y="2715939"/>
+                </a:lnTo>
+                <a:close/>
+                <a:lnTo>
+                  <a:pt x="94569" y="2709675"/>
+                </a:lnTo>
+                <a:close/>
+                <a:lnTo>
+                  <a:pt x="101324" y="2703435"/>
+                </a:lnTo>
+                <a:close/>
+                <a:lnTo>
+                  <a:pt x="108079" y="2697202"/>
+                </a:lnTo>
+                <a:close/>
+                <a:lnTo>
+                  <a:pt x="114834" y="2690960"/>
+                </a:lnTo>
+                <a:close/>
+                <a:lnTo>
+                  <a:pt x="121589" y="2684691"/>
+                </a:lnTo>
+                <a:close/>
+                <a:lnTo>
+                  <a:pt x="128344" y="2678379"/>
+                </a:lnTo>
+                <a:close/>
+                <a:lnTo>
+                  <a:pt x="135099" y="2672007"/>
+                </a:lnTo>
+                <a:close/>
+                <a:lnTo>
+                  <a:pt x="141854" y="2665560"/>
+                </a:lnTo>
+                <a:close/>
+                <a:lnTo>
+                  <a:pt x="148609" y="2659054"/>
+                </a:lnTo>
+                <a:close/>
+                <a:lnTo>
+                  <a:pt x="155364" y="2652519"/>
+                </a:lnTo>
+                <a:close/>
+                <a:lnTo>
+                  <a:pt x="162119" y="2645988"/>
+                </a:lnTo>
+                <a:close/>
+                <a:lnTo>
+                  <a:pt x="168874" y="2639491"/>
+                </a:lnTo>
+                <a:close/>
+                <a:lnTo>
+                  <a:pt x="175629" y="2633062"/>
+                </a:lnTo>
+                <a:close/>
+                <a:lnTo>
+                  <a:pt x="182384" y="2626730"/>
+                </a:lnTo>
+                <a:close/>
+                <a:lnTo>
+                  <a:pt x="189139" y="2620529"/>
+                </a:lnTo>
+                <a:close/>
+                <a:lnTo>
+                  <a:pt x="195894" y="2614489"/>
+                </a:lnTo>
+                <a:close/>
+                <a:lnTo>
+                  <a:pt x="202649" y="2608642"/>
+                </a:lnTo>
+                <a:close/>
+                <a:lnTo>
+                  <a:pt x="209404" y="2603019"/>
+                </a:lnTo>
+                <a:close/>
+                <a:lnTo>
+                  <a:pt x="216159" y="2597617"/>
+                </a:lnTo>
+                <a:close/>
+                <a:lnTo>
+                  <a:pt x="222914" y="2592407"/>
+                </a:lnTo>
+                <a:close/>
+                <a:lnTo>
+                  <a:pt x="229669" y="2587357"/>
+                </a:lnTo>
+                <a:close/>
+                <a:lnTo>
+                  <a:pt x="236424" y="2582435"/>
+                </a:lnTo>
+                <a:close/>
+                <a:lnTo>
+                  <a:pt x="243178" y="2577612"/>
+                </a:lnTo>
+                <a:close/>
+                <a:lnTo>
+                  <a:pt x="249933" y="2572855"/>
+                </a:lnTo>
+                <a:close/>
+                <a:lnTo>
+                  <a:pt x="256688" y="2568133"/>
+                </a:lnTo>
+                <a:close/>
+                <a:lnTo>
+                  <a:pt x="263443" y="2563415"/>
+                </a:lnTo>
+                <a:close/>
+                <a:lnTo>
+                  <a:pt x="270198" y="2558670"/>
+                </a:lnTo>
+                <a:close/>
+                <a:lnTo>
+                  <a:pt x="276953" y="2553867"/>
+                </a:lnTo>
+                <a:close/>
+                <a:lnTo>
+                  <a:pt x="283708" y="2548994"/>
+                </a:lnTo>
+                <a:close/>
+                <a:lnTo>
+                  <a:pt x="290463" y="2544064"/>
+                </a:lnTo>
+                <a:close/>
+                <a:lnTo>
+                  <a:pt x="297218" y="2539091"/>
+                </a:lnTo>
+                <a:close/>
+                <a:lnTo>
+                  <a:pt x="303973" y="2534090"/>
+                </a:lnTo>
+                <a:close/>
+                <a:lnTo>
+                  <a:pt x="310728" y="2529076"/>
+                </a:lnTo>
+                <a:close/>
+                <a:lnTo>
+                  <a:pt x="317483" y="2524062"/>
+                </a:lnTo>
+                <a:close/>
+                <a:lnTo>
+                  <a:pt x="324238" y="2519064"/>
+                </a:lnTo>
+                <a:close/>
+                <a:lnTo>
+                  <a:pt x="330993" y="2514096"/>
+                </a:lnTo>
+                <a:close/>
+                <a:lnTo>
+                  <a:pt x="337748" y="2509172"/>
+                </a:lnTo>
+                <a:close/>
+                <a:lnTo>
+                  <a:pt x="344503" y="2504308"/>
+                </a:lnTo>
+                <a:close/>
+                <a:lnTo>
+                  <a:pt x="351258" y="2499512"/>
+                </a:lnTo>
+                <a:close/>
+                <a:lnTo>
+                  <a:pt x="358013" y="2494785"/>
+                </a:lnTo>
+                <a:close/>
+                <a:lnTo>
+                  <a:pt x="364768" y="2490128"/>
+                </a:lnTo>
+                <a:close/>
+                <a:lnTo>
+                  <a:pt x="371523" y="2485537"/>
+                </a:lnTo>
+                <a:close/>
+                <a:lnTo>
+                  <a:pt x="378278" y="2481015"/>
+                </a:lnTo>
+                <a:close/>
+                <a:lnTo>
+                  <a:pt x="385033" y="2476558"/>
+                </a:lnTo>
+                <a:close/>
+                <a:lnTo>
+                  <a:pt x="391788" y="2472167"/>
+                </a:lnTo>
+                <a:close/>
+                <a:lnTo>
+                  <a:pt x="398543" y="2467842"/>
+                </a:lnTo>
+                <a:close/>
+                <a:lnTo>
+                  <a:pt x="405297" y="2463580"/>
+                </a:lnTo>
+                <a:close/>
+                <a:lnTo>
+                  <a:pt x="412052" y="2459383"/>
+                </a:lnTo>
+                <a:close/>
+                <a:lnTo>
+                  <a:pt x="418807" y="2455246"/>
+                </a:lnTo>
+                <a:close/>
+                <a:lnTo>
+                  <a:pt x="425562" y="2451159"/>
+                </a:lnTo>
+                <a:close/>
+                <a:lnTo>
+                  <a:pt x="432317" y="2447111"/>
+                </a:lnTo>
+                <a:close/>
+                <a:lnTo>
+                  <a:pt x="439072" y="2443089"/>
+                </a:lnTo>
+                <a:close/>
+                <a:lnTo>
+                  <a:pt x="445827" y="2439083"/>
+                </a:lnTo>
+                <a:close/>
+                <a:lnTo>
+                  <a:pt x="452582" y="2435080"/>
+                </a:lnTo>
+                <a:close/>
+                <a:lnTo>
+                  <a:pt x="459337" y="2431069"/>
+                </a:lnTo>
+                <a:close/>
+                <a:lnTo>
+                  <a:pt x="466092" y="2427038"/>
+                </a:lnTo>
+                <a:close/>
+                <a:lnTo>
+                  <a:pt x="472847" y="2422975"/>
+                </a:lnTo>
+                <a:close/>
+                <a:lnTo>
+                  <a:pt x="479602" y="2418868"/>
+                </a:lnTo>
+                <a:close/>
+                <a:lnTo>
+                  <a:pt x="486357" y="2414711"/>
+                </a:lnTo>
+                <a:close/>
+                <a:lnTo>
+                  <a:pt x="493112" y="2410517"/>
+                </a:lnTo>
+                <a:close/>
+                <a:lnTo>
+                  <a:pt x="499867" y="2406309"/>
+                </a:lnTo>
+                <a:close/>
+                <a:lnTo>
+                  <a:pt x="506622" y="2402108"/>
+                </a:lnTo>
+                <a:close/>
+                <a:lnTo>
+                  <a:pt x="513377" y="2397934"/>
+                </a:lnTo>
+                <a:close/>
+                <a:lnTo>
+                  <a:pt x="520132" y="2393811"/>
+                </a:lnTo>
+                <a:close/>
+                <a:lnTo>
+                  <a:pt x="526887" y="2389757"/>
+                </a:lnTo>
+                <a:close/>
+                <a:lnTo>
+                  <a:pt x="533642" y="2385797"/>
+                </a:lnTo>
+                <a:close/>
+                <a:lnTo>
+                  <a:pt x="540397" y="2381950"/>
+                </a:lnTo>
+                <a:close/>
+                <a:lnTo>
+                  <a:pt x="547152" y="2378238"/>
+                </a:lnTo>
+                <a:close/>
+                <a:lnTo>
+                  <a:pt x="553907" y="2374679"/>
+                </a:lnTo>
+                <a:close/>
+                <a:lnTo>
+                  <a:pt x="560662" y="2371264"/>
+                </a:lnTo>
+                <a:close/>
+                <a:lnTo>
+                  <a:pt x="567416" y="2367973"/>
+                </a:lnTo>
+                <a:close/>
+                <a:lnTo>
+                  <a:pt x="574171" y="2364783"/>
+                </a:lnTo>
+                <a:close/>
+                <a:lnTo>
+                  <a:pt x="580926" y="2361673"/>
+                </a:lnTo>
+                <a:close/>
+                <a:lnTo>
+                  <a:pt x="587681" y="2358622"/>
+                </a:lnTo>
+                <a:close/>
+                <a:lnTo>
+                  <a:pt x="594436" y="2355608"/>
+                </a:lnTo>
+                <a:close/>
+                <a:lnTo>
+                  <a:pt x="601191" y="2352611"/>
+                </a:lnTo>
+                <a:close/>
+                <a:lnTo>
+                  <a:pt x="607946" y="2349607"/>
+                </a:lnTo>
+                <a:close/>
+                <a:lnTo>
+                  <a:pt x="614701" y="2346577"/>
+                </a:lnTo>
+                <a:close/>
+                <a:lnTo>
+                  <a:pt x="621456" y="2343500"/>
+                </a:lnTo>
+                <a:close/>
+                <a:lnTo>
+                  <a:pt x="628211" y="2340374"/>
+                </a:lnTo>
+                <a:close/>
+                <a:lnTo>
+                  <a:pt x="634966" y="2337211"/>
+                </a:lnTo>
+                <a:close/>
+                <a:lnTo>
+                  <a:pt x="641721" y="2334023"/>
+                </a:lnTo>
+                <a:close/>
+                <a:lnTo>
+                  <a:pt x="648476" y="2330822"/>
+                </a:lnTo>
+                <a:close/>
+                <a:lnTo>
+                  <a:pt x="655231" y="2327619"/>
+                </a:lnTo>
+                <a:close/>
+                <a:lnTo>
+                  <a:pt x="661986" y="2324427"/>
+                </a:lnTo>
+                <a:close/>
+                <a:lnTo>
+                  <a:pt x="668741" y="2321257"/>
+                </a:lnTo>
+                <a:close/>
+                <a:lnTo>
+                  <a:pt x="675496" y="2318122"/>
+                </a:lnTo>
+                <a:close/>
+                <a:lnTo>
+                  <a:pt x="682251" y="2315033"/>
+                </a:lnTo>
+                <a:close/>
+                <a:lnTo>
+                  <a:pt x="689006" y="2312001"/>
+                </a:lnTo>
+                <a:close/>
+                <a:lnTo>
+                  <a:pt x="695761" y="2309034"/>
+                </a:lnTo>
+                <a:close/>
+                <a:lnTo>
+                  <a:pt x="702516" y="2306132"/>
+                </a:lnTo>
+                <a:close/>
+                <a:lnTo>
+                  <a:pt x="709271" y="2303294"/>
+                </a:lnTo>
+                <a:close/>
+                <a:lnTo>
+                  <a:pt x="716026" y="2300520"/>
+                </a:lnTo>
+                <a:close/>
+                <a:lnTo>
+                  <a:pt x="722781" y="2297811"/>
+                </a:lnTo>
+                <a:close/>
+                <a:lnTo>
+                  <a:pt x="729535" y="2295167"/>
+                </a:lnTo>
+                <a:close/>
+                <a:lnTo>
+                  <a:pt x="736290" y="2292588"/>
+                </a:lnTo>
+                <a:close/>
+                <a:lnTo>
+                  <a:pt x="743045" y="2290073"/>
+                </a:lnTo>
+                <a:close/>
+                <a:lnTo>
+                  <a:pt x="749800" y="2287624"/>
+                </a:lnTo>
+                <a:close/>
+                <a:lnTo>
+                  <a:pt x="756555" y="2285239"/>
+                </a:lnTo>
+                <a:close/>
+                <a:lnTo>
+                  <a:pt x="763310" y="2282915"/>
+                </a:lnTo>
+                <a:close/>
+                <a:lnTo>
+                  <a:pt x="770065" y="2280640"/>
+                </a:lnTo>
+                <a:close/>
+                <a:lnTo>
+                  <a:pt x="776820" y="2278401"/>
+                </a:lnTo>
+                <a:close/>
+                <a:lnTo>
+                  <a:pt x="783575" y="2276188"/>
+                </a:lnTo>
+                <a:close/>
+                <a:lnTo>
+                  <a:pt x="790330" y="2273986"/>
+                </a:lnTo>
+                <a:close/>
+                <a:lnTo>
+                  <a:pt x="797085" y="2271785"/>
+                </a:lnTo>
+                <a:close/>
+                <a:lnTo>
+                  <a:pt x="803840" y="2269573"/>
+                </a:lnTo>
+                <a:close/>
+                <a:lnTo>
+                  <a:pt x="810595" y="2267336"/>
+                </a:lnTo>
+                <a:close/>
+                <a:lnTo>
+                  <a:pt x="817350" y="2265064"/>
+                </a:lnTo>
+                <a:close/>
+                <a:lnTo>
+                  <a:pt x="824105" y="2262743"/>
+                </a:lnTo>
+                <a:close/>
+                <a:lnTo>
+                  <a:pt x="830860" y="2260371"/>
+                </a:lnTo>
+                <a:close/>
+                <a:lnTo>
+                  <a:pt x="837615" y="2257966"/>
+                </a:lnTo>
+                <a:close/>
+                <a:lnTo>
+                  <a:pt x="844370" y="2255552"/>
+                </a:lnTo>
+                <a:close/>
+                <a:lnTo>
+                  <a:pt x="851125" y="2253150"/>
+                </a:lnTo>
+                <a:close/>
+                <a:lnTo>
+                  <a:pt x="857880" y="2250783"/>
+                </a:lnTo>
+                <a:close/>
+                <a:lnTo>
+                  <a:pt x="864635" y="2248473"/>
+                </a:lnTo>
+                <a:close/>
+                <a:lnTo>
+                  <a:pt x="871390" y="2246243"/>
+                </a:lnTo>
+                <a:close/>
+                <a:lnTo>
+                  <a:pt x="878145" y="2244114"/>
+                </a:lnTo>
+                <a:close/>
+                <a:lnTo>
+                  <a:pt x="884900" y="2242109"/>
+                </a:lnTo>
+                <a:close/>
+                <a:lnTo>
+                  <a:pt x="891654" y="2240250"/>
+                </a:lnTo>
+                <a:close/>
+                <a:lnTo>
+                  <a:pt x="898409" y="2238551"/>
+                </a:lnTo>
+                <a:close/>
+                <a:lnTo>
+                  <a:pt x="905164" y="2236996"/>
+                </a:lnTo>
+                <a:close/>
+                <a:lnTo>
+                  <a:pt x="911919" y="2235559"/>
+                </a:lnTo>
+                <a:close/>
+                <a:lnTo>
+                  <a:pt x="918674" y="2234216"/>
+                </a:lnTo>
+                <a:close/>
+                <a:lnTo>
+                  <a:pt x="925429" y="2232942"/>
+                </a:lnTo>
+                <a:close/>
+                <a:lnTo>
+                  <a:pt x="932184" y="2231713"/>
+                </a:lnTo>
+                <a:close/>
+                <a:lnTo>
+                  <a:pt x="938939" y="2230503"/>
+                </a:lnTo>
+                <a:close/>
+                <a:lnTo>
+                  <a:pt x="945694" y="2229289"/>
+                </a:lnTo>
+                <a:close/>
+                <a:lnTo>
+                  <a:pt x="952449" y="2228044"/>
+                </a:lnTo>
+                <a:close/>
+                <a:lnTo>
+                  <a:pt x="959204" y="2226746"/>
+                </a:lnTo>
+                <a:close/>
+                <a:lnTo>
+                  <a:pt x="965959" y="2225373"/>
+                </a:lnTo>
+                <a:close/>
+                <a:lnTo>
+                  <a:pt x="972714" y="2223939"/>
+                </a:lnTo>
+                <a:close/>
+                <a:lnTo>
+                  <a:pt x="979469" y="2222468"/>
+                </a:lnTo>
+                <a:close/>
+                <a:lnTo>
+                  <a:pt x="986224" y="2220983"/>
+                </a:lnTo>
+                <a:close/>
+                <a:lnTo>
+                  <a:pt x="992979" y="2219508"/>
+                </a:lnTo>
+                <a:close/>
+                <a:lnTo>
+                  <a:pt x="999734" y="2218067"/>
+                </a:lnTo>
+                <a:close/>
+                <a:lnTo>
+                  <a:pt x="1006489" y="2216685"/>
+                </a:lnTo>
+                <a:close/>
+                <a:lnTo>
+                  <a:pt x="1013244" y="2215385"/>
+                </a:lnTo>
+                <a:close/>
+                <a:lnTo>
+                  <a:pt x="1019999" y="2214191"/>
+                </a:lnTo>
+                <a:close/>
+                <a:lnTo>
+                  <a:pt x="1026754" y="2213127"/>
+                </a:lnTo>
+                <a:close/>
+                <a:lnTo>
+                  <a:pt x="1033509" y="2212215"/>
+                </a:lnTo>
+                <a:close/>
+                <a:lnTo>
+                  <a:pt x="1040264" y="2211450"/>
+                </a:lnTo>
+                <a:close/>
+                <a:lnTo>
+                  <a:pt x="1047019" y="2210814"/>
+                </a:lnTo>
+                <a:close/>
+                <a:lnTo>
+                  <a:pt x="1053773" y="2210289"/>
+                </a:lnTo>
+                <a:close/>
+                <a:lnTo>
+                  <a:pt x="1060528" y="2209854"/>
+                </a:lnTo>
+                <a:close/>
+                <a:lnTo>
+                  <a:pt x="1067283" y="2209492"/>
+                </a:lnTo>
+                <a:close/>
+                <a:lnTo>
+                  <a:pt x="1074038" y="2209185"/>
+                </a:lnTo>
+                <a:close/>
+                <a:lnTo>
+                  <a:pt x="1080793" y="2208912"/>
+                </a:lnTo>
+                <a:close/>
+                <a:lnTo>
+                  <a:pt x="1087548" y="2208655"/>
+                </a:lnTo>
+                <a:close/>
+                <a:lnTo>
+                  <a:pt x="1094303" y="2208396"/>
+                </a:lnTo>
+                <a:close/>
+                <a:lnTo>
+                  <a:pt x="1101058" y="2208116"/>
+                </a:lnTo>
+                <a:close/>
+                <a:lnTo>
+                  <a:pt x="1107813" y="2207806"/>
+                </a:lnTo>
+                <a:close/>
+                <a:lnTo>
+                  <a:pt x="1114568" y="2207464"/>
+                </a:lnTo>
+                <a:close/>
+                <a:lnTo>
+                  <a:pt x="1121323" y="2207090"/>
+                </a:lnTo>
+                <a:close/>
+                <a:lnTo>
+                  <a:pt x="1128078" y="2206681"/>
+                </a:lnTo>
+                <a:close/>
+                <a:lnTo>
+                  <a:pt x="1134833" y="2206237"/>
+                </a:lnTo>
+                <a:close/>
+                <a:lnTo>
+                  <a:pt x="1141588" y="2205756"/>
+                </a:lnTo>
+                <a:close/>
+                <a:lnTo>
+                  <a:pt x="1148343" y="2205237"/>
+                </a:lnTo>
+                <a:close/>
+                <a:lnTo>
+                  <a:pt x="1155098" y="2204679"/>
+                </a:lnTo>
+                <a:close/>
+                <a:lnTo>
+                  <a:pt x="1161853" y="2204079"/>
+                </a:lnTo>
+                <a:close/>
+                <a:lnTo>
+                  <a:pt x="1168608" y="2203438"/>
+                </a:lnTo>
+                <a:close/>
+                <a:lnTo>
+                  <a:pt x="1175363" y="2202753"/>
+                </a:lnTo>
+                <a:close/>
+                <a:lnTo>
+                  <a:pt x="1182118" y="2202022"/>
+                </a:lnTo>
+                <a:close/>
+                <a:lnTo>
+                  <a:pt x="1188873" y="2201243"/>
+                </a:lnTo>
+                <a:close/>
+                <a:lnTo>
+                  <a:pt x="1195628" y="2200413"/>
+                </a:lnTo>
+                <a:close/>
+                <a:lnTo>
+                  <a:pt x="1202383" y="2199531"/>
+                </a:lnTo>
+                <a:close/>
+                <a:lnTo>
+                  <a:pt x="1209138" y="2198594"/>
+                </a:lnTo>
+                <a:close/>
+                <a:lnTo>
+                  <a:pt x="1215892" y="2197600"/>
+                </a:lnTo>
+                <a:close/>
+                <a:lnTo>
+                  <a:pt x="1222647" y="2196547"/>
+                </a:lnTo>
+                <a:close/>
+                <a:lnTo>
+                  <a:pt x="1229402" y="2195432"/>
+                </a:lnTo>
+                <a:close/>
+                <a:lnTo>
+                  <a:pt x="1236157" y="2194254"/>
+                </a:lnTo>
+                <a:close/>
+                <a:lnTo>
+                  <a:pt x="1242912" y="2193014"/>
+                </a:lnTo>
+                <a:close/>
+                <a:lnTo>
+                  <a:pt x="1249667" y="2191722"/>
+                </a:lnTo>
+                <a:close/>
+                <a:lnTo>
+                  <a:pt x="1256422" y="2190387"/>
+                </a:lnTo>
+                <a:close/>
+                <a:lnTo>
+                  <a:pt x="1263177" y="2189020"/>
+                </a:lnTo>
+                <a:close/>
+                <a:lnTo>
+                  <a:pt x="1269932" y="2187631"/>
+                </a:lnTo>
+                <a:close/>
+                <a:lnTo>
+                  <a:pt x="1276687" y="2186230"/>
+                </a:lnTo>
+                <a:close/>
+                <a:lnTo>
+                  <a:pt x="1283442" y="2184827"/>
+                </a:lnTo>
+                <a:close/>
+                <a:lnTo>
+                  <a:pt x="1290197" y="2183432"/>
+                </a:lnTo>
+                <a:close/>
+                <a:lnTo>
+                  <a:pt x="1296952" y="2182056"/>
+                </a:lnTo>
+                <a:close/>
+                <a:lnTo>
+                  <a:pt x="1303707" y="2180709"/>
+                </a:lnTo>
+                <a:close/>
+                <a:lnTo>
+                  <a:pt x="1310462" y="2179395"/>
+                </a:lnTo>
+                <a:close/>
+                <a:lnTo>
+                  <a:pt x="1317217" y="2178105"/>
+                </a:lnTo>
+                <a:close/>
+                <a:lnTo>
+                  <a:pt x="1323972" y="2176828"/>
+                </a:lnTo>
+                <a:close/>
+                <a:lnTo>
+                  <a:pt x="1330727" y="2175551"/>
+                </a:lnTo>
+                <a:close/>
+                <a:lnTo>
+                  <a:pt x="1337482" y="2174261"/>
+                </a:lnTo>
+                <a:close/>
+                <a:lnTo>
+                  <a:pt x="1344237" y="2172948"/>
+                </a:lnTo>
+                <a:close/>
+                <a:lnTo>
+                  <a:pt x="1350992" y="2171598"/>
+                </a:lnTo>
+                <a:close/>
+                <a:lnTo>
+                  <a:pt x="1357747" y="2170199"/>
+                </a:lnTo>
+                <a:close/>
+                <a:lnTo>
+                  <a:pt x="1364502" y="2168740"/>
+                </a:lnTo>
+                <a:close/>
+                <a:lnTo>
+                  <a:pt x="1371257" y="2167208"/>
+                </a:lnTo>
+                <a:close/>
+                <a:lnTo>
+                  <a:pt x="1378011" y="2165595"/>
+                </a:lnTo>
+                <a:close/>
+                <a:lnTo>
+                  <a:pt x="1384766" y="2163907"/>
+                </a:lnTo>
+                <a:close/>
+                <a:lnTo>
+                  <a:pt x="1391521" y="2162158"/>
+                </a:lnTo>
+                <a:close/>
+                <a:lnTo>
+                  <a:pt x="1398276" y="2160359"/>
+                </a:lnTo>
+                <a:close/>
+                <a:lnTo>
+                  <a:pt x="1405031" y="2158523"/>
+                </a:lnTo>
+                <a:close/>
+                <a:lnTo>
+                  <a:pt x="1411786" y="2156662"/>
+                </a:lnTo>
+                <a:close/>
+                <a:lnTo>
+                  <a:pt x="1418541" y="2154788"/>
+                </a:lnTo>
+                <a:close/>
+                <a:lnTo>
+                  <a:pt x="1425296" y="2152913"/>
+                </a:lnTo>
+                <a:close/>
+                <a:lnTo>
+                  <a:pt x="1432051" y="2151050"/>
+                </a:lnTo>
+                <a:close/>
+                <a:lnTo>
+                  <a:pt x="1438806" y="2149210"/>
+                </a:lnTo>
+                <a:close/>
+                <a:lnTo>
+                  <a:pt x="1445561" y="2147404"/>
+                </a:lnTo>
+                <a:close/>
+                <a:lnTo>
+                  <a:pt x="1452316" y="2145629"/>
+                </a:lnTo>
+                <a:close/>
+                <a:lnTo>
+                  <a:pt x="1459071" y="2143873"/>
+                </a:lnTo>
+                <a:close/>
+                <a:lnTo>
+                  <a:pt x="1465826" y="2142125"/>
+                </a:lnTo>
+                <a:close/>
+                <a:lnTo>
+                  <a:pt x="1472581" y="2140377"/>
+                </a:lnTo>
+                <a:close/>
+                <a:lnTo>
+                  <a:pt x="1479336" y="2138617"/>
+                </a:lnTo>
+                <a:close/>
+                <a:lnTo>
+                  <a:pt x="1486091" y="2136834"/>
+                </a:lnTo>
+                <a:close/>
+                <a:lnTo>
+                  <a:pt x="1492846" y="2135019"/>
+                </a:lnTo>
+                <a:close/>
+                <a:lnTo>
+                  <a:pt x="1499601" y="2133160"/>
+                </a:lnTo>
+                <a:close/>
+                <a:lnTo>
+                  <a:pt x="1506356" y="2131248"/>
+                </a:lnTo>
+                <a:close/>
+                <a:lnTo>
+                  <a:pt x="1513111" y="2129272"/>
+                </a:lnTo>
+                <a:close/>
+                <a:lnTo>
+                  <a:pt x="1519866" y="2127230"/>
+                </a:lnTo>
+                <a:close/>
+                <a:lnTo>
+                  <a:pt x="1526621" y="2125127"/>
+                </a:lnTo>
+                <a:close/>
+                <a:lnTo>
+                  <a:pt x="1533376" y="2122964"/>
+                </a:lnTo>
+                <a:close/>
+                <a:lnTo>
+                  <a:pt x="1540130" y="2120746"/>
+                </a:lnTo>
+                <a:close/>
+                <a:lnTo>
+                  <a:pt x="1546885" y="2118476"/>
+                </a:lnTo>
+                <a:close/>
+                <a:lnTo>
+                  <a:pt x="1553640" y="2116158"/>
+                </a:lnTo>
+                <a:close/>
+                <a:lnTo>
+                  <a:pt x="1560395" y="2113795"/>
+                </a:lnTo>
+                <a:close/>
+                <a:lnTo>
+                  <a:pt x="1567150" y="2111390"/>
+                </a:lnTo>
+                <a:close/>
+                <a:lnTo>
+                  <a:pt x="1573905" y="2108948"/>
+                </a:lnTo>
+                <a:close/>
+                <a:lnTo>
+                  <a:pt x="1580660" y="2106470"/>
+                </a:lnTo>
+                <a:close/>
+                <a:lnTo>
+                  <a:pt x="1587415" y="2103958"/>
+                </a:lnTo>
+                <a:close/>
+                <a:lnTo>
+                  <a:pt x="1594170" y="2101408"/>
+                </a:lnTo>
+                <a:close/>
+                <a:lnTo>
+                  <a:pt x="1600925" y="2098816"/>
+                </a:lnTo>
+                <a:close/>
+                <a:lnTo>
+                  <a:pt x="1607680" y="2096180"/>
+                </a:lnTo>
+                <a:close/>
+                <a:lnTo>
+                  <a:pt x="1614435" y="2093497"/>
+                </a:lnTo>
+                <a:close/>
+                <a:lnTo>
+                  <a:pt x="1621190" y="2090762"/>
+                </a:lnTo>
+                <a:close/>
+                <a:lnTo>
+                  <a:pt x="1627945" y="2087973"/>
+                </a:lnTo>
+                <a:close/>
+                <a:lnTo>
+                  <a:pt x="1634700" y="2085126"/>
+                </a:lnTo>
+                <a:close/>
+                <a:lnTo>
+                  <a:pt x="1641455" y="2082218"/>
+                </a:lnTo>
+                <a:close/>
+                <a:lnTo>
+                  <a:pt x="1648210" y="2079245"/>
+                </a:lnTo>
+                <a:close/>
+                <a:lnTo>
+                  <a:pt x="1654965" y="2076210"/>
+                </a:lnTo>
+                <a:close/>
+                <a:lnTo>
+                  <a:pt x="1661720" y="2073121"/>
+                </a:lnTo>
+                <a:close/>
+                <a:lnTo>
+                  <a:pt x="1668475" y="2069989"/>
+                </a:lnTo>
+                <a:close/>
+                <a:lnTo>
+                  <a:pt x="1675230" y="2066823"/>
+                </a:lnTo>
+                <a:close/>
+                <a:lnTo>
+                  <a:pt x="1681985" y="2063633"/>
+                </a:lnTo>
+                <a:close/>
+                <a:lnTo>
+                  <a:pt x="1688740" y="2060429"/>
+                </a:lnTo>
+                <a:close/>
+                <a:lnTo>
+                  <a:pt x="1695495" y="2057221"/>
+                </a:lnTo>
+                <a:close/>
+                <a:lnTo>
+                  <a:pt x="1702249" y="2054018"/>
+                </a:lnTo>
+                <a:close/>
+                <a:lnTo>
+                  <a:pt x="1709004" y="2050831"/>
+                </a:lnTo>
+                <a:close/>
+                <a:lnTo>
+                  <a:pt x="1715759" y="2047669"/>
+                </a:lnTo>
+                <a:close/>
+                <a:lnTo>
+                  <a:pt x="1722514" y="2044537"/>
+                </a:lnTo>
+                <a:close/>
+                <a:lnTo>
+                  <a:pt x="1729269" y="2041426"/>
+                </a:lnTo>
+                <a:close/>
+                <a:lnTo>
+                  <a:pt x="1736024" y="2038327"/>
+                </a:lnTo>
+                <a:close/>
+                <a:lnTo>
+                  <a:pt x="1742779" y="2035230"/>
+                </a:lnTo>
+                <a:close/>
+                <a:lnTo>
+                  <a:pt x="1749534" y="2032125"/>
+                </a:lnTo>
+                <a:close/>
+                <a:lnTo>
+                  <a:pt x="1756289" y="2029003"/>
+                </a:lnTo>
+                <a:close/>
+                <a:lnTo>
+                  <a:pt x="1763044" y="2025853"/>
+                </a:lnTo>
+                <a:close/>
+                <a:lnTo>
+                  <a:pt x="1769799" y="2022666"/>
+                </a:lnTo>
+                <a:close/>
+                <a:lnTo>
+                  <a:pt x="1776554" y="2019431"/>
+                </a:lnTo>
+                <a:close/>
+                <a:lnTo>
+                  <a:pt x="1783309" y="2016139"/>
+                </a:lnTo>
+                <a:close/>
+                <a:lnTo>
+                  <a:pt x="1790064" y="2012783"/>
+                </a:lnTo>
+                <a:close/>
+                <a:lnTo>
+                  <a:pt x="1796819" y="2009364"/>
+                </a:lnTo>
+                <a:close/>
+                <a:lnTo>
+                  <a:pt x="1803574" y="2005885"/>
+                </a:lnTo>
+                <a:close/>
+                <a:lnTo>
+                  <a:pt x="1810329" y="2002349"/>
+                </a:lnTo>
+                <a:close/>
+                <a:lnTo>
+                  <a:pt x="1817084" y="1998760"/>
+                </a:lnTo>
+                <a:close/>
+                <a:lnTo>
+                  <a:pt x="1823839" y="1995121"/>
+                </a:lnTo>
+                <a:close/>
+                <a:lnTo>
+                  <a:pt x="1830594" y="1991435"/>
+                </a:lnTo>
+                <a:close/>
+                <a:lnTo>
+                  <a:pt x="1837349" y="1987706"/>
+                </a:lnTo>
+                <a:close/>
+                <a:lnTo>
+                  <a:pt x="1844104" y="1983936"/>
+                </a:lnTo>
+                <a:close/>
+                <a:lnTo>
+                  <a:pt x="1850859" y="1980130"/>
+                </a:lnTo>
+                <a:close/>
+                <a:lnTo>
+                  <a:pt x="1857614" y="1976289"/>
+                </a:lnTo>
+                <a:close/>
+                <a:lnTo>
+                  <a:pt x="1864368" y="1972412"/>
+                </a:lnTo>
+                <a:close/>
+                <a:lnTo>
+                  <a:pt x="1871123" y="1968495"/>
+                </a:lnTo>
+                <a:close/>
+                <a:lnTo>
+                  <a:pt x="1877878" y="1964536"/>
+                </a:lnTo>
+                <a:close/>
+                <a:lnTo>
+                  <a:pt x="1884633" y="1960531"/>
+                </a:lnTo>
+                <a:close/>
+                <a:lnTo>
+                  <a:pt x="1891388" y="1956476"/>
+                </a:lnTo>
+                <a:close/>
+                <a:lnTo>
+                  <a:pt x="1898143" y="1952369"/>
+                </a:lnTo>
+                <a:close/>
+                <a:lnTo>
+                  <a:pt x="1904898" y="1948207"/>
+                </a:lnTo>
+                <a:close/>
+                <a:lnTo>
+                  <a:pt x="1911653" y="1943985"/>
+                </a:lnTo>
+                <a:close/>
+                <a:lnTo>
+                  <a:pt x="1918408" y="1939701"/>
+                </a:lnTo>
+                <a:close/>
+                <a:lnTo>
+                  <a:pt x="1925163" y="1935352"/>
+                </a:lnTo>
+                <a:close/>
+                <a:lnTo>
+                  <a:pt x="1931918" y="1930944"/>
+                </a:lnTo>
+                <a:close/>
+                <a:lnTo>
+                  <a:pt x="1938673" y="1926487"/>
+                </a:lnTo>
+                <a:close/>
+                <a:lnTo>
+                  <a:pt x="1945428" y="1921989"/>
+                </a:lnTo>
+                <a:close/>
+                <a:lnTo>
+                  <a:pt x="1952183" y="1917462"/>
+                </a:lnTo>
+                <a:close/>
+                <a:lnTo>
+                  <a:pt x="1958938" y="1912915"/>
+                </a:lnTo>
+                <a:close/>
+                <a:lnTo>
+                  <a:pt x="1965693" y="1908357"/>
+                </a:lnTo>
+                <a:close/>
+                <a:lnTo>
+                  <a:pt x="1972448" y="1903799"/>
+                </a:lnTo>
+                <a:close/>
+                <a:lnTo>
+                  <a:pt x="1979203" y="1899250"/>
+                </a:lnTo>
+                <a:close/>
+                <a:lnTo>
+                  <a:pt x="1985958" y="1894719"/>
+                </a:lnTo>
+                <a:close/>
+                <a:lnTo>
+                  <a:pt x="1992713" y="1890217"/>
+                </a:lnTo>
+                <a:close/>
+                <a:lnTo>
+                  <a:pt x="1999468" y="1885742"/>
+                </a:lnTo>
+                <a:close/>
+                <a:lnTo>
+                  <a:pt x="2006223" y="1881285"/>
+                </a:lnTo>
+                <a:close/>
+                <a:lnTo>
+                  <a:pt x="2012978" y="1876836"/>
+                </a:lnTo>
+                <a:close/>
+                <a:lnTo>
+                  <a:pt x="2019733" y="1872385"/>
+                </a:lnTo>
+                <a:close/>
+                <a:lnTo>
+                  <a:pt x="2026487" y="1867923"/>
+                </a:lnTo>
+                <a:close/>
+                <a:lnTo>
+                  <a:pt x="2033242" y="1863439"/>
+                </a:lnTo>
+                <a:close/>
+                <a:lnTo>
+                  <a:pt x="2039997" y="1858926"/>
+                </a:lnTo>
+                <a:close/>
+                <a:lnTo>
+                  <a:pt x="2046752" y="1854372"/>
+                </a:lnTo>
+                <a:close/>
+                <a:lnTo>
+                  <a:pt x="2053507" y="1849768"/>
+                </a:lnTo>
+                <a:close/>
+                <a:lnTo>
+                  <a:pt x="2060262" y="1845104"/>
+                </a:lnTo>
+                <a:close/>
+                <a:lnTo>
+                  <a:pt x="2067017" y="1840377"/>
+                </a:lnTo>
+                <a:close/>
+                <a:lnTo>
+                  <a:pt x="2073772" y="1835589"/>
+                </a:lnTo>
+                <a:close/>
+                <a:lnTo>
+                  <a:pt x="2080527" y="1830741"/>
+                </a:lnTo>
+                <a:close/>
+                <a:lnTo>
+                  <a:pt x="2087282" y="1825838"/>
+                </a:lnTo>
+                <a:close/>
+                <a:lnTo>
+                  <a:pt x="2094037" y="1820881"/>
+                </a:lnTo>
+                <a:close/>
+                <a:lnTo>
+                  <a:pt x="2100792" y="1815873"/>
+                </a:lnTo>
+                <a:close/>
+                <a:lnTo>
+                  <a:pt x="2107547" y="1810817"/>
+                </a:lnTo>
+                <a:close/>
+                <a:lnTo>
+                  <a:pt x="2114302" y="1805716"/>
+                </a:lnTo>
+                <a:close/>
+                <a:lnTo>
+                  <a:pt x="2121057" y="1800571"/>
+                </a:lnTo>
+                <a:close/>
+                <a:lnTo>
+                  <a:pt x="2127812" y="1795386"/>
+                </a:lnTo>
+                <a:close/>
+                <a:lnTo>
+                  <a:pt x="2134567" y="1790162"/>
+                </a:lnTo>
+                <a:close/>
+                <a:lnTo>
+                  <a:pt x="2141322" y="1784899"/>
+                </a:lnTo>
+                <a:close/>
+                <a:lnTo>
+                  <a:pt x="2148077" y="1779595"/>
+                </a:lnTo>
+                <a:close/>
+                <a:lnTo>
+                  <a:pt x="2154832" y="1774250"/>
+                </a:lnTo>
+                <a:close/>
+                <a:lnTo>
+                  <a:pt x="2161587" y="1768863"/>
+                </a:lnTo>
+                <a:close/>
+                <a:lnTo>
+                  <a:pt x="2168342" y="1763433"/>
+                </a:lnTo>
+                <a:close/>
+                <a:lnTo>
+                  <a:pt x="2175097" y="1757958"/>
+                </a:lnTo>
+                <a:close/>
+                <a:lnTo>
+                  <a:pt x="2181852" y="1752440"/>
+                </a:lnTo>
+                <a:close/>
+                <a:lnTo>
+                  <a:pt x="2188606" y="1746875"/>
+                </a:lnTo>
+                <a:close/>
+                <a:lnTo>
+                  <a:pt x="2195361" y="1741264"/>
+                </a:lnTo>
+                <a:close/>
+                <a:lnTo>
+                  <a:pt x="2202116" y="1735606"/>
+                </a:lnTo>
+                <a:close/>
+                <a:lnTo>
+                  <a:pt x="2208871" y="1729901"/>
+                </a:lnTo>
+                <a:close/>
+                <a:lnTo>
+                  <a:pt x="2215626" y="1724151"/>
+                </a:lnTo>
+                <a:close/>
+                <a:lnTo>
+                  <a:pt x="2222381" y="1718357"/>
+                </a:lnTo>
+                <a:close/>
+                <a:lnTo>
+                  <a:pt x="2229136" y="1712518"/>
+                </a:lnTo>
+                <a:close/>
+                <a:lnTo>
+                  <a:pt x="2235891" y="1706637"/>
+                </a:lnTo>
+                <a:close/>
+                <a:lnTo>
+                  <a:pt x="2242646" y="1700714"/>
+                </a:lnTo>
+                <a:close/>
+                <a:lnTo>
+                  <a:pt x="2249401" y="1694750"/>
+                </a:lnTo>
+                <a:close/>
+                <a:lnTo>
+                  <a:pt x="2256156" y="1688745"/>
+                </a:lnTo>
+                <a:close/>
+                <a:lnTo>
+                  <a:pt x="2262911" y="1682702"/>
+                </a:lnTo>
+                <a:close/>
+                <a:lnTo>
+                  <a:pt x="2269666" y="1676619"/>
+                </a:lnTo>
+                <a:close/>
+                <a:lnTo>
+                  <a:pt x="2276421" y="1670495"/>
+                </a:lnTo>
+                <a:close/>
+                <a:lnTo>
+                  <a:pt x="2283176" y="1664327"/>
+                </a:lnTo>
+                <a:close/>
+                <a:lnTo>
+                  <a:pt x="2289931" y="1658114"/>
+                </a:lnTo>
+                <a:close/>
+                <a:lnTo>
+                  <a:pt x="2296686" y="1651851"/>
+                </a:lnTo>
+                <a:close/>
+                <a:lnTo>
+                  <a:pt x="2303441" y="1645537"/>
+                </a:lnTo>
+                <a:close/>
+                <a:lnTo>
+                  <a:pt x="2310196" y="1639169"/>
+                </a:lnTo>
+                <a:close/>
+                <a:lnTo>
+                  <a:pt x="2316951" y="1632745"/>
+                </a:lnTo>
+                <a:close/>
+                <a:lnTo>
+                  <a:pt x="2323706" y="1626261"/>
+                </a:lnTo>
+                <a:close/>
+                <a:lnTo>
+                  <a:pt x="2330461" y="1619715"/>
+                </a:lnTo>
+                <a:close/>
+                <a:lnTo>
+                  <a:pt x="2337215" y="1613107"/>
+                </a:lnTo>
+                <a:close/>
+                <a:lnTo>
+                  <a:pt x="2343970" y="1606441"/>
+                </a:lnTo>
+                <a:close/>
+                <a:lnTo>
+                  <a:pt x="2350724" y="1599727"/>
+                </a:lnTo>
+                <a:close/>
+                <a:lnTo>
+                  <a:pt x="2357478" y="1592975"/>
+                </a:lnTo>
+                <a:close/>
+                <a:lnTo>
+                  <a:pt x="2364233" y="1586195"/>
+                </a:lnTo>
+                <a:close/>
+                <a:lnTo>
+                  <a:pt x="2370988" y="1579396"/>
+                </a:lnTo>
+                <a:close/>
+                <a:lnTo>
+                  <a:pt x="2377743" y="1572587"/>
+                </a:lnTo>
+                <a:close/>
+                <a:lnTo>
+                  <a:pt x="2384498" y="1565779"/>
+                </a:lnTo>
+                <a:close/>
+                <a:lnTo>
+                  <a:pt x="2391254" y="1558980"/>
+                </a:lnTo>
+                <a:close/>
+                <a:lnTo>
+                  <a:pt x="2398010" y="1552200"/>
+                </a:lnTo>
+                <a:close/>
+                <a:lnTo>
+                  <a:pt x="2404766" y="1545448"/>
+                </a:lnTo>
+                <a:close/>
+                <a:lnTo>
+                  <a:pt x="2411523" y="1538722"/>
+                </a:lnTo>
+                <a:close/>
+                <a:lnTo>
+                  <a:pt x="2418280" y="1532012"/>
+                </a:lnTo>
+                <a:close/>
+                <a:lnTo>
+                  <a:pt x="2425037" y="1525309"/>
+                </a:lnTo>
+                <a:close/>
+                <a:lnTo>
+                  <a:pt x="2431794" y="1518604"/>
+                </a:lnTo>
+                <a:close/>
+                <a:lnTo>
+                  <a:pt x="2438550" y="1511887"/>
+                </a:lnTo>
+                <a:close/>
+                <a:lnTo>
+                  <a:pt x="2445305" y="1505150"/>
+                </a:lnTo>
+                <a:close/>
+                <a:lnTo>
+                  <a:pt x="2452059" y="1498382"/>
+                </a:lnTo>
+                <a:close/>
+                <a:lnTo>
+                  <a:pt x="2458811" y="1491575"/>
+                </a:lnTo>
+                <a:close/>
+                <a:lnTo>
+                  <a:pt x="2465562" y="1484719"/>
+                </a:lnTo>
+                <a:close/>
+                <a:lnTo>
+                  <a:pt x="2472312" y="1477805"/>
+                </a:lnTo>
+                <a:close/>
+                <a:lnTo>
+                  <a:pt x="2479059" y="1470829"/>
+                </a:lnTo>
+                <a:close/>
+                <a:lnTo>
+                  <a:pt x="2485806" y="1463793"/>
+                </a:lnTo>
+                <a:close/>
+                <a:lnTo>
+                  <a:pt x="2492554" y="1456698"/>
+                </a:lnTo>
+                <a:close/>
+                <a:lnTo>
+                  <a:pt x="2499302" y="1449545"/>
+                </a:lnTo>
+                <a:close/>
+                <a:lnTo>
+                  <a:pt x="2506053" y="1442337"/>
+                </a:lnTo>
+                <a:close/>
+                <a:lnTo>
+                  <a:pt x="2512807" y="1435075"/>
+                </a:lnTo>
+                <a:close/>
+                <a:lnTo>
+                  <a:pt x="2519565" y="1427760"/>
+                </a:lnTo>
+                <a:close/>
+                <a:lnTo>
+                  <a:pt x="2526328" y="1420394"/>
+                </a:lnTo>
+                <a:close/>
+                <a:lnTo>
+                  <a:pt x="2533097" y="1412978"/>
+                </a:lnTo>
+                <a:close/>
+                <a:lnTo>
+                  <a:pt x="2539872" y="1405514"/>
+                </a:lnTo>
+                <a:close/>
+                <a:lnTo>
+                  <a:pt x="2546654" y="1398004"/>
+                </a:lnTo>
+                <a:close/>
+                <a:lnTo>
+                  <a:pt x="2553438" y="1390452"/>
+                </a:lnTo>
+                <a:close/>
+                <a:lnTo>
+                  <a:pt x="2560222" y="1382859"/>
+                </a:lnTo>
+                <a:close/>
+                <a:lnTo>
+                  <a:pt x="2567001" y="1375231"/>
+                </a:lnTo>
+                <a:close/>
+                <a:lnTo>
+                  <a:pt x="2573773" y="1367569"/>
+                </a:lnTo>
+                <a:close/>
+                <a:lnTo>
+                  <a:pt x="2580533" y="1359876"/>
+                </a:lnTo>
+                <a:close/>
+                <a:lnTo>
+                  <a:pt x="2587280" y="1352157"/>
+                </a:lnTo>
+                <a:close/>
+                <a:lnTo>
+                  <a:pt x="2594008" y="1344414"/>
+                </a:lnTo>
+                <a:close/>
+                <a:lnTo>
+                  <a:pt x="2600715" y="1336650"/>
+                </a:lnTo>
+                <a:close/>
+                <a:lnTo>
+                  <a:pt x="2607397" y="1328868"/>
+                </a:lnTo>
+                <a:close/>
+                <a:lnTo>
+                  <a:pt x="2614055" y="1321067"/>
+                </a:lnTo>
+                <a:close/>
+                <a:lnTo>
+                  <a:pt x="2620702" y="1313234"/>
+                </a:lnTo>
+                <a:close/>
+                <a:lnTo>
+                  <a:pt x="2627349" y="1305354"/>
+                </a:lnTo>
+                <a:close/>
+                <a:lnTo>
+                  <a:pt x="2634010" y="1297415"/>
+                </a:lnTo>
+                <a:close/>
+                <a:lnTo>
+                  <a:pt x="2640697" y="1289400"/>
+                </a:lnTo>
+                <a:close/>
+                <a:lnTo>
+                  <a:pt x="2647424" y="1281297"/>
+                </a:lnTo>
+                <a:close/>
+                <a:lnTo>
+                  <a:pt x="2654202" y="1273091"/>
+                </a:lnTo>
+                <a:close/>
+                <a:lnTo>
+                  <a:pt x="2661046" y="1264768"/>
+                </a:lnTo>
+                <a:close/>
+                <a:lnTo>
+                  <a:pt x="2667967" y="1256314"/>
+                </a:lnTo>
+                <a:close/>
+                <a:lnTo>
+                  <a:pt x="2674979" y="1247715"/>
+                </a:lnTo>
+                <a:close/>
+                <a:lnTo>
+                  <a:pt x="2682082" y="1238969"/>
+                </a:lnTo>
+                <a:close/>
+                <a:lnTo>
+                  <a:pt x="2689238" y="1230121"/>
+                </a:lnTo>
+                <a:close/>
+                <a:lnTo>
+                  <a:pt x="2696399" y="1221224"/>
+                </a:lnTo>
+                <a:close/>
+                <a:lnTo>
+                  <a:pt x="2703516" y="1212331"/>
+                </a:lnTo>
+                <a:close/>
+                <a:lnTo>
+                  <a:pt x="2710542" y="1203496"/>
+                </a:lnTo>
+                <a:close/>
+                <a:lnTo>
+                  <a:pt x="2717429" y="1194772"/>
+                </a:lnTo>
+                <a:close/>
+                <a:lnTo>
+                  <a:pt x="2724128" y="1186212"/>
+                </a:lnTo>
+                <a:close/>
+                <a:lnTo>
+                  <a:pt x="2730593" y="1177871"/>
+                </a:lnTo>
+                <a:close/>
+                <a:lnTo>
+                  <a:pt x="2736775" y="1169801"/>
+                </a:lnTo>
+                <a:close/>
+                <a:lnTo>
+                  <a:pt x="2742625" y="1162055"/>
+                </a:lnTo>
+                <a:close/>
+                <a:lnTo>
+                  <a:pt x="2748109" y="1154677"/>
+                </a:lnTo>
+                <a:close/>
+                <a:lnTo>
+                  <a:pt x="2753252" y="1147644"/>
+                </a:lnTo>
+                <a:close/>
+                <a:lnTo>
+                  <a:pt x="2758102" y="1140915"/>
+                </a:lnTo>
+                <a:close/>
+                <a:lnTo>
+                  <a:pt x="2762707" y="1134447"/>
+                </a:lnTo>
+                <a:close/>
+                <a:lnTo>
+                  <a:pt x="2767114" y="1128198"/>
+                </a:lnTo>
+                <a:close/>
+                <a:lnTo>
+                  <a:pt x="2771371" y="1122125"/>
+                </a:lnTo>
+                <a:close/>
+                <a:lnTo>
+                  <a:pt x="2775526" y="1116187"/>
+                </a:lnTo>
+                <a:close/>
+                <a:lnTo>
+                  <a:pt x="2779627" y="1110341"/>
+                </a:lnTo>
+                <a:close/>
+                <a:lnTo>
+                  <a:pt x="2783721" y="1104544"/>
+                </a:lnTo>
+                <a:close/>
+                <a:lnTo>
+                  <a:pt x="2787856" y="1098756"/>
+                </a:lnTo>
+                <a:close/>
+                <a:lnTo>
+                  <a:pt x="2792076" y="1092936"/>
+                </a:lnTo>
+                <a:close/>
+                <a:lnTo>
+                  <a:pt x="2796388" y="1087078"/>
+                </a:lnTo>
+                <a:close/>
+                <a:lnTo>
+                  <a:pt x="2800780" y="1081195"/>
+                </a:lnTo>
+                <a:close/>
+                <a:lnTo>
+                  <a:pt x="2805240" y="1075295"/>
+                </a:lnTo>
+                <a:close/>
+                <a:lnTo>
+                  <a:pt x="2809757" y="1069390"/>
+                </a:lnTo>
+                <a:close/>
+                <a:lnTo>
+                  <a:pt x="2814317" y="1063492"/>
+                </a:lnTo>
+                <a:close/>
+                <a:lnTo>
+                  <a:pt x="2818911" y="1057610"/>
+                </a:lnTo>
+                <a:close/>
+                <a:lnTo>
+                  <a:pt x="2823524" y="1051756"/>
+                </a:lnTo>
+                <a:close/>
+                <a:lnTo>
+                  <a:pt x="2828146" y="1045940"/>
+                </a:lnTo>
+                <a:close/>
+                <a:lnTo>
+                  <a:pt x="2832765" y="1040173"/>
+                </a:lnTo>
+                <a:close/>
+                <a:lnTo>
+                  <a:pt x="2837369" y="1034465"/>
+                </a:lnTo>
+                <a:close/>
+                <a:lnTo>
+                  <a:pt x="2841952" y="1028805"/>
+                </a:lnTo>
+                <a:close/>
+                <a:lnTo>
+                  <a:pt x="2846516" y="1023166"/>
+                </a:lnTo>
+                <a:close/>
+                <a:lnTo>
+                  <a:pt x="2851059" y="1017521"/>
+                </a:lnTo>
+                <a:close/>
+                <a:lnTo>
+                  <a:pt x="2855582" y="1011843"/>
+                </a:lnTo>
+                <a:close/>
+                <a:lnTo>
+                  <a:pt x="2860085" y="1006103"/>
+                </a:lnTo>
+                <a:close/>
+                <a:lnTo>
+                  <a:pt x="2864568" y="1000276"/>
+                </a:lnTo>
+                <a:close/>
+                <a:lnTo>
+                  <a:pt x="2869031" y="994333"/>
+                </a:lnTo>
+                <a:close/>
+                <a:lnTo>
+                  <a:pt x="2873473" y="988247"/>
+                </a:lnTo>
+                <a:close/>
+                <a:lnTo>
+                  <a:pt x="2877895" y="981991"/>
+                </a:lnTo>
+                <a:close/>
+                <a:lnTo>
+                  <a:pt x="2882298" y="975539"/>
+                </a:lnTo>
+                <a:close/>
+                <a:lnTo>
+                  <a:pt x="2886685" y="968884"/>
+                </a:lnTo>
+                <a:close/>
+                <a:lnTo>
+                  <a:pt x="2891070" y="962045"/>
+                </a:lnTo>
+                <a:close/>
+                <a:lnTo>
+                  <a:pt x="2895463" y="955042"/>
+                </a:lnTo>
+                <a:close/>
+                <a:lnTo>
+                  <a:pt x="2899878" y="947894"/>
+                </a:lnTo>
+                <a:close/>
+                <a:lnTo>
+                  <a:pt x="2904325" y="940620"/>
+                </a:lnTo>
+                <a:close/>
+                <a:lnTo>
+                  <a:pt x="2908817" y="933241"/>
+                </a:lnTo>
+                <a:close/>
+                <a:lnTo>
+                  <a:pt x="2913365" y="925776"/>
+                </a:lnTo>
+                <a:close/>
+                <a:lnTo>
+                  <a:pt x="2917983" y="918245"/>
+                </a:lnTo>
+                <a:close/>
+                <a:lnTo>
+                  <a:pt x="2922680" y="910668"/>
+                </a:lnTo>
+                <a:close/>
+                <a:lnTo>
+                  <a:pt x="2927470" y="903063"/>
+                </a:lnTo>
+                <a:close/>
+                <a:lnTo>
+                  <a:pt x="2932344" y="895454"/>
+                </a:lnTo>
+                <a:close/>
+                <a:lnTo>
+                  <a:pt x="2937257" y="887868"/>
+                </a:lnTo>
+                <a:close/>
+                <a:lnTo>
+                  <a:pt x="2942161" y="880331"/>
+                </a:lnTo>
+                <a:close/>
+                <a:lnTo>
+                  <a:pt x="2947010" y="872870"/>
+                </a:lnTo>
+                <a:close/>
+                <a:lnTo>
+                  <a:pt x="2951755" y="865514"/>
+                </a:lnTo>
+                <a:close/>
+                <a:lnTo>
+                  <a:pt x="2956349" y="858289"/>
+                </a:lnTo>
+                <a:close/>
+                <a:lnTo>
+                  <a:pt x="2960743" y="851222"/>
+                </a:lnTo>
+                <a:close/>
+                <a:lnTo>
+                  <a:pt x="2964891" y="844342"/>
+                </a:lnTo>
+                <a:close/>
+                <a:lnTo>
+                  <a:pt x="2968744" y="837675"/>
+                </a:lnTo>
+                <a:close/>
+                <a:lnTo>
+                  <a:pt x="2972254" y="831248"/>
+                </a:lnTo>
+                <a:close/>
+                <a:lnTo>
+                  <a:pt x="2975398" y="825076"/>
+                </a:lnTo>
+                <a:close/>
+                <a:lnTo>
+                  <a:pt x="2978213" y="819141"/>
+                </a:lnTo>
+                <a:close/>
+                <a:lnTo>
+                  <a:pt x="2980746" y="813419"/>
+                </a:lnTo>
+                <a:close/>
+                <a:lnTo>
+                  <a:pt x="2983046" y="807886"/>
+                </a:lnTo>
+                <a:close/>
+                <a:lnTo>
+                  <a:pt x="2985160" y="802518"/>
+                </a:lnTo>
+                <a:close/>
+                <a:lnTo>
+                  <a:pt x="2987137" y="797292"/>
+                </a:lnTo>
+                <a:close/>
+                <a:lnTo>
+                  <a:pt x="2989024" y="792183"/>
+                </a:lnTo>
+                <a:close/>
+                <a:lnTo>
+                  <a:pt x="2990870" y="787168"/>
+                </a:lnTo>
+                <a:close/>
+                <a:lnTo>
+                  <a:pt x="2992721" y="782223"/>
+                </a:lnTo>
+                <a:close/>
+                <a:lnTo>
+                  <a:pt x="2994627" y="777323"/>
+                </a:lnTo>
+                <a:close/>
+                <a:lnTo>
+                  <a:pt x="2996625" y="772447"/>
+                </a:lnTo>
+                <a:close/>
+                <a:lnTo>
+                  <a:pt x="2998713" y="767583"/>
+                </a:lnTo>
+                <a:close/>
+                <a:lnTo>
+                  <a:pt x="3000879" y="762719"/>
+                </a:lnTo>
+                <a:close/>
+                <a:lnTo>
+                  <a:pt x="3003109" y="757846"/>
+                </a:lnTo>
+                <a:close/>
+                <a:lnTo>
+                  <a:pt x="3005390" y="752954"/>
+                </a:lnTo>
+                <a:close/>
+                <a:lnTo>
+                  <a:pt x="3007711" y="748031"/>
+                </a:lnTo>
+                <a:close/>
+                <a:lnTo>
+                  <a:pt x="3010057" y="743067"/>
+                </a:lnTo>
+                <a:close/>
+                <a:lnTo>
+                  <a:pt x="3012417" y="738052"/>
+                </a:lnTo>
+                <a:close/>
+                <a:lnTo>
+                  <a:pt x="3014777" y="732976"/>
+                </a:lnTo>
+                <a:close/>
+                <a:lnTo>
+                  <a:pt x="3017124" y="727828"/>
+                </a:lnTo>
+                <a:close/>
+                <a:lnTo>
+                  <a:pt x="3019448" y="722600"/>
+                </a:lnTo>
+                <a:close/>
+                <a:lnTo>
+                  <a:pt x="3021747" y="717299"/>
+                </a:lnTo>
+                <a:close/>
+                <a:lnTo>
+                  <a:pt x="3024024" y="711938"/>
+                </a:lnTo>
+                <a:close/>
+                <a:lnTo>
+                  <a:pt x="3026284" y="706530"/>
+                </a:lnTo>
+                <a:close/>
+                <a:lnTo>
+                  <a:pt x="3028530" y="701088"/>
+                </a:lnTo>
+                <a:close/>
+                <a:lnTo>
+                  <a:pt x="3030764" y="695624"/>
+                </a:lnTo>
+                <a:close/>
+                <a:lnTo>
+                  <a:pt x="3032991" y="690153"/>
+                </a:lnTo>
+                <a:close/>
+                <a:lnTo>
+                  <a:pt x="3035215" y="684686"/>
+                </a:lnTo>
+                <a:close/>
+                <a:lnTo>
+                  <a:pt x="3037437" y="679237"/>
+                </a:lnTo>
+                <a:close/>
+                <a:lnTo>
+                  <a:pt x="3039662" y="673820"/>
+                </a:lnTo>
+                <a:close/>
+                <a:lnTo>
+                  <a:pt x="3041894" y="668445"/>
+                </a:lnTo>
+                <a:close/>
+                <a:lnTo>
+                  <a:pt x="3044132" y="663107"/>
+                </a:lnTo>
+                <a:close/>
+                <a:lnTo>
+                  <a:pt x="3046375" y="657792"/>
+                </a:lnTo>
+                <a:close/>
+                <a:lnTo>
+                  <a:pt x="3048624" y="652484"/>
+                </a:lnTo>
+                <a:close/>
+                <a:lnTo>
+                  <a:pt x="3050877" y="647167"/>
+                </a:lnTo>
+                <a:close/>
+                <a:lnTo>
+                  <a:pt x="3053133" y="641826"/>
+                </a:lnTo>
+                <a:close/>
+                <a:lnTo>
+                  <a:pt x="3055391" y="636445"/>
+                </a:lnTo>
+                <a:close/>
+                <a:lnTo>
+                  <a:pt x="3057650" y="631009"/>
+                </a:lnTo>
+                <a:close/>
+                <a:lnTo>
+                  <a:pt x="3059910" y="625502"/>
+                </a:lnTo>
+                <a:close/>
+                <a:lnTo>
+                  <a:pt x="3062168" y="619909"/>
+                </a:lnTo>
+                <a:close/>
+                <a:lnTo>
+                  <a:pt x="3064426" y="614215"/>
+                </a:lnTo>
+                <a:close/>
+                <a:lnTo>
+                  <a:pt x="3066681" y="608425"/>
+                </a:lnTo>
+                <a:close/>
+                <a:lnTo>
+                  <a:pt x="3068935" y="602561"/>
+                </a:lnTo>
+                <a:close/>
+                <a:lnTo>
+                  <a:pt x="3071188" y="596645"/>
+                </a:lnTo>
+                <a:close/>
+                <a:lnTo>
+                  <a:pt x="3073439" y="590700"/>
+                </a:lnTo>
+                <a:close/>
+                <a:lnTo>
+                  <a:pt x="3075690" y="584749"/>
+                </a:lnTo>
+                <a:close/>
+                <a:lnTo>
+                  <a:pt x="3077940" y="578815"/>
+                </a:lnTo>
+                <a:close/>
+                <a:lnTo>
+                  <a:pt x="3080190" y="572919"/>
+                </a:lnTo>
+                <a:close/>
+                <a:lnTo>
+                  <a:pt x="3082439" y="567085"/>
+                </a:lnTo>
+                <a:close/>
+                <a:lnTo>
+                  <a:pt x="3084689" y="561336"/>
+                </a:lnTo>
+                <a:close/>
+                <a:lnTo>
+                  <a:pt x="3086939" y="555694"/>
+                </a:lnTo>
+                <a:close/>
+                <a:lnTo>
+                  <a:pt x="3089190" y="550163"/>
+                </a:lnTo>
+                <a:close/>
+                <a:lnTo>
+                  <a:pt x="3091441" y="544721"/>
+                </a:lnTo>
+                <a:close/>
+                <a:lnTo>
+                  <a:pt x="3093692" y="539347"/>
+                </a:lnTo>
+                <a:close/>
+                <a:lnTo>
+                  <a:pt x="3095944" y="534017"/>
+                </a:lnTo>
+                <a:close/>
+                <a:lnTo>
+                  <a:pt x="3098195" y="528709"/>
+                </a:lnTo>
+                <a:close/>
+                <a:lnTo>
+                  <a:pt x="3100448" y="523400"/>
+                </a:lnTo>
+                <a:close/>
+                <a:lnTo>
+                  <a:pt x="3102700" y="518066"/>
+                </a:lnTo>
+                <a:close/>
+                <a:lnTo>
+                  <a:pt x="3104952" y="512684"/>
+                </a:lnTo>
+                <a:close/>
+                <a:lnTo>
+                  <a:pt x="3107204" y="507233"/>
+                </a:lnTo>
+                <a:close/>
+                <a:lnTo>
+                  <a:pt x="3109456" y="501689"/>
+                </a:lnTo>
+                <a:close/>
+                <a:lnTo>
+                  <a:pt x="3111708" y="496041"/>
+                </a:lnTo>
+                <a:close/>
+                <a:lnTo>
+                  <a:pt x="3113960" y="490303"/>
+                </a:lnTo>
+                <a:close/>
+                <a:lnTo>
+                  <a:pt x="3116212" y="484490"/>
+                </a:lnTo>
+                <a:close/>
+                <a:lnTo>
+                  <a:pt x="3118463" y="478618"/>
+                </a:lnTo>
+                <a:close/>
+                <a:lnTo>
+                  <a:pt x="3120715" y="472705"/>
+                </a:lnTo>
+                <a:close/>
+                <a:lnTo>
+                  <a:pt x="3122967" y="466767"/>
+                </a:lnTo>
+                <a:close/>
+                <a:lnTo>
+                  <a:pt x="3125218" y="460820"/>
+                </a:lnTo>
+                <a:close/>
+                <a:lnTo>
+                  <a:pt x="3127470" y="454880"/>
+                </a:lnTo>
+                <a:close/>
+                <a:lnTo>
+                  <a:pt x="3129721" y="448964"/>
+                </a:lnTo>
+                <a:close/>
+                <a:lnTo>
+                  <a:pt x="3131973" y="443087"/>
+                </a:lnTo>
+                <a:close/>
+                <a:lnTo>
+                  <a:pt x="3134224" y="437261"/>
+                </a:lnTo>
+                <a:close/>
+                <a:lnTo>
+                  <a:pt x="3136476" y="431472"/>
+                </a:lnTo>
+                <a:close/>
+                <a:lnTo>
+                  <a:pt x="3138727" y="425705"/>
+                </a:lnTo>
+                <a:close/>
+                <a:lnTo>
+                  <a:pt x="3140979" y="419943"/>
+                </a:lnTo>
+                <a:close/>
+                <a:lnTo>
+                  <a:pt x="3143231" y="414170"/>
+                </a:lnTo>
+                <a:close/>
+                <a:lnTo>
+                  <a:pt x="3145482" y="408369"/>
+                </a:lnTo>
+                <a:close/>
+                <a:lnTo>
+                  <a:pt x="3147734" y="402525"/>
+                </a:lnTo>
+                <a:close/>
+                <a:lnTo>
+                  <a:pt x="3149986" y="396621"/>
+                </a:lnTo>
+                <a:close/>
+                <a:lnTo>
+                  <a:pt x="3152237" y="390640"/>
+                </a:lnTo>
+                <a:close/>
+                <a:lnTo>
+                  <a:pt x="3154489" y="384567"/>
+                </a:lnTo>
+                <a:close/>
+                <a:lnTo>
+                  <a:pt x="3156741" y="378391"/>
+                </a:lnTo>
+                <a:close/>
+                <a:lnTo>
+                  <a:pt x="3158993" y="372124"/>
+                </a:lnTo>
+                <a:close/>
+                <a:lnTo>
+                  <a:pt x="3161244" y="365791"/>
+                </a:lnTo>
+                <a:close/>
+                <a:lnTo>
+                  <a:pt x="3163496" y="359413"/>
+                </a:lnTo>
+                <a:close/>
+                <a:lnTo>
+                  <a:pt x="3165747" y="353014"/>
+                </a:lnTo>
+                <a:close/>
+                <a:lnTo>
+                  <a:pt x="3167999" y="346616"/>
+                </a:lnTo>
+                <a:close/>
+                <a:lnTo>
+                  <a:pt x="3170251" y="340241"/>
+                </a:lnTo>
+                <a:close/>
+                <a:lnTo>
+                  <a:pt x="3172502" y="333914"/>
+                </a:lnTo>
+                <a:close/>
+                <a:lnTo>
+                  <a:pt x="3174754" y="327655"/>
+                </a:lnTo>
+                <a:close/>
+                <a:lnTo>
+                  <a:pt x="3177006" y="321487"/>
+                </a:lnTo>
+                <a:close/>
+                <a:lnTo>
+                  <a:pt x="3179257" y="315431"/>
+                </a:lnTo>
+                <a:close/>
+                <a:lnTo>
+                  <a:pt x="3181509" y="309478"/>
+                </a:lnTo>
+                <a:close/>
+                <a:lnTo>
+                  <a:pt x="3183761" y="303606"/>
+                </a:lnTo>
+                <a:close/>
+                <a:lnTo>
+                  <a:pt x="3186012" y="297793"/>
+                </a:lnTo>
+                <a:close/>
+                <a:lnTo>
+                  <a:pt x="3188264" y="292018"/>
+                </a:lnTo>
+                <a:close/>
+                <a:lnTo>
+                  <a:pt x="3190516" y="286258"/>
+                </a:lnTo>
+                <a:close/>
+                <a:lnTo>
+                  <a:pt x="3192767" y="280492"/>
+                </a:lnTo>
+                <a:close/>
+                <a:lnTo>
+                  <a:pt x="3195019" y="274697"/>
+                </a:lnTo>
+                <a:close/>
+                <a:lnTo>
+                  <a:pt x="3197271" y="268852"/>
+                </a:lnTo>
+                <a:close/>
+                <a:lnTo>
+                  <a:pt x="3199522" y="262935"/>
+                </a:lnTo>
+                <a:close/>
+                <a:lnTo>
+                  <a:pt x="3201774" y="256925"/>
+                </a:lnTo>
+                <a:close/>
+                <a:lnTo>
+                  <a:pt x="3204026" y="250821"/>
+                </a:lnTo>
+                <a:close/>
+                <a:lnTo>
+                  <a:pt x="3206277" y="244634"/>
+                </a:lnTo>
+                <a:close/>
+                <a:lnTo>
+                  <a:pt x="3208529" y="238377"/>
+                </a:lnTo>
+                <a:close/>
+                <a:lnTo>
+                  <a:pt x="3210781" y="232063"/>
+                </a:lnTo>
+                <a:close/>
+                <a:lnTo>
+                  <a:pt x="3213032" y="225704"/>
+                </a:lnTo>
+                <a:close/>
+                <a:lnTo>
+                  <a:pt x="3215284" y="219312"/>
+                </a:lnTo>
+                <a:close/>
+                <a:lnTo>
+                  <a:pt x="3217535" y="212901"/>
+                </a:lnTo>
+                <a:close/>
+                <a:lnTo>
+                  <a:pt x="3219787" y="206482"/>
+                </a:lnTo>
+                <a:close/>
+                <a:lnTo>
+                  <a:pt x="3222039" y="200068"/>
+                </a:lnTo>
+                <a:close/>
+                <a:lnTo>
+                  <a:pt x="3224290" y="193672"/>
+                </a:lnTo>
+                <a:close/>
+                <a:lnTo>
+                  <a:pt x="3226542" y="187298"/>
+                </a:lnTo>
+                <a:close/>
+                <a:lnTo>
+                  <a:pt x="3228794" y="180947"/>
+                </a:lnTo>
+                <a:close/>
+                <a:lnTo>
+                  <a:pt x="3231045" y="174615"/>
+                </a:lnTo>
+                <a:close/>
+                <a:lnTo>
+                  <a:pt x="3233297" y="168301"/>
+                </a:lnTo>
+                <a:close/>
+                <a:lnTo>
+                  <a:pt x="3235549" y="162003"/>
+                </a:lnTo>
+                <a:close/>
+                <a:lnTo>
+                  <a:pt x="3237800" y="155718"/>
+                </a:lnTo>
+                <a:close/>
+                <a:lnTo>
+                  <a:pt x="3240052" y="149446"/>
+                </a:lnTo>
+                <a:close/>
+                <a:lnTo>
+                  <a:pt x="3242304" y="143184"/>
+                </a:lnTo>
+                <a:close/>
+                <a:lnTo>
+                  <a:pt x="3244555" y="136930"/>
+                </a:lnTo>
+                <a:close/>
+                <a:lnTo>
+                  <a:pt x="3246807" y="130683"/>
+                </a:lnTo>
+                <a:close/>
+                <a:lnTo>
+                  <a:pt x="3249059" y="124438"/>
+                </a:lnTo>
+                <a:close/>
+                <a:lnTo>
+                  <a:pt x="3251310" y="118193"/>
+                </a:lnTo>
+                <a:close/>
+                <a:lnTo>
+                  <a:pt x="3253562" y="111941"/>
+                </a:lnTo>
+                <a:close/>
+                <a:lnTo>
+                  <a:pt x="3255814" y="105678"/>
+                </a:lnTo>
+                <a:close/>
+                <a:lnTo>
+                  <a:pt x="3258065" y="99399"/>
+                </a:lnTo>
+                <a:close/>
+                <a:lnTo>
+                  <a:pt x="3260317" y="93100"/>
+                </a:lnTo>
+                <a:close/>
+                <a:lnTo>
+                  <a:pt x="3262569" y="86774"/>
+                </a:lnTo>
+                <a:close/>
+                <a:lnTo>
+                  <a:pt x="3264820" y="80419"/>
+                </a:lnTo>
+                <a:close/>
+                <a:lnTo>
+                  <a:pt x="3267072" y="74028"/>
+                </a:lnTo>
+                <a:close/>
+                <a:lnTo>
+                  <a:pt x="3269323" y="67596"/>
+                </a:lnTo>
+                <a:close/>
+                <a:lnTo>
+                  <a:pt x="3271575" y="61120"/>
+                </a:lnTo>
+                <a:close/>
+                <a:lnTo>
+                  <a:pt x="3273827" y="54593"/>
+                </a:lnTo>
+                <a:close/>
+                <a:lnTo>
+                  <a:pt x="3276078" y="48012"/>
+                </a:lnTo>
+                <a:close/>
+                <a:lnTo>
+                  <a:pt x="3278330" y="41371"/>
+                </a:lnTo>
+                <a:close/>
+                <a:lnTo>
+                  <a:pt x="3280582" y="34666"/>
+                </a:lnTo>
+                <a:close/>
+                <a:lnTo>
+                  <a:pt x="3282833" y="27891"/>
+                </a:lnTo>
+                <a:close/>
+                <a:lnTo>
+                  <a:pt x="3285085" y="21042"/>
+                </a:lnTo>
+                <a:close/>
+                <a:lnTo>
+                  <a:pt x="3287337" y="14113"/>
+                </a:lnTo>
+                <a:close/>
+                <a:lnTo>
+                  <a:pt x="3289588" y="7101"/>
+                </a:lnTo>
+                <a:close/>
+                <a:lnTo>
+                  <a:pt x="3291840" y="0"/>
                 </a:lnTo>
                 <a:close/>
               </a:path>
             </a:pathLst>
           </a:custGeom>
-          <a:ln w="31750">
+          <a:ln w="38100">
             <a:solidFill>
               <a:srgbClr val="000000"/>
             </a:solidFill>
@@ -4423,8 +5623,8 @@
         </p:nvCxnSpPr>
         <p:spPr>
           <a:xfrm flipV="1">
-            <a:off x="5715000.0" y="1657350.0"/>
-            <a:ext cx="0.0" cy="914400.0"/>
+            <a:off x="6400800.0" y="1200150.0"/>
+            <a:ext cx="0.0" cy="1371600.0"/>
           </a:xfrm>
           <a:prstGeom prst="line">
             <a:avLst/>
@@ -4459,8 +5659,8 @@
         </p:nvCxnSpPr>
         <p:spPr>
           <a:xfrm>
-            <a:off x="4572000.0" y="1657350.0"/>
-            <a:ext cx="1143000.0" cy="0.0"/>
+            <a:off x="4572000.0" y="1200150.0"/>
+            <a:ext cx="1828800.0" cy="0.0"/>
           </a:xfrm>
           <a:prstGeom prst="line">
             <a:avLst/>
@@ -4495,8 +5695,8 @@
         </p:nvSpPr>
         <p:spPr>
           <a:xfrm>
-            <a:off x="5638800" y="1581150"/>
-            <a:ext cx="152400" cy="152400"/>
+            <a:off x="6311900" y="1111250"/>
+            <a:ext cx="177800" cy="177800"/>
           </a:xfrm>
           <a:prstGeom prst="ellipse">
             <a:avLst/>
@@ -4504,455 +5704,6 @@
           <a:solidFill>
             <a:srgbClr val="000000"/>
           </a:solidFill>
-          <a:ln w="12700">
-            <a:solidFill>
-              <a:srgbClr val="FFFFFF"/>
-            </a:solidFill>
-          </a:ln>
-        </p:spPr>
-        <p:style>
-          <a:lnRef idx="1">
-            <a:schemeClr val="accent1"/>
-          </a:lnRef>
-          <a:fillRef idx="3">
-            <a:schemeClr val="accent1"/>
-          </a:fillRef>
-          <a:effectRef idx="2">
-            <a:schemeClr val="accent1"/>
-          </a:effectRef>
-          <a:fontRef idx="minor">
-            <a:schemeClr val="lt1"/>
-          </a:fontRef>
-        </p:style>
-        <p:txBody>
-          <a:bodyPr rtlCol="0" anchor="ctr"/>
-          <a:lstStyle/>
-          <a:p>
-            <a:pPr algn="ctr"/>
-          </a:p>
-        </p:txBody>
-      </p:sp>
-      <p:sp>
-        <p:nvSpPr>
-          <p:cNvPr id="8" name="Freeform 7"/>
-          <p:cNvSpPr/>
-          <p:nvPr/>
-        </p:nvSpPr>
-        <p:spPr>
-          <a:xfrm>
-            <a:off x="5349240" y="1794510"/>
-            <a:ext cx="251460" cy="274320"/>
-          </a:xfrm>
-          <a:custGeom>
-            <a:avLst/>
-            <a:gdLst/>
-            <a:ahLst/>
-            <a:cxnLst/>
-            <a:rect l="l" t="t" r="r" b="b"/>
-            <a:pathLst>
-              <a:path w="251460" h="274320">
-                <a:moveTo>
-                  <a:pt x="0" y="274320"/>
-                </a:moveTo>
-                <a:lnTo>
-                  <a:pt x="2550" y="271549"/>
-                </a:lnTo>
-                <a:close/>
-                <a:lnTo>
-                  <a:pt x="5121" y="268778"/>
-                </a:lnTo>
-                <a:close/>
-                <a:lnTo>
-                  <a:pt x="7712" y="266007"/>
-                </a:lnTo>
-                <a:close/>
-                <a:lnTo>
-                  <a:pt x="10321" y="263236"/>
-                </a:lnTo>
-                <a:close/>
-                <a:lnTo>
-                  <a:pt x="12949" y="260465"/>
-                </a:lnTo>
-                <a:close/>
-                <a:lnTo>
-                  <a:pt x="15595" y="257695"/>
-                </a:lnTo>
-                <a:close/>
-                <a:lnTo>
-                  <a:pt x="18258" y="254924"/>
-                </a:lnTo>
-                <a:close/>
-                <a:lnTo>
-                  <a:pt x="20937" y="252153"/>
-                </a:lnTo>
-                <a:close/>
-                <a:lnTo>
-                  <a:pt x="23633" y="249382"/>
-                </a:lnTo>
-                <a:close/>
-                <a:lnTo>
-                  <a:pt x="26344" y="246611"/>
-                </a:lnTo>
-                <a:close/>
-                <a:lnTo>
-                  <a:pt x="29069" y="243840"/>
-                </a:lnTo>
-                <a:close/>
-                <a:lnTo>
-                  <a:pt x="31808" y="241069"/>
-                </a:lnTo>
-                <a:close/>
-                <a:lnTo>
-                  <a:pt x="34561" y="238298"/>
-                </a:lnTo>
-                <a:close/>
-                <a:lnTo>
-                  <a:pt x="37326" y="235527"/>
-                </a:lnTo>
-                <a:close/>
-                <a:lnTo>
-                  <a:pt x="40104" y="232756"/>
-                </a:lnTo>
-                <a:close/>
-                <a:lnTo>
-                  <a:pt x="42893" y="229985"/>
-                </a:lnTo>
-                <a:close/>
-                <a:lnTo>
-                  <a:pt x="45692" y="227215"/>
-                </a:lnTo>
-                <a:close/>
-                <a:lnTo>
-                  <a:pt x="48502" y="224444"/>
-                </a:lnTo>
-                <a:close/>
-                <a:lnTo>
-                  <a:pt x="51322" y="221673"/>
-                </a:lnTo>
-                <a:close/>
-                <a:lnTo>
-                  <a:pt x="54150" y="218902"/>
-                </a:lnTo>
-                <a:close/>
-                <a:lnTo>
-                  <a:pt x="56987" y="216131"/>
-                </a:lnTo>
-                <a:close/>
-                <a:lnTo>
-                  <a:pt x="59831" y="213360"/>
-                </a:lnTo>
-                <a:close/>
-                <a:lnTo>
-                  <a:pt x="62682" y="210589"/>
-                </a:lnTo>
-                <a:close/>
-                <a:lnTo>
-                  <a:pt x="65540" y="207818"/>
-                </a:lnTo>
-                <a:close/>
-                <a:lnTo>
-                  <a:pt x="68403" y="205047"/>
-                </a:lnTo>
-                <a:close/>
-                <a:lnTo>
-                  <a:pt x="71272" y="202276"/>
-                </a:lnTo>
-                <a:close/>
-                <a:lnTo>
-                  <a:pt x="74145" y="199505"/>
-                </a:lnTo>
-                <a:close/>
-                <a:lnTo>
-                  <a:pt x="77021" y="196735"/>
-                </a:lnTo>
-                <a:close/>
-                <a:lnTo>
-                  <a:pt x="79901" y="193964"/>
-                </a:lnTo>
-                <a:close/>
-                <a:lnTo>
-                  <a:pt x="82784" y="191193"/>
-                </a:lnTo>
-                <a:close/>
-                <a:lnTo>
-                  <a:pt x="85668" y="188422"/>
-                </a:lnTo>
-                <a:close/>
-                <a:lnTo>
-                  <a:pt x="88554" y="185651"/>
-                </a:lnTo>
-                <a:close/>
-                <a:lnTo>
-                  <a:pt x="91440" y="182880"/>
-                </a:lnTo>
-                <a:close/>
-                <a:lnTo>
-                  <a:pt x="94326" y="180109"/>
-                </a:lnTo>
-                <a:close/>
-                <a:lnTo>
-                  <a:pt x="97212" y="177338"/>
-                </a:lnTo>
-                <a:close/>
-                <a:lnTo>
-                  <a:pt x="100096" y="174567"/>
-                </a:lnTo>
-                <a:close/>
-                <a:lnTo>
-                  <a:pt x="102979" y="171796"/>
-                </a:lnTo>
-                <a:close/>
-                <a:lnTo>
-                  <a:pt x="105859" y="169025"/>
-                </a:lnTo>
-                <a:close/>
-                <a:lnTo>
-                  <a:pt x="108735" y="166255"/>
-                </a:lnTo>
-                <a:close/>
-                <a:lnTo>
-                  <a:pt x="111608" y="163484"/>
-                </a:lnTo>
-                <a:close/>
-                <a:lnTo>
-                  <a:pt x="114477" y="160713"/>
-                </a:lnTo>
-                <a:close/>
-                <a:lnTo>
-                  <a:pt x="117340" y="157942"/>
-                </a:lnTo>
-                <a:close/>
-                <a:lnTo>
-                  <a:pt x="120198" y="155171"/>
-                </a:lnTo>
-                <a:close/>
-                <a:lnTo>
-                  <a:pt x="123049" y="152400"/>
-                </a:lnTo>
-                <a:close/>
-                <a:lnTo>
-                  <a:pt x="125893" y="149629"/>
-                </a:lnTo>
-                <a:close/>
-                <a:lnTo>
-                  <a:pt x="128730" y="146858"/>
-                </a:lnTo>
-                <a:close/>
-                <a:lnTo>
-                  <a:pt x="131558" y="144087"/>
-                </a:lnTo>
-                <a:close/>
-                <a:lnTo>
-                  <a:pt x="134378" y="141316"/>
-                </a:lnTo>
-                <a:close/>
-                <a:lnTo>
-                  <a:pt x="137188" y="138545"/>
-                </a:lnTo>
-                <a:close/>
-                <a:lnTo>
-                  <a:pt x="139987" y="135775"/>
-                </a:lnTo>
-                <a:close/>
-                <a:lnTo>
-                  <a:pt x="142776" y="133004"/>
-                </a:lnTo>
-                <a:close/>
-                <a:lnTo>
-                  <a:pt x="145554" y="130233"/>
-                </a:lnTo>
-                <a:close/>
-                <a:lnTo>
-                  <a:pt x="148319" y="127462"/>
-                </a:lnTo>
-                <a:close/>
-                <a:lnTo>
-                  <a:pt x="151072" y="124691"/>
-                </a:lnTo>
-                <a:close/>
-                <a:lnTo>
-                  <a:pt x="153811" y="121920"/>
-                </a:lnTo>
-                <a:close/>
-                <a:lnTo>
-                  <a:pt x="156536" y="119149"/>
-                </a:lnTo>
-                <a:close/>
-                <a:lnTo>
-                  <a:pt x="159247" y="116378"/>
-                </a:lnTo>
-                <a:close/>
-                <a:lnTo>
-                  <a:pt x="161943" y="113607"/>
-                </a:lnTo>
-                <a:close/>
-                <a:lnTo>
-                  <a:pt x="164622" y="110836"/>
-                </a:lnTo>
-                <a:close/>
-                <a:lnTo>
-                  <a:pt x="167285" y="108065"/>
-                </a:lnTo>
-                <a:close/>
-                <a:lnTo>
-                  <a:pt x="169931" y="105295"/>
-                </a:lnTo>
-                <a:close/>
-                <a:lnTo>
-                  <a:pt x="172559" y="102524"/>
-                </a:lnTo>
-                <a:close/>
-                <a:lnTo>
-                  <a:pt x="175168" y="99753"/>
-                </a:lnTo>
-                <a:close/>
-                <a:lnTo>
-                  <a:pt x="177759" y="96982"/>
-                </a:lnTo>
-                <a:close/>
-                <a:lnTo>
-                  <a:pt x="180330" y="94211"/>
-                </a:lnTo>
-                <a:close/>
-                <a:lnTo>
-                  <a:pt x="182880" y="91440"/>
-                </a:lnTo>
-                <a:close/>
-                <a:lnTo>
-                  <a:pt x="185409" y="88669"/>
-                </a:lnTo>
-                <a:close/>
-                <a:lnTo>
-                  <a:pt x="187917" y="85898"/>
-                </a:lnTo>
-                <a:close/>
-                <a:lnTo>
-                  <a:pt x="190403" y="83127"/>
-                </a:lnTo>
-                <a:close/>
-                <a:lnTo>
-                  <a:pt x="192865" y="80356"/>
-                </a:lnTo>
-                <a:close/>
-                <a:lnTo>
-                  <a:pt x="195304" y="77585"/>
-                </a:lnTo>
-                <a:close/>
-                <a:lnTo>
-                  <a:pt x="197719" y="74815"/>
-                </a:lnTo>
-                <a:close/>
-                <a:lnTo>
-                  <a:pt x="200109" y="72044"/>
-                </a:lnTo>
-                <a:close/>
-                <a:lnTo>
-                  <a:pt x="202474" y="69273"/>
-                </a:lnTo>
-                <a:close/>
-                <a:lnTo>
-                  <a:pt x="204813" y="66502"/>
-                </a:lnTo>
-                <a:close/>
-                <a:lnTo>
-                  <a:pt x="207124" y="63731"/>
-                </a:lnTo>
-                <a:close/>
-                <a:lnTo>
-                  <a:pt x="209409" y="60960"/>
-                </a:lnTo>
-                <a:close/>
-                <a:lnTo>
-                  <a:pt x="211665" y="58189"/>
-                </a:lnTo>
-                <a:close/>
-                <a:lnTo>
-                  <a:pt x="213893" y="55418"/>
-                </a:lnTo>
-                <a:close/>
-                <a:lnTo>
-                  <a:pt x="216092" y="52647"/>
-                </a:lnTo>
-                <a:close/>
-                <a:lnTo>
-                  <a:pt x="218261" y="49876"/>
-                </a:lnTo>
-                <a:close/>
-                <a:lnTo>
-                  <a:pt x="220399" y="47105"/>
-                </a:lnTo>
-                <a:close/>
-                <a:lnTo>
-                  <a:pt x="222506" y="44335"/>
-                </a:lnTo>
-                <a:close/>
-                <a:lnTo>
-                  <a:pt x="224581" y="41564"/>
-                </a:lnTo>
-                <a:close/>
-                <a:lnTo>
-                  <a:pt x="226624" y="38793"/>
-                </a:lnTo>
-                <a:close/>
-                <a:lnTo>
-                  <a:pt x="228634" y="36022"/>
-                </a:lnTo>
-                <a:close/>
-                <a:lnTo>
-                  <a:pt x="230609" y="33251"/>
-                </a:lnTo>
-                <a:close/>
-                <a:lnTo>
-                  <a:pt x="232551" y="30480"/>
-                </a:lnTo>
-                <a:close/>
-                <a:lnTo>
-                  <a:pt x="234458" y="27709"/>
-                </a:lnTo>
-                <a:close/>
-                <a:lnTo>
-                  <a:pt x="236329" y="24938"/>
-                </a:lnTo>
-                <a:close/>
-                <a:lnTo>
-                  <a:pt x="238164" y="22167"/>
-                </a:lnTo>
-                <a:close/>
-                <a:lnTo>
-                  <a:pt x="239961" y="19396"/>
-                </a:lnTo>
-                <a:close/>
-                <a:lnTo>
-                  <a:pt x="241722" y="16625"/>
-                </a:lnTo>
-                <a:close/>
-                <a:lnTo>
-                  <a:pt x="243444" y="13855"/>
-                </a:lnTo>
-                <a:close/>
-                <a:lnTo>
-                  <a:pt x="245127" y="11084"/>
-                </a:lnTo>
-                <a:close/>
-                <a:lnTo>
-                  <a:pt x="246771" y="8313"/>
-                </a:lnTo>
-                <a:close/>
-                <a:lnTo>
-                  <a:pt x="248375" y="5542"/>
-                </a:lnTo>
-                <a:close/>
-                <a:lnTo>
-                  <a:pt x="249938" y="2771"/>
-                </a:lnTo>
-                <a:close/>
-                <a:lnTo>
-                  <a:pt x="251460" y="0"/>
-                </a:lnTo>
-                <a:close/>
-              </a:path>
-            </a:pathLst>
-          </a:custGeom>
           <a:ln w="19050">
             <a:solidFill>
               <a:srgbClr val="FFFFFF"/>
@@ -4981,455 +5732,76 @@
           </a:p>
         </p:txBody>
       </p:sp>
-      <p:sp>
-        <p:nvSpPr>
-          <p:cNvPr id="9" name="Freeform 8"/>
-          <p:cNvSpPr/>
+      <p:cxnSp>
+        <p:nvCxnSpPr>
+          <p:cNvPr id="8" name="Connector 7"/>
+          <p:cNvCxnSpPr/>
           <p:nvPr/>
-        </p:nvSpPr>
+        </p:nvCxnSpPr>
         <p:spPr>
           <a:xfrm>
-            <a:off x="5760720" y="1337310"/>
-            <a:ext cx="91440" cy="251460"/>
+            <a:off x="5852160.0" y="2571750.0"/>
+            <a:ext cx="480060.0" cy="0.0"/>
           </a:xfrm>
-          <a:custGeom>
+          <a:prstGeom prst="line">
             <a:avLst/>
-            <a:gdLst/>
-            <a:ahLst/>
-            <a:cxnLst/>
-            <a:rect l="l" t="t" r="r" b="b"/>
-            <a:pathLst>
-              <a:path w="91440" h="251460">
-                <a:moveTo>
-                  <a:pt x="91440" y="0"/>
-                </a:moveTo>
-                <a:lnTo>
-                  <a:pt x="90516" y="2997"/>
-                </a:lnTo>
-                <a:close/>
-                <a:lnTo>
-                  <a:pt x="89593" y="5985"/>
-                </a:lnTo>
-                <a:close/>
-                <a:lnTo>
-                  <a:pt x="88669" y="8963"/>
-                </a:lnTo>
-                <a:close/>
-                <a:lnTo>
-                  <a:pt x="87745" y="11933"/>
-                </a:lnTo>
-                <a:close/>
-                <a:lnTo>
-                  <a:pt x="86822" y="14892"/>
-                </a:lnTo>
-                <a:close/>
-                <a:lnTo>
-                  <a:pt x="85898" y="17843"/>
-                </a:lnTo>
-                <a:close/>
-                <a:lnTo>
-                  <a:pt x="84975" y="20784"/>
-                </a:lnTo>
-                <a:close/>
-                <a:lnTo>
-                  <a:pt x="84051" y="23716"/>
-                </a:lnTo>
-                <a:close/>
-                <a:lnTo>
-                  <a:pt x="83127" y="26639"/>
-                </a:lnTo>
-                <a:close/>
-                <a:lnTo>
-                  <a:pt x="82204" y="29552"/>
-                </a:lnTo>
-                <a:close/>
-                <a:lnTo>
-                  <a:pt x="81280" y="32456"/>
-                </a:lnTo>
-                <a:close/>
-                <a:lnTo>
-                  <a:pt x="80356" y="35350"/>
-                </a:lnTo>
-                <a:close/>
-                <a:lnTo>
-                  <a:pt x="79433" y="38235"/>
-                </a:lnTo>
-                <a:close/>
-                <a:lnTo>
-                  <a:pt x="78509" y="41111"/>
-                </a:lnTo>
-                <a:close/>
-                <a:lnTo>
-                  <a:pt x="77585" y="43978"/>
-                </a:lnTo>
-                <a:close/>
-                <a:lnTo>
-                  <a:pt x="76662" y="46835"/>
-                </a:lnTo>
-                <a:close/>
-                <a:lnTo>
-                  <a:pt x="75738" y="49683"/>
-                </a:lnTo>
-                <a:close/>
-                <a:lnTo>
-                  <a:pt x="74815" y="52521"/>
-                </a:lnTo>
-                <a:close/>
-                <a:lnTo>
-                  <a:pt x="73891" y="55351"/>
-                </a:lnTo>
-                <a:close/>
-                <a:lnTo>
-                  <a:pt x="72967" y="58170"/>
-                </a:lnTo>
-                <a:close/>
-                <a:lnTo>
-                  <a:pt x="72044" y="60981"/>
-                </a:lnTo>
-                <a:close/>
-                <a:lnTo>
-                  <a:pt x="71120" y="63782"/>
-                </a:lnTo>
-                <a:close/>
-                <a:lnTo>
-                  <a:pt x="70196" y="66574"/>
-                </a:lnTo>
-                <a:close/>
-                <a:lnTo>
-                  <a:pt x="69273" y="69357"/>
-                </a:lnTo>
-                <a:close/>
-                <a:lnTo>
-                  <a:pt x="68349" y="72130"/>
-                </a:lnTo>
-                <a:close/>
-                <a:lnTo>
-                  <a:pt x="67425" y="74894"/>
-                </a:lnTo>
-                <a:close/>
-                <a:lnTo>
-                  <a:pt x="66502" y="77648"/>
-                </a:lnTo>
-                <a:close/>
-                <a:lnTo>
-                  <a:pt x="65578" y="80394"/>
-                </a:lnTo>
-                <a:close/>
-                <a:lnTo>
-                  <a:pt x="64655" y="83130"/>
-                </a:lnTo>
-                <a:close/>
-                <a:lnTo>
-                  <a:pt x="63731" y="85856"/>
-                </a:lnTo>
-                <a:close/>
-                <a:lnTo>
-                  <a:pt x="62807" y="88573"/>
-                </a:lnTo>
-                <a:close/>
-                <a:lnTo>
-                  <a:pt x="61884" y="91281"/>
-                </a:lnTo>
-                <a:close/>
-                <a:lnTo>
-                  <a:pt x="60960" y="93980"/>
-                </a:lnTo>
-                <a:close/>
-                <a:lnTo>
-                  <a:pt x="60036" y="96669"/>
-                </a:lnTo>
-                <a:close/>
-                <a:lnTo>
-                  <a:pt x="59113" y="99349"/>
-                </a:lnTo>
-                <a:close/>
-                <a:lnTo>
-                  <a:pt x="58189" y="102020"/>
-                </a:lnTo>
-                <a:close/>
-                <a:lnTo>
-                  <a:pt x="57265" y="104681"/>
-                </a:lnTo>
-                <a:close/>
-                <a:lnTo>
-                  <a:pt x="56342" y="107333"/>
-                </a:lnTo>
-                <a:close/>
-                <a:lnTo>
-                  <a:pt x="55418" y="109976"/>
-                </a:lnTo>
-                <a:close/>
-                <a:lnTo>
-                  <a:pt x="54495" y="112609"/>
-                </a:lnTo>
-                <a:close/>
-                <a:lnTo>
-                  <a:pt x="53571" y="115233"/>
-                </a:lnTo>
-                <a:close/>
-                <a:lnTo>
-                  <a:pt x="52647" y="117848"/>
-                </a:lnTo>
-                <a:close/>
-                <a:lnTo>
-                  <a:pt x="51724" y="120453"/>
-                </a:lnTo>
-                <a:close/>
-                <a:lnTo>
-                  <a:pt x="50800" y="123049"/>
-                </a:lnTo>
-                <a:close/>
-                <a:lnTo>
-                  <a:pt x="49876" y="125636"/>
-                </a:lnTo>
-                <a:close/>
-                <a:lnTo>
-                  <a:pt x="48953" y="128213"/>
-                </a:lnTo>
-                <a:close/>
-                <a:lnTo>
-                  <a:pt x="48029" y="130781"/>
-                </a:lnTo>
-                <a:close/>
-                <a:lnTo>
-                  <a:pt x="47105" y="133340"/>
-                </a:lnTo>
-                <a:close/>
-                <a:lnTo>
-                  <a:pt x="46182" y="135889"/>
-                </a:lnTo>
-                <a:close/>
-                <a:lnTo>
-                  <a:pt x="45258" y="138429"/>
-                </a:lnTo>
-                <a:close/>
-                <a:lnTo>
-                  <a:pt x="44335" y="140960"/>
-                </a:lnTo>
-                <a:close/>
-                <a:lnTo>
-                  <a:pt x="43411" y="143481"/>
-                </a:lnTo>
-                <a:close/>
-                <a:lnTo>
-                  <a:pt x="42487" y="145993"/>
-                </a:lnTo>
-                <a:close/>
-                <a:lnTo>
-                  <a:pt x="41564" y="148496"/>
-                </a:lnTo>
-                <a:close/>
-                <a:lnTo>
-                  <a:pt x="40640" y="150989"/>
-                </a:lnTo>
-                <a:close/>
-                <a:lnTo>
-                  <a:pt x="39716" y="153473"/>
-                </a:lnTo>
-                <a:close/>
-                <a:lnTo>
-                  <a:pt x="38793" y="155948"/>
-                </a:lnTo>
-                <a:close/>
-                <a:lnTo>
-                  <a:pt x="37869" y="158413"/>
-                </a:lnTo>
-                <a:close/>
-                <a:lnTo>
-                  <a:pt x="36945" y="160869"/>
-                </a:lnTo>
-                <a:close/>
-                <a:lnTo>
-                  <a:pt x="36022" y="163316"/>
-                </a:lnTo>
-                <a:close/>
-                <a:lnTo>
-                  <a:pt x="35098" y="165753"/>
-                </a:lnTo>
-                <a:close/>
-                <a:lnTo>
-                  <a:pt x="34175" y="168181"/>
-                </a:lnTo>
-                <a:close/>
-                <a:lnTo>
-                  <a:pt x="33251" y="170600"/>
-                </a:lnTo>
-                <a:close/>
-                <a:lnTo>
-                  <a:pt x="32327" y="173009"/>
-                </a:lnTo>
-                <a:close/>
-                <a:lnTo>
-                  <a:pt x="31404" y="175409"/>
-                </a:lnTo>
-                <a:close/>
-                <a:lnTo>
-                  <a:pt x="30480" y="177800"/>
-                </a:lnTo>
-                <a:close/>
-                <a:lnTo>
-                  <a:pt x="29556" y="180181"/>
-                </a:lnTo>
-                <a:close/>
-                <a:lnTo>
-                  <a:pt x="28633" y="182553"/>
-                </a:lnTo>
-                <a:close/>
-                <a:lnTo>
-                  <a:pt x="27709" y="184916"/>
-                </a:lnTo>
-                <a:close/>
-                <a:lnTo>
-                  <a:pt x="26785" y="187270"/>
-                </a:lnTo>
-                <a:close/>
-                <a:lnTo>
-                  <a:pt x="25862" y="189614"/>
-                </a:lnTo>
-                <a:close/>
-                <a:lnTo>
-                  <a:pt x="24938" y="191948"/>
-                </a:lnTo>
-                <a:close/>
-                <a:lnTo>
-                  <a:pt x="24015" y="194274"/>
-                </a:lnTo>
-                <a:close/>
-                <a:lnTo>
-                  <a:pt x="23091" y="196590"/>
-                </a:lnTo>
-                <a:close/>
-                <a:lnTo>
-                  <a:pt x="22167" y="198897"/>
-                </a:lnTo>
-                <a:close/>
-                <a:lnTo>
-                  <a:pt x="21244" y="201194"/>
-                </a:lnTo>
-                <a:close/>
-                <a:lnTo>
-                  <a:pt x="20320" y="203482"/>
-                </a:lnTo>
-                <a:close/>
-                <a:lnTo>
-                  <a:pt x="19396" y="205761"/>
-                </a:lnTo>
-                <a:close/>
-                <a:lnTo>
-                  <a:pt x="18473" y="208030"/>
-                </a:lnTo>
-                <a:close/>
-                <a:lnTo>
-                  <a:pt x="17549" y="210291"/>
-                </a:lnTo>
-                <a:close/>
-                <a:lnTo>
-                  <a:pt x="16625" y="212541"/>
-                </a:lnTo>
-                <a:close/>
-                <a:lnTo>
-                  <a:pt x="15702" y="214783"/>
-                </a:lnTo>
-                <a:close/>
-                <a:lnTo>
-                  <a:pt x="14778" y="217015"/>
-                </a:lnTo>
-                <a:close/>
-                <a:lnTo>
-                  <a:pt x="13855" y="219238"/>
-                </a:lnTo>
-                <a:close/>
-                <a:lnTo>
-                  <a:pt x="12931" y="221451"/>
-                </a:lnTo>
-                <a:close/>
-                <a:lnTo>
-                  <a:pt x="12007" y="223655"/>
-                </a:lnTo>
-                <a:close/>
-                <a:lnTo>
-                  <a:pt x="11084" y="225850"/>
-                </a:lnTo>
-                <a:close/>
-                <a:lnTo>
-                  <a:pt x="10160" y="228036"/>
-                </a:lnTo>
-                <a:close/>
-                <a:lnTo>
-                  <a:pt x="9236" y="230212"/>
-                </a:lnTo>
-                <a:close/>
-                <a:lnTo>
-                  <a:pt x="8313" y="232379"/>
-                </a:lnTo>
-                <a:close/>
-                <a:lnTo>
-                  <a:pt x="7389" y="234536"/>
-                </a:lnTo>
-                <a:close/>
-                <a:lnTo>
-                  <a:pt x="6465" y="236684"/>
-                </a:lnTo>
-                <a:close/>
-                <a:lnTo>
-                  <a:pt x="5542" y="238823"/>
-                </a:lnTo>
-                <a:close/>
-                <a:lnTo>
-                  <a:pt x="4618" y="240952"/>
-                </a:lnTo>
-                <a:close/>
-                <a:lnTo>
-                  <a:pt x="3695" y="243073"/>
-                </a:lnTo>
-                <a:close/>
-                <a:lnTo>
-                  <a:pt x="2771" y="245183"/>
-                </a:lnTo>
-                <a:close/>
-                <a:lnTo>
-                  <a:pt x="1847" y="247285"/>
-                </a:lnTo>
-                <a:close/>
-                <a:lnTo>
-                  <a:pt x="924" y="249377"/>
-                </a:lnTo>
-                <a:close/>
-                <a:lnTo>
-                  <a:pt x="0" y="251460"/>
-                </a:lnTo>
-                <a:close/>
-              </a:path>
-            </a:pathLst>
-          </a:custGeom>
-          <a:ln w="19050">
+          </a:prstGeom>
+          <a:ln w="15240">
             <a:solidFill>
               <a:srgbClr val="FFFFFF"/>
             </a:solidFill>
           </a:ln>
         </p:spPr>
         <p:style>
-          <a:lnRef idx="1">
+          <a:lnRef idx="2">
             <a:schemeClr val="accent1"/>
           </a:lnRef>
-          <a:fillRef idx="3">
+          <a:fillRef idx="0">
             <a:schemeClr val="accent1"/>
           </a:fillRef>
-          <a:effectRef idx="2">
+          <a:effectRef idx="1">
             <a:schemeClr val="accent1"/>
           </a:effectRef>
           <a:fontRef idx="minor">
-            <a:schemeClr val="lt1"/>
+            <a:schemeClr val="tx1"/>
           </a:fontRef>
         </p:style>
-        <p:txBody>
-          <a:bodyPr rtlCol="0" anchor="ctr"/>
-          <a:lstStyle/>
-          <a:p>
-            <a:pPr algn="ctr"/>
-          </a:p>
-        </p:txBody>
-      </p:sp>
+      </p:cxnSp>
+      <p:cxnSp>
+        <p:nvCxnSpPr>
+          <p:cNvPr id="9" name="Connector 8"/>
+          <p:cNvCxnSpPr/>
+          <p:nvPr/>
+        </p:nvCxnSpPr>
+        <p:spPr>
+          <a:xfrm flipH="1">
+            <a:off x="6469380.0" y="2571750.0"/>
+            <a:ext cx="480060.0" cy="0.0"/>
+          </a:xfrm>
+          <a:prstGeom prst="line">
+            <a:avLst/>
+          </a:prstGeom>
+          <a:ln w="15240">
+            <a:solidFill>
+              <a:srgbClr val="FFFFFF"/>
+            </a:solidFill>
+          </a:ln>
+        </p:spPr>
+        <p:style>
+          <a:lnRef idx="2">
+            <a:schemeClr val="accent1"/>
+          </a:lnRef>
+          <a:fillRef idx="0">
+            <a:schemeClr val="accent1"/>
+          </a:fillRef>
+          <a:effectRef idx="1">
+            <a:schemeClr val="accent1"/>
+          </a:effectRef>
+          <a:fontRef idx="minor">
+            <a:schemeClr val="tx1"/>
+          </a:fontRef>
+        </p:style>
+      </p:cxnSp>
       <p:cxnSp>
         <p:nvCxnSpPr>
           <p:cNvPr id="10" name="Connector 9"/>
@@ -5437,9 +5809,9 @@
           <p:nvPr/>
         </p:nvCxnSpPr>
         <p:spPr>
-          <a:xfrm>
-            <a:off x="4572000.0" y="2571750.0"/>
-            <a:ext cx="0.0" cy="0.0"/>
+          <a:xfrm flipV="1">
+            <a:off x="6080760.0" y="1346454.0"/>
+            <a:ext cx="228600.0" cy="306324.0"/>
           </a:xfrm>
           <a:prstGeom prst="line">
             <a:avLst/>
@@ -5472,9 +5844,9 @@
           <p:nvPr/>
         </p:nvCxnSpPr>
         <p:spPr>
-          <a:xfrm>
-            <a:off x="4572000.0" y="2571750.0"/>
-            <a:ext cx="0.0" cy="0.0"/>
+          <a:xfrm flipH="1">
+            <a:off x="6446520.0" y="752094.0"/>
+            <a:ext cx="137160.0" cy="342900.0"/>
           </a:xfrm>
           <a:prstGeom prst="line">
             <a:avLst/>
@@ -5508,7 +5880,7 @@
         </p:nvSpPr>
         <p:spPr>
           <a:xfrm>
-            <a:off x="5461000" y="2391410"/>
+            <a:off x="5232400" y="196850"/>
             <a:ext cx="1524000" cy="508000"/>
           </a:xfrm>
           <a:prstGeom prst="rect">
@@ -5523,15 +5895,15 @@
           <a:lstStyle/>
           <a:p>
             <a:pPr>
-              <a:defRPr sz="1800" b="1">
+              <a:defRPr sz="2200" b="1">
                 <a:solidFill>
                   <a:srgbClr val="FFFFFF"/>
                 </a:solidFill>
-                <a:latin typeface="Inter"/>
+                <a:latin typeface="Arial"/>
               </a:defRPr>
             </a:pPr>
             <a:r>
-              <a:t>a</a:t>
+              <a:t>y=f(x)</a:t>
             </a:r>
           </a:p>
         </p:txBody>
@@ -5544,7 +5916,7 @@
         </p:nvSpPr>
         <p:spPr>
           <a:xfrm>
-            <a:off x="4135120" y="1339850"/>
+            <a:off x="6146800" y="2437130"/>
             <a:ext cx="1524000" cy="508000"/>
           </a:xfrm>
           <a:prstGeom prst="rect">
@@ -5559,15 +5931,87 @@
           <a:lstStyle/>
           <a:p>
             <a:pPr>
-              <a:defRPr sz="1800" b="1">
+              <a:defRPr sz="2200" b="1">
                 <a:solidFill>
                   <a:srgbClr val="FFFFFF"/>
                 </a:solidFill>
-                <a:latin typeface="Inter"/>
+                <a:latin typeface="Arial"/>
               </a:defRPr>
             </a:pPr>
             <a:r>
+              <a:t>a</a:t>
+            </a:r>
+          </a:p>
+        </p:txBody>
+      </p:sp>
+      <p:sp>
+        <p:nvSpPr>
+          <p:cNvPr id="14" name="TextBox 13"/>
+          <p:cNvSpPr txBox="1"/>
+          <p:nvPr/>
+        </p:nvSpPr>
+        <p:spPr>
+          <a:xfrm>
+            <a:off x="4089400" y="882650"/>
+            <a:ext cx="1524000" cy="508000"/>
+          </a:xfrm>
+          <a:prstGeom prst="rect">
+            <a:avLst/>
+          </a:prstGeom>
+          <a:noFill/>
+        </p:spPr>
+        <p:txBody>
+          <a:bodyPr wrap="none">
+            <a:spAutoFit/>
+          </a:bodyPr>
+          <a:lstStyle/>
+          <a:p>
+            <a:pPr>
+              <a:defRPr sz="2200" b="1">
+                <a:solidFill>
+                  <a:srgbClr val="FFFFFF"/>
+                </a:solidFill>
+                <a:latin typeface="Arial"/>
+              </a:defRPr>
+            </a:pPr>
+            <a:r>
               <a:t>L</a:t>
+            </a:r>
+          </a:p>
+        </p:txBody>
+      </p:sp>
+      <p:sp>
+        <p:nvSpPr>
+          <p:cNvPr id="15" name="TextBox 14"/>
+          <p:cNvSpPr txBox="1"/>
+          <p:nvPr/>
+        </p:nvSpPr>
+        <p:spPr>
+          <a:xfrm>
+            <a:off x="4135120" y="2437130"/>
+            <a:ext cx="1524000" cy="508000"/>
+          </a:xfrm>
+          <a:prstGeom prst="rect">
+            <a:avLst/>
+          </a:prstGeom>
+          <a:noFill/>
+        </p:spPr>
+        <p:txBody>
+          <a:bodyPr wrap="none">
+            <a:spAutoFit/>
+          </a:bodyPr>
+          <a:lstStyle/>
+          <a:p>
+            <a:pPr>
+              <a:defRPr sz="2200" b="1">
+                <a:solidFill>
+                  <a:srgbClr val="FFFFFF"/>
+                </a:solidFill>
+                <a:latin typeface="Arial"/>
+              </a:defRPr>
+            </a:pPr>
+            <a:r>
+              <a:t>O</a:t>
             </a:r>
           </a:p>
         </p:txBody>

</xml_diff>

<commit_message>
Fix AI curve hallucination by extracting key landmarks only
</commit_message>
<xml_diff>
--- a/output/1.pptx
+++ b/output/1.pptx
@@ -3104,8 +3104,8 @@
         </p:nvCxnSpPr>
         <p:spPr>
           <a:xfrm>
-            <a:off x="2286000.0" y="2571750.0"/>
-            <a:ext cx="4572000.0" cy="0.0"/>
+            <a:off x="3657600.0" y="2571750.0"/>
+            <a:ext cx="2743200.0" cy="0.0"/>
           </a:xfrm>
           <a:prstGeom prst="line">
             <a:avLst/>
@@ -3139,8 +3139,8 @@
         </p:nvCxnSpPr>
         <p:spPr>
           <a:xfrm flipV="1">
-            <a:off x="4572000.0" y="285750.0"/>
-            <a:ext cx="0.0" cy="4572000.0"/>
+            <a:off x="4572000.0" y="-171450.0"/>
+            <a:ext cx="0.0" cy="4114800.0"/>
           </a:xfrm>
           <a:prstGeom prst="line">
             <a:avLst/>
@@ -3174,8 +3174,8 @@
         </p:nvSpPr>
         <p:spPr>
           <a:xfrm>
-            <a:off x="3749040" y="-1681627"/>
-            <a:ext cx="1965960" cy="5576285"/>
+            <a:off x="3886200" y="57150"/>
+            <a:ext cx="2318811" cy="3657600"/>
           </a:xfrm>
           <a:custGeom>
             <a:avLst/>
@@ -3184,2404 +3184,2404 @@
             <a:cxnLst/>
             <a:rect l="l" t="t" r="r" b="b"/>
             <a:pathLst>
-              <a:path w="1965960" h="5576285">
+              <a:path w="2318811" h="3657600">
                 <a:moveTo>
-                  <a:pt x="0" y="5576285"/>
+                  <a:pt x="0" y="3657600"/>
                 </a:moveTo>
                 <a:lnTo>
-                  <a:pt x="3293" y="5567854"/>
-                </a:lnTo>
-                <a:close/>
-                <a:lnTo>
-                  <a:pt x="6584" y="5559444"/>
-                </a:lnTo>
-                <a:close/>
-                <a:lnTo>
-                  <a:pt x="9871" y="5551057"/>
-                </a:lnTo>
-                <a:close/>
-                <a:lnTo>
-                  <a:pt x="13156" y="5542692"/>
-                </a:lnTo>
-                <a:close/>
-                <a:lnTo>
-                  <a:pt x="16438" y="5534349"/>
-                </a:lnTo>
-                <a:close/>
-                <a:lnTo>
-                  <a:pt x="19719" y="5526029"/>
-                </a:lnTo>
-                <a:close/>
-                <a:lnTo>
-                  <a:pt x="22999" y="5517731"/>
-                </a:lnTo>
-                <a:close/>
-                <a:lnTo>
-                  <a:pt x="26278" y="5509457"/>
-                </a:lnTo>
-                <a:close/>
-                <a:lnTo>
-                  <a:pt x="29555" y="5501205"/>
-                </a:lnTo>
-                <a:close/>
-                <a:lnTo>
-                  <a:pt x="32833" y="5492976"/>
-                </a:lnTo>
-                <a:close/>
-                <a:lnTo>
-                  <a:pt x="36111" y="5484770"/>
-                </a:lnTo>
-                <a:close/>
-                <a:lnTo>
-                  <a:pt x="39389" y="5476588"/>
-                </a:lnTo>
-                <a:close/>
-                <a:lnTo>
-                  <a:pt x="42668" y="5468429"/>
-                </a:lnTo>
-                <a:close/>
-                <a:lnTo>
-                  <a:pt x="45949" y="5460293"/>
-                </a:lnTo>
-                <a:close/>
-                <a:lnTo>
-                  <a:pt x="49231" y="5452181"/>
-                </a:lnTo>
-                <a:close/>
-                <a:lnTo>
-                  <a:pt x="52515" y="5444093"/>
-                </a:lnTo>
-                <a:close/>
-                <a:lnTo>
-                  <a:pt x="55800" y="5436029"/>
-                </a:lnTo>
-                <a:close/>
-                <a:lnTo>
-                  <a:pt x="59087" y="5427989"/>
-                </a:lnTo>
-                <a:close/>
-                <a:lnTo>
-                  <a:pt x="62373" y="5419972"/>
-                </a:lnTo>
-                <a:close/>
-                <a:lnTo>
-                  <a:pt x="65659" y="5411979"/>
-                </a:lnTo>
-                <a:close/>
-                <a:lnTo>
-                  <a:pt x="68945" y="5404011"/>
-                </a:lnTo>
-                <a:close/>
-                <a:lnTo>
-                  <a:pt x="72228" y="5396066"/>
-                </a:lnTo>
-                <a:close/>
-                <a:lnTo>
-                  <a:pt x="75510" y="5388145"/>
-                </a:lnTo>
-                <a:close/>
-                <a:lnTo>
-                  <a:pt x="78790" y="5380248"/>
-                </a:lnTo>
-                <a:close/>
-                <a:lnTo>
-                  <a:pt x="82068" y="5372376"/>
-                </a:lnTo>
-                <a:close/>
-                <a:lnTo>
-                  <a:pt x="85346" y="5364529"/>
-                </a:lnTo>
-                <a:close/>
-                <a:lnTo>
-                  <a:pt x="88623" y="5356708"/>
-                </a:lnTo>
-                <a:close/>
-                <a:lnTo>
-                  <a:pt x="91902" y="5348912"/>
-                </a:lnTo>
-                <a:close/>
-                <a:lnTo>
-                  <a:pt x="95181" y="5341143"/>
-                </a:lnTo>
-                <a:close/>
-                <a:lnTo>
-                  <a:pt x="98462" y="5333400"/>
-                </a:lnTo>
-                <a:close/>
-                <a:lnTo>
-                  <a:pt x="101745" y="5325684"/>
-                </a:lnTo>
-                <a:close/>
-                <a:lnTo>
-                  <a:pt x="105031" y="5317995"/>
-                </a:lnTo>
-                <a:close/>
-                <a:lnTo>
-                  <a:pt x="108317" y="5310332"/>
-                </a:lnTo>
-                <a:close/>
-                <a:lnTo>
-                  <a:pt x="111603" y="5302695"/>
-                </a:lnTo>
-                <a:close/>
-                <a:lnTo>
-                  <a:pt x="114890" y="5295084"/>
-                </a:lnTo>
-                <a:close/>
-                <a:lnTo>
-                  <a:pt x="118175" y="5287498"/>
-                </a:lnTo>
-                <a:close/>
-                <a:lnTo>
-                  <a:pt x="121459" y="5279937"/>
-                </a:lnTo>
-                <a:close/>
-                <a:lnTo>
-                  <a:pt x="124741" y="5272400"/>
-                </a:lnTo>
-                <a:close/>
-                <a:lnTo>
-                  <a:pt x="128021" y="5264888"/>
-                </a:lnTo>
-                <a:close/>
-                <a:lnTo>
-                  <a:pt x="131299" y="5257401"/>
-                </a:lnTo>
-                <a:close/>
-                <a:lnTo>
-                  <a:pt x="134577" y="5249939"/>
-                </a:lnTo>
-                <a:close/>
-                <a:lnTo>
-                  <a:pt x="137855" y="5242503"/>
-                </a:lnTo>
-                <a:close/>
-                <a:lnTo>
-                  <a:pt x="141133" y="5235093"/>
-                </a:lnTo>
-                <a:close/>
-                <a:lnTo>
-                  <a:pt x="144412" y="5227709"/>
-                </a:lnTo>
-                <a:close/>
-                <a:lnTo>
-                  <a:pt x="147693" y="5220353"/>
-                </a:lnTo>
-                <a:close/>
-                <a:lnTo>
-                  <a:pt x="150977" y="5213024"/>
-                </a:lnTo>
-                <a:close/>
-                <a:lnTo>
-                  <a:pt x="154262" y="5205722"/>
-                </a:lnTo>
-                <a:close/>
-                <a:lnTo>
-                  <a:pt x="157548" y="5198448"/>
-                </a:lnTo>
-                <a:close/>
-                <a:lnTo>
-                  <a:pt x="160834" y="5191201"/>
-                </a:lnTo>
-                <a:close/>
-                <a:lnTo>
-                  <a:pt x="164121" y="5183982"/>
-                </a:lnTo>
-                <a:close/>
-                <a:lnTo>
-                  <a:pt x="167406" y="5176790"/>
-                </a:lnTo>
-                <a:close/>
-                <a:lnTo>
-                  <a:pt x="170690" y="5169627"/>
-                </a:lnTo>
-                <a:close/>
-                <a:lnTo>
-                  <a:pt x="173972" y="5162491"/>
-                </a:lnTo>
-                <a:close/>
-                <a:lnTo>
-                  <a:pt x="177252" y="5155383"/>
-                </a:lnTo>
-                <a:close/>
-                <a:lnTo>
-                  <a:pt x="180530" y="5148303"/>
-                </a:lnTo>
-                <a:close/>
-                <a:lnTo>
-                  <a:pt x="183808" y="5141250"/>
-                </a:lnTo>
-                <a:close/>
-                <a:lnTo>
-                  <a:pt x="187086" y="5134226"/>
-                </a:lnTo>
-                <a:close/>
-                <a:lnTo>
-                  <a:pt x="190364" y="5127229"/>
-                </a:lnTo>
-                <a:close/>
-                <a:lnTo>
-                  <a:pt x="193643" y="5120259"/>
-                </a:lnTo>
-                <a:close/>
-                <a:lnTo>
-                  <a:pt x="196924" y="5113317"/>
-                </a:lnTo>
-                <a:close/>
-                <a:lnTo>
-                  <a:pt x="200208" y="5106403"/>
-                </a:lnTo>
-                <a:close/>
-                <a:lnTo>
-                  <a:pt x="203493" y="5099516"/>
-                </a:lnTo>
-                <a:close/>
-                <a:lnTo>
-                  <a:pt x="206779" y="5092657"/>
-                </a:lnTo>
-                <a:close/>
-                <a:lnTo>
-                  <a:pt x="210066" y="5085826"/>
-                </a:lnTo>
-                <a:close/>
-                <a:lnTo>
-                  <a:pt x="213352" y="5079023"/>
-                </a:lnTo>
-                <a:close/>
-                <a:lnTo>
-                  <a:pt x="216637" y="5072248"/>
-                </a:lnTo>
-                <a:close/>
-                <a:lnTo>
-                  <a:pt x="219921" y="5065502"/>
-                </a:lnTo>
-                <a:close/>
-                <a:lnTo>
-                  <a:pt x="223203" y="5058784"/>
-                </a:lnTo>
-                <a:close/>
-                <a:lnTo>
-                  <a:pt x="226483" y="5052094"/>
-                </a:lnTo>
-                <a:close/>
-                <a:lnTo>
-                  <a:pt x="229761" y="5045434"/>
-                </a:lnTo>
-                <a:close/>
-                <a:lnTo>
-                  <a:pt x="233039" y="5038802"/>
-                </a:lnTo>
-                <a:close/>
-                <a:lnTo>
-                  <a:pt x="236317" y="5032199"/>
-                </a:lnTo>
-                <a:close/>
-                <a:lnTo>
-                  <a:pt x="239595" y="5025626"/>
-                </a:lnTo>
-                <a:close/>
-                <a:lnTo>
-                  <a:pt x="242874" y="5019082"/>
-                </a:lnTo>
-                <a:close/>
-                <a:lnTo>
-                  <a:pt x="246155" y="5012568"/>
-                </a:lnTo>
-                <a:close/>
-                <a:lnTo>
-                  <a:pt x="249439" y="5006083"/>
-                </a:lnTo>
-                <a:close/>
-                <a:lnTo>
-                  <a:pt x="252724" y="4999628"/>
-                </a:lnTo>
-                <a:close/>
-                <a:lnTo>
-                  <a:pt x="256010" y="4993203"/>
-                </a:lnTo>
-                <a:close/>
-                <a:lnTo>
-                  <a:pt x="259297" y="4986806"/>
-                </a:lnTo>
-                <a:close/>
-                <a:lnTo>
-                  <a:pt x="262583" y="4980439"/>
-                </a:lnTo>
-                <a:close/>
-                <a:lnTo>
-                  <a:pt x="265869" y="4974101"/>
-                </a:lnTo>
-                <a:close/>
-                <a:lnTo>
-                  <a:pt x="269152" y="4967792"/>
-                </a:lnTo>
-                <a:close/>
-                <a:lnTo>
-                  <a:pt x="272434" y="4961511"/>
-                </a:lnTo>
-                <a:close/>
-                <a:lnTo>
-                  <a:pt x="275714" y="4955260"/>
-                </a:lnTo>
-                <a:close/>
-                <a:lnTo>
-                  <a:pt x="278992" y="4949037"/>
-                </a:lnTo>
-                <a:close/>
-                <a:lnTo>
-                  <a:pt x="282270" y="4942845"/>
-                </a:lnTo>
-                <a:close/>
-                <a:lnTo>
-                  <a:pt x="285548" y="4936683"/>
-                </a:lnTo>
-                <a:close/>
-                <a:lnTo>
-                  <a:pt x="288826" y="4930551"/>
-                </a:lnTo>
-                <a:close/>
-                <a:lnTo>
-                  <a:pt x="292105" y="4924450"/>
-                </a:lnTo>
-                <a:close/>
-                <a:lnTo>
-                  <a:pt x="295386" y="4918380"/>
-                </a:lnTo>
-                <a:close/>
-                <a:lnTo>
-                  <a:pt x="298670" y="4912342"/>
-                </a:lnTo>
-                <a:close/>
-                <a:lnTo>
-                  <a:pt x="301955" y="4906336"/>
-                </a:lnTo>
-                <a:close/>
-                <a:lnTo>
-                  <a:pt x="305241" y="4900361"/>
-                </a:lnTo>
-                <a:close/>
-                <a:lnTo>
-                  <a:pt x="308528" y="4894417"/>
-                </a:lnTo>
-                <a:close/>
-                <a:lnTo>
-                  <a:pt x="311814" y="4888504"/>
-                </a:lnTo>
-                <a:close/>
-                <a:lnTo>
-                  <a:pt x="315100" y="4882622"/>
-                </a:lnTo>
-                <a:close/>
-                <a:lnTo>
-                  <a:pt x="318384" y="4876771"/>
-                </a:lnTo>
-                <a:close/>
-                <a:lnTo>
-                  <a:pt x="321665" y="4870950"/>
-                </a:lnTo>
-                <a:close/>
-                <a:lnTo>
-                  <a:pt x="324945" y="4865160"/>
-                </a:lnTo>
-                <a:close/>
-                <a:lnTo>
-                  <a:pt x="328223" y="4859401"/>
-                </a:lnTo>
-                <a:close/>
-                <a:lnTo>
-                  <a:pt x="331501" y="4853673"/>
-                </a:lnTo>
-                <a:close/>
-                <a:lnTo>
-                  <a:pt x="334778" y="4847976"/>
-                </a:lnTo>
-                <a:close/>
-                <a:lnTo>
-                  <a:pt x="338057" y="4842311"/>
-                </a:lnTo>
-                <a:close/>
-                <a:lnTo>
-                  <a:pt x="341336" y="4836678"/>
-                </a:lnTo>
-                <a:close/>
-                <a:lnTo>
-                  <a:pt x="344617" y="4831077"/>
-                </a:lnTo>
-                <a:close/>
-                <a:lnTo>
-                  <a:pt x="347901" y="4825508"/>
-                </a:lnTo>
-                <a:close/>
-                <a:lnTo>
-                  <a:pt x="351186" y="4819972"/>
-                </a:lnTo>
-                <a:close/>
-                <a:lnTo>
-                  <a:pt x="354472" y="4814467"/>
-                </a:lnTo>
-                <a:close/>
-                <a:lnTo>
-                  <a:pt x="357759" y="4808994"/>
-                </a:lnTo>
-                <a:close/>
-                <a:lnTo>
-                  <a:pt x="361045" y="4803553"/>
-                </a:lnTo>
-                <a:close/>
-                <a:lnTo>
-                  <a:pt x="364331" y="4798143"/>
-                </a:lnTo>
-                <a:close/>
-                <a:lnTo>
-                  <a:pt x="367615" y="4792764"/>
-                </a:lnTo>
-                <a:close/>
-                <a:lnTo>
-                  <a:pt x="370896" y="4787417"/>
-                </a:lnTo>
-                <a:close/>
-                <a:lnTo>
-                  <a:pt x="374176" y="4782101"/>
-                </a:lnTo>
-                <a:close/>
-                <a:lnTo>
-                  <a:pt x="377454" y="4776816"/>
-                </a:lnTo>
-                <a:close/>
-                <a:lnTo>
-                  <a:pt x="380732" y="4771564"/>
-                </a:lnTo>
-                <a:close/>
-                <a:lnTo>
-                  <a:pt x="384009" y="4766345"/>
-                </a:lnTo>
-                <a:close/>
-                <a:lnTo>
-                  <a:pt x="387288" y="4761158"/>
-                </a:lnTo>
-                <a:close/>
-                <a:lnTo>
-                  <a:pt x="390567" y="4756006"/>
-                </a:lnTo>
-                <a:close/>
-                <a:lnTo>
-                  <a:pt x="393848" y="4750887"/>
-                </a:lnTo>
-                <a:close/>
-                <a:lnTo>
-                  <a:pt x="397132" y="4745802"/>
-                </a:lnTo>
-                <a:close/>
-                <a:lnTo>
-                  <a:pt x="400417" y="4740752"/>
-                </a:lnTo>
-                <a:close/>
-                <a:lnTo>
-                  <a:pt x="403704" y="4735735"/>
-                </a:lnTo>
-                <a:close/>
-                <a:lnTo>
-                  <a:pt x="406990" y="4730752"/>
-                </a:lnTo>
-                <a:close/>
-                <a:lnTo>
-                  <a:pt x="410277" y="4725801"/>
-                </a:lnTo>
-                <a:close/>
-                <a:lnTo>
-                  <a:pt x="413562" y="4720884"/>
-                </a:lnTo>
-                <a:close/>
-                <a:lnTo>
-                  <a:pt x="416846" y="4715999"/>
-                </a:lnTo>
-                <a:close/>
-                <a:lnTo>
-                  <a:pt x="420127" y="4711146"/>
-                </a:lnTo>
-                <a:close/>
-                <a:lnTo>
-                  <a:pt x="423407" y="4706325"/>
-                </a:lnTo>
-                <a:close/>
-                <a:lnTo>
-                  <a:pt x="426685" y="4701537"/>
-                </a:lnTo>
-                <a:close/>
-                <a:lnTo>
-                  <a:pt x="429963" y="4696781"/>
-                </a:lnTo>
-                <a:close/>
-                <a:lnTo>
-                  <a:pt x="433240" y="4692057"/>
-                </a:lnTo>
-                <a:close/>
-                <a:lnTo>
-                  <a:pt x="436519" y="4687367"/>
-                </a:lnTo>
-                <a:close/>
-                <a:lnTo>
-                  <a:pt x="439798" y="4682709"/>
-                </a:lnTo>
-                <a:close/>
-                <a:lnTo>
-                  <a:pt x="443080" y="4678084"/>
-                </a:lnTo>
-                <a:close/>
-                <a:lnTo>
-                  <a:pt x="446363" y="4673492"/>
-                </a:lnTo>
-                <a:close/>
-                <a:lnTo>
-                  <a:pt x="449648" y="4668934"/>
-                </a:lnTo>
-                <a:close/>
-                <a:lnTo>
-                  <a:pt x="452935" y="4664411"/>
-                </a:lnTo>
-                <a:close/>
-                <a:lnTo>
-                  <a:pt x="456221" y="4659921"/>
-                </a:lnTo>
-                <a:close/>
-                <a:lnTo>
-                  <a:pt x="459508" y="4655466"/>
-                </a:lnTo>
-                <a:close/>
-                <a:lnTo>
-                  <a:pt x="462793" y="4651046"/>
-                </a:lnTo>
-                <a:close/>
-                <a:lnTo>
-                  <a:pt x="466077" y="4646662"/>
-                </a:lnTo>
-                <a:close/>
-                <a:lnTo>
-                  <a:pt x="469358" y="4642314"/>
-                </a:lnTo>
-                <a:close/>
-                <a:lnTo>
-                  <a:pt x="472638" y="4638001"/>
-                </a:lnTo>
-                <a:close/>
-                <a:lnTo>
-                  <a:pt x="475916" y="4633724"/>
-                </a:lnTo>
-                <a:close/>
-                <a:lnTo>
-                  <a:pt x="479194" y="4629482"/>
-                </a:lnTo>
-                <a:close/>
-                <a:lnTo>
-                  <a:pt x="482471" y="4625275"/>
-                </a:lnTo>
-                <a:close/>
-                <a:lnTo>
-                  <a:pt x="485750" y="4621101"/>
-                </a:lnTo>
-                <a:close/>
-                <a:lnTo>
-                  <a:pt x="489029" y="4616962"/>
-                </a:lnTo>
-                <a:close/>
-                <a:lnTo>
-                  <a:pt x="492311" y="4612856"/>
-                </a:lnTo>
-                <a:close/>
-                <a:lnTo>
-                  <a:pt x="495594" y="4608783"/>
-                </a:lnTo>
-                <a:close/>
-                <a:lnTo>
-                  <a:pt x="498880" y="4604745"/>
-                </a:lnTo>
-                <a:close/>
-                <a:lnTo>
-                  <a:pt x="502166" y="4600740"/>
-                </a:lnTo>
-                <a:close/>
-                <a:lnTo>
-                  <a:pt x="505453" y="4596770"/>
-                </a:lnTo>
-                <a:close/>
-                <a:lnTo>
-                  <a:pt x="508739" y="4592836"/>
-                </a:lnTo>
-                <a:close/>
-                <a:lnTo>
-                  <a:pt x="512024" y="4588936"/>
-                </a:lnTo>
-                <a:close/>
-                <a:lnTo>
-                  <a:pt x="515308" y="4585073"/>
-                </a:lnTo>
-                <a:close/>
-                <a:lnTo>
-                  <a:pt x="518589" y="4581247"/>
-                </a:lnTo>
-                <a:close/>
-                <a:lnTo>
-                  <a:pt x="521869" y="4577456"/>
-                </a:lnTo>
-                <a:close/>
-                <a:lnTo>
-                  <a:pt x="525147" y="4573703"/>
-                </a:lnTo>
-                <a:close/>
-                <a:lnTo>
-                  <a:pt x="528425" y="4569985"/>
-                </a:lnTo>
-                <a:close/>
-                <a:lnTo>
-                  <a:pt x="531702" y="4566304"/>
-                </a:lnTo>
-                <a:close/>
-                <a:lnTo>
-                  <a:pt x="534981" y="4562658"/>
-                </a:lnTo>
-                <a:close/>
-                <a:lnTo>
-                  <a:pt x="538260" y="4559049"/>
-                </a:lnTo>
-                <a:close/>
-                <a:lnTo>
-                  <a:pt x="541542" y="4555476"/>
-                </a:lnTo>
-                <a:close/>
-                <a:lnTo>
-                  <a:pt x="544825" y="4551938"/>
-                </a:lnTo>
-                <a:close/>
-                <a:lnTo>
-                  <a:pt x="548111" y="4548437"/>
-                </a:lnTo>
-                <a:close/>
-                <a:lnTo>
-                  <a:pt x="551397" y="4544971"/>
-                </a:lnTo>
-                <a:close/>
-                <a:lnTo>
-                  <a:pt x="554684" y="4541540"/>
-                </a:lnTo>
-                <a:close/>
-                <a:lnTo>
-                  <a:pt x="557970" y="4538145"/>
-                </a:lnTo>
-                <a:close/>
-                <a:lnTo>
-                  <a:pt x="561255" y="4534786"/>
-                </a:lnTo>
-                <a:close/>
-                <a:lnTo>
-                  <a:pt x="564539" y="4531462"/>
-                </a:lnTo>
-                <a:close/>
-                <a:lnTo>
-                  <a:pt x="567820" y="4528174"/>
-                </a:lnTo>
-                <a:close/>
-                <a:lnTo>
-                  <a:pt x="571100" y="4524921"/>
-                </a:lnTo>
-                <a:close/>
-                <a:lnTo>
-                  <a:pt x="574378" y="4521704"/>
-                </a:lnTo>
-                <a:close/>
-                <a:lnTo>
-                  <a:pt x="577656" y="4518523"/>
-                </a:lnTo>
-                <a:close/>
-                <a:lnTo>
-                  <a:pt x="580933" y="4515379"/>
-                </a:lnTo>
-                <a:close/>
-                <a:lnTo>
-                  <a:pt x="584211" y="4512273"/>
-                </a:lnTo>
-                <a:close/>
-                <a:lnTo>
-                  <a:pt x="587491" y="4509203"/>
-                </a:lnTo>
-                <a:close/>
-                <a:lnTo>
-                  <a:pt x="590773" y="4506172"/>
-                </a:lnTo>
-                <a:close/>
-                <a:lnTo>
-                  <a:pt x="594057" y="4503178"/>
-                </a:lnTo>
-                <a:close/>
-                <a:lnTo>
-                  <a:pt x="597342" y="4500223"/>
-                </a:lnTo>
-                <a:close/>
-                <a:lnTo>
-                  <a:pt x="600628" y="4497305"/>
-                </a:lnTo>
-                <a:close/>
-                <a:lnTo>
-                  <a:pt x="603915" y="4494425"/>
-                </a:lnTo>
-                <a:close/>
-                <a:lnTo>
-                  <a:pt x="607201" y="4491583"/>
-                </a:lnTo>
-                <a:close/>
-                <a:lnTo>
-                  <a:pt x="610486" y="4488779"/>
-                </a:lnTo>
-                <a:close/>
-                <a:lnTo>
-                  <a:pt x="613770" y="4486012"/>
-                </a:lnTo>
-                <a:close/>
-                <a:lnTo>
-                  <a:pt x="617051" y="4483283"/>
-                </a:lnTo>
-                <a:close/>
-                <a:lnTo>
-                  <a:pt x="620331" y="4480591"/>
-                </a:lnTo>
-                <a:close/>
-                <a:lnTo>
-                  <a:pt x="623609" y="4477937"/>
-                </a:lnTo>
-                <a:close/>
-                <a:lnTo>
-                  <a:pt x="626887" y="4475320"/>
-                </a:lnTo>
-                <a:close/>
-                <a:lnTo>
-                  <a:pt x="630164" y="4472740"/>
-                </a:lnTo>
-                <a:close/>
-                <a:lnTo>
-                  <a:pt x="633442" y="4470197"/>
-                </a:lnTo>
-                <a:close/>
-                <a:lnTo>
-                  <a:pt x="636722" y="4467691"/>
-                </a:lnTo>
-                <a:close/>
-                <a:lnTo>
-                  <a:pt x="640004" y="4465222"/>
-                </a:lnTo>
-                <a:close/>
-                <a:lnTo>
-                  <a:pt x="643288" y="4462790"/>
-                </a:lnTo>
-                <a:close/>
-                <a:lnTo>
-                  <a:pt x="646573" y="4460396"/>
-                </a:lnTo>
-                <a:close/>
-                <a:lnTo>
-                  <a:pt x="649859" y="4458039"/>
-                </a:lnTo>
-                <a:close/>
-                <a:lnTo>
-                  <a:pt x="653146" y="4455721"/>
-                </a:lnTo>
-                <a:close/>
-                <a:lnTo>
-                  <a:pt x="656432" y="4453442"/>
-                </a:lnTo>
-                <a:close/>
-                <a:lnTo>
-                  <a:pt x="659717" y="4451201"/>
-                </a:lnTo>
-                <a:close/>
-                <a:lnTo>
-                  <a:pt x="663001" y="4449001"/>
-                </a:lnTo>
-                <a:close/>
-                <a:lnTo>
-                  <a:pt x="666282" y="4446841"/>
-                </a:lnTo>
-                <a:close/>
-                <a:lnTo>
-                  <a:pt x="669562" y="4444720"/>
-                </a:lnTo>
-                <a:close/>
-                <a:lnTo>
-                  <a:pt x="672840" y="4442639"/>
-                </a:lnTo>
-                <a:close/>
-                <a:lnTo>
-                  <a:pt x="676117" y="4440597"/>
-                </a:lnTo>
-                <a:close/>
-                <a:lnTo>
-                  <a:pt x="679395" y="4438594"/>
-                </a:lnTo>
-                <a:close/>
-                <a:lnTo>
-                  <a:pt x="682673" y="4436628"/>
-                </a:lnTo>
-                <a:close/>
-                <a:lnTo>
-                  <a:pt x="685953" y="4434701"/>
-                </a:lnTo>
-                <a:close/>
-                <a:lnTo>
-                  <a:pt x="689235" y="4432811"/>
-                </a:lnTo>
-                <a:close/>
-                <a:lnTo>
-                  <a:pt x="692519" y="4430958"/>
-                </a:lnTo>
-                <a:close/>
-                <a:lnTo>
-                  <a:pt x="695804" y="4429143"/>
-                </a:lnTo>
-                <a:close/>
-                <a:lnTo>
-                  <a:pt x="699091" y="4427366"/>
-                </a:lnTo>
-                <a:close/>
-                <a:lnTo>
-                  <a:pt x="702377" y="4425629"/>
-                </a:lnTo>
-                <a:close/>
-                <a:lnTo>
-                  <a:pt x="705663" y="4423931"/>
-                </a:lnTo>
-                <a:close/>
-                <a:lnTo>
-                  <a:pt x="708949" y="4422274"/>
-                </a:lnTo>
-                <a:close/>
-                <a:lnTo>
-                  <a:pt x="712232" y="4420657"/>
-                </a:lnTo>
-                <a:close/>
-                <a:lnTo>
-                  <a:pt x="715513" y="4419082"/>
-                </a:lnTo>
-                <a:close/>
-                <a:lnTo>
-                  <a:pt x="718793" y="4417547"/>
-                </a:lnTo>
-                <a:close/>
-                <a:lnTo>
-                  <a:pt x="722071" y="4416053"/>
-                </a:lnTo>
-                <a:close/>
-                <a:lnTo>
-                  <a:pt x="725348" y="4414599"/>
-                </a:lnTo>
-                <a:close/>
-                <a:lnTo>
-                  <a:pt x="728626" y="4413184"/>
-                </a:lnTo>
-                <a:close/>
-                <a:lnTo>
-                  <a:pt x="731904" y="4411806"/>
-                </a:lnTo>
-                <a:close/>
-                <a:lnTo>
-                  <a:pt x="735184" y="4410467"/>
-                </a:lnTo>
-                <a:close/>
-                <a:lnTo>
-                  <a:pt x="738466" y="4409164"/>
-                </a:lnTo>
-                <a:close/>
-                <a:lnTo>
-                  <a:pt x="741750" y="4407898"/>
-                </a:lnTo>
-                <a:close/>
-                <a:lnTo>
-                  <a:pt x="745035" y="4406669"/>
-                </a:lnTo>
-                <a:close/>
-                <a:lnTo>
-                  <a:pt x="748322" y="4405479"/>
-                </a:lnTo>
-                <a:close/>
-                <a:lnTo>
-                  <a:pt x="751608" y="4404328"/>
-                </a:lnTo>
-                <a:close/>
-                <a:lnTo>
-                  <a:pt x="754894" y="4403217"/>
-                </a:lnTo>
-                <a:close/>
-                <a:lnTo>
-                  <a:pt x="758180" y="4402148"/>
-                </a:lnTo>
-                <a:close/>
-                <a:lnTo>
-                  <a:pt x="761463" y="4401120"/>
-                </a:lnTo>
-                <a:close/>
-                <a:lnTo>
-                  <a:pt x="764744" y="4400134"/>
-                </a:lnTo>
-                <a:close/>
-                <a:lnTo>
-                  <a:pt x="768024" y="4399191"/>
-                </a:lnTo>
-                <a:close/>
-                <a:lnTo>
-                  <a:pt x="771302" y="4398289"/>
-                </a:lnTo>
-                <a:close/>
-                <a:lnTo>
-                  <a:pt x="774580" y="4397428"/>
-                </a:lnTo>
-                <a:close/>
-                <a:lnTo>
-                  <a:pt x="777857" y="4396607"/>
-                </a:lnTo>
-                <a:close/>
-                <a:lnTo>
-                  <a:pt x="781136" y="4395824"/>
-                </a:lnTo>
-                <a:close/>
-                <a:lnTo>
-                  <a:pt x="784415" y="4395080"/>
-                </a:lnTo>
-                <a:close/>
-                <a:lnTo>
-                  <a:pt x="787697" y="4394374"/>
-                </a:lnTo>
-                <a:close/>
-                <a:lnTo>
-                  <a:pt x="790980" y="4393705"/>
-                </a:lnTo>
-                <a:close/>
-                <a:lnTo>
-                  <a:pt x="794265" y="4393074"/>
-                </a:lnTo>
-                <a:close/>
-                <a:lnTo>
-                  <a:pt x="797551" y="4392483"/>
-                </a:lnTo>
-                <a:close/>
-                <a:lnTo>
-                  <a:pt x="800838" y="4391932"/>
-                </a:lnTo>
-                <a:close/>
-                <a:lnTo>
-                  <a:pt x="804124" y="4391421"/>
-                </a:lnTo>
-                <a:close/>
-                <a:lnTo>
-                  <a:pt x="807410" y="4390953"/>
-                </a:lnTo>
-                <a:close/>
-                <a:lnTo>
-                  <a:pt x="810694" y="4390527"/>
-                </a:lnTo>
-                <a:close/>
-                <a:lnTo>
-                  <a:pt x="813977" y="4390144"/>
-                </a:lnTo>
-                <a:close/>
-                <a:lnTo>
-                  <a:pt x="817258" y="4389803"/>
-                </a:lnTo>
-                <a:close/>
-                <a:lnTo>
-                  <a:pt x="820538" y="4389504"/>
-                </a:lnTo>
-                <a:close/>
-                <a:lnTo>
-                  <a:pt x="823817" y="4389243"/>
-                </a:lnTo>
-                <a:close/>
-                <a:lnTo>
-                  <a:pt x="827095" y="4389022"/>
-                </a:lnTo>
-                <a:close/>
-                <a:lnTo>
-                  <a:pt x="830372" y="4388837"/>
-                </a:lnTo>
-                <a:close/>
-                <a:lnTo>
-                  <a:pt x="833649" y="4388687"/>
-                </a:lnTo>
-                <a:close/>
-                <a:lnTo>
-                  <a:pt x="836926" y="4388572"/>
-                </a:lnTo>
-                <a:close/>
-                <a:lnTo>
-                  <a:pt x="840203" y="4388489"/>
-                </a:lnTo>
-                <a:close/>
-                <a:lnTo>
-                  <a:pt x="843480" y="4388438"/>
-                </a:lnTo>
-                <a:close/>
-                <a:lnTo>
-                  <a:pt x="846758" y="4388417"/>
-                </a:lnTo>
-                <a:close/>
-                <a:lnTo>
-                  <a:pt x="850036" y="4388425"/>
-                </a:lnTo>
-                <a:close/>
-                <a:lnTo>
-                  <a:pt x="853316" y="4388461"/>
-                </a:lnTo>
-                <a:close/>
-                <a:lnTo>
-                  <a:pt x="856597" y="4388523"/>
-                </a:lnTo>
-                <a:close/>
-                <a:lnTo>
-                  <a:pt x="859879" y="4388611"/>
-                </a:lnTo>
-                <a:close/>
-                <a:lnTo>
-                  <a:pt x="863164" y="4388722"/>
-                </a:lnTo>
-                <a:close/>
-                <a:lnTo>
-                  <a:pt x="866449" y="4388856"/>
-                </a:lnTo>
-                <a:close/>
-                <a:lnTo>
-                  <a:pt x="869735" y="4389012"/>
-                </a:lnTo>
-                <a:close/>
-                <a:lnTo>
-                  <a:pt x="873022" y="4389191"/>
-                </a:lnTo>
-                <a:close/>
-                <a:lnTo>
-                  <a:pt x="876308" y="4389390"/>
-                </a:lnTo>
-                <a:close/>
-                <a:lnTo>
-                  <a:pt x="879593" y="4389609"/>
-                </a:lnTo>
-                <a:close/>
-                <a:lnTo>
-                  <a:pt x="882877" y="4389849"/>
-                </a:lnTo>
-                <a:close/>
-                <a:lnTo>
-                  <a:pt x="886159" y="4390107"/>
-                </a:lnTo>
-                <a:close/>
-                <a:lnTo>
-                  <a:pt x="889438" y="4390383"/>
-                </a:lnTo>
-                <a:close/>
-                <a:lnTo>
-                  <a:pt x="892717" y="4390676"/>
-                </a:lnTo>
-                <a:close/>
-                <a:lnTo>
-                  <a:pt x="895995" y="4390985"/>
-                </a:lnTo>
-                <a:close/>
-                <a:lnTo>
-                  <a:pt x="899272" y="4391308"/>
-                </a:lnTo>
-                <a:close/>
-                <a:lnTo>
-                  <a:pt x="902550" y="4391644"/>
-                </a:lnTo>
-                <a:close/>
-                <a:lnTo>
-                  <a:pt x="905830" y="4391993"/>
-                </a:lnTo>
-                <a:close/>
-                <a:lnTo>
-                  <a:pt x="909111" y="4392352"/>
-                </a:lnTo>
-                <a:close/>
-                <a:lnTo>
-                  <a:pt x="912394" y="4392721"/>
-                </a:lnTo>
-                <a:close/>
-                <a:lnTo>
-                  <a:pt x="915679" y="4393099"/>
-                </a:lnTo>
-                <a:close/>
-                <a:lnTo>
-                  <a:pt x="918965" y="4393485"/>
-                </a:lnTo>
-                <a:close/>
-                <a:lnTo>
-                  <a:pt x="922251" y="4393877"/>
-                </a:lnTo>
-                <a:close/>
-                <a:lnTo>
-                  <a:pt x="925538" y="4394274"/>
-                </a:lnTo>
-                <a:close/>
-                <a:lnTo>
-                  <a:pt x="928823" y="4394675"/>
-                </a:lnTo>
-                <a:close/>
-                <a:lnTo>
-                  <a:pt x="932108" y="4395079"/>
-                </a:lnTo>
-                <a:close/>
-                <a:lnTo>
-                  <a:pt x="935390" y="4395485"/>
-                </a:lnTo>
-                <a:close/>
-                <a:lnTo>
-                  <a:pt x="938670" y="4395892"/>
-                </a:lnTo>
-                <a:close/>
-                <a:lnTo>
-                  <a:pt x="941948" y="4396299"/>
-                </a:lnTo>
-                <a:close/>
-                <a:lnTo>
-                  <a:pt x="945226" y="4396705"/>
-                </a:lnTo>
-                <a:close/>
-                <a:lnTo>
-                  <a:pt x="948503" y="4397109"/>
-                </a:lnTo>
-                <a:close/>
-                <a:lnTo>
-                  <a:pt x="951782" y="4397511"/>
-                </a:lnTo>
-                <a:close/>
-                <a:lnTo>
-                  <a:pt x="955061" y="4397910"/>
-                </a:lnTo>
-                <a:close/>
-                <a:lnTo>
-                  <a:pt x="958342" y="4398304"/>
-                </a:lnTo>
-                <a:close/>
-                <a:lnTo>
-                  <a:pt x="961625" y="4398694"/>
-                </a:lnTo>
-                <a:close/>
-                <a:lnTo>
-                  <a:pt x="964910" y="4399077"/>
-                </a:lnTo>
-                <a:close/>
-                <a:lnTo>
-                  <a:pt x="968196" y="4399452"/>
-                </a:lnTo>
-                <a:close/>
-                <a:lnTo>
-                  <a:pt x="971482" y="4399818"/>
-                </a:lnTo>
-                <a:close/>
-                <a:lnTo>
-                  <a:pt x="974769" y="4400174"/>
-                </a:lnTo>
-                <a:close/>
-                <a:lnTo>
-                  <a:pt x="978055" y="4400517"/>
-                </a:lnTo>
-                <a:close/>
-                <a:lnTo>
-                  <a:pt x="981339" y="4400847"/>
-                </a:lnTo>
-                <a:close/>
-                <a:lnTo>
-                  <a:pt x="984621" y="4401163"/>
-                </a:lnTo>
-                <a:close/>
-                <a:lnTo>
-                  <a:pt x="987901" y="4401462"/>
-                </a:lnTo>
-                <a:close/>
-                <a:lnTo>
-                  <a:pt x="991179" y="4401745"/>
-                </a:lnTo>
-                <a:close/>
-                <a:lnTo>
-                  <a:pt x="994457" y="4402011"/>
-                </a:lnTo>
-                <a:close/>
-                <a:lnTo>
-                  <a:pt x="997734" y="4402258"/>
-                </a:lnTo>
-                <a:close/>
-                <a:lnTo>
-                  <a:pt x="1001013" y="4402487"/>
-                </a:lnTo>
-                <a:close/>
-                <a:lnTo>
-                  <a:pt x="1004292" y="4402696"/>
-                </a:lnTo>
-                <a:close/>
-                <a:lnTo>
-                  <a:pt x="1007573" y="4402884"/>
-                </a:lnTo>
-                <a:close/>
-                <a:lnTo>
-                  <a:pt x="1010856" y="4403050"/>
-                </a:lnTo>
-                <a:close/>
-                <a:lnTo>
-                  <a:pt x="1014141" y="4403194"/>
-                </a:lnTo>
-                <a:close/>
-                <a:lnTo>
-                  <a:pt x="1017427" y="4403314"/>
-                </a:lnTo>
-                <a:close/>
-                <a:lnTo>
-                  <a:pt x="1020714" y="4403409"/>
-                </a:lnTo>
-                <a:close/>
-                <a:lnTo>
-                  <a:pt x="1024000" y="4403477"/>
-                </a:lnTo>
-                <a:close/>
-                <a:lnTo>
-                  <a:pt x="1027286" y="4403517"/>
-                </a:lnTo>
-                <a:close/>
-                <a:lnTo>
-                  <a:pt x="1030570" y="4403527"/>
-                </a:lnTo>
-                <a:close/>
-                <a:lnTo>
-                  <a:pt x="1033852" y="4403507"/>
-                </a:lnTo>
-                <a:close/>
-                <a:lnTo>
-                  <a:pt x="1037132" y="4403455"/>
-                </a:lnTo>
-                <a:close/>
-                <a:lnTo>
-                  <a:pt x="1040410" y="4403370"/>
-                </a:lnTo>
-                <a:close/>
-                <a:lnTo>
-                  <a:pt x="1043688" y="4403251"/>
-                </a:lnTo>
-                <a:close/>
-                <a:lnTo>
-                  <a:pt x="1046965" y="4403097"/>
-                </a:lnTo>
-                <a:close/>
-                <a:lnTo>
-                  <a:pt x="1050243" y="4402907"/>
-                </a:lnTo>
-                <a:close/>
-                <a:lnTo>
-                  <a:pt x="1053523" y="4402679"/>
-                </a:lnTo>
-                <a:close/>
-                <a:lnTo>
-                  <a:pt x="1056804" y="4402414"/>
-                </a:lnTo>
-                <a:close/>
-                <a:lnTo>
-                  <a:pt x="1060087" y="4402108"/>
-                </a:lnTo>
-                <a:close/>
-                <a:lnTo>
-                  <a:pt x="1063372" y="4401762"/>
-                </a:lnTo>
-                <a:close/>
-                <a:lnTo>
-                  <a:pt x="1066658" y="4401376"/>
-                </a:lnTo>
-                <a:close/>
-                <a:lnTo>
-                  <a:pt x="1069945" y="4400947"/>
-                </a:lnTo>
-                <a:close/>
-                <a:lnTo>
-                  <a:pt x="1073231" y="4400475"/>
-                </a:lnTo>
-                <a:close/>
-                <a:lnTo>
-                  <a:pt x="1076517" y="4399959"/>
-                </a:lnTo>
-                <a:close/>
-                <a:lnTo>
-                  <a:pt x="1079801" y="4399399"/>
-                </a:lnTo>
-                <a:close/>
-                <a:lnTo>
-                  <a:pt x="1083083" y="4398794"/>
-                </a:lnTo>
-                <a:close/>
-                <a:lnTo>
-                  <a:pt x="1086363" y="4398141"/>
-                </a:lnTo>
-                <a:close/>
-                <a:lnTo>
-                  <a:pt x="1089641" y="4397441"/>
-                </a:lnTo>
-                <a:close/>
-                <a:lnTo>
-                  <a:pt x="1092919" y="4396692"/>
-                </a:lnTo>
-                <a:close/>
-                <a:lnTo>
-                  <a:pt x="1096196" y="4395891"/>
-                </a:lnTo>
-                <a:close/>
-                <a:lnTo>
-                  <a:pt x="1099474" y="4395039"/>
-                </a:lnTo>
-                <a:close/>
-                <a:lnTo>
-                  <a:pt x="1102754" y="4394133"/>
-                </a:lnTo>
-                <a:close/>
-                <a:lnTo>
-                  <a:pt x="1106035" y="4393173"/>
-                </a:lnTo>
-                <a:close/>
-                <a:lnTo>
-                  <a:pt x="1109318" y="4392156"/>
-                </a:lnTo>
-                <a:close/>
-                <a:lnTo>
-                  <a:pt x="1112603" y="4391082"/>
-                </a:lnTo>
-                <a:close/>
-                <a:lnTo>
-                  <a:pt x="1115889" y="4389951"/>
-                </a:lnTo>
-                <a:close/>
-                <a:lnTo>
-                  <a:pt x="1119176" y="4388761"/>
-                </a:lnTo>
-                <a:close/>
-                <a:lnTo>
-                  <a:pt x="1122462" y="4387511"/>
-                </a:lnTo>
-                <a:close/>
-                <a:lnTo>
-                  <a:pt x="1125748" y="4386201"/>
-                </a:lnTo>
-                <a:close/>
-                <a:lnTo>
-                  <a:pt x="1129032" y="4384829"/>
-                </a:lnTo>
-                <a:close/>
-                <a:lnTo>
-                  <a:pt x="1132314" y="4383396"/>
-                </a:lnTo>
-                <a:close/>
-                <a:lnTo>
-                  <a:pt x="1135594" y="4381899"/>
-                </a:lnTo>
-                <a:close/>
-                <a:lnTo>
-                  <a:pt x="1138872" y="4380338"/>
-                </a:lnTo>
-                <a:close/>
-                <a:lnTo>
-                  <a:pt x="1142150" y="4378712"/>
-                </a:lnTo>
-                <a:close/>
-                <a:lnTo>
-                  <a:pt x="1145427" y="4377020"/>
-                </a:lnTo>
-                <a:close/>
-                <a:lnTo>
-                  <a:pt x="1148705" y="4375259"/>
-                </a:lnTo>
-                <a:close/>
-                <a:lnTo>
-                  <a:pt x="1151985" y="4373430"/>
-                </a:lnTo>
-                <a:close/>
-                <a:lnTo>
-                  <a:pt x="1155266" y="4371531"/>
-                </a:lnTo>
-                <a:close/>
-                <a:lnTo>
-                  <a:pt x="1158549" y="4369561"/>
-                </a:lnTo>
-                <a:close/>
-                <a:lnTo>
-                  <a:pt x="1161834" y="4367519"/>
-                </a:lnTo>
-                <a:close/>
-                <a:lnTo>
-                  <a:pt x="1165120" y="4365404"/>
-                </a:lnTo>
-                <a:close/>
-                <a:lnTo>
-                  <a:pt x="1168407" y="4363214"/>
-                </a:lnTo>
-                <a:close/>
-                <a:lnTo>
-                  <a:pt x="1171693" y="4360948"/>
-                </a:lnTo>
-                <a:close/>
-                <a:lnTo>
-                  <a:pt x="1174979" y="4358606"/>
-                </a:lnTo>
-                <a:close/>
-                <a:lnTo>
-                  <a:pt x="1178263" y="4356186"/>
-                </a:lnTo>
-                <a:close/>
-                <a:lnTo>
-                  <a:pt x="1181545" y="4353686"/>
-                </a:lnTo>
-                <a:close/>
-                <a:lnTo>
-                  <a:pt x="1184825" y="4351107"/>
-                </a:lnTo>
-                <a:close/>
-                <a:lnTo>
-                  <a:pt x="1188103" y="4348447"/>
-                </a:lnTo>
-                <a:close/>
-                <a:lnTo>
-                  <a:pt x="1191381" y="4345705"/>
-                </a:lnTo>
-                <a:close/>
-                <a:lnTo>
-                  <a:pt x="1194658" y="4342880"/>
-                </a:lnTo>
-                <a:close/>
-                <a:lnTo>
-                  <a:pt x="1197936" y="4339973"/>
-                </a:lnTo>
-                <a:close/>
-                <a:lnTo>
-                  <a:pt x="1201216" y="4336982"/>
-                </a:lnTo>
-                <a:close/>
-                <a:lnTo>
-                  <a:pt x="1204497" y="4333905"/>
-                </a:lnTo>
-                <a:close/>
-                <a:lnTo>
-                  <a:pt x="1207780" y="4330743"/>
-                </a:lnTo>
-                <a:close/>
-                <a:lnTo>
-                  <a:pt x="1211065" y="4327494"/>
-                </a:lnTo>
-                <a:close/>
-                <a:lnTo>
-                  <a:pt x="1214352" y="4324156"/>
-                </a:lnTo>
-                <a:close/>
-                <a:lnTo>
-                  <a:pt x="1217638" y="4320728"/>
-                </a:lnTo>
-                <a:close/>
-                <a:lnTo>
-                  <a:pt x="1220925" y="4317208"/>
-                </a:lnTo>
-                <a:close/>
-                <a:lnTo>
-                  <a:pt x="1224210" y="4313594"/>
-                </a:lnTo>
-                <a:close/>
-                <a:lnTo>
-                  <a:pt x="1227494" y="4309885"/>
-                </a:lnTo>
-                <a:close/>
-                <a:lnTo>
-                  <a:pt x="1230776" y="4306080"/>
-                </a:lnTo>
-                <a:close/>
-                <a:lnTo>
-                  <a:pt x="1234056" y="4302178"/>
-                </a:lnTo>
-                <a:close/>
-                <a:lnTo>
-                  <a:pt x="1237334" y="4298179"/>
-                </a:lnTo>
-                <a:close/>
-                <a:lnTo>
-                  <a:pt x="1240612" y="4294085"/>
-                </a:lnTo>
-                <a:close/>
-                <a:lnTo>
-                  <a:pt x="1243889" y="4289895"/>
-                </a:lnTo>
-                <a:close/>
-                <a:lnTo>
-                  <a:pt x="1247167" y="4285611"/>
-                </a:lnTo>
-                <a:close/>
-                <a:lnTo>
-                  <a:pt x="1250447" y="4281232"/>
-                </a:lnTo>
-                <a:close/>
-                <a:lnTo>
-                  <a:pt x="1253728" y="4276759"/>
-                </a:lnTo>
-                <a:close/>
-                <a:lnTo>
-                  <a:pt x="1257011" y="4272193"/>
-                </a:lnTo>
-                <a:close/>
-                <a:lnTo>
-                  <a:pt x="1260297" y="4267532"/>
-                </a:lnTo>
-                <a:close/>
-                <a:lnTo>
-                  <a:pt x="1263583" y="4262775"/>
-                </a:lnTo>
-                <a:close/>
-                <a:lnTo>
-                  <a:pt x="1266869" y="4257922"/>
-                </a:lnTo>
-                <a:close/>
-                <a:lnTo>
-                  <a:pt x="1270156" y="4252970"/>
-                </a:lnTo>
-                <a:close/>
-                <a:lnTo>
-                  <a:pt x="1273441" y="4247919"/>
-                </a:lnTo>
-                <a:close/>
-                <a:lnTo>
-                  <a:pt x="1276725" y="4242768"/>
-                </a:lnTo>
-                <a:close/>
-                <a:lnTo>
-                  <a:pt x="1280007" y="4237515"/>
-                </a:lnTo>
-                <a:close/>
-                <a:lnTo>
-                  <a:pt x="1283287" y="4232160"/>
-                </a:lnTo>
-                <a:close/>
-                <a:lnTo>
-                  <a:pt x="1286565" y="4226701"/>
-                </a:lnTo>
-                <a:close/>
-                <a:lnTo>
-                  <a:pt x="1289843" y="4221137"/>
-                </a:lnTo>
-                <a:close/>
-                <a:lnTo>
-                  <a:pt x="1293120" y="4215467"/>
-                </a:lnTo>
-                <a:close/>
-                <a:lnTo>
-                  <a:pt x="1296398" y="4209689"/>
-                </a:lnTo>
-                <a:close/>
-                <a:lnTo>
-                  <a:pt x="1299678" y="4203802"/>
-                </a:lnTo>
-                <a:close/>
-                <a:lnTo>
-                  <a:pt x="1302959" y="4197805"/>
-                </a:lnTo>
-                <a:close/>
-                <a:lnTo>
-                  <a:pt x="1306243" y="4191697"/>
-                </a:lnTo>
-                <a:close/>
-                <a:lnTo>
-                  <a:pt x="1309528" y="4185477"/>
-                </a:lnTo>
-                <a:close/>
-                <a:lnTo>
-                  <a:pt x="1312814" y="4179143"/>
-                </a:lnTo>
-                <a:close/>
-                <a:lnTo>
-                  <a:pt x="1316101" y="4172694"/>
-                </a:lnTo>
-                <a:close/>
-                <a:lnTo>
-                  <a:pt x="1319387" y="4166130"/>
-                </a:lnTo>
-                <a:close/>
-                <a:lnTo>
-                  <a:pt x="1322672" y="4159449"/>
-                </a:lnTo>
-                <a:close/>
-                <a:lnTo>
-                  <a:pt x="1325956" y="4152651"/>
-                </a:lnTo>
-                <a:close/>
-                <a:lnTo>
-                  <a:pt x="1329238" y="4145733"/>
-                </a:lnTo>
-                <a:close/>
-                <a:lnTo>
-                  <a:pt x="1332518" y="4138696"/>
-                </a:lnTo>
-                <a:close/>
-                <a:lnTo>
-                  <a:pt x="1335796" y="4131537"/>
-                </a:lnTo>
-                <a:close/>
-                <a:lnTo>
-                  <a:pt x="1339073" y="4124257"/>
-                </a:lnTo>
-                <a:close/>
-                <a:lnTo>
-                  <a:pt x="1342351" y="4116854"/>
-                </a:lnTo>
-                <a:close/>
-                <a:lnTo>
-                  <a:pt x="1345629" y="4109328"/>
-                </a:lnTo>
-                <a:close/>
-                <a:lnTo>
-                  <a:pt x="1348909" y="4101677"/>
-                </a:lnTo>
-                <a:close/>
-                <a:lnTo>
-                  <a:pt x="1352190" y="4093901"/>
-                </a:lnTo>
-                <a:close/>
-                <a:lnTo>
-                  <a:pt x="1355474" y="4085998"/>
-                </a:lnTo>
-                <a:close/>
-                <a:lnTo>
-                  <a:pt x="1358759" y="4077967"/>
-                </a:lnTo>
-                <a:close/>
-                <a:lnTo>
-                  <a:pt x="1362045" y="4069806"/>
-                </a:lnTo>
-                <a:close/>
-                <a:lnTo>
-                  <a:pt x="1365332" y="4061513"/>
-                </a:lnTo>
-                <a:close/>
-                <a:lnTo>
-                  <a:pt x="1368618" y="4053087"/>
-                </a:lnTo>
-                <a:close/>
-                <a:lnTo>
-                  <a:pt x="1371903" y="4044525"/>
-                </a:lnTo>
-                <a:close/>
-                <a:lnTo>
-                  <a:pt x="1375187" y="4035826"/>
-                </a:lnTo>
-                <a:close/>
-                <a:lnTo>
-                  <a:pt x="1378469" y="4026989"/>
-                </a:lnTo>
-                <a:close/>
-                <a:lnTo>
-                  <a:pt x="1381749" y="4018013"/>
-                </a:lnTo>
-                <a:close/>
-                <a:lnTo>
-                  <a:pt x="1385027" y="4008898"/>
-                </a:lnTo>
-                <a:close/>
-                <a:lnTo>
-                  <a:pt x="1388304" y="3999647"/>
-                </a:lnTo>
-                <a:close/>
-                <a:lnTo>
-                  <a:pt x="1391582" y="3990259"/>
-                </a:lnTo>
-                <a:close/>
-                <a:lnTo>
-                  <a:pt x="1394860" y="3980735"/>
-                </a:lnTo>
-                <a:close/>
-                <a:lnTo>
-                  <a:pt x="1398140" y="3971076"/>
-                </a:lnTo>
-                <a:close/>
-                <a:lnTo>
-                  <a:pt x="1401421" y="3961283"/>
-                </a:lnTo>
-                <a:close/>
-                <a:lnTo>
-                  <a:pt x="1404705" y="3951356"/>
-                </a:lnTo>
-                <a:close/>
-                <a:lnTo>
-                  <a:pt x="1407990" y="3941294"/>
-                </a:lnTo>
-                <a:close/>
-                <a:lnTo>
-                  <a:pt x="1411276" y="3931097"/>
-                </a:lnTo>
-                <a:close/>
-                <a:lnTo>
-                  <a:pt x="1414563" y="3920765"/>
-                </a:lnTo>
-                <a:close/>
-                <a:lnTo>
-                  <a:pt x="1417849" y="3910297"/>
-                </a:lnTo>
-                <a:close/>
-                <a:lnTo>
-                  <a:pt x="1421135" y="3899692"/>
-                </a:lnTo>
-                <a:close/>
-                <a:lnTo>
-                  <a:pt x="1424418" y="3888949"/>
-                </a:lnTo>
-                <a:close/>
-                <a:lnTo>
-                  <a:pt x="1427700" y="3878069"/>
-                </a:lnTo>
-                <a:close/>
-                <a:lnTo>
-                  <a:pt x="1430979" y="3867051"/>
-                </a:lnTo>
-                <a:close/>
-                <a:lnTo>
-                  <a:pt x="1434258" y="3855896"/>
-                </a:lnTo>
-                <a:close/>
-                <a:lnTo>
-                  <a:pt x="1437535" y="3844603"/>
-                </a:lnTo>
-                <a:close/>
-                <a:lnTo>
-                  <a:pt x="1440813" y="3833172"/>
-                </a:lnTo>
-                <a:close/>
-                <a:lnTo>
-                  <a:pt x="1444091" y="3821605"/>
-                </a:lnTo>
-                <a:close/>
-                <a:lnTo>
-                  <a:pt x="1447371" y="3809902"/>
-                </a:lnTo>
-                <a:close/>
-                <a:lnTo>
-                  <a:pt x="1450652" y="3798062"/>
-                </a:lnTo>
-                <a:close/>
-                <a:lnTo>
-                  <a:pt x="1453936" y="3786086"/>
-                </a:lnTo>
-                <a:close/>
-                <a:lnTo>
-                  <a:pt x="1457221" y="3773974"/>
-                </a:lnTo>
-                <a:close/>
-                <a:lnTo>
-                  <a:pt x="1460507" y="3761726"/>
-                </a:lnTo>
-                <a:close/>
-                <a:lnTo>
-                  <a:pt x="1463794" y="3749343"/>
-                </a:lnTo>
-                <a:close/>
-                <a:lnTo>
-                  <a:pt x="1467080" y="3736825"/>
-                </a:lnTo>
-                <a:close/>
-                <a:lnTo>
-                  <a:pt x="1470366" y="3724172"/>
-                </a:lnTo>
-                <a:close/>
-                <a:lnTo>
-                  <a:pt x="1473649" y="3711384"/>
-                </a:lnTo>
-                <a:close/>
-                <a:lnTo>
-                  <a:pt x="1476931" y="3698462"/>
-                </a:lnTo>
-                <a:close/>
-                <a:lnTo>
-                  <a:pt x="1480210" y="3685403"/>
-                </a:lnTo>
-                <a:close/>
-                <a:lnTo>
-                  <a:pt x="1483489" y="3672208"/>
-                </a:lnTo>
-                <a:close/>
-                <a:lnTo>
-                  <a:pt x="1486766" y="3658872"/>
-                </a:lnTo>
-                <a:close/>
-                <a:lnTo>
-                  <a:pt x="1490044" y="3645396"/>
-                </a:lnTo>
-                <a:close/>
-                <a:lnTo>
-                  <a:pt x="1493322" y="3631776"/>
-                </a:lnTo>
-                <a:close/>
-                <a:lnTo>
-                  <a:pt x="1496602" y="3618011"/>
-                </a:lnTo>
-                <a:close/>
-                <a:lnTo>
-                  <a:pt x="1499883" y="3604099"/>
-                </a:lnTo>
-                <a:close/>
-                <a:lnTo>
-                  <a:pt x="1503167" y="3590038"/>
-                </a:lnTo>
-                <a:close/>
-                <a:lnTo>
-                  <a:pt x="1506452" y="3575831"/>
-                </a:lnTo>
-                <a:close/>
-                <a:lnTo>
-                  <a:pt x="1509739" y="3561476"/>
-                </a:lnTo>
-                <a:close/>
-                <a:lnTo>
-                  <a:pt x="1513025" y="3546976"/>
-                </a:lnTo>
-                <a:close/>
-                <a:lnTo>
-                  <a:pt x="1516312" y="3532330"/>
-                </a:lnTo>
-                <a:close/>
-                <a:lnTo>
-                  <a:pt x="1519597" y="3517540"/>
-                </a:lnTo>
-                <a:close/>
-                <a:lnTo>
-                  <a:pt x="1522880" y="3502606"/>
-                </a:lnTo>
-                <a:close/>
-                <a:lnTo>
-                  <a:pt x="1526162" y="3487528"/>
-                </a:lnTo>
-                <a:close/>
-                <a:lnTo>
-                  <a:pt x="1529441" y="3472306"/>
-                </a:lnTo>
-                <a:close/>
-                <a:lnTo>
-                  <a:pt x="1532720" y="3456938"/>
-                </a:lnTo>
-                <a:close/>
-                <a:lnTo>
-                  <a:pt x="1535997" y="3441423"/>
-                </a:lnTo>
-                <a:close/>
-                <a:lnTo>
-                  <a:pt x="1539275" y="3425758"/>
-                </a:lnTo>
-                <a:close/>
-                <a:lnTo>
-                  <a:pt x="1542553" y="3409942"/>
-                </a:lnTo>
-                <a:close/>
-                <a:lnTo>
-                  <a:pt x="1545833" y="3393974"/>
-                </a:lnTo>
-                <a:close/>
-                <a:lnTo>
-                  <a:pt x="1549114" y="3377851"/>
-                </a:lnTo>
-                <a:close/>
-                <a:lnTo>
-                  <a:pt x="1552398" y="3361573"/>
-                </a:lnTo>
-                <a:close/>
-                <a:lnTo>
-                  <a:pt x="1555683" y="3345140"/>
-                </a:lnTo>
-                <a:close/>
-                <a:lnTo>
-                  <a:pt x="1558970" y="3328552"/>
-                </a:lnTo>
-                <a:close/>
-                <a:lnTo>
-                  <a:pt x="1562256" y="3311808"/>
-                </a:lnTo>
-                <a:close/>
-                <a:lnTo>
-                  <a:pt x="1565543" y="3294908"/>
-                </a:lnTo>
-                <a:close/>
-                <a:lnTo>
-                  <a:pt x="1568828" y="3277854"/>
-                </a:lnTo>
-                <a:close/>
-                <a:lnTo>
-                  <a:pt x="1572112" y="3260644"/>
-                </a:lnTo>
-                <a:close/>
-                <a:lnTo>
-                  <a:pt x="1575393" y="3243280"/>
-                </a:lnTo>
-                <a:close/>
-                <a:lnTo>
-                  <a:pt x="1578672" y="3225760"/>
-                </a:lnTo>
-                <a:close/>
-                <a:lnTo>
-                  <a:pt x="1581951" y="3208086"/>
-                </a:lnTo>
-                <a:close/>
-                <a:lnTo>
-                  <a:pt x="1585228" y="3190257"/>
-                </a:lnTo>
-                <a:close/>
-                <a:lnTo>
-                  <a:pt x="1588506" y="3172273"/>
-                </a:lnTo>
-                <a:close/>
-                <a:lnTo>
-                  <a:pt x="1591784" y="3154135"/>
-                </a:lnTo>
-                <a:close/>
-                <a:lnTo>
-                  <a:pt x="1595064" y="3135844"/>
-                </a:lnTo>
-                <a:close/>
-                <a:lnTo>
-                  <a:pt x="1598345" y="3117398"/>
-                </a:lnTo>
-                <a:close/>
-                <a:lnTo>
-                  <a:pt x="1601629" y="3098798"/>
-                </a:lnTo>
-                <a:close/>
-                <a:lnTo>
-                  <a:pt x="1604915" y="3080045"/>
-                </a:lnTo>
-                <a:close/>
-                <a:lnTo>
-                  <a:pt x="1608201" y="3061137"/>
-                </a:lnTo>
-                <a:close/>
-                <a:lnTo>
-                  <a:pt x="1611488" y="3042076"/>
-                </a:lnTo>
-                <a:close/>
-                <a:lnTo>
-                  <a:pt x="1614774" y="3022860"/>
-                </a:lnTo>
-                <a:close/>
-                <a:lnTo>
-                  <a:pt x="1618059" y="3003490"/>
-                </a:lnTo>
-                <a:close/>
-                <a:lnTo>
-                  <a:pt x="1621343" y="2983965"/>
-                </a:lnTo>
-                <a:close/>
-                <a:lnTo>
-                  <a:pt x="1624624" y="2964286"/>
-                </a:lnTo>
-                <a:close/>
-                <a:lnTo>
-                  <a:pt x="1627903" y="2944452"/>
-                </a:lnTo>
-                <a:close/>
-                <a:lnTo>
-                  <a:pt x="1631182" y="2924462"/>
-                </a:lnTo>
-                <a:close/>
-                <a:lnTo>
-                  <a:pt x="1634459" y="2904317"/>
-                </a:lnTo>
-                <a:close/>
-                <a:lnTo>
-                  <a:pt x="1637737" y="2884016"/>
-                </a:lnTo>
-                <a:close/>
-                <a:lnTo>
-                  <a:pt x="1641015" y="2863558"/>
-                </a:lnTo>
-                <a:close/>
-                <a:lnTo>
-                  <a:pt x="1644295" y="2842943"/>
-                </a:lnTo>
-                <a:close/>
-                <a:lnTo>
-                  <a:pt x="1647576" y="2822171"/>
-                </a:lnTo>
-                <a:close/>
-                <a:lnTo>
-                  <a:pt x="1650860" y="2801241"/>
-                </a:lnTo>
-                <a:close/>
-                <a:lnTo>
-                  <a:pt x="1654146" y="2780155"/>
-                </a:lnTo>
-                <a:close/>
-                <a:lnTo>
-                  <a:pt x="1657432" y="2758915"/>
-                </a:lnTo>
-                <a:close/>
-                <a:lnTo>
-                  <a:pt x="1660719" y="2737520"/>
-                </a:lnTo>
-                <a:close/>
-                <a:lnTo>
-                  <a:pt x="1664005" y="2715972"/>
-                </a:lnTo>
-                <a:close/>
-                <a:lnTo>
-                  <a:pt x="1667290" y="2694273"/>
-                </a:lnTo>
-                <a:close/>
-                <a:lnTo>
-                  <a:pt x="1670574" y="2672424"/>
-                </a:lnTo>
-                <a:close/>
-                <a:lnTo>
-                  <a:pt x="1673855" y="2650424"/>
-                </a:lnTo>
-                <a:close/>
-                <a:lnTo>
-                  <a:pt x="1677134" y="2628273"/>
-                </a:lnTo>
-                <a:close/>
-                <a:lnTo>
-                  <a:pt x="1680412" y="2605968"/>
-                </a:lnTo>
-                <a:close/>
-                <a:lnTo>
-                  <a:pt x="1683690" y="2583505"/>
-                </a:lnTo>
-                <a:close/>
-                <a:lnTo>
-                  <a:pt x="1686968" y="2560883"/>
-                </a:lnTo>
-                <a:close/>
-                <a:lnTo>
-                  <a:pt x="1690246" y="2538097"/>
-                </a:lnTo>
-                <a:close/>
-                <a:lnTo>
-                  <a:pt x="1693526" y="2515146"/>
-                </a:lnTo>
-                <a:close/>
-                <a:lnTo>
-                  <a:pt x="1696808" y="2492026"/>
-                </a:lnTo>
-                <a:close/>
-                <a:lnTo>
-                  <a:pt x="1700091" y="2468736"/>
-                </a:lnTo>
-                <a:close/>
-                <a:lnTo>
-                  <a:pt x="1703377" y="2445279"/>
-                </a:lnTo>
-                <a:close/>
-                <a:lnTo>
-                  <a:pt x="1706663" y="2421655"/>
-                </a:lnTo>
-                <a:close/>
-                <a:lnTo>
-                  <a:pt x="1709950" y="2397866"/>
-                </a:lnTo>
-                <a:close/>
-                <a:lnTo>
-                  <a:pt x="1713236" y="2373915"/>
-                </a:lnTo>
-                <a:close/>
-                <a:lnTo>
-                  <a:pt x="1716521" y="2349802"/>
-                </a:lnTo>
-                <a:close/>
-                <a:lnTo>
-                  <a:pt x="1719805" y="2325529"/>
-                </a:lnTo>
-                <a:close/>
-                <a:lnTo>
-                  <a:pt x="1723086" y="2301098"/>
-                </a:lnTo>
-                <a:close/>
-                <a:lnTo>
-                  <a:pt x="1726365" y="2276507"/>
-                </a:lnTo>
-                <a:close/>
-                <a:lnTo>
-                  <a:pt x="1729643" y="2251754"/>
-                </a:lnTo>
-                <a:close/>
-                <a:lnTo>
-                  <a:pt x="1732921" y="2226835"/>
-                </a:lnTo>
-                <a:close/>
-                <a:lnTo>
-                  <a:pt x="1736199" y="2201748"/>
-                </a:lnTo>
-                <a:close/>
-                <a:lnTo>
-                  <a:pt x="1739477" y="2176491"/>
-                </a:lnTo>
-                <a:close/>
-                <a:lnTo>
-                  <a:pt x="1742757" y="2151061"/>
-                </a:lnTo>
-                <a:close/>
-                <a:lnTo>
-                  <a:pt x="1746039" y="2125455"/>
-                </a:lnTo>
-                <a:close/>
-                <a:lnTo>
-                  <a:pt x="1749323" y="2099672"/>
-                </a:lnTo>
-                <a:close/>
-                <a:lnTo>
-                  <a:pt x="1752608" y="2073713"/>
-                </a:lnTo>
-                <a:close/>
-                <a:lnTo>
-                  <a:pt x="1755894" y="2047579"/>
-                </a:lnTo>
-                <a:close/>
-                <a:lnTo>
-                  <a:pt x="1759181" y="2021271"/>
-                </a:lnTo>
-                <a:close/>
-                <a:lnTo>
-                  <a:pt x="1762467" y="1994790"/>
-                </a:lnTo>
-                <a:close/>
-                <a:lnTo>
-                  <a:pt x="1765752" y="1968136"/>
-                </a:lnTo>
-                <a:close/>
-                <a:lnTo>
-                  <a:pt x="1769036" y="1941311"/>
-                </a:lnTo>
-                <a:close/>
-                <a:lnTo>
-                  <a:pt x="1772317" y="1914315"/>
-                </a:lnTo>
-                <a:close/>
-                <a:lnTo>
-                  <a:pt x="1775596" y="1887149"/>
-                </a:lnTo>
-                <a:close/>
-                <a:lnTo>
-                  <a:pt x="1778874" y="1859811"/>
-                </a:lnTo>
-                <a:close/>
-                <a:lnTo>
-                  <a:pt x="1782152" y="1832302"/>
-                </a:lnTo>
-                <a:close/>
-                <a:lnTo>
-                  <a:pt x="1785430" y="1804621"/>
-                </a:lnTo>
-                <a:close/>
-                <a:lnTo>
-                  <a:pt x="1788708" y="1776767"/>
-                </a:lnTo>
-                <a:close/>
-                <a:lnTo>
-                  <a:pt x="1791988" y="1748740"/>
-                </a:lnTo>
-                <a:close/>
-                <a:lnTo>
-                  <a:pt x="1795270" y="1720540"/>
-                </a:lnTo>
-                <a:close/>
-                <a:lnTo>
-                  <a:pt x="1798554" y="1692166"/>
-                </a:lnTo>
-                <a:close/>
-                <a:lnTo>
-                  <a:pt x="1801839" y="1663618"/>
-                </a:lnTo>
-                <a:close/>
-                <a:lnTo>
-                  <a:pt x="1805126" y="1634897"/>
-                </a:lnTo>
-                <a:close/>
-                <a:lnTo>
-                  <a:pt x="1808412" y="1606004"/>
-                </a:lnTo>
-                <a:close/>
-                <a:lnTo>
-                  <a:pt x="1811698" y="1576937"/>
-                </a:lnTo>
-                <a:close/>
-                <a:lnTo>
-                  <a:pt x="1814983" y="1547699"/>
-                </a:lnTo>
-                <a:close/>
-                <a:lnTo>
-                  <a:pt x="1818267" y="1518288"/>
-                </a:lnTo>
-                <a:close/>
-                <a:lnTo>
-                  <a:pt x="1821548" y="1488704"/>
-                </a:lnTo>
-                <a:close/>
-                <a:lnTo>
-                  <a:pt x="1824827" y="1458948"/>
-                </a:lnTo>
-                <a:close/>
-                <a:lnTo>
-                  <a:pt x="1828105" y="1429018"/>
-                </a:lnTo>
-                <a:close/>
-                <a:lnTo>
-                  <a:pt x="1831383" y="1398912"/>
-                </a:lnTo>
-                <a:close/>
-                <a:lnTo>
-                  <a:pt x="1834661" y="1368630"/>
-                </a:lnTo>
-                <a:close/>
-                <a:lnTo>
-                  <a:pt x="1837939" y="1338170"/>
-                </a:lnTo>
-                <a:close/>
-                <a:lnTo>
-                  <a:pt x="1841219" y="1307531"/>
-                </a:lnTo>
-                <a:close/>
-                <a:lnTo>
-                  <a:pt x="1844501" y="1276713"/>
-                </a:lnTo>
-                <a:close/>
-                <a:lnTo>
-                  <a:pt x="1847785" y="1245713"/>
-                </a:lnTo>
-                <a:close/>
-                <a:lnTo>
-                  <a:pt x="1851070" y="1214531"/>
-                </a:lnTo>
-                <a:close/>
-                <a:lnTo>
-                  <a:pt x="1854357" y="1183164"/>
-                </a:lnTo>
-                <a:close/>
-                <a:lnTo>
-                  <a:pt x="1857643" y="1151611"/>
-                </a:lnTo>
-                <a:close/>
-                <a:lnTo>
-                  <a:pt x="1860929" y="1119871"/>
-                </a:lnTo>
-                <a:close/>
-                <a:lnTo>
-                  <a:pt x="1864215" y="1087942"/>
-                </a:lnTo>
-                <a:close/>
-                <a:lnTo>
-                  <a:pt x="1867498" y="1055822"/>
-                </a:lnTo>
-                <a:close/>
-                <a:lnTo>
-                  <a:pt x="1870779" y="1023511"/>
-                </a:lnTo>
-                <a:close/>
-                <a:lnTo>
-                  <a:pt x="1874058" y="991007"/>
-                </a:lnTo>
-                <a:close/>
-                <a:lnTo>
-                  <a:pt x="1877337" y="958310"/>
-                </a:lnTo>
-                <a:close/>
-                <a:lnTo>
-                  <a:pt x="1880614" y="925419"/>
-                </a:lnTo>
-                <a:close/>
-                <a:lnTo>
-                  <a:pt x="1883892" y="892334"/>
-                </a:lnTo>
-                <a:close/>
-                <a:lnTo>
-                  <a:pt x="1887170" y="859054"/>
-                </a:lnTo>
-                <a:close/>
-                <a:lnTo>
-                  <a:pt x="1890450" y="825580"/>
-                </a:lnTo>
-                <a:close/>
-                <a:lnTo>
-                  <a:pt x="1893732" y="791909"/>
-                </a:lnTo>
-                <a:close/>
-                <a:lnTo>
-                  <a:pt x="1897015" y="758042"/>
-                </a:lnTo>
-                <a:close/>
-                <a:lnTo>
-                  <a:pt x="1900301" y="723976"/>
-                </a:lnTo>
-                <a:close/>
-                <a:lnTo>
-                  <a:pt x="1903587" y="689707"/>
-                </a:lnTo>
-                <a:close/>
-                <a:lnTo>
-                  <a:pt x="1906873" y="655235"/>
-                </a:lnTo>
-                <a:close/>
-                <a:lnTo>
-                  <a:pt x="1910160" y="620557"/>
-                </a:lnTo>
-                <a:close/>
-                <a:lnTo>
-                  <a:pt x="1913445" y="585670"/>
-                </a:lnTo>
-                <a:close/>
-                <a:lnTo>
-                  <a:pt x="1916729" y="550571"/>
-                </a:lnTo>
-                <a:close/>
-                <a:lnTo>
-                  <a:pt x="1920011" y="515261"/>
-                </a:lnTo>
-                <a:close/>
-                <a:lnTo>
-                  <a:pt x="1923292" y="479739"/>
-                </a:lnTo>
-                <a:close/>
-                <a:lnTo>
-                  <a:pt x="1926571" y="444009"/>
-                </a:lnTo>
-                <a:close/>
-                <a:lnTo>
-                  <a:pt x="1929849" y="408074"/>
-                </a:lnTo>
-                <a:close/>
-                <a:lnTo>
-                  <a:pt x="1933127" y="371936"/>
-                </a:lnTo>
-                <a:close/>
-                <a:lnTo>
-                  <a:pt x="1936405" y="335598"/>
-                </a:lnTo>
-                <a:close/>
-                <a:lnTo>
-                  <a:pt x="1939682" y="299063"/>
-                </a:lnTo>
-                <a:close/>
-                <a:lnTo>
-                  <a:pt x="1942961" y="262333"/>
-                </a:lnTo>
-                <a:close/>
-                <a:lnTo>
-                  <a:pt x="1946241" y="225411"/>
-                </a:lnTo>
-                <a:close/>
-                <a:lnTo>
-                  <a:pt x="1949522" y="188300"/>
-                </a:lnTo>
-                <a:close/>
-                <a:lnTo>
-                  <a:pt x="1952804" y="151003"/>
-                </a:lnTo>
-                <a:close/>
-                <a:lnTo>
-                  <a:pt x="1956089" y="113521"/>
-                </a:lnTo>
-                <a:close/>
-                <a:lnTo>
-                  <a:pt x="1959376" y="75858"/>
-                </a:lnTo>
-                <a:close/>
-                <a:lnTo>
-                  <a:pt x="1962667" y="38017"/>
-                </a:lnTo>
-                <a:close/>
-                <a:lnTo>
-                  <a:pt x="1965960" y="0"/>
+                  <a:pt x="6546" y="3645832"/>
+                </a:lnTo>
+                <a:close/>
+                <a:lnTo>
+                  <a:pt x="13032" y="3634104"/>
+                </a:lnTo>
+                <a:close/>
+                <a:lnTo>
+                  <a:pt x="19457" y="3622416"/>
+                </a:lnTo>
+                <a:close/>
+                <a:lnTo>
+                  <a:pt x="25822" y="3610769"/>
+                </a:lnTo>
+                <a:close/>
+                <a:lnTo>
+                  <a:pt x="32128" y="3599161"/>
+                </a:lnTo>
+                <a:close/>
+                <a:lnTo>
+                  <a:pt x="38374" y="3587594"/>
+                </a:lnTo>
+                <a:close/>
+                <a:lnTo>
+                  <a:pt x="44561" y="3576066"/>
+                </a:lnTo>
+                <a:close/>
+                <a:lnTo>
+                  <a:pt x="50690" y="3564579"/>
+                </a:lnTo>
+                <a:close/>
+                <a:lnTo>
+                  <a:pt x="56761" y="3553131"/>
+                </a:lnTo>
+                <a:close/>
+                <a:lnTo>
+                  <a:pt x="62773" y="3541723"/>
+                </a:lnTo>
+                <a:close/>
+                <a:lnTo>
+                  <a:pt x="68729" y="3530354"/>
+                </a:lnTo>
+                <a:close/>
+                <a:lnTo>
+                  <a:pt x="74627" y="3519025"/>
+                </a:lnTo>
+                <a:close/>
+                <a:lnTo>
+                  <a:pt x="80469" y="3507736"/>
+                </a:lnTo>
+                <a:close/>
+                <a:lnTo>
+                  <a:pt x="86255" y="3496486"/>
+                </a:lnTo>
+                <a:close/>
+                <a:lnTo>
+                  <a:pt x="91984" y="3485275"/>
+                </a:lnTo>
+                <a:close/>
+                <a:lnTo>
+                  <a:pt x="97659" y="3474104"/>
+                </a:lnTo>
+                <a:close/>
+                <a:lnTo>
+                  <a:pt x="103278" y="3462971"/>
+                </a:lnTo>
+                <a:close/>
+                <a:lnTo>
+                  <a:pt x="108842" y="3451878"/>
+                </a:lnTo>
+                <a:close/>
+                <a:lnTo>
+                  <a:pt x="114352" y="3440824"/>
+                </a:lnTo>
+                <a:close/>
+                <a:lnTo>
+                  <a:pt x="119808" y="3429809"/>
+                </a:lnTo>
+                <a:close/>
+                <a:lnTo>
+                  <a:pt x="125210" y="3418833"/>
+                </a:lnTo>
+                <a:close/>
+                <a:lnTo>
+                  <a:pt x="130559" y="3407896"/>
+                </a:lnTo>
+                <a:close/>
+                <a:lnTo>
+                  <a:pt x="135856" y="3396998"/>
+                </a:lnTo>
+                <a:close/>
+                <a:lnTo>
+                  <a:pt x="141100" y="3386138"/>
+                </a:lnTo>
+                <a:close/>
+                <a:lnTo>
+                  <a:pt x="146291" y="3375317"/>
+                </a:lnTo>
+                <a:close/>
+                <a:lnTo>
+                  <a:pt x="151431" y="3364535"/>
+                </a:lnTo>
+                <a:close/>
+                <a:lnTo>
+                  <a:pt x="156520" y="3353791"/>
+                </a:lnTo>
+                <a:close/>
+                <a:lnTo>
+                  <a:pt x="161557" y="3343085"/>
+                </a:lnTo>
+                <a:close/>
+                <a:lnTo>
+                  <a:pt x="166544" y="3332418"/>
+                </a:lnTo>
+                <a:close/>
+                <a:lnTo>
+                  <a:pt x="171481" y="3321789"/>
+                </a:lnTo>
+                <a:close/>
+                <a:lnTo>
+                  <a:pt x="176368" y="3311199"/>
+                </a:lnTo>
+                <a:close/>
+                <a:lnTo>
+                  <a:pt x="181206" y="3300646"/>
+                </a:lnTo>
+                <a:close/>
+                <a:lnTo>
+                  <a:pt x="185994" y="3290132"/>
+                </a:lnTo>
+                <a:close/>
+                <a:lnTo>
+                  <a:pt x="190734" y="3279656"/>
+                </a:lnTo>
+                <a:close/>
+                <a:lnTo>
+                  <a:pt x="195426" y="3269217"/>
+                </a:lnTo>
+                <a:close/>
+                <a:lnTo>
+                  <a:pt x="200069" y="3258817"/>
+                </a:lnTo>
+                <a:close/>
+                <a:lnTo>
+                  <a:pt x="204665" y="3248454"/>
+                </a:lnTo>
+                <a:close/>
+                <a:lnTo>
+                  <a:pt x="209214" y="3238129"/>
+                </a:lnTo>
+                <a:close/>
+                <a:lnTo>
+                  <a:pt x="213716" y="3227842"/>
+                </a:lnTo>
+                <a:close/>
+                <a:lnTo>
+                  <a:pt x="218171" y="3217592"/>
+                </a:lnTo>
+                <a:close/>
+                <a:lnTo>
+                  <a:pt x="222581" y="3207380"/>
+                </a:lnTo>
+                <a:close/>
+                <a:lnTo>
+                  <a:pt x="226944" y="3197205"/>
+                </a:lnTo>
+                <a:close/>
+                <a:lnTo>
+                  <a:pt x="231263" y="3187067"/>
+                </a:lnTo>
+                <a:close/>
+                <a:lnTo>
+                  <a:pt x="235536" y="3176967"/>
+                </a:lnTo>
+                <a:close/>
+                <a:lnTo>
+                  <a:pt x="239765" y="3166904"/>
+                </a:lnTo>
+                <a:close/>
+                <a:lnTo>
+                  <a:pt x="243950" y="3156879"/>
+                </a:lnTo>
+                <a:close/>
+                <a:lnTo>
+                  <a:pt x="248091" y="3146890"/>
+                </a:lnTo>
+                <a:close/>
+                <a:lnTo>
+                  <a:pt x="252189" y="3136938"/>
+                </a:lnTo>
+                <a:close/>
+                <a:lnTo>
+                  <a:pt x="256243" y="3127024"/>
+                </a:lnTo>
+                <a:close/>
+                <a:lnTo>
+                  <a:pt x="260255" y="3117146"/>
+                </a:lnTo>
+                <a:close/>
+                <a:lnTo>
+                  <a:pt x="264225" y="3107305"/>
+                </a:lnTo>
+                <a:close/>
+                <a:lnTo>
+                  <a:pt x="268152" y="3097501"/>
+                </a:lnTo>
+                <a:close/>
+                <a:lnTo>
+                  <a:pt x="272038" y="3087733"/>
+                </a:lnTo>
+                <a:close/>
+                <a:lnTo>
+                  <a:pt x="275883" y="3078002"/>
+                </a:lnTo>
+                <a:close/>
+                <a:lnTo>
+                  <a:pt x="279688" y="3068307"/>
+                </a:lnTo>
+                <a:close/>
+                <a:lnTo>
+                  <a:pt x="283451" y="3058649"/>
+                </a:lnTo>
+                <a:close/>
+                <a:lnTo>
+                  <a:pt x="287175" y="3049028"/>
+                </a:lnTo>
+                <a:close/>
+                <a:lnTo>
+                  <a:pt x="290859" y="3039442"/>
+                </a:lnTo>
+                <a:close/>
+                <a:lnTo>
+                  <a:pt x="294504" y="3029893"/>
+                </a:lnTo>
+                <a:close/>
+                <a:lnTo>
+                  <a:pt x="298110" y="3020380"/>
+                </a:lnTo>
+                <a:close/>
+                <a:lnTo>
+                  <a:pt x="301678" y="3010903"/>
+                </a:lnTo>
+                <a:close/>
+                <a:lnTo>
+                  <a:pt x="305207" y="3001463"/>
+                </a:lnTo>
+                <a:close/>
+                <a:lnTo>
+                  <a:pt x="308699" y="2992058"/>
+                </a:lnTo>
+                <a:close/>
+                <a:lnTo>
+                  <a:pt x="312153" y="2982689"/>
+                </a:lnTo>
+                <a:close/>
+                <a:lnTo>
+                  <a:pt x="315570" y="2973356"/>
+                </a:lnTo>
+                <a:close/>
+                <a:lnTo>
+                  <a:pt x="318951" y="2964058"/>
+                </a:lnTo>
+                <a:close/>
+                <a:lnTo>
+                  <a:pt x="322295" y="2954796"/>
+                </a:lnTo>
+                <a:close/>
+                <a:lnTo>
+                  <a:pt x="325604" y="2945570"/>
+                </a:lnTo>
+                <a:close/>
+                <a:lnTo>
+                  <a:pt x="328877" y="2936380"/>
+                </a:lnTo>
+                <a:close/>
+                <a:lnTo>
+                  <a:pt x="332115" y="2927224"/>
+                </a:lnTo>
+                <a:close/>
+                <a:lnTo>
+                  <a:pt x="335318" y="2918105"/>
+                </a:lnTo>
+                <a:close/>
+                <a:lnTo>
+                  <a:pt x="338487" y="2909020"/>
+                </a:lnTo>
+                <a:close/>
+                <a:lnTo>
+                  <a:pt x="341622" y="2899971"/>
+                </a:lnTo>
+                <a:close/>
+                <a:lnTo>
+                  <a:pt x="344723" y="2890957"/>
+                </a:lnTo>
+                <a:close/>
+                <a:lnTo>
+                  <a:pt x="347791" y="2881978"/>
+                </a:lnTo>
+                <a:close/>
+                <a:lnTo>
+                  <a:pt x="350826" y="2873034"/>
+                </a:lnTo>
+                <a:close/>
+                <a:lnTo>
+                  <a:pt x="353829" y="2864125"/>
+                </a:lnTo>
+                <a:close/>
+                <a:lnTo>
+                  <a:pt x="356800" y="2855251"/>
+                </a:lnTo>
+                <a:close/>
+                <a:lnTo>
+                  <a:pt x="359739" y="2846412"/>
+                </a:lnTo>
+                <a:close/>
+                <a:lnTo>
+                  <a:pt x="362646" y="2837607"/>
+                </a:lnTo>
+                <a:close/>
+                <a:lnTo>
+                  <a:pt x="365523" y="2828838"/>
+                </a:lnTo>
+                <a:close/>
+                <a:lnTo>
+                  <a:pt x="368369" y="2820102"/>
+                </a:lnTo>
+                <a:close/>
+                <a:lnTo>
+                  <a:pt x="371185" y="2811402"/>
+                </a:lnTo>
+                <a:close/>
+                <a:lnTo>
+                  <a:pt x="373971" y="2802735"/>
+                </a:lnTo>
+                <a:close/>
+                <a:lnTo>
+                  <a:pt x="376728" y="2794104"/>
+                </a:lnTo>
+                <a:close/>
+                <a:lnTo>
+                  <a:pt x="379455" y="2785506"/>
+                </a:lnTo>
+                <a:close/>
+                <a:lnTo>
+                  <a:pt x="382154" y="2776943"/>
+                </a:lnTo>
+                <a:close/>
+                <a:lnTo>
+                  <a:pt x="384824" y="2768414"/>
+                </a:lnTo>
+                <a:close/>
+                <a:lnTo>
+                  <a:pt x="387467" y="2759919"/>
+                </a:lnTo>
+                <a:close/>
+                <a:lnTo>
+                  <a:pt x="390082" y="2751458"/>
+                </a:lnTo>
+                <a:close/>
+                <a:lnTo>
+                  <a:pt x="392670" y="2743031"/>
+                </a:lnTo>
+                <a:close/>
+                <a:lnTo>
+                  <a:pt x="395231" y="2734638"/>
+                </a:lnTo>
+                <a:close/>
+                <a:lnTo>
+                  <a:pt x="397766" y="2726279"/>
+                </a:lnTo>
+                <a:close/>
+                <a:lnTo>
+                  <a:pt x="400274" y="2717953"/>
+                </a:lnTo>
+                <a:close/>
+                <a:lnTo>
+                  <a:pt x="402757" y="2709662"/>
+                </a:lnTo>
+                <a:close/>
+                <a:lnTo>
+                  <a:pt x="405215" y="2701404"/>
+                </a:lnTo>
+                <a:close/>
+                <a:lnTo>
+                  <a:pt x="407647" y="2693179"/>
+                </a:lnTo>
+                <a:close/>
+                <a:lnTo>
+                  <a:pt x="410056" y="2684988"/>
+                </a:lnTo>
+                <a:close/>
+                <a:lnTo>
+                  <a:pt x="412440" y="2676830"/>
+                </a:lnTo>
+                <a:close/>
+                <a:lnTo>
+                  <a:pt x="414800" y="2668706"/>
+                </a:lnTo>
+                <a:close/>
+                <a:lnTo>
+                  <a:pt x="417137" y="2660615"/>
+                </a:lnTo>
+                <a:close/>
+                <a:lnTo>
+                  <a:pt x="419450" y="2652557"/>
+                </a:lnTo>
+                <a:close/>
+                <a:lnTo>
+                  <a:pt x="421742" y="2644532"/>
+                </a:lnTo>
+                <a:close/>
+                <a:lnTo>
+                  <a:pt x="424010" y="2636540"/>
+                </a:lnTo>
+                <a:close/>
+                <a:lnTo>
+                  <a:pt x="426257" y="2628581"/>
+                </a:lnTo>
+                <a:close/>
+                <a:lnTo>
+                  <a:pt x="428483" y="2620655"/>
+                </a:lnTo>
+                <a:close/>
+                <a:lnTo>
+                  <a:pt x="430687" y="2612762"/>
+                </a:lnTo>
+                <a:close/>
+                <a:lnTo>
+                  <a:pt x="432871" y="2604902"/>
+                </a:lnTo>
+                <a:close/>
+                <a:lnTo>
+                  <a:pt x="435034" y="2597074"/>
+                </a:lnTo>
+                <a:close/>
+                <a:lnTo>
+                  <a:pt x="437177" y="2589279"/>
+                </a:lnTo>
+                <a:close/>
+                <a:lnTo>
+                  <a:pt x="439301" y="2581517"/>
+                </a:lnTo>
+                <a:close/>
+                <a:lnTo>
+                  <a:pt x="441405" y="2573787"/>
+                </a:lnTo>
+                <a:close/>
+                <a:lnTo>
+                  <a:pt x="443490" y="2566089"/>
+                </a:lnTo>
+                <a:close/>
+                <a:lnTo>
+                  <a:pt x="445557" y="2558424"/>
+                </a:lnTo>
+                <a:close/>
+                <a:lnTo>
+                  <a:pt x="447606" y="2550791"/>
+                </a:lnTo>
+                <a:close/>
+                <a:lnTo>
+                  <a:pt x="449637" y="2543190"/>
+                </a:lnTo>
+                <a:close/>
+                <a:lnTo>
+                  <a:pt x="451651" y="2535622"/>
+                </a:lnTo>
+                <a:close/>
+                <a:lnTo>
+                  <a:pt x="453648" y="2528085"/>
+                </a:lnTo>
+                <a:close/>
+                <a:lnTo>
+                  <a:pt x="455628" y="2520581"/>
+                </a:lnTo>
+                <a:close/>
+                <a:lnTo>
+                  <a:pt x="457591" y="2513108"/>
+                </a:lnTo>
+                <a:close/>
+                <a:lnTo>
+                  <a:pt x="459540" y="2505667"/>
+                </a:lnTo>
+                <a:close/>
+                <a:lnTo>
+                  <a:pt x="461472" y="2498258"/>
+                </a:lnTo>
+                <a:close/>
+                <a:lnTo>
+                  <a:pt x="463390" y="2490881"/>
+                </a:lnTo>
+                <a:close/>
+                <a:lnTo>
+                  <a:pt x="465292" y="2483535"/>
+                </a:lnTo>
+                <a:close/>
+                <a:lnTo>
+                  <a:pt x="467181" y="2476221"/>
+                </a:lnTo>
+                <a:close/>
+                <a:lnTo>
+                  <a:pt x="469055" y="2468938"/>
+                </a:lnTo>
+                <a:close/>
+                <a:lnTo>
+                  <a:pt x="470916" y="2461687"/>
+                </a:lnTo>
+                <a:close/>
+                <a:lnTo>
+                  <a:pt x="472764" y="2454467"/>
+                </a:lnTo>
+                <a:close/>
+                <a:lnTo>
+                  <a:pt x="474598" y="2447278"/>
+                </a:lnTo>
+                <a:close/>
+                <a:lnTo>
+                  <a:pt x="476421" y="2440121"/>
+                </a:lnTo>
+                <a:close/>
+                <a:lnTo>
+                  <a:pt x="478231" y="2432995"/>
+                </a:lnTo>
+                <a:close/>
+                <a:lnTo>
+                  <a:pt x="480030" y="2425899"/>
+                </a:lnTo>
+                <a:close/>
+                <a:lnTo>
+                  <a:pt x="481817" y="2418835"/>
+                </a:lnTo>
+                <a:close/>
+                <a:lnTo>
+                  <a:pt x="483593" y="2411802"/>
+                </a:lnTo>
+                <a:close/>
+                <a:lnTo>
+                  <a:pt x="485359" y="2404799"/>
+                </a:lnTo>
+                <a:close/>
+                <a:lnTo>
+                  <a:pt x="487114" y="2397828"/>
+                </a:lnTo>
+                <a:close/>
+                <a:lnTo>
+                  <a:pt x="488860" y="2390887"/>
+                </a:lnTo>
+                <a:close/>
+                <a:lnTo>
+                  <a:pt x="490596" y="2383976"/>
+                </a:lnTo>
+                <a:close/>
+                <a:lnTo>
+                  <a:pt x="492324" y="2377096"/>
+                </a:lnTo>
+                <a:close/>
+                <a:lnTo>
+                  <a:pt x="494042" y="2370247"/>
+                </a:lnTo>
+                <a:close/>
+                <a:lnTo>
+                  <a:pt x="495752" y="2363428"/>
+                </a:lnTo>
+                <a:close/>
+                <a:lnTo>
+                  <a:pt x="497455" y="2356640"/>
+                </a:lnTo>
+                <a:close/>
+                <a:lnTo>
+                  <a:pt x="499150" y="2349881"/>
+                </a:lnTo>
+                <a:close/>
+                <a:lnTo>
+                  <a:pt x="500837" y="2343153"/>
+                </a:lnTo>
+                <a:close/>
+                <a:lnTo>
+                  <a:pt x="502518" y="2336456"/>
+                </a:lnTo>
+                <a:close/>
+                <a:lnTo>
+                  <a:pt x="504192" y="2329788"/>
+                </a:lnTo>
+                <a:close/>
+                <a:lnTo>
+                  <a:pt x="505861" y="2323150"/>
+                </a:lnTo>
+                <a:close/>
+                <a:lnTo>
+                  <a:pt x="507524" y="2316542"/>
+                </a:lnTo>
+                <a:close/>
+                <a:lnTo>
+                  <a:pt x="509181" y="2309964"/>
+                </a:lnTo>
+                <a:close/>
+                <a:lnTo>
+                  <a:pt x="510834" y="2303416"/>
+                </a:lnTo>
+                <a:close/>
+                <a:lnTo>
+                  <a:pt x="512482" y="2296897"/>
+                </a:lnTo>
+                <a:close/>
+                <a:lnTo>
+                  <a:pt x="514126" y="2290408"/>
+                </a:lnTo>
+                <a:close/>
+                <a:lnTo>
+                  <a:pt x="515766" y="2283949"/>
+                </a:lnTo>
+                <a:close/>
+                <a:lnTo>
+                  <a:pt x="517402" y="2277519"/>
+                </a:lnTo>
+                <a:close/>
+                <a:lnTo>
+                  <a:pt x="519036" y="2271119"/>
+                </a:lnTo>
+                <a:close/>
+                <a:lnTo>
+                  <a:pt x="520667" y="2264748"/>
+                </a:lnTo>
+                <a:close/>
+                <a:lnTo>
+                  <a:pt x="522296" y="2258406"/>
+                </a:lnTo>
+                <a:close/>
+                <a:lnTo>
+                  <a:pt x="523923" y="2252093"/>
+                </a:lnTo>
+                <a:close/>
+                <a:lnTo>
+                  <a:pt x="525548" y="2245810"/>
+                </a:lnTo>
+                <a:close/>
+                <a:lnTo>
+                  <a:pt x="527173" y="2239556"/>
+                </a:lnTo>
+                <a:close/>
+                <a:lnTo>
+                  <a:pt x="528796" y="2233330"/>
+                </a:lnTo>
+                <a:close/>
+                <a:lnTo>
+                  <a:pt x="530419" y="2227134"/>
+                </a:lnTo>
+                <a:close/>
+                <a:lnTo>
+                  <a:pt x="532043" y="2220967"/>
+                </a:lnTo>
+                <a:close/>
+                <a:lnTo>
+                  <a:pt x="533666" y="2214828"/>
+                </a:lnTo>
+                <a:close/>
+                <a:lnTo>
+                  <a:pt x="535290" y="2208718"/>
+                </a:lnTo>
+                <a:close/>
+                <a:lnTo>
+                  <a:pt x="536916" y="2202637"/>
+                </a:lnTo>
+                <a:close/>
+                <a:lnTo>
+                  <a:pt x="538543" y="2196584"/>
+                </a:lnTo>
+                <a:close/>
+                <a:lnTo>
+                  <a:pt x="540172" y="2190560"/>
+                </a:lnTo>
+                <a:close/>
+                <a:lnTo>
+                  <a:pt x="541803" y="2184564"/>
+                </a:lnTo>
+                <a:close/>
+                <a:lnTo>
+                  <a:pt x="543437" y="2178596"/>
+                </a:lnTo>
+                <a:close/>
+                <a:lnTo>
+                  <a:pt x="545074" y="2172657"/>
+                </a:lnTo>
+                <a:close/>
+                <a:lnTo>
+                  <a:pt x="546714" y="2166746"/>
+                </a:lnTo>
+                <a:close/>
+                <a:lnTo>
+                  <a:pt x="548358" y="2160864"/>
+                </a:lnTo>
+                <a:close/>
+                <a:lnTo>
+                  <a:pt x="550006" y="2155009"/>
+                </a:lnTo>
+                <a:close/>
+                <a:lnTo>
+                  <a:pt x="551659" y="2149182"/>
+                </a:lnTo>
+                <a:close/>
+                <a:lnTo>
+                  <a:pt x="553316" y="2143383"/>
+                </a:lnTo>
+                <a:close/>
+                <a:lnTo>
+                  <a:pt x="554979" y="2137613"/>
+                </a:lnTo>
+                <a:close/>
+                <a:lnTo>
+                  <a:pt x="556648" y="2131870"/>
+                </a:lnTo>
+                <a:close/>
+                <a:lnTo>
+                  <a:pt x="558322" y="2126154"/>
+                </a:lnTo>
+                <a:close/>
+                <a:lnTo>
+                  <a:pt x="560004" y="2120467"/>
+                </a:lnTo>
+                <a:close/>
+                <a:lnTo>
+                  <a:pt x="561691" y="2114807"/>
+                </a:lnTo>
+                <a:close/>
+                <a:lnTo>
+                  <a:pt x="563386" y="2109174"/>
+                </a:lnTo>
+                <a:close/>
+                <a:lnTo>
+                  <a:pt x="565089" y="2103569"/>
+                </a:lnTo>
+                <a:close/>
+                <a:lnTo>
+                  <a:pt x="566800" y="2097991"/>
+                </a:lnTo>
+                <a:close/>
+                <a:lnTo>
+                  <a:pt x="568518" y="2092441"/>
+                </a:lnTo>
+                <a:close/>
+                <a:lnTo>
+                  <a:pt x="570246" y="2086917"/>
+                </a:lnTo>
+                <a:close/>
+                <a:lnTo>
+                  <a:pt x="571983" y="2081421"/>
+                </a:lnTo>
+                <a:close/>
+                <a:lnTo>
+                  <a:pt x="573729" y="2075952"/>
+                </a:lnTo>
+                <a:close/>
+                <a:lnTo>
+                  <a:pt x="575485" y="2070511"/>
+                </a:lnTo>
+                <a:close/>
+                <a:lnTo>
+                  <a:pt x="577251" y="2065096"/>
+                </a:lnTo>
+                <a:close/>
+                <a:lnTo>
+                  <a:pt x="579027" y="2059707"/>
+                </a:lnTo>
+                <a:close/>
+                <a:lnTo>
+                  <a:pt x="580815" y="2054346"/>
+                </a:lnTo>
+                <a:close/>
+                <a:lnTo>
+                  <a:pt x="582614" y="2049012"/>
+                </a:lnTo>
+                <a:close/>
+                <a:lnTo>
+                  <a:pt x="584425" y="2043704"/>
+                </a:lnTo>
+                <a:close/>
+                <a:lnTo>
+                  <a:pt x="586247" y="2038422"/>
+                </a:lnTo>
+                <a:close/>
+                <a:lnTo>
+                  <a:pt x="588083" y="2033168"/>
+                </a:lnTo>
+                <a:close/>
+                <a:lnTo>
+                  <a:pt x="589931" y="2027939"/>
+                </a:lnTo>
+                <a:close/>
+                <a:lnTo>
+                  <a:pt x="591792" y="2022737"/>
+                </a:lnTo>
+                <a:close/>
+                <a:lnTo>
+                  <a:pt x="593667" y="2017562"/>
+                </a:lnTo>
+                <a:close/>
+                <a:lnTo>
+                  <a:pt x="595556" y="2012412"/>
+                </a:lnTo>
+                <a:close/>
+                <a:lnTo>
+                  <a:pt x="597459" y="2007289"/>
+                </a:lnTo>
+                <a:close/>
+                <a:lnTo>
+                  <a:pt x="599377" y="2002192"/>
+                </a:lnTo>
+                <a:close/>
+                <a:lnTo>
+                  <a:pt x="601310" y="1997121"/>
+                </a:lnTo>
+                <a:close/>
+                <a:lnTo>
+                  <a:pt x="603258" y="1992076"/>
+                </a:lnTo>
+                <a:close/>
+                <a:lnTo>
+                  <a:pt x="605223" y="1987057"/>
+                </a:lnTo>
+                <a:close/>
+                <a:lnTo>
+                  <a:pt x="607204" y="1982063"/>
+                </a:lnTo>
+                <a:close/>
+                <a:lnTo>
+                  <a:pt x="609201" y="1977095"/>
+                </a:lnTo>
+                <a:close/>
+                <a:lnTo>
+                  <a:pt x="611215" y="1972153"/>
+                </a:lnTo>
+                <a:close/>
+                <a:lnTo>
+                  <a:pt x="613247" y="1967237"/>
+                </a:lnTo>
+                <a:close/>
+                <a:lnTo>
+                  <a:pt x="615296" y="1962346"/>
+                </a:lnTo>
+                <a:close/>
+                <a:lnTo>
+                  <a:pt x="617364" y="1957481"/>
+                </a:lnTo>
+                <a:close/>
+                <a:lnTo>
+                  <a:pt x="619450" y="1952641"/>
+                </a:lnTo>
+                <a:close/>
+                <a:lnTo>
+                  <a:pt x="621555" y="1947826"/>
+                </a:lnTo>
+                <a:close/>
+                <a:lnTo>
+                  <a:pt x="623679" y="1943036"/>
+                </a:lnTo>
+                <a:close/>
+                <a:lnTo>
+                  <a:pt x="625823" y="1938272"/>
+                </a:lnTo>
+                <a:close/>
+                <a:lnTo>
+                  <a:pt x="627987" y="1933533"/>
+                </a:lnTo>
+                <a:close/>
+                <a:lnTo>
+                  <a:pt x="630171" y="1928819"/>
+                </a:lnTo>
+                <a:close/>
+                <a:lnTo>
+                  <a:pt x="632376" y="1924130"/>
+                </a:lnTo>
+                <a:close/>
+                <a:lnTo>
+                  <a:pt x="634602" y="1919465"/>
+                </a:lnTo>
+                <a:close/>
+                <a:lnTo>
+                  <a:pt x="636850" y="1914826"/>
+                </a:lnTo>
+                <a:close/>
+                <a:lnTo>
+                  <a:pt x="639119" y="1910211"/>
+                </a:lnTo>
+                <a:close/>
+                <a:lnTo>
+                  <a:pt x="641411" y="1905621"/>
+                </a:lnTo>
+                <a:close/>
+                <a:lnTo>
+                  <a:pt x="643726" y="1901056"/>
+                </a:lnTo>
+                <a:close/>
+                <a:lnTo>
+                  <a:pt x="646063" y="1896515"/>
+                </a:lnTo>
+                <a:close/>
+                <a:lnTo>
+                  <a:pt x="648424" y="1891998"/>
+                </a:lnTo>
+                <a:close/>
+                <a:lnTo>
+                  <a:pt x="650809" y="1887506"/>
+                </a:lnTo>
+                <a:close/>
+                <a:lnTo>
+                  <a:pt x="653218" y="1883039"/>
+                </a:lnTo>
+                <a:close/>
+                <a:lnTo>
+                  <a:pt x="655652" y="1878595"/>
+                </a:lnTo>
+                <a:close/>
+                <a:lnTo>
+                  <a:pt x="658110" y="1874176"/>
+                </a:lnTo>
+                <a:close/>
+                <a:lnTo>
+                  <a:pt x="660594" y="1869781"/>
+                </a:lnTo>
+                <a:close/>
+                <a:lnTo>
+                  <a:pt x="663103" y="1865410"/>
+                </a:lnTo>
+                <a:close/>
+                <a:lnTo>
+                  <a:pt x="665639" y="1861062"/>
+                </a:lnTo>
+                <a:close/>
+                <a:lnTo>
+                  <a:pt x="668201" y="1856739"/>
+                </a:lnTo>
+                <a:close/>
+                <a:lnTo>
+                  <a:pt x="670790" y="1852440"/>
+                </a:lnTo>
+                <a:close/>
+                <a:lnTo>
+                  <a:pt x="673406" y="1848164"/>
+                </a:lnTo>
+                <a:close/>
+                <a:lnTo>
+                  <a:pt x="676049" y="1843912"/>
+                </a:lnTo>
+                <a:close/>
+                <a:lnTo>
+                  <a:pt x="678721" y="1839684"/>
+                </a:lnTo>
+                <a:close/>
+                <a:lnTo>
+                  <a:pt x="681420" y="1835479"/>
+                </a:lnTo>
+                <a:close/>
+                <a:lnTo>
+                  <a:pt x="684149" y="1831298"/>
+                </a:lnTo>
+                <a:close/>
+                <a:lnTo>
+                  <a:pt x="686907" y="1827140"/>
+                </a:lnTo>
+                <a:close/>
+                <a:lnTo>
+                  <a:pt x="689693" y="1823005"/>
+                </a:lnTo>
+                <a:close/>
+                <a:lnTo>
+                  <a:pt x="692510" y="1818893"/>
+                </a:lnTo>
+                <a:close/>
+                <a:lnTo>
+                  <a:pt x="695355" y="1814803"/>
+                </a:lnTo>
+                <a:close/>
+                <a:lnTo>
+                  <a:pt x="698230" y="1810735"/>
+                </a:lnTo>
+                <a:close/>
+                <a:lnTo>
+                  <a:pt x="701135" y="1806689"/>
+                </a:lnTo>
+                <a:close/>
+                <a:lnTo>
+                  <a:pt x="704069" y="1802663"/>
+                </a:lnTo>
+                <a:close/>
+                <a:lnTo>
+                  <a:pt x="707032" y="1798658"/>
+                </a:lnTo>
+                <a:close/>
+                <a:lnTo>
+                  <a:pt x="710025" y="1794673"/>
+                </a:lnTo>
+                <a:close/>
+                <a:lnTo>
+                  <a:pt x="713047" y="1790708"/>
+                </a:lnTo>
+                <a:close/>
+                <a:lnTo>
+                  <a:pt x="716099" y="1786762"/>
+                </a:lnTo>
+                <a:close/>
+                <a:lnTo>
+                  <a:pt x="719181" y="1782835"/>
+                </a:lnTo>
+                <a:close/>
+                <a:lnTo>
+                  <a:pt x="722292" y="1778926"/>
+                </a:lnTo>
+                <a:close/>
+                <a:lnTo>
+                  <a:pt x="725433" y="1775035"/>
+                </a:lnTo>
+                <a:close/>
+                <a:lnTo>
+                  <a:pt x="728603" y="1771161"/>
+                </a:lnTo>
+                <a:close/>
+                <a:lnTo>
+                  <a:pt x="731803" y="1767304"/>
+                </a:lnTo>
+                <a:close/>
+                <a:lnTo>
+                  <a:pt x="735033" y="1763464"/>
+                </a:lnTo>
+                <a:close/>
+                <a:lnTo>
+                  <a:pt x="738293" y="1759640"/>
+                </a:lnTo>
+                <a:close/>
+                <a:lnTo>
+                  <a:pt x="741582" y="1755832"/>
+                </a:lnTo>
+                <a:close/>
+                <a:lnTo>
+                  <a:pt x="744901" y="1752038"/>
+                </a:lnTo>
+                <a:close/>
+                <a:lnTo>
+                  <a:pt x="748250" y="1748260"/>
+                </a:lnTo>
+                <a:close/>
+                <a:lnTo>
+                  <a:pt x="751629" y="1744496"/>
+                </a:lnTo>
+                <a:close/>
+                <a:lnTo>
+                  <a:pt x="755038" y="1740745"/>
+                </a:lnTo>
+                <a:close/>
+                <a:lnTo>
+                  <a:pt x="758476" y="1737009"/>
+                </a:lnTo>
+                <a:close/>
+                <a:lnTo>
+                  <a:pt x="761945" y="1733285"/>
+                </a:lnTo>
+                <a:close/>
+                <a:lnTo>
+                  <a:pt x="765443" y="1729573"/>
+                </a:lnTo>
+                <a:close/>
+                <a:lnTo>
+                  <a:pt x="768972" y="1725874"/>
+                </a:lnTo>
+                <a:close/>
+                <a:lnTo>
+                  <a:pt x="772530" y="1722187"/>
+                </a:lnTo>
+                <a:close/>
+                <a:lnTo>
+                  <a:pt x="776119" y="1718510"/>
+                </a:lnTo>
+                <a:close/>
+                <a:lnTo>
+                  <a:pt x="779738" y="1714845"/>
+                </a:lnTo>
+                <a:close/>
+                <a:lnTo>
+                  <a:pt x="783386" y="1711190"/>
+                </a:lnTo>
+                <a:close/>
+                <a:lnTo>
+                  <a:pt x="787065" y="1707544"/>
+                </a:lnTo>
+                <a:close/>
+                <a:lnTo>
+                  <a:pt x="790774" y="1703908"/>
+                </a:lnTo>
+                <a:close/>
+                <a:lnTo>
+                  <a:pt x="794513" y="1700281"/>
+                </a:lnTo>
+                <a:close/>
+                <a:lnTo>
+                  <a:pt x="798282" y="1696663"/>
+                </a:lnTo>
+                <a:close/>
+                <a:lnTo>
+                  <a:pt x="802082" y="1693053"/>
+                </a:lnTo>
+                <a:close/>
+                <a:lnTo>
+                  <a:pt x="805912" y="1689450"/>
+                </a:lnTo>
+                <a:close/>
+                <a:lnTo>
+                  <a:pt x="809772" y="1685855"/>
+                </a:lnTo>
+                <a:close/>
+                <a:lnTo>
+                  <a:pt x="813662" y="1682267"/>
+                </a:lnTo>
+                <a:close/>
+                <a:lnTo>
+                  <a:pt x="817583" y="1678684"/>
+                </a:lnTo>
+                <a:close/>
+                <a:lnTo>
+                  <a:pt x="821534" y="1675108"/>
+                </a:lnTo>
+                <a:close/>
+                <a:lnTo>
+                  <a:pt x="825515" y="1671537"/>
+                </a:lnTo>
+                <a:close/>
+                <a:lnTo>
+                  <a:pt x="829527" y="1667971"/>
+                </a:lnTo>
+                <a:close/>
+                <a:lnTo>
+                  <a:pt x="833569" y="1664410"/>
+                </a:lnTo>
+                <a:close/>
+                <a:lnTo>
+                  <a:pt x="837642" y="1660853"/>
+                </a:lnTo>
+                <a:close/>
+                <a:lnTo>
+                  <a:pt x="841745" y="1657300"/>
+                </a:lnTo>
+                <a:close/>
+                <a:lnTo>
+                  <a:pt x="845879" y="1653749"/>
+                </a:lnTo>
+                <a:close/>
+                <a:lnTo>
+                  <a:pt x="850043" y="1650202"/>
+                </a:lnTo>
+                <a:close/>
+                <a:lnTo>
+                  <a:pt x="854238" y="1646657"/>
+                </a:lnTo>
+                <a:close/>
+                <a:lnTo>
+                  <a:pt x="858464" y="1643114"/>
+                </a:lnTo>
+                <a:close/>
+                <a:lnTo>
+                  <a:pt x="862720" y="1639572"/>
+                </a:lnTo>
+                <a:close/>
+                <a:lnTo>
+                  <a:pt x="867006" y="1636032"/>
+                </a:lnTo>
+                <a:close/>
+                <a:lnTo>
+                  <a:pt x="871324" y="1632492"/>
+                </a:lnTo>
+                <a:close/>
+                <a:lnTo>
+                  <a:pt x="875672" y="1628952"/>
+                </a:lnTo>
+                <a:close/>
+                <a:lnTo>
+                  <a:pt x="880051" y="1625411"/>
+                </a:lnTo>
+                <a:close/>
+                <a:lnTo>
+                  <a:pt x="884460" y="1621870"/>
+                </a:lnTo>
+                <a:close/>
+                <a:lnTo>
+                  <a:pt x="888901" y="1618328"/>
+                </a:lnTo>
+                <a:close/>
+                <a:lnTo>
+                  <a:pt x="893372" y="1614785"/>
+                </a:lnTo>
+                <a:close/>
+                <a:lnTo>
+                  <a:pt x="897874" y="1611239"/>
+                </a:lnTo>
+                <a:close/>
+                <a:lnTo>
+                  <a:pt x="902406" y="1607690"/>
+                </a:lnTo>
+                <a:close/>
+                <a:lnTo>
+                  <a:pt x="906970" y="1604139"/>
+                </a:lnTo>
+                <a:close/>
+                <a:lnTo>
+                  <a:pt x="911565" y="1600584"/>
+                </a:lnTo>
+                <a:close/>
+                <a:lnTo>
+                  <a:pt x="916190" y="1597026"/>
+                </a:lnTo>
+                <a:close/>
+                <a:lnTo>
+                  <a:pt x="920847" y="1593463"/>
+                </a:lnTo>
+                <a:close/>
+                <a:lnTo>
+                  <a:pt x="925535" y="1589895"/>
+                </a:lnTo>
+                <a:close/>
+                <a:lnTo>
+                  <a:pt x="930253" y="1586322"/>
+                </a:lnTo>
+                <a:close/>
+                <a:lnTo>
+                  <a:pt x="935003" y="1582744"/>
+                </a:lnTo>
+                <a:close/>
+                <a:lnTo>
+                  <a:pt x="939783" y="1579159"/>
+                </a:lnTo>
+                <a:close/>
+                <a:lnTo>
+                  <a:pt x="944595" y="1575568"/>
+                </a:lnTo>
+                <a:close/>
+                <a:lnTo>
+                  <a:pt x="949438" y="1571970"/>
+                </a:lnTo>
+                <a:close/>
+                <a:lnTo>
+                  <a:pt x="954312" y="1568365"/>
+                </a:lnTo>
+                <a:close/>
+                <a:lnTo>
+                  <a:pt x="959217" y="1564752"/>
+                </a:lnTo>
+                <a:close/>
+                <a:lnTo>
+                  <a:pt x="964154" y="1561130"/>
+                </a:lnTo>
+                <a:close/>
+                <a:lnTo>
+                  <a:pt x="969122" y="1557500"/>
+                </a:lnTo>
+                <a:close/>
+                <a:lnTo>
+                  <a:pt x="974121" y="1553861"/>
+                </a:lnTo>
+                <a:close/>
+                <a:lnTo>
+                  <a:pt x="979151" y="1550212"/>
+                </a:lnTo>
+                <a:close/>
+                <a:lnTo>
+                  <a:pt x="984212" y="1546553"/>
+                </a:lnTo>
+                <a:close/>
+                <a:lnTo>
+                  <a:pt x="989305" y="1542883"/>
+                </a:lnTo>
+                <a:close/>
+                <a:lnTo>
+                  <a:pt x="994429" y="1539202"/>
+                </a:lnTo>
+                <a:close/>
+                <a:lnTo>
+                  <a:pt x="999585" y="1535511"/>
+                </a:lnTo>
+                <a:close/>
+                <a:lnTo>
+                  <a:pt x="1004772" y="1531807"/>
+                </a:lnTo>
+                <a:close/>
+                <a:lnTo>
+                  <a:pt x="1009991" y="1528091"/>
+                </a:lnTo>
+                <a:close/>
+                <a:lnTo>
+                  <a:pt x="1015241" y="1524362"/>
+                </a:lnTo>
+                <a:close/>
+                <a:lnTo>
+                  <a:pt x="1020522" y="1520620"/>
+                </a:lnTo>
+                <a:close/>
+                <a:lnTo>
+                  <a:pt x="1025835" y="1516865"/>
+                </a:lnTo>
+                <a:close/>
+                <a:lnTo>
+                  <a:pt x="1031180" y="1513095"/>
+                </a:lnTo>
+                <a:close/>
+                <a:lnTo>
+                  <a:pt x="1036556" y="1509311"/>
+                </a:lnTo>
+                <a:close/>
+                <a:lnTo>
+                  <a:pt x="1041963" y="1505513"/>
+                </a:lnTo>
+                <a:close/>
+                <a:lnTo>
+                  <a:pt x="1047403" y="1501698"/>
+                </a:lnTo>
+                <a:close/>
+                <a:lnTo>
+                  <a:pt x="1052874" y="1497868"/>
+                </a:lnTo>
+                <a:close/>
+                <a:lnTo>
+                  <a:pt x="1058377" y="1494022"/>
+                </a:lnTo>
+                <a:close/>
+                <a:lnTo>
+                  <a:pt x="1063911" y="1490159"/>
+                </a:lnTo>
+                <a:close/>
+                <a:lnTo>
+                  <a:pt x="1069477" y="1486279"/>
+                </a:lnTo>
+                <a:close/>
+                <a:lnTo>
+                  <a:pt x="1075075" y="1482381"/>
+                </a:lnTo>
+                <a:close/>
+                <a:lnTo>
+                  <a:pt x="1080705" y="1478465"/>
+                </a:lnTo>
+                <a:close/>
+                <a:lnTo>
+                  <a:pt x="1086366" y="1474531"/>
+                </a:lnTo>
+                <a:close/>
+                <a:lnTo>
+                  <a:pt x="1092060" y="1470577"/>
+                </a:lnTo>
+                <a:close/>
+                <a:lnTo>
+                  <a:pt x="1097785" y="1466605"/>
+                </a:lnTo>
+                <a:close/>
+                <a:lnTo>
+                  <a:pt x="1103542" y="1462612"/>
+                </a:lnTo>
+                <a:close/>
+                <a:lnTo>
+                  <a:pt x="1109331" y="1458600"/>
+                </a:lnTo>
+                <a:close/>
+                <a:lnTo>
+                  <a:pt x="1115152" y="1454567"/>
+                </a:lnTo>
+                <a:close/>
+                <a:lnTo>
+                  <a:pt x="1121005" y="1450512"/>
+                </a:lnTo>
+                <a:close/>
+                <a:lnTo>
+                  <a:pt x="1126890" y="1446436"/>
+                </a:lnTo>
+                <a:close/>
+                <a:lnTo>
+                  <a:pt x="1132807" y="1442338"/>
+                </a:lnTo>
+                <a:close/>
+                <a:lnTo>
+                  <a:pt x="1138756" y="1438217"/>
+                </a:lnTo>
+                <a:close/>
+                <a:lnTo>
+                  <a:pt x="1144738" y="1434074"/>
+                </a:lnTo>
+                <a:close/>
+                <a:lnTo>
+                  <a:pt x="1150751" y="1429907"/>
+                </a:lnTo>
+                <a:close/>
+                <a:lnTo>
+                  <a:pt x="1156796" y="1425717"/>
+                </a:lnTo>
+                <a:close/>
+                <a:lnTo>
+                  <a:pt x="1162874" y="1421502"/>
+                </a:lnTo>
+                <a:close/>
+                <a:lnTo>
+                  <a:pt x="1168984" y="1417262"/>
+                </a:lnTo>
+                <a:close/>
+                <a:lnTo>
+                  <a:pt x="1175126" y="1412998"/>
+                </a:lnTo>
+                <a:close/>
+                <a:lnTo>
+                  <a:pt x="1181300" y="1408708"/>
+                </a:lnTo>
+                <a:close/>
+                <a:lnTo>
+                  <a:pt x="1187506" y="1404391"/>
+                </a:lnTo>
+                <a:close/>
+                <a:lnTo>
+                  <a:pt x="1193745" y="1400049"/>
+                </a:lnTo>
+                <a:close/>
+                <a:lnTo>
+                  <a:pt x="1200016" y="1395679"/>
+                </a:lnTo>
+                <a:close/>
+                <a:lnTo>
+                  <a:pt x="1206320" y="1391282"/>
+                </a:lnTo>
+                <a:close/>
+                <a:lnTo>
+                  <a:pt x="1212656" y="1386858"/>
+                </a:lnTo>
+                <a:close/>
+                <a:lnTo>
+                  <a:pt x="1219024" y="1382405"/>
+                </a:lnTo>
+                <a:close/>
+                <a:lnTo>
+                  <a:pt x="1225425" y="1377923"/>
+                </a:lnTo>
+                <a:close/>
+                <a:lnTo>
+                  <a:pt x="1231858" y="1373413"/>
+                </a:lnTo>
+                <a:close/>
+                <a:lnTo>
+                  <a:pt x="1238323" y="1368872"/>
+                </a:lnTo>
+                <a:close/>
+                <a:lnTo>
+                  <a:pt x="1244821" y="1364303"/>
+                </a:lnTo>
+                <a:close/>
+                <a:lnTo>
+                  <a:pt x="1251350" y="1359703"/>
+                </a:lnTo>
+                <a:close/>
+                <a:lnTo>
+                  <a:pt x="1257910" y="1355075"/>
+                </a:lnTo>
+                <a:close/>
+                <a:lnTo>
+                  <a:pt x="1264500" y="1350418"/>
+                </a:lnTo>
+                <a:close/>
+                <a:lnTo>
+                  <a:pt x="1271120" y="1345733"/>
+                </a:lnTo>
+                <a:close/>
+                <a:lnTo>
+                  <a:pt x="1277769" y="1341019"/>
+                </a:lnTo>
+                <a:close/>
+                <a:lnTo>
+                  <a:pt x="1284445" y="1336277"/>
+                </a:lnTo>
+                <a:close/>
+                <a:lnTo>
+                  <a:pt x="1291150" y="1331507"/>
+                </a:lnTo>
+                <a:close/>
+                <a:lnTo>
+                  <a:pt x="1297881" y="1326709"/>
+                </a:lnTo>
+                <a:close/>
+                <a:lnTo>
+                  <a:pt x="1304639" y="1321884"/>
+                </a:lnTo>
+                <a:close/>
+                <a:lnTo>
+                  <a:pt x="1311422" y="1317032"/>
+                </a:lnTo>
+                <a:close/>
+                <a:lnTo>
+                  <a:pt x="1318231" y="1312154"/>
+                </a:lnTo>
+                <a:close/>
+                <a:lnTo>
+                  <a:pt x="1325063" y="1307248"/>
+                </a:lnTo>
+                <a:close/>
+                <a:lnTo>
+                  <a:pt x="1331920" y="1302316"/>
+                </a:lnTo>
+                <a:close/>
+                <a:lnTo>
+                  <a:pt x="1338800" y="1297358"/>
+                </a:lnTo>
+                <a:close/>
+                <a:lnTo>
+                  <a:pt x="1345702" y="1292375"/>
+                </a:lnTo>
+                <a:close/>
+                <a:lnTo>
+                  <a:pt x="1352626" y="1287365"/>
+                </a:lnTo>
+                <a:close/>
+                <a:lnTo>
+                  <a:pt x="1359571" y="1282331"/>
+                </a:lnTo>
+                <a:close/>
+                <a:lnTo>
+                  <a:pt x="1366536" y="1277271"/>
+                </a:lnTo>
+                <a:close/>
+                <a:lnTo>
+                  <a:pt x="1373522" y="1272186"/>
+                </a:lnTo>
+                <a:close/>
+                <a:lnTo>
+                  <a:pt x="1380526" y="1267077"/>
+                </a:lnTo>
+                <a:close/>
+                <a:lnTo>
+                  <a:pt x="1387550" y="1261943"/>
+                </a:lnTo>
+                <a:close/>
+                <a:lnTo>
+                  <a:pt x="1394591" y="1256785"/>
+                </a:lnTo>
+                <a:close/>
+                <a:lnTo>
+                  <a:pt x="1401649" y="1251604"/>
+                </a:lnTo>
+                <a:close/>
+                <a:lnTo>
+                  <a:pt x="1408725" y="1246398"/>
+                </a:lnTo>
+                <a:close/>
+                <a:lnTo>
+                  <a:pt x="1415816" y="1241170"/>
+                </a:lnTo>
+                <a:close/>
+                <a:lnTo>
+                  <a:pt x="1422923" y="1235918"/>
+                </a:lnTo>
+                <a:close/>
+                <a:lnTo>
+                  <a:pt x="1430044" y="1230643"/>
+                </a:lnTo>
+                <a:close/>
+                <a:lnTo>
+                  <a:pt x="1437179" y="1225346"/>
+                </a:lnTo>
+                <a:close/>
+                <a:lnTo>
+                  <a:pt x="1444328" y="1220026"/>
+                </a:lnTo>
+                <a:close/>
+                <a:lnTo>
+                  <a:pt x="1451490" y="1214684"/>
+                </a:lnTo>
+                <a:close/>
+                <a:lnTo>
+                  <a:pt x="1458664" y="1209320"/>
+                </a:lnTo>
+                <a:close/>
+                <a:lnTo>
+                  <a:pt x="1465849" y="1203935"/>
+                </a:lnTo>
+                <a:close/>
+                <a:lnTo>
+                  <a:pt x="1473045" y="1198528"/>
+                </a:lnTo>
+                <a:close/>
+                <a:lnTo>
+                  <a:pt x="1480252" y="1193100"/>
+                </a:lnTo>
+                <a:close/>
+                <a:lnTo>
+                  <a:pt x="1487468" y="1187651"/>
+                </a:lnTo>
+                <a:close/>
+                <a:lnTo>
+                  <a:pt x="1494693" y="1182182"/>
+                </a:lnTo>
+                <a:close/>
+                <a:lnTo>
+                  <a:pt x="1501926" y="1176692"/>
+                </a:lnTo>
+                <a:close/>
+                <a:lnTo>
+                  <a:pt x="1509167" y="1171182"/>
+                </a:lnTo>
+                <a:close/>
+                <a:lnTo>
+                  <a:pt x="1516415" y="1165652"/>
+                </a:lnTo>
+                <a:close/>
+                <a:lnTo>
+                  <a:pt x="1523669" y="1160102"/>
+                </a:lnTo>
+                <a:close/>
+                <a:lnTo>
+                  <a:pt x="1530929" y="1154533"/>
+                </a:lnTo>
+                <a:close/>
+                <a:lnTo>
+                  <a:pt x="1538194" y="1148945"/>
+                </a:lnTo>
+                <a:close/>
+                <a:lnTo>
+                  <a:pt x="1545464" y="1143338"/>
+                </a:lnTo>
+                <a:close/>
+                <a:lnTo>
+                  <a:pt x="1552737" y="1137712"/>
+                </a:lnTo>
+                <a:close/>
+                <a:lnTo>
+                  <a:pt x="1560014" y="1132068"/>
+                </a:lnTo>
+                <a:close/>
+                <a:lnTo>
+                  <a:pt x="1567293" y="1126406"/>
+                </a:lnTo>
+                <a:close/>
+                <a:lnTo>
+                  <a:pt x="1574574" y="1120726"/>
+                </a:lnTo>
+                <a:close/>
+                <a:lnTo>
+                  <a:pt x="1581856" y="1115028"/>
+                </a:lnTo>
+                <a:close/>
+                <a:lnTo>
+                  <a:pt x="1589138" y="1109312"/>
+                </a:lnTo>
+                <a:close/>
+                <a:lnTo>
+                  <a:pt x="1596421" y="1103580"/>
+                </a:lnTo>
+                <a:close/>
+                <a:lnTo>
+                  <a:pt x="1603703" y="1097830"/>
+                </a:lnTo>
+                <a:close/>
+                <a:lnTo>
+                  <a:pt x="1610983" y="1092064"/>
+                </a:lnTo>
+                <a:close/>
+                <a:lnTo>
+                  <a:pt x="1618262" y="1086282"/>
+                </a:lnTo>
+                <a:close/>
+                <a:lnTo>
+                  <a:pt x="1625538" y="1080483"/>
+                </a:lnTo>
+                <a:close/>
+                <a:lnTo>
+                  <a:pt x="1632810" y="1074668"/>
+                </a:lnTo>
+                <a:close/>
+                <a:lnTo>
+                  <a:pt x="1640079" y="1068838"/>
+                </a:lnTo>
+                <a:close/>
+                <a:lnTo>
+                  <a:pt x="1647343" y="1062992"/>
+                </a:lnTo>
+                <a:close/>
+                <a:lnTo>
+                  <a:pt x="1654602" y="1057131"/>
+                </a:lnTo>
+                <a:close/>
+                <a:lnTo>
+                  <a:pt x="1661855" y="1051255"/>
+                </a:lnTo>
+                <a:close/>
+                <a:lnTo>
+                  <a:pt x="1669101" y="1045365"/>
+                </a:lnTo>
+                <a:close/>
+                <a:lnTo>
+                  <a:pt x="1676341" y="1039460"/>
+                </a:lnTo>
+                <a:close/>
+                <a:lnTo>
+                  <a:pt x="1683572" y="1033540"/>
+                </a:lnTo>
+                <a:close/>
+                <a:lnTo>
+                  <a:pt x="1690796" y="1027607"/>
+                </a:lnTo>
+                <a:close/>
+                <a:lnTo>
+                  <a:pt x="1698010" y="1021660"/>
+                </a:lnTo>
+                <a:close/>
+                <a:lnTo>
+                  <a:pt x="1705214" y="1015700"/>
+                </a:lnTo>
+                <a:close/>
+                <a:lnTo>
+                  <a:pt x="1712408" y="1009726"/>
+                </a:lnTo>
+                <a:close/>
+                <a:lnTo>
+                  <a:pt x="1719591" y="1003740"/>
+                </a:lnTo>
+                <a:close/>
+                <a:lnTo>
+                  <a:pt x="1726762" y="997741"/>
+                </a:lnTo>
+                <a:close/>
+                <a:lnTo>
+                  <a:pt x="1733921" y="991729"/>
+                </a:lnTo>
+                <a:close/>
+                <a:lnTo>
+                  <a:pt x="1741067" y="985705"/>
+                </a:lnTo>
+                <a:close/>
+                <a:lnTo>
+                  <a:pt x="1748200" y="979669"/>
+                </a:lnTo>
+                <a:close/>
+                <a:lnTo>
+                  <a:pt x="1755318" y="973622"/>
+                </a:lnTo>
+                <a:close/>
+                <a:lnTo>
+                  <a:pt x="1762422" y="967563"/>
+                </a:lnTo>
+                <a:close/>
+                <a:lnTo>
+                  <a:pt x="1769509" y="961492"/>
+                </a:lnTo>
+                <a:close/>
+                <a:lnTo>
+                  <a:pt x="1776581" y="955411"/>
+                </a:lnTo>
+                <a:close/>
+                <a:lnTo>
+                  <a:pt x="1783636" y="949319"/>
+                </a:lnTo>
+                <a:close/>
+                <a:lnTo>
+                  <a:pt x="1790674" y="943217"/>
+                </a:lnTo>
+                <a:close/>
+                <a:lnTo>
+                  <a:pt x="1797693" y="937104"/>
+                </a:lnTo>
+                <a:close/>
+                <a:lnTo>
+                  <a:pt x="1804694" y="930982"/>
+                </a:lnTo>
+                <a:close/>
+                <a:lnTo>
+                  <a:pt x="1811675" y="924849"/>
+                </a:lnTo>
+                <a:close/>
+                <a:lnTo>
+                  <a:pt x="1818636" y="918708"/>
+                </a:lnTo>
+                <a:close/>
+                <a:lnTo>
+                  <a:pt x="1825577" y="912557"/>
+                </a:lnTo>
+                <a:close/>
+                <a:lnTo>
+                  <a:pt x="1832496" y="906396"/>
+                </a:lnTo>
+                <a:close/>
+                <a:lnTo>
+                  <a:pt x="1839394" y="900228"/>
+                </a:lnTo>
+                <a:close/>
+                <a:lnTo>
+                  <a:pt x="1846269" y="894050"/>
+                </a:lnTo>
+                <a:close/>
+                <a:lnTo>
+                  <a:pt x="1853120" y="887865"/>
+                </a:lnTo>
+                <a:close/>
+                <a:lnTo>
+                  <a:pt x="1859948" y="881671"/>
+                </a:lnTo>
+                <a:close/>
+                <a:lnTo>
+                  <a:pt x="1866751" y="875470"/>
+                </a:lnTo>
+                <a:close/>
+                <a:lnTo>
+                  <a:pt x="1873529" y="869262"/>
+                </a:lnTo>
+                <a:close/>
+                <a:lnTo>
+                  <a:pt x="1880281" y="863046"/>
+                </a:lnTo>
+                <a:close/>
+                <a:lnTo>
+                  <a:pt x="1887007" y="856823"/>
+                </a:lnTo>
+                <a:close/>
+                <a:lnTo>
+                  <a:pt x="1893705" y="850593"/>
+                </a:lnTo>
+                <a:close/>
+                <a:lnTo>
+                  <a:pt x="1900376" y="844357"/>
+                </a:lnTo>
+                <a:close/>
+                <a:lnTo>
+                  <a:pt x="1907019" y="838114"/>
+                </a:lnTo>
+                <a:close/>
+                <a:lnTo>
+                  <a:pt x="1913632" y="831866"/>
+                </a:lnTo>
+                <a:close/>
+                <a:lnTo>
+                  <a:pt x="1920216" y="825611"/>
+                </a:lnTo>
+                <a:close/>
+                <a:lnTo>
+                  <a:pt x="1926770" y="819352"/>
+                </a:lnTo>
+                <a:close/>
+                <a:lnTo>
+                  <a:pt x="1933292" y="813087"/>
+                </a:lnTo>
+                <a:close/>
+                <a:lnTo>
+                  <a:pt x="1939783" y="806817"/>
+                </a:lnTo>
+                <a:close/>
+                <a:lnTo>
+                  <a:pt x="1946242" y="800542"/>
+                </a:lnTo>
+                <a:close/>
+                <a:lnTo>
+                  <a:pt x="1952668" y="794263"/>
+                </a:lnTo>
+                <a:close/>
+                <a:lnTo>
+                  <a:pt x="1959060" y="787979"/>
+                </a:lnTo>
+                <a:close/>
+                <a:lnTo>
+                  <a:pt x="1965418" y="781691"/>
+                </a:lnTo>
+                <a:close/>
+                <a:lnTo>
+                  <a:pt x="1971742" y="775400"/>
+                </a:lnTo>
+                <a:close/>
+                <a:lnTo>
+                  <a:pt x="1978029" y="769105"/>
+                </a:lnTo>
+                <a:close/>
+                <a:lnTo>
+                  <a:pt x="1984281" y="762807"/>
+                </a:lnTo>
+                <a:close/>
+                <a:lnTo>
+                  <a:pt x="1990496" y="756506"/>
+                </a:lnTo>
+                <a:close/>
+                <a:lnTo>
+                  <a:pt x="1996674" y="750202"/>
+                </a:lnTo>
+                <a:close/>
+                <a:lnTo>
+                  <a:pt x="2002813" y="743895"/>
+                </a:lnTo>
+                <a:close/>
+                <a:lnTo>
+                  <a:pt x="2008914" y="737586"/>
+                </a:lnTo>
+                <a:close/>
+                <a:lnTo>
+                  <a:pt x="2014976" y="731276"/>
+                </a:lnTo>
+                <a:close/>
+                <a:lnTo>
+                  <a:pt x="2020997" y="724963"/>
+                </a:lnTo>
+                <a:close/>
+                <a:lnTo>
+                  <a:pt x="2026978" y="718649"/>
+                </a:lnTo>
+                <a:close/>
+                <a:lnTo>
+                  <a:pt x="2032918" y="712333"/>
+                </a:lnTo>
+                <a:close/>
+                <a:lnTo>
+                  <a:pt x="2038816" y="706017"/>
+                </a:lnTo>
+                <a:close/>
+                <a:lnTo>
+                  <a:pt x="2044671" y="699700"/>
+                </a:lnTo>
+                <a:close/>
+                <a:lnTo>
+                  <a:pt x="2050483" y="693382"/>
+                </a:lnTo>
+                <a:close/>
+                <a:lnTo>
+                  <a:pt x="2056252" y="687064"/>
+                </a:lnTo>
+                <a:close/>
+                <a:lnTo>
+                  <a:pt x="2061975" y="680745"/>
+                </a:lnTo>
+                <a:close/>
+                <a:lnTo>
+                  <a:pt x="2067654" y="674427"/>
+                </a:lnTo>
+                <a:close/>
+                <a:lnTo>
+                  <a:pt x="2073287" y="668110"/>
+                </a:lnTo>
+                <a:close/>
+                <a:lnTo>
+                  <a:pt x="2078874" y="661793"/>
+                </a:lnTo>
+                <a:close/>
+                <a:lnTo>
+                  <a:pt x="2084413" y="655477"/>
+                </a:lnTo>
+                <a:close/>
+                <a:lnTo>
+                  <a:pt x="2089905" y="649163"/>
+                </a:lnTo>
+                <a:close/>
+                <a:lnTo>
+                  <a:pt x="2095349" y="642849"/>
+                </a:lnTo>
+                <a:close/>
+                <a:lnTo>
+                  <a:pt x="2100743" y="636538"/>
+                </a:lnTo>
+                <a:close/>
+                <a:lnTo>
+                  <a:pt x="2106088" y="630228"/>
+                </a:lnTo>
+                <a:close/>
+                <a:lnTo>
+                  <a:pt x="2111383" y="623921"/>
+                </a:lnTo>
+                <a:close/>
+                <a:lnTo>
+                  <a:pt x="2116626" y="617616"/>
+                </a:lnTo>
+                <a:close/>
+                <a:lnTo>
+                  <a:pt x="2121819" y="611313"/>
+                </a:lnTo>
+                <a:close/>
+                <a:lnTo>
+                  <a:pt x="2126959" y="605014"/>
+                </a:lnTo>
+                <a:close/>
+                <a:lnTo>
+                  <a:pt x="2132046" y="598718"/>
+                </a:lnTo>
+                <a:close/>
+                <a:lnTo>
+                  <a:pt x="2137079" y="592425"/>
+                </a:lnTo>
+                <a:close/>
+                <a:lnTo>
+                  <a:pt x="2142059" y="586136"/>
+                </a:lnTo>
+                <a:close/>
+                <a:lnTo>
+                  <a:pt x="2146984" y="579850"/>
+                </a:lnTo>
+                <a:close/>
+                <a:lnTo>
+                  <a:pt x="2151853" y="573569"/>
+                </a:lnTo>
+                <a:close/>
+                <a:lnTo>
+                  <a:pt x="2156666" y="567293"/>
+                </a:lnTo>
+                <a:close/>
+                <a:lnTo>
+                  <a:pt x="2161423" y="561021"/>
+                </a:lnTo>
+                <a:close/>
+                <a:lnTo>
+                  <a:pt x="2166122" y="554754"/>
+                </a:lnTo>
+                <a:close/>
+                <a:lnTo>
+                  <a:pt x="2170764" y="548492"/>
+                </a:lnTo>
+                <a:close/>
+                <a:lnTo>
+                  <a:pt x="2175346" y="542235"/>
+                </a:lnTo>
+                <a:close/>
+                <a:lnTo>
+                  <a:pt x="2179870" y="535985"/>
+                </a:lnTo>
+                <a:close/>
+                <a:lnTo>
+                  <a:pt x="2184333" y="529740"/>
+                </a:lnTo>
+                <a:close/>
+                <a:lnTo>
+                  <a:pt x="2188736" y="523501"/>
+                </a:lnTo>
+                <a:close/>
+                <a:lnTo>
+                  <a:pt x="2193078" y="517269"/>
+                </a:lnTo>
+                <a:close/>
+                <a:lnTo>
+                  <a:pt x="2197358" y="511043"/>
+                </a:lnTo>
+                <a:close/>
+                <a:lnTo>
+                  <a:pt x="2201575" y="504824"/>
+                </a:lnTo>
+                <a:close/>
+                <a:lnTo>
+                  <a:pt x="2205730" y="498612"/>
+                </a:lnTo>
+                <a:close/>
+                <a:lnTo>
+                  <a:pt x="2209820" y="492408"/>
+                </a:lnTo>
+                <a:close/>
+                <a:lnTo>
+                  <a:pt x="2213846" y="486211"/>
+                </a:lnTo>
+                <a:close/>
+                <a:lnTo>
+                  <a:pt x="2217807" y="480023"/>
+                </a:lnTo>
+                <a:close/>
+                <a:lnTo>
+                  <a:pt x="2221702" y="473842"/>
+                </a:lnTo>
+                <a:close/>
+                <a:lnTo>
+                  <a:pt x="2225531" y="467670"/>
+                </a:lnTo>
+                <a:close/>
+                <a:lnTo>
+                  <a:pt x="2229293" y="461506"/>
+                </a:lnTo>
+                <a:close/>
+                <a:lnTo>
+                  <a:pt x="2232988" y="455352"/>
+                </a:lnTo>
+                <a:close/>
+                <a:lnTo>
+                  <a:pt x="2236614" y="449206"/>
+                </a:lnTo>
+                <a:close/>
+                <a:lnTo>
+                  <a:pt x="2240171" y="443070"/>
+                </a:lnTo>
+                <a:close/>
+                <a:lnTo>
+                  <a:pt x="2243659" y="436944"/>
+                </a:lnTo>
+                <a:close/>
+                <a:lnTo>
+                  <a:pt x="2247076" y="430827"/>
+                </a:lnTo>
+                <a:close/>
+                <a:lnTo>
+                  <a:pt x="2250422" y="424720"/>
+                </a:lnTo>
+                <a:close/>
+                <a:lnTo>
+                  <a:pt x="2253697" y="418624"/>
+                </a:lnTo>
+                <a:close/>
+                <a:lnTo>
+                  <a:pt x="2256900" y="412539"/>
+                </a:lnTo>
+                <a:close/>
+                <a:lnTo>
+                  <a:pt x="2260030" y="406464"/>
+                </a:lnTo>
+                <a:close/>
+                <a:lnTo>
+                  <a:pt x="2263087" y="400400"/>
+                </a:lnTo>
+                <a:close/>
+                <a:lnTo>
+                  <a:pt x="2266070" y="394348"/>
+                </a:lnTo>
+                <a:close/>
+                <a:lnTo>
+                  <a:pt x="2268977" y="388308"/>
+                </a:lnTo>
+                <a:close/>
+                <a:lnTo>
+                  <a:pt x="2271810" y="382279"/>
+                </a:lnTo>
+                <a:close/>
+                <a:lnTo>
+                  <a:pt x="2274566" y="376262"/>
+                </a:lnTo>
+                <a:close/>
+                <a:lnTo>
+                  <a:pt x="2277246" y="370258"/>
+                </a:lnTo>
+                <a:close/>
+                <a:lnTo>
+                  <a:pt x="2279849" y="364267"/>
+                </a:lnTo>
+                <a:close/>
+                <a:lnTo>
+                  <a:pt x="2282374" y="358288"/>
+                </a:lnTo>
+                <a:close/>
+                <a:lnTo>
+                  <a:pt x="2284820" y="352322"/>
+                </a:lnTo>
+                <a:close/>
+                <a:lnTo>
+                  <a:pt x="2287186" y="346370"/>
+                </a:lnTo>
+                <a:close/>
+                <a:lnTo>
+                  <a:pt x="2289473" y="340431"/>
+                </a:lnTo>
+                <a:close/>
+                <a:lnTo>
+                  <a:pt x="2291680" y="334506"/>
+                </a:lnTo>
+                <a:close/>
+                <a:lnTo>
+                  <a:pt x="2293805" y="328596"/>
+                </a:lnTo>
+                <a:close/>
+                <a:lnTo>
+                  <a:pt x="2295849" y="322699"/>
+                </a:lnTo>
+                <a:close/>
+                <a:lnTo>
+                  <a:pt x="2297810" y="316817"/>
+                </a:lnTo>
+                <a:close/>
+                <a:lnTo>
+                  <a:pt x="2299688" y="310950"/>
+                </a:lnTo>
+                <a:close/>
+                <a:lnTo>
+                  <a:pt x="2301482" y="305099"/>
+                </a:lnTo>
+                <a:close/>
+                <a:lnTo>
+                  <a:pt x="2303192" y="299262"/>
+                </a:lnTo>
+                <a:close/>
+                <a:lnTo>
+                  <a:pt x="2304817" y="293441"/>
+                </a:lnTo>
+                <a:close/>
+                <a:lnTo>
+                  <a:pt x="2306356" y="287636"/>
+                </a:lnTo>
+                <a:close/>
+                <a:lnTo>
+                  <a:pt x="2307809" y="281847"/>
+                </a:lnTo>
+                <a:close/>
+                <a:lnTo>
+                  <a:pt x="2309175" y="276074"/>
+                </a:lnTo>
+                <a:close/>
+                <a:lnTo>
+                  <a:pt x="2310454" y="270318"/>
+                </a:lnTo>
+                <a:close/>
+                <a:lnTo>
+                  <a:pt x="2311644" y="264579"/>
+                </a:lnTo>
+                <a:close/>
+                <a:lnTo>
+                  <a:pt x="2312745" y="258856"/>
+                </a:lnTo>
+                <a:close/>
+                <a:lnTo>
+                  <a:pt x="2313757" y="253151"/>
+                </a:lnTo>
+                <a:close/>
+                <a:lnTo>
+                  <a:pt x="2314679" y="247464"/>
+                </a:lnTo>
+                <a:close/>
+                <a:lnTo>
+                  <a:pt x="2315510" y="241795"/>
+                </a:lnTo>
+                <a:close/>
+                <a:lnTo>
+                  <a:pt x="2316249" y="236143"/>
+                </a:lnTo>
+                <a:close/>
+                <a:lnTo>
+                  <a:pt x="2316897" y="230510"/>
+                </a:lnTo>
+                <a:close/>
+                <a:lnTo>
+                  <a:pt x="2317451" y="224895"/>
+                </a:lnTo>
+                <a:close/>
+                <a:lnTo>
+                  <a:pt x="2317912" y="219300"/>
+                </a:lnTo>
+                <a:close/>
+                <a:lnTo>
+                  <a:pt x="2318280" y="213723"/>
+                </a:lnTo>
+                <a:close/>
+                <a:lnTo>
+                  <a:pt x="2318552" y="208166"/>
+                </a:lnTo>
+                <a:close/>
+                <a:lnTo>
+                  <a:pt x="2318729" y="202628"/>
+                </a:lnTo>
+                <a:close/>
+                <a:lnTo>
+                  <a:pt x="2318811" y="197110"/>
+                </a:lnTo>
+                <a:close/>
+                <a:lnTo>
+                  <a:pt x="2318795" y="191612"/>
+                </a:lnTo>
+                <a:close/>
+                <a:lnTo>
+                  <a:pt x="2318683" y="186134"/>
+                </a:lnTo>
+                <a:close/>
+                <a:lnTo>
+                  <a:pt x="2318472" y="180677"/>
+                </a:lnTo>
+                <a:close/>
+                <a:lnTo>
+                  <a:pt x="2318163" y="175241"/>
+                </a:lnTo>
+                <a:close/>
+                <a:lnTo>
+                  <a:pt x="2317755" y="169825"/>
+                </a:lnTo>
+                <a:close/>
+                <a:lnTo>
+                  <a:pt x="2317247" y="164431"/>
+                </a:lnTo>
+                <a:close/>
+                <a:lnTo>
+                  <a:pt x="2316639" y="159059"/>
+                </a:lnTo>
+                <a:close/>
+                <a:lnTo>
+                  <a:pt x="2315930" y="153708"/>
+                </a:lnTo>
+                <a:close/>
+                <a:lnTo>
+                  <a:pt x="2315118" y="148380"/>
+                </a:lnTo>
+                <a:close/>
+                <a:lnTo>
+                  <a:pt x="2314205" y="143073"/>
+                </a:lnTo>
+                <a:close/>
+                <a:lnTo>
+                  <a:pt x="2313188" y="137789"/>
+                </a:lnTo>
+                <a:close/>
+                <a:lnTo>
+                  <a:pt x="2312068" y="132528"/>
+                </a:lnTo>
+                <a:close/>
+                <a:lnTo>
+                  <a:pt x="2310843" y="127290"/>
+                </a:lnTo>
+                <a:close/>
+                <a:lnTo>
+                  <a:pt x="2309514" y="122076"/>
+                </a:lnTo>
+                <a:close/>
+                <a:lnTo>
+                  <a:pt x="2308078" y="116885"/>
+                </a:lnTo>
+                <a:close/>
+                <a:lnTo>
+                  <a:pt x="2306537" y="111717"/>
+                </a:lnTo>
+                <a:close/>
+                <a:lnTo>
+                  <a:pt x="2304889" y="106574"/>
+                </a:lnTo>
+                <a:close/>
+                <a:lnTo>
+                  <a:pt x="2303133" y="101455"/>
+                </a:lnTo>
+                <a:close/>
+                <a:lnTo>
+                  <a:pt x="2301269" y="96360"/>
+                </a:lnTo>
+                <a:close/>
+                <a:lnTo>
+                  <a:pt x="2299296" y="91290"/>
+                </a:lnTo>
+                <a:close/>
+                <a:lnTo>
+                  <a:pt x="2297214" y="86246"/>
+                </a:lnTo>
+                <a:close/>
+                <a:lnTo>
+                  <a:pt x="2295021" y="81226"/>
+                </a:lnTo>
+                <a:close/>
+                <a:lnTo>
+                  <a:pt x="2292718" y="76232"/>
+                </a:lnTo>
+                <a:close/>
+                <a:lnTo>
+                  <a:pt x="2290303" y="71264"/>
+                </a:lnTo>
+                <a:close/>
+                <a:lnTo>
+                  <a:pt x="2287777" y="66321"/>
+                </a:lnTo>
+                <a:close/>
+                <a:lnTo>
+                  <a:pt x="2285138" y="61405"/>
+                </a:lnTo>
+                <a:close/>
+                <a:lnTo>
+                  <a:pt x="2282385" y="56516"/>
+                </a:lnTo>
+                <a:close/>
+                <a:lnTo>
+                  <a:pt x="2279518" y="51653"/>
+                </a:lnTo>
+                <a:close/>
+                <a:lnTo>
+                  <a:pt x="2276537" y="46818"/>
+                </a:lnTo>
+                <a:close/>
+                <a:lnTo>
+                  <a:pt x="2273441" y="42009"/>
+                </a:lnTo>
+                <a:close/>
+                <a:lnTo>
+                  <a:pt x="2270228" y="37228"/>
+                </a:lnTo>
+                <a:close/>
+                <a:lnTo>
+                  <a:pt x="2266899" y="32475"/>
+                </a:lnTo>
+                <a:close/>
+                <a:lnTo>
+                  <a:pt x="2263453" y="27750"/>
+                </a:lnTo>
+                <a:close/>
+                <a:lnTo>
+                  <a:pt x="2259889" y="23053"/>
+                </a:lnTo>
+                <a:close/>
+                <a:lnTo>
+                  <a:pt x="2256207" y="18384"/>
+                </a:lnTo>
+                <a:close/>
+                <a:lnTo>
+                  <a:pt x="2252406" y="13744"/>
+                </a:lnTo>
+                <a:close/>
+                <a:lnTo>
+                  <a:pt x="2248484" y="9134"/>
+                </a:lnTo>
+                <a:close/>
+                <a:lnTo>
+                  <a:pt x="2244443" y="4552"/>
+                </a:lnTo>
+                <a:close/>
+                <a:lnTo>
+                  <a:pt x="2240280" y="0"/>
                 </a:lnTo>
                 <a:close/>
               </a:path>
@@ -5623,8 +5623,8 @@
         </p:nvCxnSpPr>
         <p:spPr>
           <a:xfrm flipV="1">
-            <a:off x="5486400.0" y="971550.0"/>
-            <a:ext cx="0.0" cy="1600200.0"/>
+            <a:off x="5943600.0" y="742950.0"/>
+            <a:ext cx="0.0" cy="1828800.0"/>
           </a:xfrm>
           <a:prstGeom prst="line">
             <a:avLst/>
@@ -5659,8 +5659,8 @@
         </p:nvCxnSpPr>
         <p:spPr>
           <a:xfrm>
-            <a:off x="4572000.0" y="971550.0"/>
-            <a:ext cx="914400.0" cy="0.0"/>
+            <a:off x="4572000.0" y="742950.0"/>
+            <a:ext cx="1371600.0" cy="0.0"/>
           </a:xfrm>
           <a:prstGeom prst="line">
             <a:avLst/>
@@ -5695,7 +5695,7 @@
         </p:nvSpPr>
         <p:spPr>
           <a:xfrm>
-            <a:off x="5397500" y="882650"/>
+            <a:off x="5854700" y="654050"/>
             <a:ext cx="177800" cy="177800"/>
           </a:xfrm>
           <a:prstGeom prst="ellipse">
@@ -5740,8 +5740,8 @@
         </p:nvCxnSpPr>
         <p:spPr>
           <a:xfrm>
-            <a:off x="5029200.0" y="2480310.0"/>
-            <a:ext cx="365760.0" cy="0.0"/>
+            <a:off x="5486400.0" y="2571750.0"/>
+            <a:ext cx="411480.0" cy="0.0"/>
           </a:xfrm>
           <a:prstGeom prst="line">
             <a:avLst/>
@@ -5775,8 +5775,8 @@
         </p:nvCxnSpPr>
         <p:spPr>
           <a:xfrm flipH="1">
-            <a:off x="5577840.0" y="2480310.0"/>
-            <a:ext cx="365760.0" cy="0.0"/>
+            <a:off x="5989320.0" y="2571750.0"/>
+            <a:ext cx="320040.0" cy="0.0"/>
           </a:xfrm>
           <a:prstGeom prst="line">
             <a:avLst/>
@@ -5810,8 +5810,8 @@
         </p:nvCxnSpPr>
         <p:spPr>
           <a:xfrm flipV="1">
-            <a:off x="5326380.0" y="1186434.0"/>
-            <a:ext cx="91440.0" cy="370332.0"/>
+            <a:off x="5440680.0" y="1017270.0"/>
+            <a:ext cx="182880.0" cy="228600.0"/>
           </a:xfrm>
           <a:prstGeom prst="line">
             <a:avLst/>
@@ -5845,8 +5845,8 @@
         </p:nvCxnSpPr>
         <p:spPr>
           <a:xfrm flipH="1">
-            <a:off x="5500116.0" y="537210.0"/>
-            <a:ext cx="54864.0" cy="365760.0"/>
+            <a:off x="5989320.0" y="331470.0"/>
+            <a:ext cx="91440.0" cy="228599.99999999977"/>
           </a:xfrm>
           <a:prstGeom prst="line">
             <a:avLst/>
@@ -5880,7 +5880,7 @@
         </p:nvSpPr>
         <p:spPr>
           <a:xfrm>
-            <a:off x="4775200" y="-31750"/>
+            <a:off x="5003800" y="-123190"/>
             <a:ext cx="1524000" cy="508000"/>
           </a:xfrm>
           <a:prstGeom prst="rect">
@@ -5916,7 +5916,7 @@
         </p:nvSpPr>
         <p:spPr>
           <a:xfrm>
-            <a:off x="4135120" y="654050"/>
+            <a:off x="4089400" y="425450"/>
             <a:ext cx="1524000" cy="508000"/>
           </a:xfrm>
           <a:prstGeom prst="rect">
@@ -5952,7 +5952,7 @@
         </p:nvSpPr>
         <p:spPr>
           <a:xfrm>
-            <a:off x="5232400" y="2437130"/>
+            <a:off x="5689600" y="2482850"/>
             <a:ext cx="1524000" cy="508000"/>
           </a:xfrm>
           <a:prstGeom prst="rect">

</xml_diff>